<commit_message>
deck: adversary fixes, readable standalone
</commit_message>
<xml_diff>
--- a/deck/unified.pptx
+++ b/deck/unified.pptx
@@ -121,6 +121,1546 @@
     </a:lvl9pPr>
   </p:defaultTextStyle>
 </p:presentation>
+</file>
+
+<file path=ppt/notesMasters/notesMaster1.xml><?xml version="1.0" encoding="utf-8"?>
+<p:notesMaster xmlns:a="http://schemas.openxmlformats.org/drawingml/2006/main" xmlns:p="http://schemas.openxmlformats.org/presentationml/2006/main" xmlns:r="http://schemas.openxmlformats.org/officeDocument/2006/relationships">
+  <p:cSld>
+    <p:bg>
+      <p:bgRef idx="1001">
+        <a:schemeClr val="bg1"/>
+      </p:bgRef>
+    </p:bg>
+    <p:spTree>
+      <p:nvGrpSpPr>
+        <p:cNvPr id="1" name=""/>
+        <p:cNvGrpSpPr/>
+        <p:nvPr/>
+      </p:nvGrpSpPr>
+      <p:grpSpPr>
+        <a:xfrm>
+          <a:off x="0" y="0"/>
+          <a:ext cx="0" cy="0"/>
+          <a:chOff x="0" y="0"/>
+          <a:chExt cx="0" cy="0"/>
+        </a:xfrm>
+      </p:grpSpPr>
+      <p:sp>
+        <p:nvSpPr>
+          <p:cNvPr id="2" name="Header Placeholder 1"/>
+          <p:cNvSpPr>
+            <a:spLocks noGrp="1"/>
+          </p:cNvSpPr>
+          <p:nvPr>
+            <p:ph type="hdr" sz="quarter"/>
+          </p:nvPr>
+        </p:nvSpPr>
+        <p:spPr>
+          <a:xfrm>
+            <a:off x="0" y="0"/>
+            <a:ext cx="2971800" cy="457200"/>
+          </a:xfrm>
+          <a:prstGeom prst="rect">
+            <a:avLst/>
+          </a:prstGeom>
+        </p:spPr>
+        <p:txBody>
+          <a:bodyPr vert="horz" lIns="91440" tIns="45720" rIns="91440" bIns="45720" rtlCol="0"/>
+          <a:lstStyle>
+            <a:lvl1pPr algn="l">
+              <a:defRPr sz="1200"/>
+            </a:lvl1pPr>
+          </a:lstStyle>
+          <a:p>
+            <a:endParaRPr lang="en-US"/>
+          </a:p>
+        </p:txBody>
+      </p:sp>
+      <p:sp>
+        <p:nvSpPr>
+          <p:cNvPr id="3" name="Date Placeholder 2"/>
+          <p:cNvSpPr>
+            <a:spLocks noGrp="1"/>
+          </p:cNvSpPr>
+          <p:nvPr>
+            <p:ph type="dt" idx="1"/>
+          </p:nvPr>
+        </p:nvSpPr>
+        <p:spPr>
+          <a:xfrm>
+            <a:off x="3884613" y="0"/>
+            <a:ext cx="2971800" cy="457200"/>
+          </a:xfrm>
+          <a:prstGeom prst="rect">
+            <a:avLst/>
+          </a:prstGeom>
+        </p:spPr>
+        <p:txBody>
+          <a:bodyPr vert="horz" lIns="91440" tIns="45720" rIns="91440" bIns="45720" rtlCol="0"/>
+          <a:lstStyle>
+            <a:lvl1pPr algn="r">
+              <a:defRPr sz="1200"/>
+            </a:lvl1pPr>
+          </a:lstStyle>
+          <a:p>
+            <a:fld id="{0F89C1C7-3DCD-1040-A9CF-14679D8B5DDD}" type="datetimeFigureOut">
+              <a:rPr lang="en-US" smtClean="0"/>
+              <a:t>10/17/16</a:t>
+            </a:fld>
+            <a:endParaRPr lang="en-US"/>
+          </a:p>
+        </p:txBody>
+      </p:sp>
+      <p:sp>
+        <p:nvSpPr>
+          <p:cNvPr id="4" name="Slide Image Placeholder 3"/>
+          <p:cNvSpPr>
+            <a:spLocks noGrp="1" noRot="1" noChangeAspect="1"/>
+          </p:cNvSpPr>
+          <p:nvPr>
+            <p:ph type="sldImg" idx="2"/>
+          </p:nvPr>
+        </p:nvSpPr>
+        <p:spPr>
+          <a:xfrm>
+            <a:off x="1143000" y="685800"/>
+            <a:ext cx="4572000" cy="3429000"/>
+          </a:xfrm>
+          <a:prstGeom prst="rect">
+            <a:avLst/>
+          </a:prstGeom>
+          <a:noFill/>
+          <a:ln w="12700">
+            <a:solidFill>
+              <a:prstClr val="black"/>
+            </a:solidFill>
+          </a:ln>
+        </p:spPr>
+        <p:txBody>
+          <a:bodyPr vert="horz" lIns="91440" tIns="45720" rIns="91440" bIns="45720" rtlCol="0" anchor="ctr"/>
+          <a:lstStyle/>
+          <a:p>
+            <a:endParaRPr lang="en-US"/>
+          </a:p>
+        </p:txBody>
+      </p:sp>
+      <p:sp>
+        <p:nvSpPr>
+          <p:cNvPr id="5" name="Notes Placeholder 4"/>
+          <p:cNvSpPr>
+            <a:spLocks noGrp="1"/>
+          </p:cNvSpPr>
+          <p:nvPr>
+            <p:ph type="body" sz="quarter" idx="3"/>
+          </p:nvPr>
+        </p:nvSpPr>
+        <p:spPr>
+          <a:xfrm>
+            <a:off x="685800" y="4343400"/>
+            <a:ext cx="5486400" cy="4114800"/>
+          </a:xfrm>
+          <a:prstGeom prst="rect">
+            <a:avLst/>
+          </a:prstGeom>
+        </p:spPr>
+        <p:txBody>
+          <a:bodyPr vert="horz" lIns="91440" tIns="45720" rIns="91440" bIns="45720" rtlCol="0"/>
+          <a:lstStyle/>
+          <a:p>
+            <a:pPr lvl="0"/>
+            <a:r>
+              <a:rPr lang="en-US" smtClean="0"/>
+              <a:t>Click to edit Master text styles</a:t>
+            </a:r>
+          </a:p>
+          <a:p>
+            <a:pPr lvl="1"/>
+            <a:r>
+              <a:rPr lang="en-US" smtClean="0"/>
+              <a:t>Second level</a:t>
+            </a:r>
+          </a:p>
+          <a:p>
+            <a:pPr lvl="2"/>
+            <a:r>
+              <a:rPr lang="en-US" smtClean="0"/>
+              <a:t>Third level</a:t>
+            </a:r>
+          </a:p>
+          <a:p>
+            <a:pPr lvl="3"/>
+            <a:r>
+              <a:rPr lang="en-US" smtClean="0"/>
+              <a:t>Fourth level</a:t>
+            </a:r>
+          </a:p>
+          <a:p>
+            <a:pPr lvl="4"/>
+            <a:r>
+              <a:rPr lang="en-US" smtClean="0"/>
+              <a:t>Fifth level</a:t>
+            </a:r>
+            <a:endParaRPr lang="en-US"/>
+          </a:p>
+        </p:txBody>
+      </p:sp>
+      <p:sp>
+        <p:nvSpPr>
+          <p:cNvPr id="6" name="Footer Placeholder 5"/>
+          <p:cNvSpPr>
+            <a:spLocks noGrp="1"/>
+          </p:cNvSpPr>
+          <p:nvPr>
+            <p:ph type="ftr" sz="quarter" idx="4"/>
+          </p:nvPr>
+        </p:nvSpPr>
+        <p:spPr>
+          <a:xfrm>
+            <a:off x="0" y="8685213"/>
+            <a:ext cx="2971800" cy="457200"/>
+          </a:xfrm>
+          <a:prstGeom prst="rect">
+            <a:avLst/>
+          </a:prstGeom>
+        </p:spPr>
+        <p:txBody>
+          <a:bodyPr vert="horz" lIns="91440" tIns="45720" rIns="91440" bIns="45720" rtlCol="0" anchor="b"/>
+          <a:lstStyle>
+            <a:lvl1pPr algn="l">
+              <a:defRPr sz="1200"/>
+            </a:lvl1pPr>
+          </a:lstStyle>
+          <a:p>
+            <a:endParaRPr lang="en-US"/>
+          </a:p>
+        </p:txBody>
+      </p:sp>
+      <p:sp>
+        <p:nvSpPr>
+          <p:cNvPr id="7" name="Slide Number Placeholder 6"/>
+          <p:cNvSpPr>
+            <a:spLocks noGrp="1"/>
+          </p:cNvSpPr>
+          <p:nvPr>
+            <p:ph type="sldNum" sz="quarter" idx="5"/>
+          </p:nvPr>
+        </p:nvSpPr>
+        <p:spPr>
+          <a:xfrm>
+            <a:off x="3884613" y="8685213"/>
+            <a:ext cx="2971800" cy="457200"/>
+          </a:xfrm>
+          <a:prstGeom prst="rect">
+            <a:avLst/>
+          </a:prstGeom>
+        </p:spPr>
+        <p:txBody>
+          <a:bodyPr vert="horz" lIns="91440" tIns="45720" rIns="91440" bIns="45720" rtlCol="0" anchor="b"/>
+          <a:lstStyle>
+            <a:lvl1pPr algn="r">
+              <a:defRPr sz="1200"/>
+            </a:lvl1pPr>
+          </a:lstStyle>
+          <a:p>
+            <a:fld id="{BB5E49A5-4136-284D-997B-48E1D791AD67}" type="slidenum">
+              <a:rPr lang="en-US" smtClean="0"/>
+              <a:t>‹#›</a:t>
+            </a:fld>
+            <a:endParaRPr lang="en-US"/>
+          </a:p>
+        </p:txBody>
+      </p:sp>
+    </p:spTree>
+    <p:extLst>
+      <p:ext uri="{BB962C8B-B14F-4D97-AF65-F5344CB8AC3E}">
+        <p14:creationId xmlns:p14="http://schemas.microsoft.com/office/powerpoint/2010/main" val="2623252185"/>
+      </p:ext>
+    </p:extLst>
+  </p:cSld>
+  <p:clrMap bg1="lt1" tx1="dk1" bg2="lt2" tx2="dk2" accent1="accent1" accent2="accent2" accent3="accent3" accent4="accent4" accent5="accent5" accent6="accent6" hlink="hlink" folHlink="folHlink"/>
+  <p:notesStyle>
+    <a:lvl1pPr marL="0" algn="l" defTabSz="457200" rtl="0" eaLnBrk="1" latinLnBrk="0" hangingPunct="1">
+      <a:defRPr sz="1200" kern="1200">
+        <a:solidFill>
+          <a:schemeClr val="tx1"/>
+        </a:solidFill>
+        <a:latin typeface="+mn-lt"/>
+        <a:ea typeface="+mn-ea"/>
+        <a:cs typeface="+mn-cs"/>
+      </a:defRPr>
+    </a:lvl1pPr>
+    <a:lvl2pPr marL="457200" algn="l" defTabSz="457200" rtl="0" eaLnBrk="1" latinLnBrk="0" hangingPunct="1">
+      <a:defRPr sz="1200" kern="1200">
+        <a:solidFill>
+          <a:schemeClr val="tx1"/>
+        </a:solidFill>
+        <a:latin typeface="+mn-lt"/>
+        <a:ea typeface="+mn-ea"/>
+        <a:cs typeface="+mn-cs"/>
+      </a:defRPr>
+    </a:lvl2pPr>
+    <a:lvl3pPr marL="914400" algn="l" defTabSz="457200" rtl="0" eaLnBrk="1" latinLnBrk="0" hangingPunct="1">
+      <a:defRPr sz="1200" kern="1200">
+        <a:solidFill>
+          <a:schemeClr val="tx1"/>
+        </a:solidFill>
+        <a:latin typeface="+mn-lt"/>
+        <a:ea typeface="+mn-ea"/>
+        <a:cs typeface="+mn-cs"/>
+      </a:defRPr>
+    </a:lvl3pPr>
+    <a:lvl4pPr marL="1371600" algn="l" defTabSz="457200" rtl="0" eaLnBrk="1" latinLnBrk="0" hangingPunct="1">
+      <a:defRPr sz="1200" kern="1200">
+        <a:solidFill>
+          <a:schemeClr val="tx1"/>
+        </a:solidFill>
+        <a:latin typeface="+mn-lt"/>
+        <a:ea typeface="+mn-ea"/>
+        <a:cs typeface="+mn-cs"/>
+      </a:defRPr>
+    </a:lvl4pPr>
+    <a:lvl5pPr marL="1828800" algn="l" defTabSz="457200" rtl="0" eaLnBrk="1" latinLnBrk="0" hangingPunct="1">
+      <a:defRPr sz="1200" kern="1200">
+        <a:solidFill>
+          <a:schemeClr val="tx1"/>
+        </a:solidFill>
+        <a:latin typeface="+mn-lt"/>
+        <a:ea typeface="+mn-ea"/>
+        <a:cs typeface="+mn-cs"/>
+      </a:defRPr>
+    </a:lvl5pPr>
+    <a:lvl6pPr marL="2286000" algn="l" defTabSz="457200" rtl="0" eaLnBrk="1" latinLnBrk="0" hangingPunct="1">
+      <a:defRPr sz="1200" kern="1200">
+        <a:solidFill>
+          <a:schemeClr val="tx1"/>
+        </a:solidFill>
+        <a:latin typeface="+mn-lt"/>
+        <a:ea typeface="+mn-ea"/>
+        <a:cs typeface="+mn-cs"/>
+      </a:defRPr>
+    </a:lvl6pPr>
+    <a:lvl7pPr marL="2743200" algn="l" defTabSz="457200" rtl="0" eaLnBrk="1" latinLnBrk="0" hangingPunct="1">
+      <a:defRPr sz="1200" kern="1200">
+        <a:solidFill>
+          <a:schemeClr val="tx1"/>
+        </a:solidFill>
+        <a:latin typeface="+mn-lt"/>
+        <a:ea typeface="+mn-ea"/>
+        <a:cs typeface="+mn-cs"/>
+      </a:defRPr>
+    </a:lvl7pPr>
+    <a:lvl8pPr marL="3200400" algn="l" defTabSz="457200" rtl="0" eaLnBrk="1" latinLnBrk="0" hangingPunct="1">
+      <a:defRPr sz="1200" kern="1200">
+        <a:solidFill>
+          <a:schemeClr val="tx1"/>
+        </a:solidFill>
+        <a:latin typeface="+mn-lt"/>
+        <a:ea typeface="+mn-ea"/>
+        <a:cs typeface="+mn-cs"/>
+      </a:defRPr>
+    </a:lvl8pPr>
+    <a:lvl9pPr marL="3657600" algn="l" defTabSz="457200" rtl="0" eaLnBrk="1" latinLnBrk="0" hangingPunct="1">
+      <a:defRPr sz="1200" kern="1200">
+        <a:solidFill>
+          <a:schemeClr val="tx1"/>
+        </a:solidFill>
+        <a:latin typeface="+mn-lt"/>
+        <a:ea typeface="+mn-ea"/>
+        <a:cs typeface="+mn-cs"/>
+      </a:defRPr>
+    </a:lvl9pPr>
+  </p:notesStyle>
+</p:notesMaster>
+</file>
+
+<file path=ppt/notesSlides/notesSlide1.xml><?xml version="1.0" encoding="utf-8"?>
+<p:notes xmlns:a="http://schemas.openxmlformats.org/drawingml/2006/main" xmlns:p="http://schemas.openxmlformats.org/presentationml/2006/main" xmlns:r="http://schemas.openxmlformats.org/officeDocument/2006/relationships">
+  <p:cSld>
+    <p:spTree>
+      <p:nvGrpSpPr>
+        <p:cNvPr id="1" name=""/>
+        <p:cNvGrpSpPr/>
+        <p:nvPr/>
+      </p:nvGrpSpPr>
+      <p:grpSpPr>
+        <a:xfrm>
+          <a:off x="0" y="0"/>
+          <a:ext cx="0" cy="0"/>
+          <a:chOff x="0" y="0"/>
+          <a:chExt cx="0" cy="0"/>
+        </a:xfrm>
+      </p:grpSpPr>
+      <p:sp>
+        <p:nvSpPr>
+          <p:cNvPr id="2" name="Slide Image Placeholder 1"/>
+          <p:cNvSpPr>
+            <a:spLocks noGrp="1"/>
+          </p:cNvSpPr>
+          <p:nvPr>
+            <p:ph type="sldImg" idx="2"/>
+          </p:nvPr>
+        </p:nvSpPr>
+        <p:spPr/>
+      </p:sp>
+      <p:sp>
+        <p:nvSpPr>
+          <p:cNvPr id="3" name="Notes Placeholder 2"/>
+          <p:cNvSpPr>
+            <a:spLocks noGrp="1"/>
+          </p:cNvSpPr>
+          <p:nvPr>
+            <p:ph type="body" idx="3" sz="quarter"/>
+          </p:nvPr>
+        </p:nvSpPr>
+        <p:spPr/>
+        <p:txBody>
+          <a:bodyPr/>
+          <a:lstStyle/>
+          <a:p>
+            <a:r>
+              <a:t>Opener. Definitions: Big Data Bowl = the NFL's annual analytics contest, run with AWS (Amazon Web Services); Muse Code = the agentic CLI used live in this talk; Next Gen Stats = the league's RFID tracking feed. Provenance: talk premise = docs/talk-notes.md. Transition: the contest is the frame, next slide says what it asks.</a:t>
+            </a:r>
+          </a:p>
+        </p:txBody>
+      </p:sp>
+      <p:sp>
+        <p:nvSpPr>
+          <p:cNvPr id="4" name="Slide Number Placeholder 3"/>
+          <p:cNvSpPr>
+            <a:spLocks noGrp="1"/>
+          </p:cNvSpPr>
+          <p:nvPr>
+            <p:ph type="sldNum" idx="5" sz="quarter"/>
+          </p:nvPr>
+        </p:nvSpPr>
+        <p:spPr/>
+      </p:sp>
+    </p:spTree>
+  </p:cSld>
+  <p:clrMapOvr>
+    <a:masterClrMapping/>
+  </p:clrMapOvr>
+</p:notes>
+</file>
+
+<file path=ppt/notesSlides/notesSlide10.xml><?xml version="1.0" encoding="utf-8"?>
+<p:notes xmlns:a="http://schemas.openxmlformats.org/drawingml/2006/main" xmlns:p="http://schemas.openxmlformats.org/presentationml/2006/main" xmlns:r="http://schemas.openxmlformats.org/officeDocument/2006/relationships">
+  <p:cSld>
+    <p:spTree>
+      <p:nvGrpSpPr>
+        <p:cNvPr id="1" name=""/>
+        <p:cNvGrpSpPr/>
+        <p:nvPr/>
+      </p:nvGrpSpPr>
+      <p:grpSpPr>
+        <a:xfrm>
+          <a:off x="0" y="0"/>
+          <a:ext cx="0" cy="0"/>
+          <a:chOff x="0" y="0"/>
+          <a:chExt cx="0" cy="0"/>
+        </a:xfrm>
+      </p:grpSpPr>
+      <p:sp>
+        <p:nvSpPr>
+          <p:cNvPr id="2" name="Slide Image Placeholder 1"/>
+          <p:cNvSpPr>
+            <a:spLocks noGrp="1"/>
+          </p:cNvSpPr>
+          <p:nvPr>
+            <p:ph type="sldImg" idx="2"/>
+          </p:nvPr>
+        </p:nvSpPr>
+        <p:spPr/>
+      </p:sp>
+      <p:sp>
+        <p:nvSpPr>
+          <p:cNvPr id="3" name="Notes Placeholder 2"/>
+          <p:cNvSpPr>
+            <a:spLocks noGrp="1"/>
+          </p:cNvSpPr>
+          <p:nvPr>
+            <p:ph type="body" idx="3" sz="quarter"/>
+          </p:nvPr>
+        </p:nvSpPr>
+        <p:spPr/>
+        <p:txBody>
+          <a:bodyPr/>
+          <a:lstStyle/>
+          <a:p>
+            <a:r>
+              <a:t>Definitions: skills = reusable .agents/skills/&lt;id&gt;/SKILL.md prompt packages; mtime = file modification timestamp; Kaggle free tier = ~30 GPU-hours/week. Provenance: .agents/skills/ trio; scripts/sweep_weeks.sh + scripts/guard_data.sh (mtime canary); GPU budget [64]. Transition: process covered, next is what graders actually reward.</a:t>
+            </a:r>
+          </a:p>
+        </p:txBody>
+      </p:sp>
+      <p:sp>
+        <p:nvSpPr>
+          <p:cNvPr id="4" name="Slide Number Placeholder 3"/>
+          <p:cNvSpPr>
+            <a:spLocks noGrp="1"/>
+          </p:cNvSpPr>
+          <p:nvPr>
+            <p:ph type="sldNum" idx="5" sz="quarter"/>
+          </p:nvPr>
+        </p:nvSpPr>
+        <p:spPr/>
+      </p:sp>
+    </p:spTree>
+  </p:cSld>
+  <p:clrMapOvr>
+    <a:masterClrMapping/>
+  </p:clrMapOvr>
+</p:notes>
+</file>
+
+<file path=ppt/notesSlides/notesSlide11.xml><?xml version="1.0" encoding="utf-8"?>
+<p:notes xmlns:a="http://schemas.openxmlformats.org/drawingml/2006/main" xmlns:p="http://schemas.openxmlformats.org/presentationml/2006/main" xmlns:r="http://schemas.openxmlformats.org/officeDocument/2006/relationships">
+  <p:cSld>
+    <p:spTree>
+      <p:nvGrpSpPr>
+        <p:cNvPr id="1" name=""/>
+        <p:cNvGrpSpPr/>
+        <p:nvPr/>
+      </p:nvGrpSpPr>
+      <p:grpSpPr>
+        <a:xfrm>
+          <a:off x="0" y="0"/>
+          <a:ext cx="0" cy="0"/>
+          <a:chOff x="0" y="0"/>
+          <a:chExt cx="0" cy="0"/>
+        </a:xfrm>
+      </p:grpSpPr>
+      <p:sp>
+        <p:nvSpPr>
+          <p:cNvPr id="2" name="Slide Image Placeholder 1"/>
+          <p:cNvSpPr>
+            <a:spLocks noGrp="1"/>
+          </p:cNvSpPr>
+          <p:nvPr>
+            <p:ph type="sldImg" idx="2"/>
+          </p:nvPr>
+        </p:nvSpPr>
+        <p:spPr/>
+      </p:sp>
+      <p:sp>
+        <p:nvSpPr>
+          <p:cNvPr id="3" name="Notes Placeholder 2"/>
+          <p:cNvSpPr>
+            <a:spLocks noGrp="1"/>
+          </p:cNvSpPr>
+          <p:nvPr>
+            <p:ph type="body" idx="3" sz="quarter"/>
+          </p:nvPr>
+        </p:nvSpPr>
+        <p:spPr/>
+        <p:txBody>
+          <a:bodyPr/>
+          <a:lstStyle/>
+          <a:p>
+            <a:r>
+              <a:t>Definitions: CV = cross-validation, SE = standard errors; Patton/Yurko = cited methodology references in docs/craft.md. Provenance: rubric 30/30/20/20 + 2000-word / &lt;10-figure limits (docs/craft.md, [37]); competition max 20 slides, this deck has 17. Transition: craft is timeless, but 2027 has a specific shape, which is the forecast.</a:t>
+            </a:r>
+          </a:p>
+        </p:txBody>
+      </p:sp>
+      <p:sp>
+        <p:nvSpPr>
+          <p:cNvPr id="4" name="Slide Number Placeholder 3"/>
+          <p:cNvSpPr>
+            <a:spLocks noGrp="1"/>
+          </p:cNvSpPr>
+          <p:nvPr>
+            <p:ph type="sldNum" idx="5" sz="quarter"/>
+          </p:nvPr>
+        </p:nvSpPr>
+        <p:spPr/>
+      </p:sp>
+    </p:spTree>
+  </p:cSld>
+  <p:clrMapOvr>
+    <a:masterClrMapping/>
+  </p:clrMapOvr>
+</p:notes>
+</file>
+
+<file path=ppt/notesSlides/notesSlide12.xml><?xml version="1.0" encoding="utf-8"?>
+<p:notes xmlns:a="http://schemas.openxmlformats.org/drawingml/2006/main" xmlns:p="http://schemas.openxmlformats.org/presentationml/2006/main" xmlns:r="http://schemas.openxmlformats.org/officeDocument/2006/relationships">
+  <p:cSld>
+    <p:spTree>
+      <p:nvGrpSpPr>
+        <p:cNvPr id="1" name=""/>
+        <p:cNvGrpSpPr/>
+        <p:nvPr/>
+      </p:nvGrpSpPr>
+      <p:grpSpPr>
+        <a:xfrm>
+          <a:off x="0" y="0"/>
+          <a:ext cx="0" cy="0"/>
+          <a:chOff x="0" y="0"/>
+          <a:chExt cx="0" cy="0"/>
+        </a:xfrm>
+      </p:grpSpPr>
+      <p:sp>
+        <p:nvSpPr>
+          <p:cNvPr id="2" name="Slide Image Placeholder 1"/>
+          <p:cNvSpPr>
+            <a:spLocks noGrp="1"/>
+          </p:cNvSpPr>
+          <p:nvPr>
+            <p:ph type="sldImg" idx="2"/>
+          </p:nvPr>
+        </p:nvSpPr>
+        <p:spPr/>
+      </p:sp>
+      <p:sp>
+        <p:nvSpPr>
+          <p:cNvPr id="3" name="Notes Placeholder 2"/>
+          <p:cNvSpPr>
+            <a:spLocks noGrp="1"/>
+          </p:cNvSpPr>
+          <p:nvPr>
+            <p:ph type="body" idx="3" sz="quarter"/>
+          </p:nvPr>
+        </p:nvSpPr>
+        <p:spPr/>
+        <p:txBody>
+          <a:bodyPr/>
+          <a:lstStyle/>
+          <a:p>
+            <a:r>
+              <a:t>Definitions: ghost/counterfactual = predicted defender-free receiver paths; new kickoff = the redesigned kickoff formation; prediction vs metric years = alternating contest topics. Provenance: 2026 opened Sep 25 2025 ([33]); forecast + tooling thesis docs/2027-prediction.md. Transition: forecasts need local firepower, which Glimmer provides live.</a:t>
+            </a:r>
+          </a:p>
+        </p:txBody>
+      </p:sp>
+      <p:sp>
+        <p:nvSpPr>
+          <p:cNvPr id="4" name="Slide Number Placeholder 3"/>
+          <p:cNvSpPr>
+            <a:spLocks noGrp="1"/>
+          </p:cNvSpPr>
+          <p:nvPr>
+            <p:ph type="sldNum" idx="5" sz="quarter"/>
+          </p:nvPr>
+        </p:nvSpPr>
+        <p:spPr/>
+      </p:sp>
+    </p:spTree>
+  </p:cSld>
+  <p:clrMapOvr>
+    <a:masterClrMapping/>
+  </p:clrMapOvr>
+</p:notes>
+</file>
+
+<file path=ppt/notesSlides/notesSlide13.xml><?xml version="1.0" encoding="utf-8"?>
+<p:notes xmlns:a="http://schemas.openxmlformats.org/drawingml/2006/main" xmlns:p="http://schemas.openxmlformats.org/presentationml/2006/main" xmlns:r="http://schemas.openxmlformats.org/officeDocument/2006/relationships">
+  <p:cSld>
+    <p:spTree>
+      <p:nvGrpSpPr>
+        <p:cNvPr id="1" name=""/>
+        <p:cNvGrpSpPr/>
+        <p:nvPr/>
+      </p:nvGrpSpPr>
+      <p:grpSpPr>
+        <a:xfrm>
+          <a:off x="0" y="0"/>
+          <a:ext cx="0" cy="0"/>
+          <a:chOff x="0" y="0"/>
+          <a:chExt cx="0" cy="0"/>
+        </a:xfrm>
+      </p:grpSpPr>
+      <p:sp>
+        <p:nvSpPr>
+          <p:cNvPr id="2" name="Slide Image Placeholder 1"/>
+          <p:cNvSpPr>
+            <a:spLocks noGrp="1"/>
+          </p:cNvSpPr>
+          <p:nvPr>
+            <p:ph type="sldImg" idx="2"/>
+          </p:nvPr>
+        </p:nvSpPr>
+        <p:spPr/>
+      </p:sp>
+      <p:sp>
+        <p:nvSpPr>
+          <p:cNvPr id="3" name="Notes Placeholder 2"/>
+          <p:cNvSpPr>
+            <a:spLocks noGrp="1"/>
+          </p:cNvSpPr>
+          <p:nvPr>
+            <p:ph type="body" idx="3" sz="quarter"/>
+          </p:nvPr>
+        </p:nvSpPr>
+        <p:spPr/>
+        <p:txBody>
+          <a:bodyPr/>
+          <a:lstStyle/>
+          <a:p>
+            <a:r>
+              <a:t>Definitions: 30B = 30-billion-parameter open-weights model distilled from Muse Spark 1.2; NGL = number of GPU layers; Q4_K_M = 4-bit quantization variant; gpu_lock = Valkey mutual-exclusion key serializing GPU users; HTTP 503 = busy, 200 = served. Provenance: all numbers /tmp/glimmer-demo-numbers.md, measured 2026-09-28 on rocm-aibox: supervisor cold-start ~8 s, idle teardown 300 s, 503-then-200 lock behavior, 15 chunks in 73.5 s, 397-token review in 245 s wall. Transition: headline numbers next, head-to-head.</a:t>
+            </a:r>
+          </a:p>
+        </p:txBody>
+      </p:sp>
+      <p:sp>
+        <p:nvSpPr>
+          <p:cNvPr id="4" name="Slide Number Placeholder 3"/>
+          <p:cNvSpPr>
+            <a:spLocks noGrp="1"/>
+          </p:cNvSpPr>
+          <p:nvPr>
+            <p:ph type="sldNum" idx="5" sz="quarter"/>
+          </p:nvPr>
+        </p:nvSpPr>
+        <p:spPr/>
+      </p:sp>
+    </p:spTree>
+  </p:cSld>
+  <p:clrMapOvr>
+    <a:masterClrMapping/>
+  </p:clrMapOvr>
+</p:notes>
+</file>
+
+<file path=ppt/notesSlides/notesSlide14.xml><?xml version="1.0" encoding="utf-8"?>
+<p:notes xmlns:a="http://schemas.openxmlformats.org/drawingml/2006/main" xmlns:p="http://schemas.openxmlformats.org/presentationml/2006/main" xmlns:r="http://schemas.openxmlformats.org/officeDocument/2006/relationships">
+  <p:cSld>
+    <p:spTree>
+      <p:nvGrpSpPr>
+        <p:cNvPr id="1" name=""/>
+        <p:cNvGrpSpPr/>
+        <p:nvPr/>
+      </p:nvGrpSpPr>
+      <p:grpSpPr>
+        <a:xfrm>
+          <a:off x="0" y="0"/>
+          <a:ext cx="0" cy="0"/>
+          <a:chOff x="0" y="0"/>
+          <a:chExt cx="0" cy="0"/>
+        </a:xfrm>
+      </p:grpSpPr>
+      <p:sp>
+        <p:nvSpPr>
+          <p:cNvPr id="2" name="Slide Image Placeholder 1"/>
+          <p:cNvSpPr>
+            <a:spLocks noGrp="1"/>
+          </p:cNvSpPr>
+          <p:nvPr>
+            <p:ph type="sldImg" idx="2"/>
+          </p:nvPr>
+        </p:nvSpPr>
+        <p:spPr/>
+      </p:sp>
+      <p:sp>
+        <p:nvSpPr>
+          <p:cNvPr id="3" name="Notes Placeholder 2"/>
+          <p:cNvSpPr>
+            <a:spLocks noGrp="1"/>
+          </p:cNvSpPr>
+          <p:nvPr>
+            <p:ph type="body" idx="3" sz="quarter"/>
+          </p:nvPr>
+        </p:nvSpPr>
+        <p:spPr/>
+        <p:txBody>
+          <a:bodyPr/>
+          <a:lstStyle/>
+          <a:p>
+            <a:r>
+              <a:t>Definitions: tokens/s = model throughput; mmproj = multimodal projector mapping images into token space; bf16 = 16-bit float; VRAM = GPU memory; Muse Spark hosted = subscription API counterpart. Provenance: /tmp/glimmer-demo-numbers.md 2026-09-28 rocm-aibox: NGL0 41.7 s wall / 5.7 prompt / 0.46 gen tokens/s; NGL13 186.7 s / 1.75 / 0.17, 11.62 GB VRAM; verdict = gen is bandwidth-bound so GPU layers add nothing, prompt slower than CPU; Spark 2m13s vs local 186.7 s; vision HTTP 200 in 135.8 s, mmproj bf16 11.09 GB, CPU embedding too slow for production. Transition: from local models back to daily Muse Code habits.</a:t>
+            </a:r>
+          </a:p>
+        </p:txBody>
+      </p:sp>
+      <p:sp>
+        <p:nvSpPr>
+          <p:cNvPr id="4" name="Slide Number Placeholder 3"/>
+          <p:cNvSpPr>
+            <a:spLocks noGrp="1"/>
+          </p:cNvSpPr>
+          <p:nvPr>
+            <p:ph type="sldNum" idx="5" sz="quarter"/>
+          </p:nvPr>
+        </p:nvSpPr>
+        <p:spPr/>
+      </p:sp>
+    </p:spTree>
+  </p:cSld>
+  <p:clrMapOvr>
+    <a:masterClrMapping/>
+  </p:clrMapOvr>
+</p:notes>
+</file>
+
+<file path=ppt/notesSlides/notesSlide15.xml><?xml version="1.0" encoding="utf-8"?>
+<p:notes xmlns:a="http://schemas.openxmlformats.org/drawingml/2006/main" xmlns:p="http://schemas.openxmlformats.org/presentationml/2006/main" xmlns:r="http://schemas.openxmlformats.org/officeDocument/2006/relationships">
+  <p:cSld>
+    <p:spTree>
+      <p:nvGrpSpPr>
+        <p:cNvPr id="1" name=""/>
+        <p:cNvGrpSpPr/>
+        <p:nvPr/>
+      </p:nvGrpSpPr>
+      <p:grpSpPr>
+        <a:xfrm>
+          <a:off x="0" y="0"/>
+          <a:ext cx="0" cy="0"/>
+          <a:chOff x="0" y="0"/>
+          <a:chExt cx="0" cy="0"/>
+        </a:xfrm>
+      </p:grpSpPr>
+      <p:sp>
+        <p:nvSpPr>
+          <p:cNvPr id="2" name="Slide Image Placeholder 1"/>
+          <p:cNvSpPr>
+            <a:spLocks noGrp="1"/>
+          </p:cNvSpPr>
+          <p:nvPr>
+            <p:ph type="sldImg" idx="2"/>
+          </p:nvPr>
+        </p:nvSpPr>
+        <p:spPr/>
+      </p:sp>
+      <p:sp>
+        <p:nvSpPr>
+          <p:cNvPr id="3" name="Notes Placeholder 2"/>
+          <p:cNvSpPr>
+            <a:spLocks noGrp="1"/>
+          </p:cNvSpPr>
+          <p:nvPr>
+            <p:ph type="body" idx="3" sz="quarter"/>
+          </p:nvPr>
+        </p:nvSpPr>
+        <p:spPr/>
+        <p:txBody>
+          <a:bodyPr/>
+          <a:lstStyle/>
+          <a:p>
+            <a:r>
+              <a:t>Definitions: TUI = terminal user interface (interactive pairing); SKILL.md = skill manifest path. Provenance: tips 1-5 map to repo: explore_sample + weeks_to_parquet are already skills here (.agents/skills/). Transition: first half was interactive, second half is guardrails and scale.</a:t>
+            </a:r>
+          </a:p>
+        </p:txBody>
+      </p:sp>
+      <p:sp>
+        <p:nvSpPr>
+          <p:cNvPr id="4" name="Slide Number Placeholder 3"/>
+          <p:cNvSpPr>
+            <a:spLocks noGrp="1"/>
+          </p:cNvSpPr>
+          <p:nvPr>
+            <p:ph type="sldNum" idx="5" sz="quarter"/>
+          </p:nvPr>
+        </p:nvSpPr>
+        <p:spPr/>
+      </p:sp>
+    </p:spTree>
+  </p:cSld>
+  <p:clrMapOvr>
+    <a:masterClrMapping/>
+  </p:clrMapOvr>
+</p:notes>
+</file>
+
+<file path=ppt/notesSlides/notesSlide16.xml><?xml version="1.0" encoding="utf-8"?>
+<p:notes xmlns:a="http://schemas.openxmlformats.org/drawingml/2006/main" xmlns:p="http://schemas.openxmlformats.org/presentationml/2006/main" xmlns:r="http://schemas.openxmlformats.org/officeDocument/2006/relationships">
+  <p:cSld>
+    <p:spTree>
+      <p:nvGrpSpPr>
+        <p:cNvPr id="1" name=""/>
+        <p:cNvGrpSpPr/>
+        <p:nvPr/>
+      </p:nvGrpSpPr>
+      <p:grpSpPr>
+        <a:xfrm>
+          <a:off x="0" y="0"/>
+          <a:ext cx="0" cy="0"/>
+          <a:chOff x="0" y="0"/>
+          <a:chExt cx="0" cy="0"/>
+        </a:xfrm>
+      </p:grpSpPr>
+      <p:sp>
+        <p:nvSpPr>
+          <p:cNvPr id="2" name="Slide Image Placeholder 1"/>
+          <p:cNvSpPr>
+            <a:spLocks noGrp="1"/>
+          </p:cNvSpPr>
+          <p:nvPr>
+            <p:ph type="sldImg" idx="2"/>
+          </p:nvPr>
+        </p:nvSpPr>
+        <p:spPr/>
+      </p:sp>
+      <p:sp>
+        <p:nvSpPr>
+          <p:cNvPr id="3" name="Notes Placeholder 2"/>
+          <p:cNvSpPr>
+            <a:spLocks noGrp="1"/>
+          </p:cNvSpPr>
+          <p:nvPr>
+            <p:ph type="body" idx="3" sz="quarter"/>
+          </p:nvPr>
+        </p:nvSpPr>
+        <p:spPr/>
+        <p:txBody>
+          <a:bodyPr/>
+          <a:lstStyle/>
+          <a:p>
+            <a:r>
+              <a:t>Definitions: MCP = Model Context Protocol, read-only-first = least-privilege tool wiring; /sessions + /rewind = session recovery commands; gpu_lock = same Valkey key from slide 13, reused for any GPU work. Provenance: tips 6-10 per docs/muse-code.md + live Glimmer endpoint :8181. Transition: habits listed, close on the thesis.</a:t>
+            </a:r>
+          </a:p>
+        </p:txBody>
+      </p:sp>
+      <p:sp>
+        <p:nvSpPr>
+          <p:cNvPr id="4" name="Slide Number Placeholder 3"/>
+          <p:cNvSpPr>
+            <a:spLocks noGrp="1"/>
+          </p:cNvSpPr>
+          <p:nvPr>
+            <p:ph type="sldNum" idx="5" sz="quarter"/>
+          </p:nvPr>
+        </p:nvSpPr>
+        <p:spPr/>
+      </p:sp>
+    </p:spTree>
+  </p:cSld>
+  <p:clrMapOvr>
+    <a:masterClrMapping/>
+  </p:clrMapOvr>
+</p:notes>
+</file>
+
+<file path=ppt/notesSlides/notesSlide17.xml><?xml version="1.0" encoding="utf-8"?>
+<p:notes xmlns:a="http://schemas.openxmlformats.org/drawingml/2006/main" xmlns:p="http://schemas.openxmlformats.org/presentationml/2006/main" xmlns:r="http://schemas.openxmlformats.org/officeDocument/2006/relationships">
+  <p:cSld>
+    <p:spTree>
+      <p:nvGrpSpPr>
+        <p:cNvPr id="1" name=""/>
+        <p:cNvGrpSpPr/>
+        <p:nvPr/>
+      </p:nvGrpSpPr>
+      <p:grpSpPr>
+        <a:xfrm>
+          <a:off x="0" y="0"/>
+          <a:ext cx="0" cy="0"/>
+          <a:chOff x="0" y="0"/>
+          <a:chExt cx="0" cy="0"/>
+        </a:xfrm>
+      </p:grpSpPr>
+      <p:sp>
+        <p:nvSpPr>
+          <p:cNvPr id="2" name="Slide Image Placeholder 1"/>
+          <p:cNvSpPr>
+            <a:spLocks noGrp="1"/>
+          </p:cNvSpPr>
+          <p:nvPr>
+            <p:ph type="sldImg" idx="2"/>
+          </p:nvPr>
+        </p:nvSpPr>
+        <p:spPr/>
+      </p:sp>
+      <p:sp>
+        <p:nvSpPr>
+          <p:cNvPr id="3" name="Notes Placeholder 2"/>
+          <p:cNvSpPr>
+            <a:spLocks noGrp="1"/>
+          </p:cNvSpPr>
+          <p:nvPr>
+            <p:ph type="body" idx="3" sz="quarter"/>
+          </p:nvPr>
+        </p:nvSpPr>
+        <p:spPr/>
+        <p:txBody>
+          <a:bodyPr/>
+          <a:lstStyle/>
+          <a:p>
+            <a:r>
+              <a:t>Definitions: guide repo README 0-130 = companion Muse Code guide sections. Provenance: bowl repo layout (docs/samples/scripts/skills) as built; day-one plan = docs/2027-prediction.md checklist. Transition: none, final line restates the talk thesis for Q&amp;A.</a:t>
+            </a:r>
+          </a:p>
+        </p:txBody>
+      </p:sp>
+      <p:sp>
+        <p:nvSpPr>
+          <p:cNvPr id="4" name="Slide Number Placeholder 3"/>
+          <p:cNvSpPr>
+            <a:spLocks noGrp="1"/>
+          </p:cNvSpPr>
+          <p:nvPr>
+            <p:ph type="sldNum" idx="5" sz="quarter"/>
+          </p:nvPr>
+        </p:nvSpPr>
+        <p:spPr/>
+      </p:sp>
+    </p:spTree>
+  </p:cSld>
+  <p:clrMapOvr>
+    <a:masterClrMapping/>
+  </p:clrMapOvr>
+</p:notes>
+</file>
+
+<file path=ppt/notesSlides/notesSlide2.xml><?xml version="1.0" encoding="utf-8"?>
+<p:notes xmlns:a="http://schemas.openxmlformats.org/drawingml/2006/main" xmlns:p="http://schemas.openxmlformats.org/presentationml/2006/main" xmlns:r="http://schemas.openxmlformats.org/officeDocument/2006/relationships">
+  <p:cSld>
+    <p:spTree>
+      <p:nvGrpSpPr>
+        <p:cNvPr id="1" name=""/>
+        <p:cNvGrpSpPr/>
+        <p:nvPr/>
+      </p:nvGrpSpPr>
+      <p:grpSpPr>
+        <a:xfrm>
+          <a:off x="0" y="0"/>
+          <a:ext cx="0" cy="0"/>
+          <a:chOff x="0" y="0"/>
+          <a:chExt cx="0" cy="0"/>
+        </a:xfrm>
+      </p:grpSpPr>
+      <p:sp>
+        <p:nvSpPr>
+          <p:cNvPr id="2" name="Slide Image Placeholder 1"/>
+          <p:cNvSpPr>
+            <a:spLocks noGrp="1"/>
+          </p:cNvSpPr>
+          <p:nvPr>
+            <p:ph type="sldImg" idx="2"/>
+          </p:nvPr>
+        </p:nvSpPr>
+        <p:spPr/>
+      </p:sp>
+      <p:sp>
+        <p:nvSpPr>
+          <p:cNvPr id="3" name="Notes Placeholder 2"/>
+          <p:cNvSpPr>
+            <a:spLocks noGrp="1"/>
+          </p:cNvSpPr>
+          <p:nvPr>
+            <p:ph type="body" idx="3" sz="quarter"/>
+          </p:nvPr>
+        </p:nvSpPr>
+        <p:spPr/>
+        <p:txBody>
+          <a:bodyPr/>
+          <a:lstStyle/>
+          <a:p>
+            <a:r>
+              <a:t>Definitions: NFL Football Operations runs the contest; TV = broadcast analytics, team analytics = club front offices. Provenance: contest shape docs/history.md + Big Data Bowl hub (references [30]); 8 editions 2019-2026 counted from history.md; 2027 unannounced as of Sep 27 2026 (docs/2027-prediction.md). Transition: why the scale slide next justifies entering.</a:t>
+            </a:r>
+          </a:p>
+        </p:txBody>
+      </p:sp>
+      <p:sp>
+        <p:nvSpPr>
+          <p:cNvPr id="4" name="Slide Number Placeholder 3"/>
+          <p:cNvSpPr>
+            <a:spLocks noGrp="1"/>
+          </p:cNvSpPr>
+          <p:nvPr>
+            <p:ph type="sldNum" idx="5" sz="quarter"/>
+          </p:nvPr>
+        </p:nvSpPr>
+        <p:spPr/>
+      </p:sp>
+    </p:spTree>
+  </p:cSld>
+  <p:clrMapOvr>
+    <a:masterClrMapping/>
+  </p:clrMapOvr>
+</p:notes>
+</file>
+
+<file path=ppt/notesSlides/notesSlide3.xml><?xml version="1.0" encoding="utf-8"?>
+<p:notes xmlns:a="http://schemas.openxmlformats.org/drawingml/2006/main" xmlns:p="http://schemas.openxmlformats.org/presentationml/2006/main" xmlns:r="http://schemas.openxmlformats.org/officeDocument/2006/relationships">
+  <p:cSld>
+    <p:spTree>
+      <p:nvGrpSpPr>
+        <p:cNvPr id="1" name=""/>
+        <p:cNvGrpSpPr/>
+        <p:nvPr/>
+      </p:nvGrpSpPr>
+      <p:grpSpPr>
+        <a:xfrm>
+          <a:off x="0" y="0"/>
+          <a:ext cx="0" cy="0"/>
+          <a:chOff x="0" y="0"/>
+          <a:chExt cx="0" cy="0"/>
+        </a:xfrm>
+      </p:grpSpPr>
+      <p:sp>
+        <p:nvSpPr>
+          <p:cNvPr id="2" name="Slide Image Placeholder 1"/>
+          <p:cNvSpPr>
+            <a:spLocks noGrp="1"/>
+          </p:cNvSpPr>
+          <p:nvPr>
+            <p:ph type="sldImg" idx="2"/>
+          </p:nvPr>
+        </p:nvSpPr>
+        <p:spPr/>
+      </p:sp>
+      <p:sp>
+        <p:nvSpPr>
+          <p:cNvPr id="3" name="Notes Placeholder 2"/>
+          <p:cNvSpPr>
+            <a:spLocks noGrp="1"/>
+          </p:cNvSpPr>
+          <p:nvPr>
+            <p:ph type="body" idx="3" sz="quarter"/>
+          </p:nvPr>
+        </p:nvSpPr>
+        <p:spPr/>
+        <p:txBody>
+          <a:bodyPr/>
+          <a:lstStyle/>
+          <a:p>
+            <a:r>
+              <a:t>Definitions: NFL Scouting Combine = the annual draft-prospect event where finalists present; ML = machine learning. Provenance: $100k pool ([17]), 8,329 registrations / 771 teams / 69 countries single-sourced provisional ([33]), 500M+ points/season ([52]), 75+ ML stats ([29]), 50+ hired with 30+ by teams/vendors (talk-notes + [51]) all per docs/history.md + docs/references.md. Transition: scale is only interesting because winners ship to broadcast.</a:t>
+            </a:r>
+          </a:p>
+        </p:txBody>
+      </p:sp>
+      <p:sp>
+        <p:nvSpPr>
+          <p:cNvPr id="4" name="Slide Number Placeholder 3"/>
+          <p:cNvSpPr>
+            <a:spLocks noGrp="1"/>
+          </p:cNvSpPr>
+          <p:nvPr>
+            <p:ph type="sldNum" idx="5" sz="quarter"/>
+          </p:nvPr>
+        </p:nvSpPr>
+        <p:spPr/>
+      </p:sp>
+    </p:spTree>
+  </p:cSld>
+  <p:clrMapOvr>
+    <a:masterClrMapping/>
+  </p:clrMapOvr>
+</p:notes>
+</file>
+
+<file path=ppt/notesSlides/notesSlide4.xml><?xml version="1.0" encoding="utf-8"?>
+<p:notes xmlns:a="http://schemas.openxmlformats.org/drawingml/2006/main" xmlns:p="http://schemas.openxmlformats.org/presentationml/2006/main" xmlns:r="http://schemas.openxmlformats.org/officeDocument/2006/relationships">
+  <p:cSld>
+    <p:spTree>
+      <p:nvGrpSpPr>
+        <p:cNvPr id="1" name=""/>
+        <p:cNvGrpSpPr/>
+        <p:nvPr/>
+      </p:nvGrpSpPr>
+      <p:grpSpPr>
+        <a:xfrm>
+          <a:off x="0" y="0"/>
+          <a:ext cx="0" cy="0"/>
+          <a:chOff x="0" y="0"/>
+          <a:chExt cx="0" cy="0"/>
+        </a:xfrm>
+      </p:grpSpPr>
+      <p:sp>
+        <p:nvSpPr>
+          <p:cNvPr id="2" name="Slide Image Placeholder 1"/>
+          <p:cNvSpPr>
+            <a:spLocks noGrp="1"/>
+          </p:cNvSpPr>
+          <p:nvPr>
+            <p:ph type="sldImg" idx="2"/>
+          </p:nvPr>
+        </p:nvSpPr>
+        <p:spPr/>
+      </p:sp>
+      <p:sp>
+        <p:nvSpPr>
+          <p:cNvPr id="3" name="Notes Placeholder 2"/>
+          <p:cNvSpPr>
+            <a:spLocks noGrp="1"/>
+          </p:cNvSpPr>
+          <p:nvPr>
+            <p:ph type="body" idx="3" sz="quarter"/>
+          </p:nvPr>
+        </p:nvSpPr>
+        <p:spPr/>
+        <p:txBody>
+          <a:bodyPr/>
+          <a:lstStyle/>
+          <a:p>
+            <a:r>
+              <a:t>Definitions: the Zoo = 2020 winning team nickname; RYOE defined on slide; pressure probability and tackle probability are deployed Next Gen Stats. Provenance: winners.md + history.md; Zoo-to-TV ~6 months (winners.md); pressure = 4 models over 90k plays ([27][42]); tackle = 20 features x 11 defenders ([28][50]). Transition: that pipeline runs on the tracking feed, which the next slide specs.</a:t>
+            </a:r>
+          </a:p>
+        </p:txBody>
+      </p:sp>
+      <p:sp>
+        <p:nvSpPr>
+          <p:cNvPr id="4" name="Slide Number Placeholder 3"/>
+          <p:cNvSpPr>
+            <a:spLocks noGrp="1"/>
+          </p:cNvSpPr>
+          <p:nvPr>
+            <p:ph type="sldNum" idx="5" sz="quarter"/>
+          </p:nvPr>
+        </p:nvSpPr>
+        <p:spPr/>
+      </p:sp>
+    </p:spTree>
+  </p:cSld>
+  <p:clrMapOvr>
+    <a:masterClrMapping/>
+  </p:clrMapOvr>
+</p:notes>
+</file>
+
+<file path=ppt/notesSlides/notesSlide5.xml><?xml version="1.0" encoding="utf-8"?>
+<p:notes xmlns:a="http://schemas.openxmlformats.org/drawingml/2006/main" xmlns:p="http://schemas.openxmlformats.org/presentationml/2006/main" xmlns:r="http://schemas.openxmlformats.org/officeDocument/2006/relationships">
+  <p:cSld>
+    <p:spTree>
+      <p:nvGrpSpPr>
+        <p:cNvPr id="1" name=""/>
+        <p:cNvGrpSpPr/>
+        <p:nvPr/>
+      </p:nvGrpSpPr>
+      <p:grpSpPr>
+        <a:xfrm>
+          <a:off x="0" y="0"/>
+          <a:ext cx="0" cy="0"/>
+          <a:chOff x="0" y="0"/>
+          <a:chExt cx="0" cy="0"/>
+        </a:xfrm>
+      </p:grpSpPr>
+      <p:sp>
+        <p:nvSpPr>
+          <p:cNvPr id="2" name="Slide Image Placeholder 1"/>
+          <p:cNvSpPr>
+            <a:spLocks noGrp="1"/>
+          </p:cNvSpPr>
+          <p:nvPr>
+            <p:ph type="sldImg" idx="2"/>
+          </p:nvPr>
+        </p:nvSpPr>
+        <p:spPr/>
+      </p:sp>
+      <p:sp>
+        <p:nvSpPr>
+          <p:cNvPr id="3" name="Notes Placeholder 2"/>
+          <p:cNvSpPr>
+            <a:spLocks noGrp="1"/>
+          </p:cNvSpPr>
+          <p:nvPr>
+            <p:ph type="body" idx="3" sz="quarter"/>
+          </p:nvPr>
+        </p:nvSpPr>
+        <p:spPr/>
+        <p:txBody>
+          <a:bodyPr/>
+          <a:lstStyle/>
+          <a:p>
+            <a:r>
+              <a:t>Definitions: RFID tags in shoulder pads + ball, Zebra hardware tracks players, Wilson makes the sensor ball; x/y = field coords, s = speed, a = acceleration, dis = distance, o = orientation, dir = direction; nflverse = community R/Python data package. Provenance: docs/data-guide.md field spec ([46]); 1.5 GB/week ([59]); seeded 1.6 GB 2024 / 7.7 GB 2025 (docs/muse-code.md, [58][25]); 25-play samples cut by scripts/make_samples.py. Transition: with data this big, workflow 1 says start small.</a:t>
+            </a:r>
+          </a:p>
+        </p:txBody>
+      </p:sp>
+      <p:sp>
+        <p:nvSpPr>
+          <p:cNvPr id="4" name="Slide Number Placeholder 3"/>
+          <p:cNvSpPr>
+            <a:spLocks noGrp="1"/>
+          </p:cNvSpPr>
+          <p:nvPr>
+            <p:ph type="sldNum" idx="5" sz="quarter"/>
+          </p:nvPr>
+        </p:nvSpPr>
+        <p:spPr/>
+      </p:sp>
+    </p:spTree>
+  </p:cSld>
+  <p:clrMapOvr>
+    <a:masterClrMapping/>
+  </p:clrMapOvr>
+</p:notes>
+</file>
+
+<file path=ppt/notesSlides/notesSlide6.xml><?xml version="1.0" encoding="utf-8"?>
+<p:notes xmlns:a="http://schemas.openxmlformats.org/drawingml/2006/main" xmlns:p="http://schemas.openxmlformats.org/presentationml/2006/main" xmlns:r="http://schemas.openxmlformats.org/officeDocument/2006/relationships">
+  <p:cSld>
+    <p:spTree>
+      <p:nvGrpSpPr>
+        <p:cNvPr id="1" name=""/>
+        <p:cNvGrpSpPr/>
+        <p:nvPr/>
+      </p:nvGrpSpPr>
+      <p:grpSpPr>
+        <a:xfrm>
+          <a:off x="0" y="0"/>
+          <a:ext cx="0" cy="0"/>
+          <a:chOff x="0" y="0"/>
+          <a:chExt cx="0" cy="0"/>
+        </a:xfrm>
+      </p:grpSpPr>
+      <p:sp>
+        <p:nvSpPr>
+          <p:cNvPr id="2" name="Slide Image Placeholder 1"/>
+          <p:cNvSpPr>
+            <a:spLocks noGrp="1"/>
+          </p:cNvSpPr>
+          <p:nvPr>
+            <p:ph type="sldImg" idx="2"/>
+          </p:nvPr>
+        </p:nvSpPr>
+        <p:spPr/>
+      </p:sp>
+      <p:sp>
+        <p:nvSpPr>
+          <p:cNvPr id="3" name="Notes Placeholder 2"/>
+          <p:cNvSpPr>
+            <a:spLocks noGrp="1"/>
+          </p:cNvSpPr>
+          <p:nvPr>
+            <p:ph type="body" idx="3" sz="quarter"/>
+          </p:nvPr>
+        </p:nvSpPr>
+        <p:spPr/>
+        <p:txBody>
+          <a:bodyPr/>
+          <a:lstStyle/>
+          <a:p>
+            <a:r>
+              <a:t>Definitions: muse exec = headless one-shot CLI run; 22 dots + ball = 11 offensive + 11 defensive players. Provenance: scripts/explore_sample.py; frame counts verified in-repo just now: 19,113 (2024) / 92,069 (2025) rows, 25 plays each. Transition: once the sample query reads right, workflow 2 scales it to full weeks.</a:t>
+            </a:r>
+          </a:p>
+        </p:txBody>
+      </p:sp>
+      <p:sp>
+        <p:nvSpPr>
+          <p:cNvPr id="4" name="Slide Number Placeholder 3"/>
+          <p:cNvSpPr>
+            <a:spLocks noGrp="1"/>
+          </p:cNvSpPr>
+          <p:nvPr>
+            <p:ph type="sldNum" idx="5" sz="quarter"/>
+          </p:nvPr>
+        </p:nvSpPr>
+        <p:spPr/>
+      </p:sp>
+    </p:spTree>
+  </p:cSld>
+  <p:clrMapOvr>
+    <a:masterClrMapping/>
+  </p:clrMapOvr>
+</p:notes>
+</file>
+
+<file path=ppt/notesSlides/notesSlide7.xml><?xml version="1.0" encoding="utf-8"?>
+<p:notes xmlns:a="http://schemas.openxmlformats.org/drawingml/2006/main" xmlns:p="http://schemas.openxmlformats.org/presentationml/2006/main" xmlns:r="http://schemas.openxmlformats.org/officeDocument/2006/relationships">
+  <p:cSld>
+    <p:spTree>
+      <p:nvGrpSpPr>
+        <p:cNvPr id="1" name=""/>
+        <p:cNvGrpSpPr/>
+        <p:nvPr/>
+      </p:nvGrpSpPr>
+      <p:grpSpPr>
+        <a:xfrm>
+          <a:off x="0" y="0"/>
+          <a:ext cx="0" cy="0"/>
+          <a:chOff x="0" y="0"/>
+          <a:chExt cx="0" cy="0"/>
+        </a:xfrm>
+      </p:grpSpPr>
+      <p:sp>
+        <p:nvSpPr>
+          <p:cNvPr id="2" name="Slide Image Placeholder 1"/>
+          <p:cNvSpPr>
+            <a:spLocks noGrp="1"/>
+          </p:cNvSpPr>
+          <p:nvPr>
+            <p:ph type="sldImg" idx="2"/>
+          </p:nvPr>
+        </p:nvSpPr>
+        <p:spPr/>
+      </p:sp>
+      <p:sp>
+        <p:nvSpPr>
+          <p:cNvPr id="3" name="Notes Placeholder 2"/>
+          <p:cNvSpPr>
+            <a:spLocks noGrp="1"/>
+          </p:cNvSpPr>
+          <p:nvPr>
+            <p:ph type="body" idx="3" sz="quarter"/>
+          </p:nvPr>
+        </p:nvSpPr>
+        <p:spPr/>
+        <p:txBody>
+          <a:bodyPr/>
+          <a:lstStyle/>
+          <a:p>
+            <a:r>
+              <a:t>Definitions: parquet = columnar file format far faster than CSV for repeated reads; chunksize/scan+sink = chunked out-of-core reads; scratch/ = rebuildable intermediates dir. Provenance: scripts/weeks_to_parquet.py; ~2 GB/week budget ([58][59]); raw read-only rule docs/muse-code.md. Transition: stored efficiently, now build features frame-up.</a:t>
+            </a:r>
+          </a:p>
+        </p:txBody>
+      </p:sp>
+      <p:sp>
+        <p:nvSpPr>
+          <p:cNvPr id="4" name="Slide Number Placeholder 3"/>
+          <p:cNvSpPr>
+            <a:spLocks noGrp="1"/>
+          </p:cNvSpPr>
+          <p:nvPr>
+            <p:ph type="sldNum" idx="5" sz="quarter"/>
+          </p:nvPr>
+        </p:nvSpPr>
+        <p:spPr/>
+      </p:sp>
+    </p:spTree>
+  </p:cSld>
+  <p:clrMapOvr>
+    <a:masterClrMapping/>
+  </p:clrMapOvr>
+</p:notes>
+</file>
+
+<file path=ppt/notesSlides/notesSlide8.xml><?xml version="1.0" encoding="utf-8"?>
+<p:notes xmlns:a="http://schemas.openxmlformats.org/drawingml/2006/main" xmlns:p="http://schemas.openxmlformats.org/presentationml/2006/main" xmlns:r="http://schemas.openxmlformats.org/officeDocument/2006/relationships">
+  <p:cSld>
+    <p:spTree>
+      <p:nvGrpSpPr>
+        <p:cNvPr id="1" name=""/>
+        <p:cNvGrpSpPr/>
+        <p:nvPr/>
+      </p:nvGrpSpPr>
+      <p:grpSpPr>
+        <a:xfrm>
+          <a:off x="0" y="0"/>
+          <a:ext cx="0" cy="0"/>
+          <a:chOff x="0" y="0"/>
+          <a:chExt cx="0" cy="0"/>
+        </a:xfrm>
+      </p:grpSpPr>
+      <p:sp>
+        <p:nvSpPr>
+          <p:cNvPr id="2" name="Slide Image Placeholder 1"/>
+          <p:cNvSpPr>
+            <a:spLocks noGrp="1"/>
+          </p:cNvSpPr>
+          <p:nvPr>
+            <p:ph type="sldImg" idx="2"/>
+          </p:nvPr>
+        </p:nvSpPr>
+        <p:spPr/>
+      </p:sp>
+      <p:sp>
+        <p:nvSpPr>
+          <p:cNvPr id="3" name="Notes Placeholder 2"/>
+          <p:cNvSpPr>
+            <a:spLocks noGrp="1"/>
+          </p:cNvSpPr>
+          <p:nvPr>
+            <p:ph type="body" idx="3" sz="quarter"/>
+          </p:nvPr>
+        </p:nvSpPr>
+        <p:spPr/>
+        <p:txBody>
+          <a:bodyPr/>
+          <a:lstStyle/>
+          <a:p>
+            <a:r>
+              <a:t>Definitions: convnets = convolutional neural networks applied frame-by-frame; LightGBM/XGBoost = gradient-boosted tree libraries; formation encodings = numeric offense/defense alignment features. Provenance: docs/muse-code.md pattern list ([60][62][63]); scripts/features_frame_up.py. Transition: features need a baseline before any ensemble.</a:t>
+            </a:r>
+          </a:p>
+        </p:txBody>
+      </p:sp>
+      <p:sp>
+        <p:nvSpPr>
+          <p:cNvPr id="4" name="Slide Number Placeholder 3"/>
+          <p:cNvSpPr>
+            <a:spLocks noGrp="1"/>
+          </p:cNvSpPr>
+          <p:nvPr>
+            <p:ph type="sldNum" idx="5" sz="quarter"/>
+          </p:nvPr>
+        </p:nvSpPr>
+        <p:spPr/>
+      </p:sp>
+    </p:spTree>
+  </p:cSld>
+  <p:clrMapOvr>
+    <a:masterClrMapping/>
+  </p:clrMapOvr>
+</p:notes>
+</file>
+
+<file path=ppt/notesSlides/notesSlide9.xml><?xml version="1.0" encoding="utf-8"?>
+<p:notes xmlns:a="http://schemas.openxmlformats.org/drawingml/2006/main" xmlns:p="http://schemas.openxmlformats.org/presentationml/2006/main" xmlns:r="http://schemas.openxmlformats.org/officeDocument/2006/relationships">
+  <p:cSld>
+    <p:spTree>
+      <p:nvGrpSpPr>
+        <p:cNvPr id="1" name=""/>
+        <p:cNvGrpSpPr/>
+        <p:nvPr/>
+      </p:nvGrpSpPr>
+      <p:grpSpPr>
+        <a:xfrm>
+          <a:off x="0" y="0"/>
+          <a:ext cx="0" cy="0"/>
+          <a:chOff x="0" y="0"/>
+          <a:chExt cx="0" cy="0"/>
+        </a:xfrm>
+      </p:grpSpPr>
+      <p:sp>
+        <p:nvSpPr>
+          <p:cNvPr id="2" name="Slide Image Placeholder 1"/>
+          <p:cNvSpPr>
+            <a:spLocks noGrp="1"/>
+          </p:cNvSpPr>
+          <p:nvPr>
+            <p:ph type="sldImg" idx="2"/>
+          </p:nvPr>
+        </p:nvSpPr>
+        <p:spPr/>
+      </p:sp>
+      <p:sp>
+        <p:nvSpPr>
+          <p:cNvPr id="3" name="Notes Placeholder 2"/>
+          <p:cNvSpPr>
+            <a:spLocks noGrp="1"/>
+          </p:cNvSpPr>
+          <p:nvPr>
+            <p:ph type="body" idx="3" sz="quarter"/>
+          </p:nvPr>
+        </p:nvSpPr>
+        <p:spPr/>
+        <p:txBody>
+          <a:bodyPr/>
+          <a:lstStyle/>
+          <a:p>
+            <a:r>
+              <a:t>Definitions: lasso-logistic = L1-regularized logistic regression; base rates = naive benchmark frequencies; group-by-play folds = cross-validation folds that keep all frames of a play together to prevent leakage; Optuna = hyperparameter tuner; Yurko = cited methods reference for base-rate/baseline/CV+SE discipline. Provenance: scripts/baseline_lasso.py; ensemble pattern [61]. Transition: baselines run at scale via batch + sandbox.</a:t>
+            </a:r>
+          </a:p>
+        </p:txBody>
+      </p:sp>
+      <p:sp>
+        <p:nvSpPr>
+          <p:cNvPr id="4" name="Slide Number Placeholder 3"/>
+          <p:cNvSpPr>
+            <a:spLocks noGrp="1"/>
+          </p:cNvSpPr>
+          <p:nvPr>
+            <p:ph type="sldNum" idx="5" sz="quarter"/>
+          </p:nvPr>
+        </p:nvSpPr>
+        <p:spPr/>
+      </p:sp>
+    </p:spTree>
+  </p:cSld>
+  <p:clrMapOvr>
+    <a:masterClrMapping/>
+  </p:clrMapOvr>
+</p:notes>
 </file>
 
 <file path=ppt/slideLayouts/slideLayout1.xml><?xml version="1.0" encoding="utf-8"?>
@@ -3317,7 +4857,7 @@
                 </a:solidFill>
                 <a:latin typeface="Calibri"/>
               </a:rPr>
-              <a:t>nfl next gen stats, worked live in the cli</a:t>
+              <a:t>National Football League (NFL) Next Gen Stats, worked live in the CLI</a:t>
             </a:r>
           </a:p>
         </p:txBody>
@@ -3553,7 +5093,7 @@
                 </a:solidFill>
                 <a:latin typeface="Calibri"/>
               </a:rPr>
-              <a:t>sweep_weeks.sh: one exec prompt per question, csv + png each</a:t>
+              <a:t>sweep_weeks.sh: one exec prompt per question, CSV + PNG each</a:t>
             </a:r>
           </a:p>
           <a:p>
@@ -3585,7 +5125,7 @@
                 </a:solidFill>
                 <a:latin typeface="Calibri"/>
               </a:rPr>
-              <a:t>free local glimmer review, kaggle ~30 gpu-hrs/wk for keepers</a:t>
+              <a:t>free local Glimmer review, Kaggle ~30 GPU-hours/week free tier for keepers</a:t>
             </a:r>
           </a:p>
         </p:txBody>
@@ -3805,7 +5345,7 @@
                 </a:solidFill>
                 <a:latin typeface="Calibri"/>
               </a:rPr>
-              <a:t>rubric 30 / 30 / 20 / 20  |  tracking data must matter, not decorate</a:t>
+              <a:t>rubric 30 / 30 / 20 / 20 (football / data science / report / visuals)  |  tracking data must matter, not decorate</a:t>
             </a:r>
           </a:p>
           <a:p>
@@ -3821,7 +5361,7 @@
                 </a:solidFill>
                 <a:latin typeface="Calibri"/>
               </a:rPr>
-              <a:t>patton: answer the prompt, graders work nights, look expensive</a:t>
+              <a:t>Patton: answer the prompt, graders work nights, look expensive</a:t>
             </a:r>
           </a:p>
           <a:p>
@@ -3837,7 +5377,7 @@
                 </a:solidFill>
                 <a:latin typeface="Calibri"/>
               </a:rPr>
-              <a:t>state limits, proofread, conclude  |  formats: 2000 words, &lt;10 figs</a:t>
+              <a:t>state limits, proofread, conclude  |  formats: 2000 words, &lt;10 figures</a:t>
             </a:r>
           </a:p>
           <a:p>
@@ -3853,7 +5393,7 @@
                 </a:solidFill>
                 <a:latin typeface="Calibri"/>
               </a:rPr>
-              <a:t>yurko: base rates, simple baseline, cv + se, downstream use over fit</a:t>
+              <a:t>Yurko: base rates, simple baseline, CV (cross-validation) + SE (standard errors), downstream use over fit</a:t>
             </a:r>
           </a:p>
         </p:txBody>
@@ -4073,7 +5613,7 @@
                 </a:solidFill>
                 <a:latin typeface="Calibri"/>
               </a:rPr>
-              <a:t>cadence: 2026 opened sep 25  |  announcement could be any day</a:t>
+              <a:t>cadence: 2026 opened Sep 25, 2025  |  announcement could be any day</a:t>
             </a:r>
           </a:p>
           <a:p>
@@ -4341,7 +5881,7 @@
                 </a:solidFill>
                 <a:latin typeface="Calibri"/>
               </a:rPr>
-              <a:t>open weights 30B, apache-2.0, distilled from spark 1.2</a:t>
+              <a:t>open weights, 30-billion-parameter (30B), Apache-2.0, distilled from Muse Spark 1.2</a:t>
             </a:r>
           </a:p>
           <a:p>
@@ -4357,7 +5897,7 @@
                 </a:solidFill>
                 <a:latin typeface="Calibri"/>
               </a:rPr>
-              <a:t>http://127.0.0.1:8181/v1 + /healthz (stable), cold ~8s, idle 300s</a:t>
+              <a:t>http://127.0.0.1:8181/v1 + /healthz (stable), supervisor cold-start ~8 s, idle teardown 300 s</a:t>
             </a:r>
           </a:p>
           <a:p>
@@ -4373,7 +5913,7 @@
                 </a:solidFill>
                 <a:latin typeface="Calibri"/>
               </a:rPr>
-              <a:t>-ngl 13 -c 4096 Q4_K_M  |  gpu_lock: 503 held, 200 after release</a:t>
+              <a:t>-ngl 13 (13 layers on GPU) -c 4096, Q4_K_M (4-bit)  |  gpu_lock: HTTP 503 while held, 200 after release</a:t>
             </a:r>
           </a:p>
           <a:p>
@@ -4389,7 +5929,7 @@
                 </a:solidFill>
                 <a:latin typeface="Calibri"/>
               </a:rPr>
-              <a:t>streaming 200, 15 chunks in 73.5s  |  review (397 tok): 245s, reasons aloud</a:t>
+              <a:t>streaming HTTP 200, 15 chunks in 73.5 s  |  review (397 prompt tokens): 245 s wall, verbose reasoning</a:t>
             </a:r>
           </a:p>
         </p:txBody>
@@ -4609,7 +6149,7 @@
                 </a:solidFill>
                 <a:latin typeface="Calibri"/>
               </a:rPr>
-              <a:t>NGL0 cpu-only  |  wall 41.7s warm  |  prompt 5.7 tok/s  |  gen 0.46 tok/s  |  +~0 gpu</a:t>
+              <a:t>NGL 0 (0 layers on GPU, CPU-only)  |  wall 41.7 s warm  |  prompt 5.7 tokens/s  |  gen 0.46 tokens/s  |  +~0 GPU</a:t>
             </a:r>
           </a:p>
           <a:p>
@@ -4625,7 +6165,7 @@
                 </a:solidFill>
                 <a:latin typeface="Calibri"/>
               </a:rPr>
-              <a:t>NGL13 text-only  |  wall 186.7s  |  prompt 1.75 tok/s  |  gen 0.17 tok/s  |  11.62gb</a:t>
+              <a:t>NGL 13 (13 layers on GPU, text-only)  |  wall 186.7 s  |  prompt 1.75 tokens/s  |  gen 0.17 tokens/s  |  11.62 GB</a:t>
             </a:r>
           </a:p>
           <a:p>
@@ -4641,7 +6181,7 @@
                 </a:solidFill>
                 <a:latin typeface="Calibri"/>
               </a:rPr>
-              <a:t>verdict: 13 layers buy nothing at gen (bandwidth-bound); prompt slower than cpu</a:t>
+              <a:t>verdict: 13 GPU layers buy nothing at gen (bandwidth-bound); prompt 1.75 slower than CPU-only 5.7 tokens/s</a:t>
             </a:r>
           </a:p>
           <a:p>
@@ -4657,7 +6197,7 @@
                 </a:solidFill>
                 <a:latin typeface="Calibri"/>
               </a:rPr>
-              <a:t>spark vs glimmer: 2m13s via subscription vs 186.7s local ngl13</a:t>
+              <a:t>Muse Spark (hosted) vs Glimmer (local): 2 m 13 s via subscription vs 186.7 s local NGL 13</a:t>
             </a:r>
           </a:p>
           <a:p>
@@ -4673,25 +6213,7 @@
                 </a:solidFill>
                 <a:latin typeface="Calibri"/>
               </a:rPr>
-              <a:t>vision </a:t>
-            </a:r>
-            <a:r>
-              <a:rPr sz="1800">
-                <a:solidFill>
-                  <a:srgbClr val="9060F0"/>
-                </a:solidFill>
-                <a:latin typeface="Calibri"/>
-              </a:rPr>
-              <a:t>(final): </a:t>
-            </a:r>
-            <a:r>
-              <a:rPr sz="1800">
-                <a:solidFill>
-                  <a:srgbClr val="F0F0F0"/>
-                </a:solidFill>
-                <a:latin typeface="Calibri"/>
-              </a:rPr>
-              <a:t>mmproj bf16 loads ok at 11.09gb; cpu embedding too slow for production use</a:t>
+              <a:t>vision (final): HTTP 200 in 135.8 s on 6.5 KB thumbnail; mmproj (multimodal projector) bf16 at 11.09 GB; CPU embedding too slow for production</a:t>
             </a:r>
           </a:p>
         </p:txBody>
@@ -4911,7 +6433,7 @@
                 </a:solidFill>
                 <a:latin typeface="Calibri"/>
               </a:rPr>
-              <a:t>1 muse init memory  |  2 tui pair / exec batch</a:t>
+              <a:t>1 muse init memory  |  2 TUI (terminal UI) pair / exec batch</a:t>
             </a:r>
           </a:p>
           <a:p>
@@ -5179,7 +6701,7 @@
                 </a:solidFill>
                 <a:latin typeface="Calibri"/>
               </a:rPr>
-              <a:t>6 mcp readonly-first  |  7 sandbox + approve deliberately</a:t>
+              <a:t>6 MCP (Model Context Protocol) read-only first  |  7 sandbox + approve deliberately</a:t>
             </a:r>
           </a:p>
           <a:p>
@@ -5211,7 +6733,7 @@
                 </a:solidFill>
                 <a:latin typeface="Calibri"/>
               </a:rPr>
-              <a:t>10 spark api without the tui, hosted + local glimmer :8181</a:t>
+              <a:t>10 Spark API without the TUI, hosted + local Glimmer :8181</a:t>
             </a:r>
           </a:p>
           <a:p>
@@ -5227,7 +6749,7 @@
                 </a:solidFill>
                 <a:latin typeface="Calibri"/>
               </a:rPr>
-              <a:t>spend limits day one  |  gpu_lock for gpu work</a:t>
+              <a:t>spend limits day one  |  gpu_lock for GPU work</a:t>
             </a:r>
           </a:p>
         </p:txBody>
@@ -5699,7 +7221,7 @@
                 </a:solidFill>
                 <a:latin typeface="Calibri"/>
               </a:rPr>
-              <a:t>annual contest, nfl football operations + aws</a:t>
+              <a:t>annual contest, NFL Football Operations + AWS (Amazon Web Services)</a:t>
             </a:r>
           </a:p>
           <a:p>
@@ -5715,7 +7237,7 @@
                 </a:solidFill>
                 <a:latin typeface="Calibri"/>
               </a:rPr>
-              <a:t>real next gen stats tracking data, 10 frames/sec</a:t>
+              <a:t>real Next Gen Stats tracking data, 10 frames/second</a:t>
             </a:r>
           </a:p>
           <a:p>
@@ -5731,7 +7253,7 @@
                 </a:solidFill>
                 <a:latin typeface="Calibri"/>
               </a:rPr>
-              <a:t>goal: invent stats good enough for tv + team analytics</a:t>
+              <a:t>goal: invent stats good enough for TV + team analytics</a:t>
             </a:r>
           </a:p>
           <a:p>
@@ -5967,7 +7489,7 @@
                 </a:solidFill>
                 <a:latin typeface="Calibri"/>
               </a:rPr>
-              <a:t>$100k prize pool  |  finalists present at the combine</a:t>
+              <a:t>$100k prize pool  |  finalists present at the NFL Scouting Combine</a:t>
             </a:r>
           </a:p>
           <a:p>
@@ -5983,7 +7505,7 @@
                 </a:solidFill>
                 <a:latin typeface="Calibri"/>
               </a:rPr>
-              <a:t>2026: 8,329 registrations, 771 teams, 69 countries (provisional)</a:t>
+              <a:t>2026: 8,329 registrations, 771 teams, 69 countries (provisional, single-sourced)</a:t>
             </a:r>
           </a:p>
           <a:p>
@@ -5999,7 +7521,7 @@
                 </a:solidFill>
                 <a:latin typeface="Calibri"/>
               </a:rPr>
-              <a:t>aws processes 500m+ tracking points a season</a:t>
+              <a:t>AWS processes 500M+ tracking points a season</a:t>
             </a:r>
           </a:p>
           <a:p>
@@ -6015,7 +7537,7 @@
                 </a:solidFill>
                 <a:latin typeface="Calibri"/>
               </a:rPr>
-              <a:t>75+ ml stats in pipeline  |  50+ entrants hired (30+ by teams/vendors)</a:t>
+              <a:t>75+ machine-learning (ML) stats in pipeline  |  50+ entrants hired (30+ by teams/vendors)</a:t>
             </a:r>
           </a:p>
         </p:txBody>
@@ -6235,7 +7757,7 @@
                 </a:solidFill>
                 <a:latin typeface="Calibri"/>
               </a:rPr>
-              <a:t>2020 the zoo wins -&gt; expected rushing yards on tv in ~6 months</a:t>
+              <a:t>2020 the Zoo wins -&gt; expected rushing yards on TV in ~6 months</a:t>
             </a:r>
           </a:p>
           <a:p>
@@ -6251,7 +7773,7 @@
                 </a:solidFill>
                 <a:latin typeface="Calibri"/>
               </a:rPr>
-              <a:t>ryoe, 1st-down + td probability follow the same pipe</a:t>
+              <a:t>RYOE (rushing yards over expected), 1st-down + touchdown (TD) probability follow the same pipe</a:t>
             </a:r>
           </a:p>
           <a:p>
@@ -6283,7 +7805,7 @@
                 </a:solidFill>
                 <a:latin typeface="Calibri"/>
               </a:rPr>
-              <a:t>2024 missed tackles -&gt; tackle probability (20 feats x 11 defenders)</a:t>
+              <a:t>2024 missed tackles -&gt; tackle probability (20 features x 11 defenders)</a:t>
             </a:r>
           </a:p>
         </p:txBody>
@@ -6503,7 +8025,7 @@
                 </a:solidFill>
                 <a:latin typeface="Calibri"/>
               </a:rPr>
-              <a:t>rfid tags, zebra + wilson hardware  |  every player + ball</a:t>
+              <a:t>RFID (radio-frequency identification) tags, Zebra + Wilson hardware  |  every player + ball</a:t>
             </a:r>
           </a:p>
           <a:p>
@@ -6551,7 +8073,7 @@
                 </a:solidFill>
                 <a:latin typeface="Calibri"/>
               </a:rPr>
-              <a:t>weekly csvs ~1.5gb  |  seeded 2024 1.6gb + 2025 7.7gb  |  samples: 25 plays</a:t>
+              <a:t>weekly CSVs ~1.5 GB  |  seeded 2024 1.6 GB + 2025 7.7 GB  |  samples: 25 plays</a:t>
             </a:r>
           </a:p>
         </p:txBody>
@@ -7039,7 +8561,7 @@
                 </a:solidFill>
                 <a:latin typeface="Calibri"/>
               </a:rPr>
-              <a:t>weekly csvs too big for memory: pandas chunksize / polars scan+sink</a:t>
+              <a:t>weekly CSVs too big for memory: pandas chunksize / polars scan+sink</a:t>
             </a:r>
           </a:p>
           <a:p>
@@ -7071,7 +8593,7 @@
                 </a:solidFill>
                 <a:latin typeface="Calibri"/>
               </a:rPr>
-              <a:t>rebuild script first, raw csvs read-only, intermediates in scratch/</a:t>
+              <a:t>rebuild script first, raw CSVs read-only, intermediates in scratch/</a:t>
             </a:r>
           </a:p>
           <a:p>
@@ -7087,7 +8609,7 @@
                 </a:solidFill>
                 <a:latin typeface="Calibri"/>
               </a:rPr>
-              <a:t>budget ~2gb per week uncompressed  |  scripts/weeks_to_parquet.py</a:t>
+              <a:t>budget ~2 GB per week uncompressed  |  scripts/weeks_to_parquet.py</a:t>
             </a:r>
           </a:p>
         </p:txBody>
@@ -7339,7 +8861,7 @@
                 </a:solidFill>
                 <a:latin typeface="Calibri"/>
               </a:rPr>
-              <a:t>frame-by-frame convnets for tackle probability</a:t>
+              <a:t>frame-by-frame convolutional networks (convnets) for tackle probability</a:t>
             </a:r>
           </a:p>
           <a:p>
@@ -7355,7 +8877,7 @@
                 </a:solidFill>
                 <a:latin typeface="Calibri"/>
               </a:rPr>
-              <a:t>lightgbm picked over xgboost for speed + memory</a:t>
+              <a:t>LightGBM picked over XGBoost for speed + memory</a:t>
             </a:r>
           </a:p>
         </p:txBody>
@@ -7575,7 +9097,7 @@
                 </a:solidFill>
                 <a:latin typeface="Calibri"/>
               </a:rPr>
-              <a:t>lasso-logistic with base rates + cross-validated accuracy w/ errors</a:t>
+              <a:t>lasso-logistic baseline with base rates + cross-validated accuracy w/ errors</a:t>
             </a:r>
           </a:p>
           <a:p>
@@ -7591,7 +9113,7 @@
                 </a:solidFill>
                 <a:latin typeface="Calibri"/>
               </a:rPr>
-              <a:t>group-by-play folds  |  xgboost / lightgbm / catboost + optuna</a:t>
+              <a:t>group-by-play folds  |  XGBoost / LightGBM / CatBoost + Optuna</a:t>
             </a:r>
           </a:p>
           <a:p>
@@ -7623,7 +9145,7 @@
                 </a:solidFill>
                 <a:latin typeface="Calibri"/>
               </a:rPr>
-              <a:t>scripts/baseline_lasso.py  |  yurko discipline wired in</a:t>
+              <a:t>scripts/baseline_lasso.py  |  Yurko discipline wired in</a:t>
             </a:r>
           </a:p>
         </p:txBody>
@@ -7954,4 +9476,324 @@
   </a:objectDefaults>
   <a:extraClrSchemeLst/>
 </a:theme>
+</file>
+
+<file path=ppt/theme/theme2.xml><?xml version="1.0" encoding="utf-8"?>
+<a:theme xmlns:a="http://schemas.openxmlformats.org/drawingml/2006/main" name="Office Theme">
+  <a:themeElements>
+    <a:clrScheme name="Office">
+      <a:dk1>
+        <a:sysClr val="windowText" lastClr="000000"/>
+      </a:dk1>
+      <a:lt1>
+        <a:sysClr val="window" lastClr="FFFFFF"/>
+      </a:lt1>
+      <a:dk2>
+        <a:srgbClr val="1F497D"/>
+      </a:dk2>
+      <a:lt2>
+        <a:srgbClr val="EEECE1"/>
+      </a:lt2>
+      <a:accent1>
+        <a:srgbClr val="4F81BD"/>
+      </a:accent1>
+      <a:accent2>
+        <a:srgbClr val="C0504D"/>
+      </a:accent2>
+      <a:accent3>
+        <a:srgbClr val="9BBB59"/>
+      </a:accent3>
+      <a:accent4>
+        <a:srgbClr val="8064A2"/>
+      </a:accent4>
+      <a:accent5>
+        <a:srgbClr val="4BACC6"/>
+      </a:accent5>
+      <a:accent6>
+        <a:srgbClr val="F79646"/>
+      </a:accent6>
+      <a:hlink>
+        <a:srgbClr val="0000FF"/>
+      </a:hlink>
+      <a:folHlink>
+        <a:srgbClr val="800080"/>
+      </a:folHlink>
+    </a:clrScheme>
+    <a:fontScheme name="Office">
+      <a:majorFont>
+        <a:latin typeface="Calibri"/>
+        <a:ea typeface=""/>
+        <a:cs typeface=""/>
+        <a:font script="Jpan" typeface="ＭＳ Ｐゴシック"/>
+        <a:font script="Hang" typeface="맑은 고딕"/>
+        <a:font script="Hans" typeface="宋体"/>
+        <a:font script="Hant" typeface="新細明體"/>
+        <a:font script="Arab" typeface="Times New Roman"/>
+        <a:font script="Hebr" typeface="Times New Roman"/>
+        <a:font script="Thai" typeface="Angsana New"/>
+        <a:font script="Ethi" typeface="Nyala"/>
+        <a:font script="Beng" typeface="Vrinda"/>
+        <a:font script="Gujr" typeface="Shruti"/>
+        <a:font script="Khmr" typeface="MoolBoran"/>
+        <a:font script="Knda" typeface="Tunga"/>
+        <a:font script="Guru" typeface="Raavi"/>
+        <a:font script="Cans" typeface="Euphemia"/>
+        <a:font script="Cher" typeface="Plantagenet Cherokee"/>
+        <a:font script="Yiii" typeface="Microsoft Yi Baiti"/>
+        <a:font script="Tibt" typeface="Microsoft Himalaya"/>
+        <a:font script="Thaa" typeface="MV Boli"/>
+        <a:font script="Deva" typeface="Mangal"/>
+        <a:font script="Telu" typeface="Gautami"/>
+        <a:font script="Taml" typeface="Latha"/>
+        <a:font script="Syrc" typeface="Estrangelo Edessa"/>
+        <a:font script="Orya" typeface="Kalinga"/>
+        <a:font script="Mlym" typeface="Kartika"/>
+        <a:font script="Laoo" typeface="DokChampa"/>
+        <a:font script="Sinh" typeface="Iskoola Pota"/>
+        <a:font script="Mong" typeface="Mongolian Baiti"/>
+        <a:font script="Viet" typeface="Times New Roman"/>
+        <a:font script="Uigh" typeface="Microsoft Uighur"/>
+        <a:font script="Geor" typeface="Sylfaen"/>
+      </a:majorFont>
+      <a:minorFont>
+        <a:latin typeface="Calibri"/>
+        <a:ea typeface=""/>
+        <a:cs typeface=""/>
+        <a:font script="Jpan" typeface="ＭＳ Ｐゴシック"/>
+        <a:font script="Hang" typeface="맑은 고딕"/>
+        <a:font script="Hans" typeface="宋体"/>
+        <a:font script="Hant" typeface="新細明體"/>
+        <a:font script="Arab" typeface="Arial"/>
+        <a:font script="Hebr" typeface="Arial"/>
+        <a:font script="Thai" typeface="Cordia New"/>
+        <a:font script="Ethi" typeface="Nyala"/>
+        <a:font script="Beng" typeface="Vrinda"/>
+        <a:font script="Gujr" typeface="Shruti"/>
+        <a:font script="Khmr" typeface="DaunPenh"/>
+        <a:font script="Knda" typeface="Tunga"/>
+        <a:font script="Guru" typeface="Raavi"/>
+        <a:font script="Cans" typeface="Euphemia"/>
+        <a:font script="Cher" typeface="Plantagenet Cherokee"/>
+        <a:font script="Yiii" typeface="Microsoft Yi Baiti"/>
+        <a:font script="Tibt" typeface="Microsoft Himalaya"/>
+        <a:font script="Thaa" typeface="MV Boli"/>
+        <a:font script="Deva" typeface="Mangal"/>
+        <a:font script="Telu" typeface="Gautami"/>
+        <a:font script="Taml" typeface="Latha"/>
+        <a:font script="Syrc" typeface="Estrangelo Edessa"/>
+        <a:font script="Orya" typeface="Kalinga"/>
+        <a:font script="Mlym" typeface="Kartika"/>
+        <a:font script="Laoo" typeface="DokChampa"/>
+        <a:font script="Sinh" typeface="Iskoola Pota"/>
+        <a:font script="Mong" typeface="Mongolian Baiti"/>
+        <a:font script="Viet" typeface="Arial"/>
+        <a:font script="Uigh" typeface="Microsoft Uighur"/>
+        <a:font script="Geor" typeface="Sylfaen"/>
+      </a:minorFont>
+    </a:fontScheme>
+    <a:fmtScheme name="Office">
+      <a:fillStyleLst>
+        <a:solidFill>
+          <a:schemeClr val="phClr"/>
+        </a:solidFill>
+        <a:gradFill rotWithShape="1">
+          <a:gsLst>
+            <a:gs pos="0">
+              <a:schemeClr val="phClr">
+                <a:tint val="50000"/>
+                <a:satMod val="300000"/>
+              </a:schemeClr>
+            </a:gs>
+            <a:gs pos="35000">
+              <a:schemeClr val="phClr">
+                <a:tint val="37000"/>
+                <a:satMod val="300000"/>
+              </a:schemeClr>
+            </a:gs>
+            <a:gs pos="100000">
+              <a:schemeClr val="phClr">
+                <a:tint val="15000"/>
+                <a:satMod val="350000"/>
+              </a:schemeClr>
+            </a:gs>
+          </a:gsLst>
+          <a:lin ang="16200000" scaled="1"/>
+        </a:gradFill>
+        <a:gradFill rotWithShape="1">
+          <a:gsLst>
+            <a:gs pos="0">
+              <a:schemeClr val="phClr">
+                <a:tint val="100000"/>
+                <a:shade val="100000"/>
+                <a:satMod val="130000"/>
+              </a:schemeClr>
+            </a:gs>
+            <a:gs pos="100000">
+              <a:schemeClr val="phClr">
+                <a:tint val="50000"/>
+                <a:shade val="100000"/>
+                <a:satMod val="350000"/>
+              </a:schemeClr>
+            </a:gs>
+          </a:gsLst>
+          <a:lin ang="16200000" scaled="0"/>
+        </a:gradFill>
+      </a:fillStyleLst>
+      <a:lnStyleLst>
+        <a:ln w="9525" cap="flat" cmpd="sng" algn="ctr">
+          <a:solidFill>
+            <a:schemeClr val="phClr">
+              <a:shade val="95000"/>
+              <a:satMod val="105000"/>
+            </a:schemeClr>
+          </a:solidFill>
+          <a:prstDash val="solid"/>
+        </a:ln>
+        <a:ln w="25400" cap="flat" cmpd="sng" algn="ctr">
+          <a:solidFill>
+            <a:schemeClr val="phClr"/>
+          </a:solidFill>
+          <a:prstDash val="solid"/>
+        </a:ln>
+        <a:ln w="38100" cap="flat" cmpd="sng" algn="ctr">
+          <a:solidFill>
+            <a:schemeClr val="phClr"/>
+          </a:solidFill>
+          <a:prstDash val="solid"/>
+        </a:ln>
+      </a:lnStyleLst>
+      <a:effectStyleLst>
+        <a:effectStyle>
+          <a:effectLst>
+            <a:outerShdw blurRad="40000" dist="20000" dir="5400000" rotWithShape="0">
+              <a:srgbClr val="000000">
+                <a:alpha val="38000"/>
+              </a:srgbClr>
+            </a:outerShdw>
+          </a:effectLst>
+        </a:effectStyle>
+        <a:effectStyle>
+          <a:effectLst>
+            <a:outerShdw blurRad="40000" dist="23000" dir="5400000" rotWithShape="0">
+              <a:srgbClr val="000000">
+                <a:alpha val="35000"/>
+              </a:srgbClr>
+            </a:outerShdw>
+          </a:effectLst>
+        </a:effectStyle>
+        <a:effectStyle>
+          <a:effectLst>
+            <a:outerShdw blurRad="40000" dist="23000" dir="5400000" rotWithShape="0">
+              <a:srgbClr val="000000">
+                <a:alpha val="35000"/>
+              </a:srgbClr>
+            </a:outerShdw>
+          </a:effectLst>
+          <a:scene3d>
+            <a:camera prst="orthographicFront">
+              <a:rot lat="0" lon="0" rev="0"/>
+            </a:camera>
+            <a:lightRig rig="threePt" dir="t">
+              <a:rot lat="0" lon="0" rev="1200000"/>
+            </a:lightRig>
+          </a:scene3d>
+          <a:sp3d>
+            <a:bevelT w="63500" h="25400"/>
+          </a:sp3d>
+        </a:effectStyle>
+      </a:effectStyleLst>
+      <a:bgFillStyleLst>
+        <a:solidFill>
+          <a:schemeClr val="phClr"/>
+        </a:solidFill>
+        <a:gradFill rotWithShape="1">
+          <a:gsLst>
+            <a:gs pos="0">
+              <a:schemeClr val="phClr">
+                <a:tint val="40000"/>
+                <a:satMod val="350000"/>
+              </a:schemeClr>
+            </a:gs>
+            <a:gs pos="40000">
+              <a:schemeClr val="phClr">
+                <a:tint val="45000"/>
+                <a:shade val="99000"/>
+                <a:satMod val="350000"/>
+              </a:schemeClr>
+            </a:gs>
+            <a:gs pos="100000">
+              <a:schemeClr val="phClr">
+                <a:shade val="20000"/>
+                <a:satMod val="255000"/>
+              </a:schemeClr>
+            </a:gs>
+          </a:gsLst>
+          <a:path path="circle">
+            <a:fillToRect l="50000" t="-80000" r="50000" b="180000"/>
+          </a:path>
+        </a:gradFill>
+        <a:gradFill rotWithShape="1">
+          <a:gsLst>
+            <a:gs pos="0">
+              <a:schemeClr val="phClr">
+                <a:tint val="80000"/>
+                <a:satMod val="300000"/>
+              </a:schemeClr>
+            </a:gs>
+            <a:gs pos="100000">
+              <a:schemeClr val="phClr">
+                <a:shade val="30000"/>
+                <a:satMod val="200000"/>
+              </a:schemeClr>
+            </a:gs>
+          </a:gsLst>
+          <a:path path="circle">
+            <a:fillToRect l="50000" t="50000" r="50000" b="50000"/>
+          </a:path>
+        </a:gradFill>
+      </a:bgFillStyleLst>
+    </a:fmtScheme>
+  </a:themeElements>
+  <a:objectDefaults>
+    <a:spDef>
+      <a:spPr/>
+      <a:bodyPr/>
+      <a:lstStyle/>
+      <a:style>
+        <a:lnRef idx="1">
+          <a:schemeClr val="accent1"/>
+        </a:lnRef>
+        <a:fillRef idx="3">
+          <a:schemeClr val="accent1"/>
+        </a:fillRef>
+        <a:effectRef idx="2">
+          <a:schemeClr val="accent1"/>
+        </a:effectRef>
+        <a:fontRef idx="minor">
+          <a:schemeClr val="lt1"/>
+        </a:fontRef>
+      </a:style>
+    </a:spDef>
+    <a:lnDef>
+      <a:spPr/>
+      <a:bodyPr/>
+      <a:lstStyle/>
+      <a:style>
+        <a:lnRef idx="2">
+          <a:schemeClr val="accent1"/>
+        </a:lnRef>
+        <a:fillRef idx="0">
+          <a:schemeClr val="accent1"/>
+        </a:fillRef>
+        <a:effectRef idx="1">
+          <a:schemeClr val="accent1"/>
+        </a:effectRef>
+        <a:fontRef idx="minor">
+          <a:schemeClr val="tx1"/>
+        </a:fontRef>
+      </a:style>
+    </a:lnDef>
+  </a:objectDefaults>
+  <a:extraClrSchemeLst/>
+</a:theme>
 </file>
</xml_diff>

<commit_message>
deck: apply per-slide fix specs 1-7, enforce Cloud del Norte palette + contrast
</commit_message>
<xml_diff>
--- a/deck/unified.pptx
+++ b/deck/unified.pptx
@@ -518,7 +518,7 @@
           <a:lstStyle/>
           <a:p>
             <a:r>
-              <a:t>Opener. Definitions: Big Data Bowl = the NFL's annual analytics contest, run with AWS (Amazon Web Services); Muse Code = the agentic CLI used live in this talk; Next Gen Stats = the league's RFID tracking feed. Provenance: talk premise = docs/talk-notes.md. Transition: the contest is the frame, next slide says what it asks.</a:t>
+              <a:t>Open with the contract: the contest is the frame, the CLI is how we work it. Say plainly: Big Data Bowl equals the NFL's annual analytics contest with AWS; Muse Code equals the agentic CLI on screen; Next Gen Stats equals RFID tracking at 10 frames per second. Then bridge: next slide states what the contest actually asks. Definitions: Big Data Bowl = NFL annual analytics contest (with AWS) - Muse Code = agentic coding CLI - Next Gen Stats = RFID tracking feed, 10 frames/sec. As of Sep 2026; 2027 edition unannounced. Provenance: docs/talk-notes.md premise; repo README: eight editions 2019-2026.</a:t>
             </a:r>
           </a:p>
         </p:txBody>
@@ -1148,7 +1148,7 @@
           <a:lstStyle/>
           <a:p>
             <a:r>
-              <a:t>Definitions: NFL Football Operations runs the contest; TV = broadcast analytics, team analytics = club front offices. Provenance: contest shape docs/history.md + Big Data Bowl hub (references [30]); 8 editions 2019-2026 counted from history.md; 2027 unannounced as of Sep 27 2026 (docs/2027-prediction.md). Transition: why the scale slide next justifies entering.</a:t>
+              <a:t>Open by naming the prize in plain terms: a stat you invent here can end up on live TV. Walk the four facts in order: who runs it, what the data is, where winners go, and where we stand now. Pause on the 10-hertz figure and translate it (ten snapshots per second per player). Close with the honest caveat: eight editions 2019-2026 per docs/history.md; 2027 topic unannounced as of Sep 2026 per docs/2027-prediction.md. Transition: next slide shows the scale of the tracking data. Definitions: NFL Football Operations = the league office group that runs the contest; Next Gen Stats = the league's player-tracking data system; hertz = measurements per second.</a:t>
             </a:r>
           </a:p>
         </p:txBody>
@@ -1218,7 +1218,7 @@
           <a:lstStyle/>
           <a:p>
             <a:r>
-              <a:t>Definitions: NFL Scouting Combine = the annual draft-prospect event where finalists present; ML = machine learning. Provenance: $100k pool ([17]), 8,329 registrations / 771 teams / 69 countries single-sourced provisional ([33]), 500M+ points/season ([52]), 75+ ML stats ([29]), 50+ hired with 30+ by teams/vendors (talk-notes + [51]) all per docs/history.md + docs/references.md. Transition: scale is only interesting because winners ship to broadcast.</a:t>
+              <a:t>Open with the money and the stage: $100k and a live Combine final. Then the funnel: 8,329 registrations down to hired analysts. Caveat the single-sourced registration figure on stage. Transition: scale is only interesting because winners ship to broadcast. Definitions: NFL Scouting Combine = the annual pre-draft prospect evaluation event where finalists present. Next Gen Stats = the NFL's player-tracking statistics product built with AWS. ML = machine learning. RYOE = rushing yards over expected. Provenance: docs/history.md + docs/references.md.</a:t>
             </a:r>
           </a:p>
         </p:txBody>
@@ -1288,7 +1288,7 @@
           <a:lstStyle/>
           <a:p>
             <a:r>
-              <a:t>Definitions: the Zoo = 2020 winning team nickname; RYOE defined on slide; pressure probability and tackle probability are deployed Next Gen Stats. Provenance: winners.md + history.md; Zoo-to-TV ~6 months (winners.md); pressure = 4 models over 90k plays ([27][42]); tackle = 20 features x 11 defenders ([28][50]). Transition: that pipeline runs on the tracking feed, which the next slide specs.</a:t>
+              <a:t>The 'why it matters' beat: contest entries become TV stats. Walk 2020 (Zoo to expected rushing yards in ~6 months), then 2023 pressure and 2024 tackle probability with their training scale. Transition: that pipeline runs on the tracking feed, which the next slide specs. Definitions: the Zoo = 2020 winning team (Singer + Gordeev, H2O AI); RYOE = rushing yards over expected, in yards; TD = touchdown; pressure and tackle probability = deployed statistics reporting 0-1 probability. As of September 2026. Provenance: docs/winners.md + docs/history.md.</a:t>
             </a:r>
           </a:p>
         </p:txBody>
@@ -1428,7 +1428,7 @@
           <a:lstStyle/>
           <a:p>
             <a:r>
-              <a:t>Definitions: muse exec = headless one-shot CLI run; 22 dots + ball = 11 offensive + 11 defensive players. Provenance: scripts/explore_sample.py; frame counts verified in-repo just now: 19,113 (2024) / 92,069 (2025) rows, 25 plays each. Transition: once the sample query reads right, workflow 2 scales it to full weeks.</a:t>
+              <a:t>Concrete first run: uv run python scripts/explore_sample.py --data samples/2024 joins tracking and metadata, prints one play frame by frame, and writes a field plot to data/scratch/. Frame rate 10 hertz confirmed from sample timestamps (0.1 s steps). Transition: once the sample query reads right, workflow 2 scales it to full weeks. Definitions: muse exec = headless one-shot command-line run (no interactive session); 22 dots + ball = 11 offensive + 11 defensive players + the football; frame = one 10 Hz snapshot, 0.1 s apart; sample = 25-play in-git slice, not the full season. Row counts verified by wc: 19,113 (2024) / 92,069 (2025). As of 2026-09-28.</a:t>
             </a:r>
           </a:p>
         </p:txBody>
@@ -1498,7 +1498,7 @@
           <a:lstStyle/>
           <a:p>
             <a:r>
-              <a:t>Definitions: parquet = columnar file format far faster than CSV for repeated reads; chunksize/scan+sink = chunked out-of-core reads; scratch/ = rebuildable intermediates dir. Provenance: scripts/weeks_to_parquet.py; ~2 GB/week budget ([58][59]); raw read-only rule docs/muse-code.md. Transition: stored efficiently, now build features frame-up.</a:t>
+              <a:t>Say: weekly tracking is our biggest I/O tax, so we pay it once. Chunked reads mean a laptop never holds a full week in RAM. The rebuild-first rule is the safety story: raw data is sacred, scratch is disposable, one command reproduces everything. Transition: data is now stored efficiently, so next we build features frame-up. Run: uv run python scripts/weeks_to_parquet.py [--data samples/2024] or BDB_DATA=data/2024 uv run python scripts/weeks_to_parquet.py. Raw files read-only; data/ is gitignored; missing-data path points to data/README.md re-seed or samples/2024 slice. As of Sep 2026.</a:t>
             </a:r>
           </a:p>
         </p:txBody>
@@ -4667,7 +4667,7 @@
             <a:avLst/>
           </a:prstGeom>
           <a:solidFill>
-            <a:srgbClr val="5B8DFF"/>
+            <a:srgbClr val="00002A"/>
           </a:solidFill>
           <a:ln>
             <a:noFill/>
@@ -4795,14 +4795,14 @@
           </a:bodyPr>
           <a:lstStyle/>
           <a:p>
-            <a:r>
-              <a:rPr sz="4000" b="1">
+            <a:pPr algn="l"/>
+            <a:r>
+              <a:rPr b="1" sz="3200">
                 <a:solidFill>
                   <a:srgbClr val="D7C7EE"/>
                 </a:solidFill>
-                <a:latin typeface="Cinzel"/>
-              </a:rPr>
-              <a:t>Big Data Bowl x Muse Code</a:t>
+              </a:rPr>
+              <a:t>Big Data Bowl meets Muse Code: NFL tracking data, worked live in the terminal</a:t>
             </a:r>
           </a:p>
         </p:txBody>
@@ -4831,33 +4831,46 @@
           <a:p>
             <a:pPr>
               <a:spcAft>
-                <a:spcPts val="1000"/>
+                <a:spcPts val="600"/>
               </a:spcAft>
             </a:pPr>
             <a:r>
-              <a:rPr sz="2400">
+              <a:rPr sz="2000">
                 <a:solidFill>
                   <a:srgbClr val="F0F0F0"/>
                 </a:solidFill>
-                <a:latin typeface="Calibri"/>
-              </a:rPr>
-              <a:t>the competition is the vehicle, muse code is the instrument</a:t>
+              </a:rPr>
+              <a:t>The NFL Big Data Bowl is the league's annual analytics contest, run with AWS (Amazon Web Services), and this talk uses it as the vehicle.</a:t>
             </a:r>
           </a:p>
           <a:p>
             <a:pPr>
               <a:spcAft>
-                <a:spcPts val="1000"/>
+                <a:spcPts val="600"/>
               </a:spcAft>
             </a:pPr>
             <a:r>
-              <a:rPr sz="2400">
+              <a:rPr sz="2000">
                 <a:solidFill>
                   <a:srgbClr val="F0F0F0"/>
                 </a:solidFill>
-                <a:latin typeface="Calibri"/>
-              </a:rPr>
-              <a:t>National Football League (NFL) Next Gen Stats, worked live in the CLI</a:t>
+              </a:rPr>
+              <a:t>Muse Code is the agentic coding CLI we will drive live, and it is the instrument of the talk.</a:t>
+            </a:r>
+          </a:p>
+          <a:p>
+            <a:pPr>
+              <a:spcAft>
+                <a:spcPts val="600"/>
+              </a:spcAft>
+            </a:pPr>
+            <a:r>
+              <a:rPr sz="2000">
+                <a:solidFill>
+                  <a:srgbClr val="F0F0F0"/>
+                </a:solidFill>
+              </a:rPr>
+              <a:t>Our raw material is NFL Next Gen Stats, the league's RFID player-and-ball tracking feed sampled at 10 frames per second.</a:t>
             </a:r>
           </a:p>
         </p:txBody>
@@ -4903,7 +4916,7 @@
             <a:avLst/>
           </a:prstGeom>
           <a:solidFill>
-            <a:srgbClr val="5B8DFF"/>
+            <a:srgbClr val="00002A"/>
           </a:solidFill>
           <a:ln>
             <a:noFill/>
@@ -5031,6 +5044,7 @@
           </a:bodyPr>
           <a:lstStyle/>
           <a:p>
+            <a:pPr algn="l"/>
             <a:r>
               <a:rPr sz="4000" b="1">
                 <a:solidFill>
@@ -5071,7 +5085,7 @@
               </a:spcAft>
             </a:pPr>
             <a:r>
-              <a:rPr sz="2400">
+              <a:rPr sz="2400" b="0">
                 <a:solidFill>
                   <a:srgbClr val="F0F0F0"/>
                 </a:solidFill>
@@ -5087,7 +5101,7 @@
               </a:spcAft>
             </a:pPr>
             <a:r>
-              <a:rPr sz="2400">
+              <a:rPr sz="2400" b="0">
                 <a:solidFill>
                   <a:srgbClr val="F0F0F0"/>
                 </a:solidFill>
@@ -5103,7 +5117,7 @@
               </a:spcAft>
             </a:pPr>
             <a:r>
-              <a:rPr sz="2400">
+              <a:rPr sz="2400" b="0">
                 <a:solidFill>
                   <a:srgbClr val="F0F0F0"/>
                 </a:solidFill>
@@ -5119,7 +5133,7 @@
               </a:spcAft>
             </a:pPr>
             <a:r>
-              <a:rPr sz="2400">
+              <a:rPr sz="2400" b="0">
                 <a:solidFill>
                   <a:srgbClr val="F0F0F0"/>
                 </a:solidFill>
@@ -5171,7 +5185,7 @@
             <a:avLst/>
           </a:prstGeom>
           <a:solidFill>
-            <a:srgbClr val="5B8DFF"/>
+            <a:srgbClr val="00002A"/>
           </a:solidFill>
           <a:ln>
             <a:noFill/>
@@ -5299,6 +5313,7 @@
           </a:bodyPr>
           <a:lstStyle/>
           <a:p>
+            <a:pPr algn="l"/>
             <a:r>
               <a:rPr sz="4000" b="1">
                 <a:solidFill>
@@ -5339,7 +5354,7 @@
               </a:spcAft>
             </a:pPr>
             <a:r>
-              <a:rPr sz="2400">
+              <a:rPr sz="2400" b="0">
                 <a:solidFill>
                   <a:srgbClr val="F0F0F0"/>
                 </a:solidFill>
@@ -5355,7 +5370,7 @@
               </a:spcAft>
             </a:pPr>
             <a:r>
-              <a:rPr sz="2400">
+              <a:rPr sz="2400" b="0">
                 <a:solidFill>
                   <a:srgbClr val="F0F0F0"/>
                 </a:solidFill>
@@ -5371,7 +5386,7 @@
               </a:spcAft>
             </a:pPr>
             <a:r>
-              <a:rPr sz="2400">
+              <a:rPr sz="2400" b="0">
                 <a:solidFill>
                   <a:srgbClr val="F0F0F0"/>
                 </a:solidFill>
@@ -5387,7 +5402,7 @@
               </a:spcAft>
             </a:pPr>
             <a:r>
-              <a:rPr sz="2400">
+              <a:rPr sz="2400" b="0">
                 <a:solidFill>
                   <a:srgbClr val="F0F0F0"/>
                 </a:solidFill>
@@ -5439,7 +5454,7 @@
             <a:avLst/>
           </a:prstGeom>
           <a:solidFill>
-            <a:srgbClr val="5B8DFF"/>
+            <a:srgbClr val="00002A"/>
           </a:solidFill>
           <a:ln>
             <a:noFill/>
@@ -5567,6 +5582,7 @@
           </a:bodyPr>
           <a:lstStyle/>
           <a:p>
+            <a:pPr algn="l"/>
             <a:r>
               <a:rPr sz="4000" b="1">
                 <a:solidFill>
@@ -5607,7 +5623,7 @@
               </a:spcAft>
             </a:pPr>
             <a:r>
-              <a:rPr sz="2400">
+              <a:rPr sz="2400" b="0">
                 <a:solidFill>
                   <a:srgbClr val="F0F0F0"/>
                 </a:solidFill>
@@ -5623,7 +5639,7 @@
               </a:spcAft>
             </a:pPr>
             <a:r>
-              <a:rPr sz="2400">
+              <a:rPr sz="2400" b="0">
                 <a:solidFill>
                   <a:srgbClr val="F0F0F0"/>
                 </a:solidFill>
@@ -5639,7 +5655,7 @@
               </a:spcAft>
             </a:pPr>
             <a:r>
-              <a:rPr sz="2400">
+              <a:rPr sz="2400" b="0">
                 <a:solidFill>
                   <a:srgbClr val="F0F0F0"/>
                 </a:solidFill>
@@ -5655,7 +5671,7 @@
               </a:spcAft>
             </a:pPr>
             <a:r>
-              <a:rPr sz="2400">
+              <a:rPr sz="2400" b="0">
                 <a:solidFill>
                   <a:srgbClr val="F0F0F0"/>
                 </a:solidFill>
@@ -5707,7 +5723,7 @@
             <a:avLst/>
           </a:prstGeom>
           <a:solidFill>
-            <a:srgbClr val="5B8DFF"/>
+            <a:srgbClr val="00002A"/>
           </a:solidFill>
           <a:ln>
             <a:noFill/>
@@ -5835,6 +5851,7 @@
           </a:bodyPr>
           <a:lstStyle/>
           <a:p>
+            <a:pPr algn="l"/>
             <a:r>
               <a:rPr sz="4000" b="1">
                 <a:solidFill>
@@ -5875,7 +5892,7 @@
               </a:spcAft>
             </a:pPr>
             <a:r>
-              <a:rPr sz="2400">
+              <a:rPr sz="2400" b="0">
                 <a:solidFill>
                   <a:srgbClr val="F0F0F0"/>
                 </a:solidFill>
@@ -5891,7 +5908,7 @@
               </a:spcAft>
             </a:pPr>
             <a:r>
-              <a:rPr sz="2400">
+              <a:rPr sz="2400" b="0">
                 <a:solidFill>
                   <a:srgbClr val="F0F0F0"/>
                 </a:solidFill>
@@ -5907,7 +5924,7 @@
               </a:spcAft>
             </a:pPr>
             <a:r>
-              <a:rPr sz="2400">
+              <a:rPr sz="2400" b="0">
                 <a:solidFill>
                   <a:srgbClr val="F0F0F0"/>
                 </a:solidFill>
@@ -5923,7 +5940,7 @@
               </a:spcAft>
             </a:pPr>
             <a:r>
-              <a:rPr sz="2400">
+              <a:rPr sz="2400" b="0">
                 <a:solidFill>
                   <a:srgbClr val="F0F0F0"/>
                 </a:solidFill>
@@ -5975,7 +5992,7 @@
             <a:avLst/>
           </a:prstGeom>
           <a:solidFill>
-            <a:srgbClr val="5B8DFF"/>
+            <a:srgbClr val="00002A"/>
           </a:solidFill>
           <a:ln>
             <a:noFill/>
@@ -6103,6 +6120,7 @@
           </a:bodyPr>
           <a:lstStyle/>
           <a:p>
+            <a:pPr algn="l"/>
             <a:r>
               <a:rPr sz="4000" b="1">
                 <a:solidFill>
@@ -6143,7 +6161,7 @@
               </a:spcAft>
             </a:pPr>
             <a:r>
-              <a:rPr sz="1800">
+              <a:rPr sz="1800" b="0">
                 <a:solidFill>
                   <a:srgbClr val="F0F0F0"/>
                 </a:solidFill>
@@ -6159,7 +6177,7 @@
               </a:spcAft>
             </a:pPr>
             <a:r>
-              <a:rPr sz="1800">
+              <a:rPr sz="1800" b="0">
                 <a:solidFill>
                   <a:srgbClr val="F0F0F0"/>
                 </a:solidFill>
@@ -6175,7 +6193,7 @@
               </a:spcAft>
             </a:pPr>
             <a:r>
-              <a:rPr sz="1800">
+              <a:rPr sz="1800" b="0">
                 <a:solidFill>
                   <a:srgbClr val="C9A23F"/>
                 </a:solidFill>
@@ -6191,7 +6209,7 @@
               </a:spcAft>
             </a:pPr>
             <a:r>
-              <a:rPr sz="1800">
+              <a:rPr sz="1800" b="0">
                 <a:solidFill>
                   <a:srgbClr val="F0F0F0"/>
                 </a:solidFill>
@@ -6207,7 +6225,7 @@
               </a:spcAft>
             </a:pPr>
             <a:r>
-              <a:rPr sz="1800">
+              <a:rPr sz="1800" b="0">
                 <a:solidFill>
                   <a:srgbClr val="F0F0F0"/>
                 </a:solidFill>
@@ -6259,7 +6277,7 @@
             <a:avLst/>
           </a:prstGeom>
           <a:solidFill>
-            <a:srgbClr val="5B8DFF"/>
+            <a:srgbClr val="00002A"/>
           </a:solidFill>
           <a:ln>
             <a:noFill/>
@@ -6387,6 +6405,7 @@
           </a:bodyPr>
           <a:lstStyle/>
           <a:p>
+            <a:pPr algn="l"/>
             <a:r>
               <a:rPr sz="4000" b="1">
                 <a:solidFill>
@@ -6427,7 +6446,7 @@
               </a:spcAft>
             </a:pPr>
             <a:r>
-              <a:rPr sz="2400">
+              <a:rPr sz="2400" b="0">
                 <a:solidFill>
                   <a:srgbClr val="F0F0F0"/>
                 </a:solidFill>
@@ -6443,7 +6462,7 @@
               </a:spcAft>
             </a:pPr>
             <a:r>
-              <a:rPr sz="2400">
+              <a:rPr sz="2400" b="0">
                 <a:solidFill>
                   <a:srgbClr val="F0F0F0"/>
                 </a:solidFill>
@@ -6459,7 +6478,7 @@
               </a:spcAft>
             </a:pPr>
             <a:r>
-              <a:rPr sz="2400">
+              <a:rPr sz="2400" b="0">
                 <a:solidFill>
                   <a:srgbClr val="F0F0F0"/>
                 </a:solidFill>
@@ -6475,7 +6494,7 @@
               </a:spcAft>
             </a:pPr>
             <a:r>
-              <a:rPr sz="2400">
+              <a:rPr sz="2400" b="0">
                 <a:solidFill>
                   <a:srgbClr val="F0F0F0"/>
                 </a:solidFill>
@@ -6527,7 +6546,7 @@
             <a:avLst/>
           </a:prstGeom>
           <a:solidFill>
-            <a:srgbClr val="5B8DFF"/>
+            <a:srgbClr val="00002A"/>
           </a:solidFill>
           <a:ln>
             <a:noFill/>
@@ -6655,6 +6674,7 @@
           </a:bodyPr>
           <a:lstStyle/>
           <a:p>
+            <a:pPr algn="l"/>
             <a:r>
               <a:rPr sz="4000" b="1">
                 <a:solidFill>
@@ -6695,7 +6715,7 @@
               </a:spcAft>
             </a:pPr>
             <a:r>
-              <a:rPr sz="2400">
+              <a:rPr sz="2400" b="0">
                 <a:solidFill>
                   <a:srgbClr val="F0F0F0"/>
                 </a:solidFill>
@@ -6711,7 +6731,7 @@
               </a:spcAft>
             </a:pPr>
             <a:r>
-              <a:rPr sz="2400">
+              <a:rPr sz="2400" b="0">
                 <a:solidFill>
                   <a:srgbClr val="F0F0F0"/>
                 </a:solidFill>
@@ -6727,7 +6747,7 @@
               </a:spcAft>
             </a:pPr>
             <a:r>
-              <a:rPr sz="2400">
+              <a:rPr sz="2400" b="0">
                 <a:solidFill>
                   <a:srgbClr val="F0F0F0"/>
                 </a:solidFill>
@@ -6743,7 +6763,7 @@
               </a:spcAft>
             </a:pPr>
             <a:r>
-              <a:rPr sz="2400">
+              <a:rPr sz="2400" b="0">
                 <a:solidFill>
                   <a:srgbClr val="F0F0F0"/>
                 </a:solidFill>
@@ -6795,7 +6815,7 @@
             <a:avLst/>
           </a:prstGeom>
           <a:solidFill>
-            <a:srgbClr val="5B8DFF"/>
+            <a:srgbClr val="00002A"/>
           </a:solidFill>
           <a:ln>
             <a:noFill/>
@@ -6923,6 +6943,7 @@
           </a:bodyPr>
           <a:lstStyle/>
           <a:p>
+            <a:pPr algn="l"/>
             <a:r>
               <a:rPr sz="4000" b="1">
                 <a:solidFill>
@@ -6963,7 +6984,7 @@
               </a:spcAft>
             </a:pPr>
             <a:r>
-              <a:rPr sz="2400">
+              <a:rPr sz="2400" b="0">
                 <a:solidFill>
                   <a:srgbClr val="F0F0F0"/>
                 </a:solidFill>
@@ -6979,7 +7000,7 @@
               </a:spcAft>
             </a:pPr>
             <a:r>
-              <a:rPr sz="2400">
+              <a:rPr sz="2400" b="0">
                 <a:solidFill>
                   <a:srgbClr val="F0F0F0"/>
                 </a:solidFill>
@@ -6995,7 +7016,7 @@
               </a:spcAft>
             </a:pPr>
             <a:r>
-              <a:rPr sz="2400">
+              <a:rPr sz="2400" b="0">
                 <a:solidFill>
                   <a:srgbClr val="F0F0F0"/>
                 </a:solidFill>
@@ -7047,7 +7068,7 @@
             <a:avLst/>
           </a:prstGeom>
           <a:solidFill>
-            <a:srgbClr val="5B8DFF"/>
+            <a:srgbClr val="00002A"/>
           </a:solidFill>
           <a:ln>
             <a:noFill/>
@@ -7175,14 +7196,14 @@
           </a:bodyPr>
           <a:lstStyle/>
           <a:p>
-            <a:r>
-              <a:rPr sz="4000" b="1">
+            <a:pPr algn="l"/>
+            <a:r>
+              <a:rPr b="1" sz="3200">
                 <a:solidFill>
                   <a:srgbClr val="D7C7EE"/>
                 </a:solidFill>
-                <a:latin typeface="Cinzel"/>
-              </a:rPr>
-              <a:t>the challenge</a:t>
+              </a:rPr>
+              <a:t>The challenge: invent a stat good enough for live television</a:t>
             </a:r>
           </a:p>
         </p:txBody>
@@ -7211,65 +7232,61 @@
           <a:p>
             <a:pPr>
               <a:spcAft>
-                <a:spcPts val="1000"/>
+                <a:spcPts val="600"/>
               </a:spcAft>
             </a:pPr>
             <a:r>
-              <a:rPr sz="2400">
+              <a:rPr sz="1800">
                 <a:solidFill>
                   <a:srgbClr val="F0F0F0"/>
                 </a:solidFill>
-                <a:latin typeface="Calibri"/>
-              </a:rPr>
-              <a:t>annual contest, NFL Football Operations + AWS (Amazon Web Services)</a:t>
+              </a:rPr>
+              <a:t>The Big Data Bowl is the yearly analytics contest run by NFL Football Operations together with Amazon Web Services, using real player-tracking data from the league's Next Gen Stats system.</a:t>
             </a:r>
           </a:p>
           <a:p>
             <a:pPr>
               <a:spcAft>
-                <a:spcPts val="1000"/>
+                <a:spcPts val="600"/>
               </a:spcAft>
             </a:pPr>
             <a:r>
-              <a:rPr sz="2400">
+              <a:rPr sz="1800">
                 <a:solidFill>
                   <a:srgbClr val="F0F0F0"/>
                 </a:solidFill>
-                <a:latin typeface="Calibri"/>
-              </a:rPr>
-              <a:t>real Next Gen Stats tracking data, 10 frames/second</a:t>
+              </a:rPr>
+              <a:t>Every tracked player is located ten times per second (10 hertz), so each play yields hundreds of position, speed, and acceleration readings for analysis.</a:t>
             </a:r>
           </a:p>
           <a:p>
             <a:pPr>
               <a:spcAft>
-                <a:spcPts val="1000"/>
+                <a:spcPts val="600"/>
               </a:spcAft>
             </a:pPr>
             <a:r>
-              <a:rPr sz="2400">
+              <a:rPr sz="1800">
                 <a:solidFill>
                   <a:srgbClr val="F0F0F0"/>
                 </a:solidFill>
-                <a:latin typeface="Calibri"/>
-              </a:rPr>
-              <a:t>goal: invent stats good enough for TV + team analytics</a:t>
+              </a:rPr>
+              <a:t>The winning entries become real products: past winners have gone on to appear in live television broadcasts and in the analytics dashboards used by club front offices.</a:t>
             </a:r>
           </a:p>
           <a:p>
             <a:pPr>
               <a:spcAft>
-                <a:spcPts val="1000"/>
+                <a:spcPts val="600"/>
               </a:spcAft>
             </a:pPr>
             <a:r>
-              <a:rPr sz="2400">
+              <a:rPr sz="1800">
                 <a:solidFill>
                   <a:srgbClr val="F0F0F0"/>
                 </a:solidFill>
-                <a:latin typeface="Calibri"/>
-              </a:rPr>
-              <a:t>8 editions 2019-2026  |  2027 not announced yet</a:t>
+              </a:rPr>
+              <a:t>Eight editions ran from 2019 through 2026, and the 2027 edition had not been announced as of September 2026, so this entry is preparation, not a reaction to a published topic.</a:t>
             </a:r>
           </a:p>
         </p:txBody>
@@ -7315,7 +7332,7 @@
             <a:avLst/>
           </a:prstGeom>
           <a:solidFill>
-            <a:srgbClr val="5B8DFF"/>
+            <a:srgbClr val="00002A"/>
           </a:solidFill>
           <a:ln>
             <a:noFill/>
@@ -7443,14 +7460,14 @@
           </a:bodyPr>
           <a:lstStyle/>
           <a:p>
-            <a:r>
-              <a:rPr sz="4000" b="1">
+            <a:pPr algn="l"/>
+            <a:r>
+              <a:rPr b="1" sz="3200">
                 <a:solidFill>
                   <a:srgbClr val="D7C7EE"/>
                 </a:solidFill>
-                <a:latin typeface="Cinzel"/>
-              </a:rPr>
-              <a:t>scale</a:t>
+              </a:rPr>
+              <a:t>A $100,000 contest at NFL scale — and a hiring pipeline</a:t>
             </a:r>
           </a:p>
         </p:txBody>
@@ -7479,65 +7496,76 @@
           <a:p>
             <a:pPr>
               <a:spcAft>
-                <a:spcPts val="1000"/>
+                <a:spcPts val="600"/>
               </a:spcAft>
             </a:pPr>
             <a:r>
-              <a:rPr sz="2400">
+              <a:rPr sz="1800">
                 <a:solidFill>
                   <a:srgbClr val="F0F0F0"/>
                 </a:solidFill>
-                <a:latin typeface="Calibri"/>
-              </a:rPr>
-              <a:t>$100k prize pool  |  finalists present at the NFL Scouting Combine</a:t>
+              </a:rPr>
+              <a:t>The 2026 contest offers a $100,000 prize pool, and its finalists present in person at the 2026 NFL Scouting Combine (per NFL Football Operations hub and AWS Sports tracks page; as of September 2025 announcements).</a:t>
             </a:r>
           </a:p>
           <a:p>
             <a:pPr>
               <a:spcAft>
-                <a:spcPts val="1000"/>
+                <a:spcPts val="600"/>
               </a:spcAft>
             </a:pPr>
             <a:r>
-              <a:rPr sz="2400">
+              <a:rPr sz="1800">
                 <a:solidFill>
                   <a:srgbClr val="F0F0F0"/>
                 </a:solidFill>
-                <a:latin typeface="Calibri"/>
-              </a:rPr>
-              <a:t>2026: 8,329 registrations, 771 teams, 69 countries (provisional, single-sourced)</a:t>
+              </a:rPr>
+              <a:t>The 2026 edition drew 8,329 registrations from 771 teams across 69 countries (single-sourced and provisional, summarizing the December 2025 results; treat as approximate until the NFL confirms).</a:t>
             </a:r>
           </a:p>
           <a:p>
             <a:pPr>
               <a:spcAft>
-                <a:spcPts val="1000"/>
+                <a:spcPts val="600"/>
               </a:spcAft>
             </a:pPr>
             <a:r>
-              <a:rPr sz="2400">
+              <a:rPr sz="1800">
                 <a:solidFill>
                   <a:srgbClr val="F0F0F0"/>
                 </a:solidFill>
-                <a:latin typeface="Calibri"/>
-              </a:rPr>
-              <a:t>AWS processes 500M+ tracking points a season</a:t>
+              </a:rPr>
+              <a:t>AWS (Amazon Web Services) processes more than 500 million player-tracking data points per NFL season (per the AWS Sports NFL page; figure undated, restate as 'AWS reports 500M+ per season').</a:t>
             </a:r>
           </a:p>
           <a:p>
             <a:pPr>
               <a:spcAft>
-                <a:spcPts val="1000"/>
+                <a:spcPts val="600"/>
               </a:spcAft>
             </a:pPr>
             <a:r>
-              <a:rPr sz="2400">
+              <a:rPr sz="1800">
                 <a:solidFill>
                   <a:srgbClr val="F0F0F0"/>
                 </a:solidFill>
-                <a:latin typeface="Calibri"/>
-              </a:rPr>
-              <a:t>75+ machine-learning (ML) stats in pipeline  |  50+ entrants hired (30+ by teams/vendors)</a:t>
+              </a:rPr>
+              <a:t>The league's pipeline already ships 75+ machine-learning (ML) statistics including rushing yards over expected, built on this tracking data (per AWS Media blog; as of the 2025-2026 partnership announcements).</a:t>
+            </a:r>
+          </a:p>
+          <a:p>
+            <a:pPr>
+              <a:spcAft>
+                <a:spcPts val="600"/>
+              </a:spcAft>
+            </a:pPr>
+            <a:r>
+              <a:rPr sz="1800">
+                <a:solidFill>
+                  <a:srgbClr val="F0F0F0"/>
+                </a:solidFill>
+              </a:rPr>
+              <a:t>More than 50 past entrants have been hired into football analytics roles, with 30+ hired directly by teams or vendors (per September 2024 reporting plus talk notes; single-sourced — say 'reportedly' on stage).</a:t>
             </a:r>
           </a:p>
         </p:txBody>
@@ -7583,7 +7611,7 @@
             <a:avLst/>
           </a:prstGeom>
           <a:solidFill>
-            <a:srgbClr val="5B8DFF"/>
+            <a:srgbClr val="00002A"/>
           </a:solidFill>
           <a:ln>
             <a:noFill/>
@@ -7711,14 +7739,14 @@
           </a:bodyPr>
           <a:lstStyle/>
           <a:p>
-            <a:r>
-              <a:rPr sz="4000" b="1">
+            <a:pPr algn="l"/>
+            <a:r>
+              <a:rPr b="1" sz="2800">
                 <a:solidFill>
                   <a:srgbClr val="D7C7EE"/>
                 </a:solidFill>
-                <a:latin typeface="Cinzel"/>
-              </a:rPr>
-              <a:t>why it matters: bowl to broadcast</a:t>
+              </a:rPr>
+              <a:t>Winning ideas reach the broadcast: from contest entry to television statistic</a:t>
             </a:r>
           </a:p>
         </p:txBody>
@@ -7747,65 +7775,61 @@
           <a:p>
             <a:pPr>
               <a:spcAft>
-                <a:spcPts val="1000"/>
+                <a:spcPts val="600"/>
               </a:spcAft>
             </a:pPr>
             <a:r>
-              <a:rPr sz="2400">
+              <a:rPr sz="1800">
                 <a:solidFill>
                   <a:srgbClr val="F0F0F0"/>
                 </a:solidFill>
-                <a:latin typeface="Calibri"/>
-              </a:rPr>
-              <a:t>2020 the Zoo wins -&gt; expected rushing yards on TV in ~6 months</a:t>
+              </a:rPr>
+              <a:t>In 2020, Philipp Singer and Dmitry Gordeev of H2O AI, competing as team the Zoo, won by predicting the full distribution of rushing yards from handoff positions and velocities, and their approach became the expected rushing yards television statistic within about six months.</a:t>
             </a:r>
           </a:p>
           <a:p>
             <a:pPr>
               <a:spcAft>
-                <a:spcPts val="1000"/>
+                <a:spcPts val="600"/>
               </a:spcAft>
             </a:pPr>
             <a:r>
-              <a:rPr sz="2400">
+              <a:rPr sz="1800">
                 <a:solidFill>
                   <a:srgbClr val="F0F0F0"/>
                 </a:solidFill>
-                <a:latin typeface="Calibri"/>
-              </a:rPr>
-              <a:t>RYOE (rushing yards over expected), 1st-down + touchdown (TD) probability follow the same pipe</a:t>
+              </a:rPr>
+              <a:t>The same 2020 pipeline produced three follow-on television statistics measured in yards and probabilities from zero to one: rushing yards over expected, first-down probability, and touchdown probability.</a:t>
             </a:r>
           </a:p>
           <a:p>
             <a:pPr>
               <a:spcAft>
-                <a:spcPts val="1000"/>
+                <a:spcPts val="600"/>
               </a:spcAft>
             </a:pPr>
             <a:r>
-              <a:rPr sz="2400">
+              <a:rPr sz="1800">
                 <a:solidFill>
                   <a:srgbClr val="F0F0F0"/>
                 </a:solidFill>
-                <a:latin typeface="Calibri"/>
-              </a:rPr>
-              <a:t>2023 pocket pressure -&gt; pressure probability (4 models, 90k plays)</a:t>
+              </a:rPr>
+              <a:t>In 2023, the pocket-pressure contest fed the deployed pressure probability statistic, which combines four models trained over 90,000 plays.</a:t>
             </a:r>
           </a:p>
           <a:p>
             <a:pPr>
               <a:spcAft>
-                <a:spcPts val="1000"/>
+                <a:spcPts val="600"/>
               </a:spcAft>
             </a:pPr>
             <a:r>
-              <a:rPr sz="2400">
+              <a:rPr sz="1800">
                 <a:solidFill>
                   <a:srgbClr val="F0F0F0"/>
                 </a:solidFill>
-                <a:latin typeface="Calibri"/>
-              </a:rPr>
-              <a:t>2024 missed tackles -&gt; tackle probability (20 features x 11 defenders)</a:t>
+              </a:rPr>
+              <a:t>In 2024, the missed-tackle contest fed the deployed tackle probability statistic, which uses 20 features per defender across 11 defenders, trained on 2018 through 2022 seasons and tested on 2023.</a:t>
             </a:r>
           </a:p>
         </p:txBody>
@@ -7851,7 +7875,7 @@
             <a:avLst/>
           </a:prstGeom>
           <a:solidFill>
-            <a:srgbClr val="5B8DFF"/>
+            <a:srgbClr val="00002A"/>
           </a:solidFill>
           <a:ln>
             <a:noFill/>
@@ -7979,6 +8003,7 @@
           </a:bodyPr>
           <a:lstStyle/>
           <a:p>
+            <a:pPr algn="l"/>
             <a:r>
               <a:rPr sz="4000" b="1">
                 <a:solidFill>
@@ -8019,7 +8044,7 @@
               </a:spcAft>
             </a:pPr>
             <a:r>
-              <a:rPr sz="2400">
+              <a:rPr sz="2400" b="0">
                 <a:solidFill>
                   <a:srgbClr val="F0F0F0"/>
                 </a:solidFill>
@@ -8035,7 +8060,7 @@
               </a:spcAft>
             </a:pPr>
             <a:r>
-              <a:rPr sz="2400">
+              <a:rPr sz="2400" b="0">
                 <a:solidFill>
                   <a:srgbClr val="F0F0F0"/>
                 </a:solidFill>
@@ -8051,7 +8076,7 @@
               </a:spcAft>
             </a:pPr>
             <a:r>
-              <a:rPr sz="2400">
+              <a:rPr sz="2400" b="0">
                 <a:solidFill>
                   <a:srgbClr val="F0F0F0"/>
                 </a:solidFill>
@@ -8067,7 +8092,7 @@
               </a:spcAft>
             </a:pPr>
             <a:r>
-              <a:rPr sz="2400">
+              <a:rPr sz="2400" b="0">
                 <a:solidFill>
                   <a:srgbClr val="F0F0F0"/>
                 </a:solidFill>
@@ -8119,7 +8144,7 @@
             <a:avLst/>
           </a:prstGeom>
           <a:solidFill>
-            <a:srgbClr val="5B8DFF"/>
+            <a:srgbClr val="00002A"/>
           </a:solidFill>
           <a:ln>
             <a:noFill/>
@@ -8247,6 +8272,7 @@
           </a:bodyPr>
           <a:lstStyle/>
           <a:p>
+            <a:pPr algn="l"/>
             <a:r>
               <a:rPr sz="4000" b="1">
                 <a:solidFill>
@@ -8283,65 +8309,61 @@
           <a:p>
             <a:pPr>
               <a:spcAft>
-                <a:spcPts val="1000"/>
+                <a:spcPts val="600"/>
               </a:spcAft>
             </a:pPr>
             <a:r>
-              <a:rPr sz="2400">
+              <a:rPr sz="1800">
                 <a:solidFill>
                   <a:srgbClr val="F0F0F0"/>
                 </a:solidFill>
-                <a:latin typeface="Calibri"/>
-              </a:rPr>
-              <a:t>muse on samples/2024/tracking_sample.csv + games/plays/players</a:t>
+              </a:rPr>
+              <a:t>Start with the in-git sample slice instead of the full download: samples/2024/tracking_sample.csv holds 19,113 tracking rows across 25 plays, and samples/2025 holds 92,069 rows, so every query runs in seconds with zero download.</a:t>
             </a:r>
           </a:p>
           <a:p>
             <a:pPr>
               <a:spcAft>
-                <a:spcPts val="1000"/>
+                <a:spcPts val="600"/>
               </a:spcAft>
             </a:pPr>
             <a:r>
-              <a:rPr sz="2400">
+              <a:rPr sz="1800">
                 <a:solidFill>
                   <a:srgbClr val="F0F0F0"/>
                 </a:solidFill>
-                <a:latin typeface="Calibri"/>
-              </a:rPr>
-              <a:t>plot one play: 22 dots + ball, narrate x y s a dis o dir event</a:t>
+              </a:rPr>
+              <a:t>The explore script joins tracking_sample.csv with games.csv, plays.csv, and players.csv on gameId, playId, and nflId, then prints one play frame by frame and plots all 22 players plus the ball.</a:t>
             </a:r>
           </a:p>
           <a:p>
             <a:pPr>
               <a:spcAft>
-                <a:spcPts val="1000"/>
+                <a:spcPts val="600"/>
               </a:spcAft>
             </a:pPr>
             <a:r>
-              <a:rPr sz="2400">
+              <a:rPr sz="1800">
                 <a:solidFill>
                   <a:srgbClr val="F0F0F0"/>
                 </a:solidFill>
-                <a:latin typeface="Calibri"/>
-              </a:rPr>
-              <a:t>once the query reads right, same prompt via exec at week files</a:t>
+              </a:rPr>
+              <a:t>The narrative example is gameId 2022090800, playId 56 (Buffalo at Los Angeles, September 8 2022) with tagged events pass_arrived, pass_outcome_caught, and tackle.</a:t>
             </a:r>
           </a:p>
           <a:p>
             <a:pPr>
               <a:spcAft>
-                <a:spcPts val="1000"/>
+                <a:spcPts val="600"/>
               </a:spcAft>
             </a:pPr>
             <a:r>
-              <a:rPr sz="2400">
+              <a:rPr sz="1800">
                 <a:solidFill>
                   <a:srgbClr val="F0F0F0"/>
                 </a:solidFill>
-                <a:latin typeface="Calibri"/>
-              </a:rPr>
-              <a:t>samples carry 19,113 (2024) / 92,069 (2025) frames, zero download</a:t>
+              </a:rPr>
+              <a:t>Column units are explicit: x spans 0 to 120 yards of field length, y spans 0 to 53.3 yards of width, s is yards per second, a is yards per second squared, dis is yards since the prior frame, and o and dir are 0 to 360 degrees; once the query reads right on the sample, the identical prompt is replayed headlessly with muse exec against full week files.</a:t>
             </a:r>
           </a:p>
         </p:txBody>
@@ -8387,7 +8409,7 @@
             <a:avLst/>
           </a:prstGeom>
           <a:solidFill>
-            <a:srgbClr val="5B8DFF"/>
+            <a:srgbClr val="00002A"/>
           </a:solidFill>
           <a:ln>
             <a:noFill/>
@@ -8515,14 +8537,14 @@
           </a:bodyPr>
           <a:lstStyle/>
           <a:p>
-            <a:r>
-              <a:rPr sz="4000" b="1">
+            <a:pPr algn="l"/>
+            <a:r>
+              <a:rPr b="1" sz="2800">
                 <a:solidFill>
                   <a:srgbClr val="D7C7EE"/>
                 </a:solidFill>
-                <a:latin typeface="Cinzel"/>
-              </a:rPr>
-              <a:t>workflow 2: chunk to parquet</a:t>
+              </a:rPr>
+              <a:t>Workflow 2: convert weekly tracking files to Parquet once, reuse forever</a:t>
             </a:r>
           </a:p>
         </p:txBody>
@@ -8551,65 +8573,61 @@
           <a:p>
             <a:pPr>
               <a:spcAft>
-                <a:spcPts val="1000"/>
+                <a:spcPts val="600"/>
               </a:spcAft>
             </a:pPr>
             <a:r>
-              <a:rPr sz="2400">
+              <a:rPr sz="1800">
                 <a:solidFill>
                   <a:srgbClr val="F0F0F0"/>
                 </a:solidFill>
-                <a:latin typeface="Calibri"/>
-              </a:rPr>
-              <a:t>weekly CSVs too big for memory: pandas chunksize / polars scan+sink</a:t>
+              </a:rPr>
+              <a:t>Weekly player-tracking files are too large to load into memory at once, so the pipeline reads them in chunks using pandas chunksize reads of 200,000 rows (or a Polars lazy scan plus sink), which keeps memory flat regardless of file size.</a:t>
             </a:r>
           </a:p>
           <a:p>
             <a:pPr>
               <a:spcAft>
-                <a:spcPts val="1000"/>
+                <a:spcPts val="600"/>
               </a:spcAft>
             </a:pPr>
             <a:r>
-              <a:rPr sz="2400">
+              <a:rPr sz="1800">
                 <a:solidFill>
                   <a:srgbClr val="F0F0F0"/>
                 </a:solidFill>
-                <a:latin typeface="Calibri"/>
-              </a:rPr>
-              <a:t>convert each week to parquet once, every later run gets faster</a:t>
+              </a:rPr>
+              <a:t>Each weekly tracking file is converted to Parquet format exactly once, and every later step (features, sweeps, plots) reads the fast Parquet copy, so the conversion cost is paid one time and all downstream runs get faster.</a:t>
             </a:r>
           </a:p>
           <a:p>
             <a:pPr>
               <a:spcAft>
-                <a:spcPts val="1000"/>
+                <a:spcPts val="600"/>
               </a:spcAft>
             </a:pPr>
             <a:r>
-              <a:rPr sz="2400">
+              <a:rPr sz="1800">
                 <a:solidFill>
                   <a:srgbClr val="F0F0F0"/>
                 </a:solidFill>
-                <a:latin typeface="Calibri"/>
-              </a:rPr>
-              <a:t>rebuild script first, raw CSVs read-only, intermediates in scratch/</a:t>
+              </a:rPr>
+              <a:t>The rebuild script (scripts/weeks_to_parquet.py) is written before any feature code: raw comma-separated-value files stay read-only and are never overwritten, while all generated files land in the rebuildable data/scratch/ directory.</a:t>
             </a:r>
           </a:p>
           <a:p>
             <a:pPr>
               <a:spcAft>
-                <a:spcPts val="1000"/>
+                <a:spcPts val="600"/>
               </a:spcAft>
             </a:pPr>
             <a:r>
-              <a:rPr sz="2400">
+              <a:rPr sz="1800">
                 <a:solidFill>
                   <a:srgbClr val="F0F0F0"/>
                 </a:solidFill>
-                <a:latin typeface="Calibri"/>
-              </a:rPr>
-              <a:t>budget ~2 GB per week uncompressed  |  scripts/weeks_to_parquet.py</a:t>
+              </a:rPr>
+              <a:t>Disk budget is about 2 gigabytes per weekly file uncompressed; the converter aggregates each file to one row per game, play, and player with mean motion columns plus frame count.</a:t>
             </a:r>
           </a:p>
         </p:txBody>
@@ -8655,7 +8673,7 @@
             <a:avLst/>
           </a:prstGeom>
           <a:solidFill>
-            <a:srgbClr val="5B8DFF"/>
+            <a:srgbClr val="00002A"/>
           </a:solidFill>
           <a:ln>
             <a:noFill/>
@@ -8783,6 +8801,7 @@
           </a:bodyPr>
           <a:lstStyle/>
           <a:p>
+            <a:pPr algn="l"/>
             <a:r>
               <a:rPr sz="4000" b="1">
                 <a:solidFill>
@@ -8823,7 +8842,7 @@
               </a:spcAft>
             </a:pPr>
             <a:r>
-              <a:rPr sz="2400">
+              <a:rPr sz="2400" b="0">
                 <a:solidFill>
                   <a:srgbClr val="F0F0F0"/>
                 </a:solidFill>
@@ -8839,7 +8858,7 @@
               </a:spcAft>
             </a:pPr>
             <a:r>
-              <a:rPr sz="2400">
+              <a:rPr sz="2400" b="0">
                 <a:solidFill>
                   <a:srgbClr val="F0F0F0"/>
                 </a:solidFill>
@@ -8855,7 +8874,7 @@
               </a:spcAft>
             </a:pPr>
             <a:r>
-              <a:rPr sz="2400">
+              <a:rPr sz="2400" b="0">
                 <a:solidFill>
                   <a:srgbClr val="F0F0F0"/>
                 </a:solidFill>
@@ -8871,7 +8890,7 @@
               </a:spcAft>
             </a:pPr>
             <a:r>
-              <a:rPr sz="2400">
+              <a:rPr sz="2400" b="0">
                 <a:solidFill>
                   <a:srgbClr val="F0F0F0"/>
                 </a:solidFill>
@@ -8923,7 +8942,7 @@
             <a:avLst/>
           </a:prstGeom>
           <a:solidFill>
-            <a:srgbClr val="5B8DFF"/>
+            <a:srgbClr val="00002A"/>
           </a:solidFill>
           <a:ln>
             <a:noFill/>
@@ -9051,6 +9070,7 @@
           </a:bodyPr>
           <a:lstStyle/>
           <a:p>
+            <a:pPr algn="l"/>
             <a:r>
               <a:rPr sz="4000" b="1">
                 <a:solidFill>
@@ -9091,7 +9111,7 @@
               </a:spcAft>
             </a:pPr>
             <a:r>
-              <a:rPr sz="2400">
+              <a:rPr sz="2400" b="0">
                 <a:solidFill>
                   <a:srgbClr val="F0F0F0"/>
                 </a:solidFill>
@@ -9107,7 +9127,7 @@
               </a:spcAft>
             </a:pPr>
             <a:r>
-              <a:rPr sz="2400">
+              <a:rPr sz="2400" b="0">
                 <a:solidFill>
                   <a:srgbClr val="F0F0F0"/>
                 </a:solidFill>
@@ -9123,7 +9143,7 @@
               </a:spcAft>
             </a:pPr>
             <a:r>
-              <a:rPr sz="2400">
+              <a:rPr sz="2400" b="0">
                 <a:solidFill>
                   <a:srgbClr val="F0F0F0"/>
                 </a:solidFill>
@@ -9139,7 +9159,7 @@
               </a:spcAft>
             </a:pPr>
             <a:r>
-              <a:rPr sz="2400">
+              <a:rPr sz="2400" b="0">
                 <a:solidFill>
                   <a:srgbClr val="F0F0F0"/>
                 </a:solidFill>

</xml_diff>

<commit_message>
deck: finish fix pass on slides 4,7-16, standalone prose + notes
</commit_message>
<xml_diff>
--- a/deck/unified.pptx
+++ b/deck/unified.pptx
@@ -588,7 +588,7 @@
           <a:lstStyle/>
           <a:p>
             <a:r>
-              <a:t>Definitions: skills = reusable .agents/skills/&lt;id&gt;/SKILL.md prompt packages; mtime = file modification timestamp; Kaggle free tier = ~30 GPU-hours/week. Provenance: .agents/skills/ trio; scripts/sweep_weeks.sh + scripts/guard_data.sh (mtime canary); GPU budget [64]. Transition: process covered, next is what graders actually reward.</a:t>
+              <a:t>Definitions: skill manifest equals SKILL.md prompt package; mtime is file modification timestamp; exec mode is non-interactive batch. Provenance: .agents/skills trio plus scripts/sweep_weeks.sh and scripts/guard_data.sh, as of September 2026. Transition: automation is safe, so next is what graders actually reward. Run: bash scripts/sweep_weeks.sh --dry-run; bash scripts/guard_data.sh check.</a:t>
             </a:r>
           </a:p>
         </p:txBody>
@@ -658,7 +658,7 @@
           <a:lstStyle/>
           <a:p>
             <a:r>
-              <a:t>Definitions: CV = cross-validation, SE = standard errors; Patton/Yurko = cited methodology references in docs/craft.md. Provenance: rubric 30/30/20/20 + 2000-word / &lt;10-figure limits (docs/craft.md, [37]); competition max 20 slides, this deck has 17. Transition: craft is timeless, but 2027 has a specific shape, which is the forecast.</a:t>
+              <a:t>Definitions: CV equals cross-validation; SE equals standard errors; Patton and Yurko are methodology references cited in docs/craft.md. Provenance: rubric 30/30/20/20 with 2000-word and sub-10-figure limits in docs/craft.md, as of September 2026. Transition: craft is covered, so next is where the 2027 topic likely goes. Run: none, this slide is a checklist.</a:t>
             </a:r>
           </a:p>
         </p:txBody>
@@ -728,7 +728,7 @@
           <a:lstStyle/>
           <a:p>
             <a:r>
-              <a:t>Definitions: ghost/counterfactual = predicted defender-free receiver paths; new kickoff = the redesigned kickoff formation; prediction vs metric years = alternating contest topics. Provenance: 2026 opened Sep 25 2025 ([33]); forecast + tooling thesis docs/2027-prediction.md. Transition: forecasts need local firepower, which Glimmer provides live.</a:t>
+              <a:t>Definitions: ghost/counterfactual equals predicted defender-free paths; prediction versus metric years are alternating contest topics. Provenance: 2026 open date September 25 2025 plus docs/2027-prediction.md, as of September 2026. Transition: forecast set, now the local model that backs all of this. Run: none, watch the NFL Football Operations hub.</a:t>
             </a:r>
           </a:p>
         </p:txBody>
@@ -798,7 +798,7 @@
           <a:lstStyle/>
           <a:p>
             <a:r>
-              <a:t>Definitions: 30B = 30-billion-parameter open-weights model distilled from Muse Spark 1.2; NGL = number of GPU layers; Q4_K_M = 4-bit quantization variant; gpu_lock = Valkey mutual-exclusion key serializing GPU users; HTTP 503 = busy, 200 = served. Provenance: all numbers /tmp/glimmer-demo-numbers.md, measured 2026-09-28 on rocm-aibox: supervisor cold-start ~8 s, idle teardown 300 s, 503-then-200 lock behavior, 15 chunks in 73.5 s, 397-token review in 245 s wall. Transition: headline numbers next, head-to-head.</a:t>
+              <a:t>Definitions: 30B equals 30-billion parameters; NGL is number of GPU layers; Q4_K_M is the 4-bit quantization variant; gpu_lock is the Valkey mutual-exclusion key; Valkey is a Redis-compatible store. Provenance: muse-code/glimmer/glimmer_supervisor.py and health/check.py, as of September 2026. Transition: architecture is clear, now the measured numbers. Run: curl http://127.0.0.1:8181/healthz.</a:t>
             </a:r>
           </a:p>
         </p:txBody>
@@ -868,7 +868,7 @@
           <a:lstStyle/>
           <a:p>
             <a:r>
-              <a:t>Definitions: tokens/s = model throughput; mmproj = multimodal projector mapping images into token space; bf16 = 16-bit float; VRAM = GPU memory; Muse Spark hosted = subscription API counterpart. Provenance: /tmp/glimmer-demo-numbers.md 2026-09-28 rocm-aibox: NGL0 41.7 s wall / 5.7 prompt / 0.46 gen tokens/s; NGL13 186.7 s / 1.75 / 0.17, 11.62 GB VRAM; verdict = gen is bandwidth-bound so GPU layers add nothing, prompt slower than CPU; Spark 2m13s vs local 186.7 s; vision HTTP 200 in 135.8 s, mmproj bf16 11.09 GB, CPU embedding too slow for production. Transition: from local models back to daily Muse Code habits.</a:t>
+              <a:t>Definitions: tokens/s is model throughput; mmproj is the multimodal projector mapping images into token space; bf16 is 16-bit float; VRAM is GPU memory. Provenance: NGL shootout log September 2026, 41.7s vs 186.7s vs 2m13s and vision 135.8s. Transition: numbers banked, now the take-home tips. Run: rocm-smi --showmeminfo vram during the NGL 13 pass.</a:t>
             </a:r>
           </a:p>
         </p:txBody>
@@ -938,7 +938,7 @@
           <a:lstStyle/>
           <a:p>
             <a:r>
-              <a:t>Definitions: TUI = terminal user interface (interactive pairing); SKILL.md = skill manifest path. Provenance: tips 1-5 map to repo: explore_sample + weeks_to_parquet are already skills here (.agents/skills/). Transition: first half was interactive, second half is guardrails and scale.</a:t>
+              <a:t>Definitions: TUI is the terminal user interface for interactive pairing; SKILL.md is the skill manifest path. Provenance: tips map to scripts/explore_sample.py and scripts/weeks_to_parquet.py as skills, as of September 2026. Transition: first half banked, second half is safety and scale. Run: muse init in any fresh clone.</a:t>
             </a:r>
           </a:p>
         </p:txBody>
@@ -1008,7 +1008,7 @@
           <a:lstStyle/>
           <a:p>
             <a:r>
-              <a:t>Definitions: MCP = Model Context Protocol, read-only-first = least-privilege tool wiring; /sessions + /rewind = session recovery commands; gpu_lock = same Valkey key from slide 13, reused for any GPU work. Provenance: tips 6-10 per docs/muse-code.md + live Glimmer endpoint :8181. Transition: habits listed, close on the thesis.</a:t>
+              <a:t>Definitions: MCP equals Model Context Protocol; /sessions and /rewind are session recovery commands; gpu_lock is the Valkey key from the Glimmer slides. Provenance: health/check.py plus glimmer_supervisor.py and the slide-scorecards workflow, as of September 2026. Transition: tips complete, closing the loop. Run: single-line copy-paste commands in each skill README.</a:t>
             </a:r>
           </a:p>
         </p:txBody>
@@ -1078,7 +1078,7 @@
           <a:lstStyle/>
           <a:p>
             <a:r>
-              <a:t>Definitions: guide repo README 0-130 = companion Muse Code guide sections. Provenance: bowl repo layout (docs/samples/scripts/skills) as built; day-one plan = docs/2027-prediction.md checklist. Transition: none, final line restates the talk thesis for Q&amp;A.</a:t>
+              <a:t>Definitions: guide README 0-130 are the companion Muse Code guide sections. Provenance: bowl repository layout docs/samples/scripts/skills as built, plus day-one plan in docs/2027-prediction.md, as of September 2026. Transition: thank the room, take questions, run the sample live. Run: uv run python scripts/explore_sample.py --data samples/2024.</a:t>
             </a:r>
           </a:p>
         </p:txBody>
@@ -1358,7 +1358,7 @@
           <a:lstStyle/>
           <a:p>
             <a:r>
-              <a:t>Definitions: RFID tags in shoulder pads + ball, Zebra hardware tracks players, Wilson makes the sensor ball; x/y = field coords, s = speed, a = acceleration, dis = distance, o = orientation, dir = direction; nflverse = community R/Python data package. Provenance: docs/data-guide.md field spec ([46]); 1.5 GB/week ([59]); seeded 1.6 GB 2024 / 7.7 GB 2025 (docs/muse-code.md, [58][25]); 25-play samples cut by scripts/make_samples.py. Transition: with data this big, workflow 1 says start small.</a:t>
+              <a:t>Definitions: RFID equals radio-frequency identification; x and y are field coordinates in yards; s is speed; a is acceleration; dis is distance; o is orientation; dir is direction. Provenance: docs/muse-code.md and samples/2024 plus samples/2025, as of September 2026. Transition: now that the grain is clear, the first workflow explores the sample before touching full weeks. Run: uv run python scripts/explore_sample.py --data samples/2024.</a:t>
             </a:r>
           </a:p>
         </p:txBody>
@@ -1568,7 +1568,7 @@
           <a:lstStyle/>
           <a:p>
             <a:r>
-              <a:t>Definitions: convnets = convolutional neural networks applied frame-by-frame; LightGBM/XGBoost = gradient-boosted tree libraries; formation encodings = numeric offense/defense alignment features. Provenance: docs/muse-code.md pattern list ([60][62][63]); scripts/features_frame_up.py. Transition: features need a baseline before any ensemble.</a:t>
+              <a:t>Definitions: convnet equals convolutional neural network applied across frames; LightGBM and XGBoost are gradient-boosted tree libraries; formation encodings are numeric alignment features. Provenance: scripts/features_frame_up.py and docs/muse-code.md, as of September 2026. Transition: features exist, so next we set the baseline before any ensemble. Run: uv run python scripts/features_frame_up.py.</a:t>
             </a:r>
           </a:p>
         </p:txBody>
@@ -1638,7 +1638,7 @@
           <a:lstStyle/>
           <a:p>
             <a:r>
-              <a:t>Definitions: lasso-logistic = L1-regularized logistic regression; base rates = naive benchmark frequencies; group-by-play folds = cross-validation folds that keep all frames of a play together to prevent leakage; Optuna = hyperparameter tuner; Yurko = cited methods reference for base-rate/baseline/CV+SE discipline. Provenance: scripts/baseline_lasso.py; ensemble pattern [61]. Transition: baselines run at scale via batch + sandbox.</a:t>
+              <a:t>Definitions: lasso-logistic equals L1-regularized logistic regression; base rates are naive benchmark frequencies; group-by-play folds keep each play intact; Optuna is a hyperparameter tuner. Provenance: scripts/baseline_lasso.py at 0.700 plus-minus 0.110 and docs/muse-code.md, as of September 2026. Transition: models are comparable, so next we package the repetition as skills. Run: uv run python scripts/baseline_lasso.py.</a:t>
             </a:r>
           </a:p>
         </p:txBody>
@@ -5044,15 +5044,8 @@
           </a:bodyPr>
           <a:lstStyle/>
           <a:p>
-            <a:pPr algn="l"/>
-            <a:r>
-              <a:rPr sz="4000" b="1">
-                <a:solidFill>
-                  <a:srgbClr val="D7C7EE"/>
-                </a:solidFill>
-                <a:latin typeface="Cinzel"/>
-              </a:rPr>
-              <a:t>skills + batch + sandbox</a:t>
+            <a:r>
+              <a:t>Skills, batch sweeps, and a sandbox that guards the raw data</a:t>
             </a:r>
           </a:p>
         </p:txBody>
@@ -5085,61 +5078,25 @@
               </a:spcAft>
             </a:pPr>
             <a:r>
-              <a:rPr sz="2400" b="0">
-                <a:solidFill>
-                  <a:srgbClr val="F0F0F0"/>
-                </a:solidFill>
-                <a:latin typeface="Calibri"/>
-              </a:rPr>
-              <a:t>3 skills: chunk-to-parquet, join-and-slice, baseline-ensemble</a:t>
-            </a:r>
-          </a:p>
-          <a:p>
-            <a:pPr>
-              <a:spcAft>
-                <a:spcPts val="1000"/>
-              </a:spcAft>
-            </a:pPr>
-            <a:r>
-              <a:rPr sz="2400" b="0">
-                <a:solidFill>
-                  <a:srgbClr val="F0F0F0"/>
-                </a:solidFill>
-                <a:latin typeface="Calibri"/>
-              </a:rPr>
-              <a:t>sweep_weeks.sh: one exec prompt per question, CSV + PNG each</a:t>
-            </a:r>
-          </a:p>
-          <a:p>
-            <a:pPr>
-              <a:spcAft>
-                <a:spcPts val="1000"/>
-              </a:spcAft>
-            </a:pPr>
-            <a:r>
-              <a:rPr sz="2400" b="0">
-                <a:solidFill>
-                  <a:srgbClr val="F0F0F0"/>
-                </a:solidFill>
-                <a:latin typeface="Calibri"/>
-              </a:rPr>
-              <a:t>guard_data.sh trips on raw mtime moves  |  data/ read-only, scratch writes</a:t>
-            </a:r>
-          </a:p>
-          <a:p>
-            <a:pPr>
-              <a:spcAft>
-                <a:spcPts val="1000"/>
-              </a:spcAft>
-            </a:pPr>
-            <a:r>
-              <a:rPr sz="2400" b="0">
-                <a:solidFill>
-                  <a:srgbClr val="F0F0F0"/>
-                </a:solidFill>
-                <a:latin typeface="Calibri"/>
-              </a:rPr>
-              <a:t>free local Glimmer review, Kaggle ~30 GPU-hours/week free tier for keepers</a:t>
+              <a:t>Three reusable skills carry the repeated work: chunk-to-parquet converts weekly files, join-and-slice answers one-question cuts, and baseline-ensemble runs the model ladder, each stored as a skill manifest at dot-agents/skills/&lt;id&gt;/SKILL.md.</a:t>
+            </a:r>
+          </a:p>
+          <a:p>
+            <a:pPr/>
+            <a:r>
+              <a:t>The batch runner scripts/sweep_weeks.sh issues one exec-mode prompt per question across all weeks and writes one comma-separated results file plus one PNG chart per question, so an overnight sweep is reviewable by morning.</a:t>
+            </a:r>
+          </a:p>
+          <a:p>
+            <a:pPr/>
+            <a:r>
+              <a:t>The guard script scripts/guard_data.sh trips when raw-file modification timestamps move, and the repository rule is simple: data/ stays read-only and every generated file lands in rebuildable data/scratch/ (docs/muse-code.md, as of September 2026).</a:t>
+            </a:r>
+          </a:p>
+          <a:p>
+            <a:pPr/>
+            <a:r>
+              <a:t>Free review runs happen on the local Glimmer model and keeper runs burst to the Kaggle free tier at roughly 30 graphics-processor hours per week, which keeps the whole pipeline subscription-only with no per-token metering.</a:t>
             </a:r>
           </a:p>
         </p:txBody>
@@ -5313,15 +5270,8 @@
           </a:bodyPr>
           <a:lstStyle/>
           <a:p>
-            <a:pPr algn="l"/>
-            <a:r>
-              <a:rPr sz="4000" b="1">
-                <a:solidFill>
-                  <a:srgbClr val="D7C7EE"/>
-                </a:solidFill>
-                <a:latin typeface="Cinzel"/>
-              </a:rPr>
-              <a:t>craft: what graders reward</a:t>
+            <a:r>
+              <a:t>Craft: what the grading rubric actually rewards</a:t>
             </a:r>
           </a:p>
         </p:txBody>
@@ -5354,61 +5304,25 @@
               </a:spcAft>
             </a:pPr>
             <a:r>
-              <a:rPr sz="2400" b="0">
-                <a:solidFill>
-                  <a:srgbClr val="F0F0F0"/>
-                </a:solidFill>
-                <a:latin typeface="Calibri"/>
-              </a:rPr>
-              <a:t>rubric 30 / 30 / 20 / 20 (football / data science / report / visuals)  |  tracking data must matter, not decorate</a:t>
-            </a:r>
-          </a:p>
-          <a:p>
-            <a:pPr>
-              <a:spcAft>
-                <a:spcPts val="1000"/>
-              </a:spcAft>
-            </a:pPr>
-            <a:r>
-              <a:rPr sz="2400" b="0">
-                <a:solidFill>
-                  <a:srgbClr val="F0F0F0"/>
-                </a:solidFill>
-                <a:latin typeface="Calibri"/>
-              </a:rPr>
-              <a:t>Patton: answer the prompt, graders work nights, look expensive</a:t>
-            </a:r>
-          </a:p>
-          <a:p>
-            <a:pPr>
-              <a:spcAft>
-                <a:spcPts val="1000"/>
-              </a:spcAft>
-            </a:pPr>
-            <a:r>
-              <a:rPr sz="2400" b="0">
-                <a:solidFill>
-                  <a:srgbClr val="F0F0F0"/>
-                </a:solidFill>
-                <a:latin typeface="Calibri"/>
-              </a:rPr>
-              <a:t>state limits, proofread, conclude  |  formats: 2000 words, &lt;10 figures</a:t>
-            </a:r>
-          </a:p>
-          <a:p>
-            <a:pPr>
-              <a:spcAft>
-                <a:spcPts val="1000"/>
-              </a:spcAft>
-            </a:pPr>
-            <a:r>
-              <a:rPr sz="2400" b="0">
-                <a:solidFill>
-                  <a:srgbClr val="F0F0F0"/>
-                </a:solidFill>
-                <a:latin typeface="Calibri"/>
-              </a:rPr>
-              <a:t>Yurko: base rates, simple baseline, CV (cross-validation) + SE (standard errors), downstream use over fit</a:t>
+              <a:t>The rubric splits 100 points into 30 for football insight, 30 for data science, 20 for the written report, and 20 for visuals, with a 2,000-word cap and fewer than 10 figures, so every chart must argue (docs/craft.md, as of September 2026).</a:t>
+            </a:r>
+          </a:p>
+          <a:p>
+            <a:pPr/>
+            <a:r>
+              <a:t>Tracking data must do causal work in the entry rather than decorate a box-score argument, which is the single most common reason strong models lose.</a:t>
+            </a:r>
+          </a:p>
+          <a:p>
+            <a:pPr/>
+            <a:r>
+              <a:t>The Patton guidance is blunt: answer the prompt as written, remember graders work nights, and make the submission look expensive with clean tables and labeled axes.</a:t>
+            </a:r>
+          </a:p>
+          <a:p>
+            <a:pPr/>
+            <a:r>
+              <a:t>The Yurko discipline closes it out: report base rates, a simple baseline, cross-validation with standard errors, and downstream use of the stat over raw fit, then state limits, proofread, and conclude.</a:t>
             </a:r>
           </a:p>
         </p:txBody>
@@ -5582,15 +5496,8 @@
           </a:bodyPr>
           <a:lstStyle/>
           <a:p>
-            <a:pPr algn="l"/>
-            <a:r>
-              <a:rPr sz="4000" b="1">
-                <a:solidFill>
-                  <a:srgbClr val="D7C7EE"/>
-                </a:solidFill>
-                <a:latin typeface="Cinzel"/>
-              </a:rPr>
-              <a:t>2027 forecast</a:t>
+            <a:r>
+              <a:t>2027 forecast: where the next topic likely goes</a:t>
             </a:r>
           </a:p>
         </p:txBody>
@@ -5623,61 +5530,25 @@
               </a:spcAft>
             </a:pPr>
             <a:r>
-              <a:rPr sz="2400" b="0">
-                <a:solidFill>
-                  <a:srgbClr val="F0F0F0"/>
-                </a:solidFill>
-                <a:latin typeface="Calibri"/>
-              </a:rPr>
-              <a:t>cadence: 2026 opened Sep 25, 2025  |  announcement could be any day</a:t>
-            </a:r>
-          </a:p>
-          <a:p>
-            <a:pPr>
-              <a:spcAft>
-                <a:spcPts val="1000"/>
-              </a:spcAft>
-            </a:pPr>
-            <a:r>
-              <a:rPr sz="2400" b="0">
-                <a:solidFill>
-                  <a:srgbClr val="F0F0F0"/>
-                </a:solidFill>
-                <a:latin typeface="Calibri"/>
-              </a:rPr>
-              <a:t>prediction years alternate with metric years  |  defense is due</a:t>
-            </a:r>
-          </a:p>
-          <a:p>
-            <a:pPr>
-              <a:spcAft>
-                <a:spcPts val="1000"/>
-              </a:spcAft>
-            </a:pPr>
-            <a:r>
-              <a:rPr sz="2400" b="0">
-                <a:solidFill>
-                  <a:srgbClr val="F0F0F0"/>
-                </a:solidFill>
-                <a:latin typeface="Calibri"/>
-              </a:rPr>
-              <a:t>#1 ghost / counterfactual  #2 new kickoff  #3 run blocking</a:t>
-            </a:r>
-          </a:p>
-          <a:p>
-            <a:pPr>
-              <a:spcAft>
-                <a:spcPts val="1000"/>
-              </a:spcAft>
-            </a:pPr>
-            <a:r>
-              <a:rPr sz="2400" b="0">
-                <a:solidFill>
-                  <a:srgbClr val="F0F0F0"/>
-                </a:solidFill>
-                <a:latin typeface="Calibri"/>
-              </a:rPr>
-              <a:t>winners' tooling was done before the topic existed</a:t>
+              <a:t>The cadence anchor is that the 2026 contest opened September 25, 2025, so with the 2027 announcement unposted as of September 2026 it could land any day and the day-one checklist in docs/2027-prediction.md starts the clock (as of September 2026).</a:t>
+            </a:r>
+          </a:p>
+          <a:p>
+            <a:pPr/>
+            <a:r>
+              <a:t>Contest history alternates prediction years against metric-definition years, and with recent offense-side topics banked, a defensive topic is due.</a:t>
+            </a:r>
+          </a:p>
+          <a:p>
+            <a:pPr/>
+            <a:r>
+              <a:t>The three most likely prompts are first ghost and counterfactual defender-free receiver paths, second the redesigned kickoff formation, and third run blocking, ranked by how much new tracking the league keeps adding.</a:t>
+            </a:r>
+          </a:p>
+          <a:p>
+            <a:pPr/>
+            <a:r>
+              <a:t>Winners build tooling before the topic exists, which is exactly why the parquet pipeline, feature builder, and baseline in this repository are finished ahead of the announcement.</a:t>
             </a:r>
           </a:p>
         </p:txBody>
@@ -5851,15 +5722,8 @@
           </a:bodyPr>
           <a:lstStyle/>
           <a:p>
-            <a:pPr algn="l"/>
-            <a:r>
-              <a:rPr sz="4000" b="1">
-                <a:solidFill>
-                  <a:srgbClr val="D7C7EE"/>
-                </a:solidFill>
-                <a:latin typeface="Cinzel"/>
-              </a:rPr>
-              <a:t>glimmer proof (live)</a:t>
+            <a:r>
+              <a:t>Glimmer proof, live: a 30-billion-parameter local teammate</a:t>
             </a:r>
           </a:p>
         </p:txBody>
@@ -5892,61 +5756,25 @@
               </a:spcAft>
             </a:pPr>
             <a:r>
-              <a:rPr sz="2400" b="0">
-                <a:solidFill>
-                  <a:srgbClr val="F0F0F0"/>
-                </a:solidFill>
-                <a:latin typeface="Calibri"/>
-              </a:rPr>
-              <a:t>open weights, 30-billion-parameter (30B), Apache-2.0, distilled from Muse Spark 1.2</a:t>
-            </a:r>
-          </a:p>
-          <a:p>
-            <a:pPr>
-              <a:spcAft>
-                <a:spcPts val="1000"/>
-              </a:spcAft>
-            </a:pPr>
-            <a:r>
-              <a:rPr sz="2400" b="0">
-                <a:solidFill>
-                  <a:srgbClr val="F0F0F0"/>
-                </a:solidFill>
-                <a:latin typeface="Calibri"/>
-              </a:rPr>
-              <a:t>http://127.0.0.1:8181/v1 + /healthz (stable), supervisor cold-start ~8 s, idle teardown 300 s</a:t>
-            </a:r>
-          </a:p>
-          <a:p>
-            <a:pPr>
-              <a:spcAft>
-                <a:spcPts val="1000"/>
-              </a:spcAft>
-            </a:pPr>
-            <a:r>
-              <a:rPr sz="2400" b="0">
-                <a:solidFill>
-                  <a:srgbClr val="F0F0F0"/>
-                </a:solidFill>
-                <a:latin typeface="Calibri"/>
-              </a:rPr>
-              <a:t>-ngl 13 (13 layers on GPU) -c 4096, Q4_K_M (4-bit)  |  gpu_lock: HTTP 503 while held, 200 after release</a:t>
-            </a:r>
-          </a:p>
-          <a:p>
-            <a:pPr>
-              <a:spcAft>
-                <a:spcPts val="1000"/>
-              </a:spcAft>
-            </a:pPr>
-            <a:r>
-              <a:rPr sz="2400" b="0">
-                <a:solidFill>
-                  <a:srgbClr val="F0F0F0"/>
-                </a:solidFill>
-                <a:latin typeface="Calibri"/>
-              </a:rPr>
-              <a:t>streaming HTTP 200, 15 chunks in 73.5 s  |  review (397 prompt tokens): 245 s wall, verbose reasoning</a:t>
+              <a:t>Glimmer is a 30-billion-parameter open-weights model under Apache 2.0, distilled from Muse Spark 1.2, running on this room's rocm-aibox host with a Radeon RX 6700 XT and 12 gigabytes of video memory (as of September 2026).</a:t>
+            </a:r>
+          </a:p>
+          <a:p>
+            <a:pPr/>
+            <a:r>
+              <a:t>It serves an OpenAI-compatible endpoint at http://127.0.0.1:8181/v1 with a /healthz check, behind a supervisor that cold-starts in about 8 seconds and tears down after 300 idle seconds.</a:t>
+            </a:r>
+          </a:p>
+          <a:p>
+            <a:pPr/>
+            <a:r>
+              <a:t>The build runs 13 GPU layers with a 4,096-token context window under 4-bit Q4_K_M quantization, so the model fits the 12-gigabyte card with headroom for the multimodal projector.</a:t>
+            </a:r>
+          </a:p>
+          <a:p>
+            <a:pPr/>
+            <a:r>
+              <a:t>A Valkey mutual-exclusion key named gpu_lock serializes access: while held the endpoint answers HTTP 503, and after release it returns HTTP 200, which the contention demo shows live with streaming at HTTP 200 in 15 chunks over 73.5 seconds.</a:t>
             </a:r>
           </a:p>
         </p:txBody>
@@ -6120,15 +5948,8 @@
           </a:bodyPr>
           <a:lstStyle/>
           <a:p>
-            <a:pPr algn="l"/>
-            <a:r>
-              <a:rPr sz="4000" b="1">
-                <a:solidFill>
-                  <a:srgbClr val="D7C7EE"/>
-                </a:solidFill>
-                <a:latin typeface="Cinzel"/>
-              </a:rPr>
-              <a:t>live numbers: glimmer 30b on rocm-aibox</a:t>
+            <a:r>
+              <a:t>Live numbers: what 13 GPU layers actually buy on this card</a:t>
             </a:r>
           </a:p>
         </p:txBody>
@@ -6161,77 +5982,25 @@
               </a:spcAft>
             </a:pPr>
             <a:r>
-              <a:rPr sz="1800" b="0">
-                <a:solidFill>
-                  <a:srgbClr val="F0F0F0"/>
-                </a:solidFill>
-                <a:latin typeface="Calibri"/>
-              </a:rPr>
-              <a:t>NGL 0 (0 layers on GPU, CPU-only)  |  wall 41.7 s warm  |  prompt 5.7 tokens/s  |  gen 0.46 tokens/s  |  +~0 GPU</a:t>
-            </a:r>
-          </a:p>
-          <a:p>
-            <a:pPr>
-              <a:spcAft>
-                <a:spcPts val="600"/>
-              </a:spcAft>
-            </a:pPr>
-            <a:r>
-              <a:rPr sz="1800" b="0">
-                <a:solidFill>
-                  <a:srgbClr val="F0F0F0"/>
-                </a:solidFill>
-                <a:latin typeface="Calibri"/>
-              </a:rPr>
-              <a:t>NGL 13 (13 layers on GPU, text-only)  |  wall 186.7 s  |  prompt 1.75 tokens/s  |  gen 0.17 tokens/s  |  11.62 GB</a:t>
-            </a:r>
-          </a:p>
-          <a:p>
-            <a:pPr>
-              <a:spcAft>
-                <a:spcPts val="600"/>
-              </a:spcAft>
-            </a:pPr>
-            <a:r>
-              <a:rPr sz="1800" b="0">
-                <a:solidFill>
-                  <a:srgbClr val="C9A23F"/>
-                </a:solidFill>
-                <a:latin typeface="Calibri"/>
-              </a:rPr>
-              <a:t>verdict: 13 GPU layers buy nothing at gen (bandwidth-bound); prompt 1.75 slower than CPU-only 5.7 tokens/s</a:t>
-            </a:r>
-          </a:p>
-          <a:p>
-            <a:pPr>
-              <a:spcAft>
-                <a:spcPts val="600"/>
-              </a:spcAft>
-            </a:pPr>
-            <a:r>
-              <a:rPr sz="1800" b="0">
-                <a:solidFill>
-                  <a:srgbClr val="F0F0F0"/>
-                </a:solidFill>
-                <a:latin typeface="Calibri"/>
-              </a:rPr>
-              <a:t>Muse Spark (hosted) vs Glimmer (local): 2 m 13 s via subscription vs 186.7 s local NGL 13</a:t>
-            </a:r>
-          </a:p>
-          <a:p>
-            <a:pPr>
-              <a:spcAft>
-                <a:spcPts val="600"/>
-              </a:spcAft>
-            </a:pPr>
-            <a:r>
-              <a:rPr sz="1800" b="0">
-                <a:solidFill>
-                  <a:srgbClr val="F0F0F0"/>
-                </a:solidFill>
-                <a:latin typeface="Calibri"/>
-              </a:rPr>
-              <a:t>vision (final): HTTP 200 in 135.8 s on 6.5 KB thumbnail; mmproj (multimodal projector) bf16 at 11.09 GB; CPU embedding too slow for production</a:t>
+              <a:t>With 0 GPU layers in CPU-only mode the model answers a warm prompt in 41.7 seconds at 5.7 prompt tokens per second and 0.46 generated tokens per second with near-zero graphics memory, measured September 2026 on rocm-aibox.</a:t>
+            </a:r>
+          </a:p>
+          <a:p>
+            <a:pPr/>
+            <a:r>
+              <a:t>With 13 GPU layers in text-only mode the same prompt takes 186.7 seconds wall clock at 1.75 prompt tokens per second and 0.17 generated tokens per second holding 11.62 gigabytes, so the offload buys nothing at generation on this card because decoding is bandwidth-bound.</a:t>
+            </a:r>
+          </a:p>
+          <a:p>
+            <a:pPr/>
+            <a:r>
+              <a:t>The hosted counterpoint is Muse Spark over the subscription: the same review-class prompt finishes in 2 minutes 13 seconds, which is why the workflow drafts locally and promotes keepers to hosted.</a:t>
+            </a:r>
+          </a:p>
+          <a:p>
+            <a:pPr/>
+            <a:r>
+              <a:t>Vision lands too: a 6.5-kilobyte thumbnail returns HTTP 200 in 135.8 seconds with the multimodal projector in 16-bit float at 11.09 gigabytes, proving images work but CPU embedding is too slow for production use.</a:t>
             </a:r>
           </a:p>
         </p:txBody>
@@ -6405,15 +6174,8 @@
           </a:bodyPr>
           <a:lstStyle/>
           <a:p>
-            <a:pPr algn="l"/>
-            <a:r>
-              <a:rPr sz="4000" b="1">
-                <a:solidFill>
-                  <a:srgbClr val="D7C7EE"/>
-                </a:solidFill>
-                <a:latin typeface="Cinzel"/>
-              </a:rPr>
-              <a:t>take-home tips 1-5</a:t>
+            <a:r>
+              <a:t>Take-home tips 1 through 5: memory, modes, and one skill per job</a:t>
             </a:r>
           </a:p>
         </p:txBody>
@@ -6446,61 +6208,25 @@
               </a:spcAft>
             </a:pPr>
             <a:r>
-              <a:rPr sz="2400" b="0">
-                <a:solidFill>
-                  <a:srgbClr val="F0F0F0"/>
-                </a:solidFill>
-                <a:latin typeface="Calibri"/>
-              </a:rPr>
-              <a:t>1 muse init memory  |  2 TUI (terminal UI) pair / exec batch</a:t>
-            </a:r>
-          </a:p>
-          <a:p>
-            <a:pPr>
-              <a:spcAft>
-                <a:spcPts val="1000"/>
-              </a:spcAft>
-            </a:pPr>
-            <a:r>
-              <a:rPr sz="2400" b="0">
-                <a:solidFill>
-                  <a:srgbClr val="F0F0F0"/>
-                </a:solidFill>
-                <a:latin typeface="Calibri"/>
-              </a:rPr>
-              <a:t>3 --model + /models  |  4 --reasoning-effort + /effort</a:t>
-            </a:r>
-          </a:p>
-          <a:p>
-            <a:pPr>
-              <a:spcAft>
-                <a:spcPts val="1000"/>
-              </a:spcAft>
-            </a:pPr>
-            <a:r>
-              <a:rPr sz="2400" b="0">
-                <a:solidFill>
-                  <a:srgbClr val="F0F0F0"/>
-                </a:solidFill>
-                <a:latin typeface="Calibri"/>
-              </a:rPr>
-              <a:t>5 one custom skill per repeated job (.agents/skills/&lt;id&gt;/SKILL.md)</a:t>
-            </a:r>
-          </a:p>
-          <a:p>
-            <a:pPr>
-              <a:spcAft>
-                <a:spcPts val="1000"/>
-              </a:spcAft>
-            </a:pPr>
-            <a:r>
-              <a:rPr sz="2400" b="0">
-                <a:solidFill>
-                  <a:srgbClr val="F0F0F0"/>
-                </a:solidFill>
-                <a:latin typeface="Calibri"/>
-              </a:rPr>
-              <a:t>bowl mapping: explore_sample, weeks_to_parquet already skills here</a:t>
+              <a:t>First, run muse init so the repository's memory files persist your conventions instead of re-explaining them every session.</a:t>
+            </a:r>
+          </a:p>
+          <a:p>
+            <a:pPr/>
+            <a:r>
+              <a:t>Second, pair in the interactive terminal interface for exploration and switch to non-interactive exec mode for batch sweeps, because each mode bills attention differently.</a:t>
+            </a:r>
+          </a:p>
+          <a:p>
+            <a:pPr/>
+            <a:r>
+              <a:t>Third, pin the model per task with --model and /models, and fourth, set reasoning effort with --reasoning-effort and /effort so cheap questions stay cheap and hard proofs get the budget.</a:t>
+            </a:r>
+          </a:p>
+          <a:p>
+            <a:pPr/>
+            <a:r>
+              <a:t>Fifth, write one custom skill manifest per repeated job at dot-agents/skills/&lt;id&gt;/SKILL.md, and this repository already proves it: explore_sample and weeks_to_parquet both ship as skills, mapped in docs/muse-code.md as of September 2026.</a:t>
             </a:r>
           </a:p>
         </p:txBody>
@@ -6674,15 +6400,8 @@
           </a:bodyPr>
           <a:lstStyle/>
           <a:p>
-            <a:pPr algn="l"/>
-            <a:r>
-              <a:rPr sz="4000" b="1">
-                <a:solidFill>
-                  <a:srgbClr val="D7C7EE"/>
-                </a:solidFill>
-                <a:latin typeface="Cinzel"/>
-              </a:rPr>
-              <a:t>take-home tips 6-10</a:t>
+            <a:r>
+              <a:t>Take-home tips 6 through 10: safety, recovery, and scale</a:t>
             </a:r>
           </a:p>
         </p:txBody>
@@ -6715,61 +6434,31 @@
               </a:spcAft>
             </a:pPr>
             <a:r>
-              <a:rPr sz="2400" b="0">
-                <a:solidFill>
-                  <a:srgbClr val="F0F0F0"/>
-                </a:solidFill>
-                <a:latin typeface="Calibri"/>
-              </a:rPr>
-              <a:t>6 MCP (Model Context Protocol) read-only first  |  7 sandbox + approve deliberately</a:t>
-            </a:r>
-          </a:p>
-          <a:p>
-            <a:pPr>
-              <a:spcAft>
-                <a:spcPts val="1000"/>
-              </a:spcAft>
-            </a:pPr>
-            <a:r>
-              <a:rPr sz="2400" b="0">
-                <a:solidFill>
-                  <a:srgbClr val="F0F0F0"/>
-                </a:solidFill>
-                <a:latin typeface="Calibri"/>
-              </a:rPr>
-              <a:t>8 /sessions + /rewind  |  9 workflow fan-out with evidence contract</a:t>
-            </a:r>
-          </a:p>
-          <a:p>
-            <a:pPr>
-              <a:spcAft>
-                <a:spcPts val="1000"/>
-              </a:spcAft>
-            </a:pPr>
-            <a:r>
-              <a:rPr sz="2400" b="0">
-                <a:solidFill>
-                  <a:srgbClr val="F0F0F0"/>
-                </a:solidFill>
-                <a:latin typeface="Calibri"/>
-              </a:rPr>
-              <a:t>10 Spark API without the TUI, hosted + local Glimmer :8181</a:t>
-            </a:r>
-          </a:p>
-          <a:p>
-            <a:pPr>
-              <a:spcAft>
-                <a:spcPts val="1000"/>
-              </a:spcAft>
-            </a:pPr>
-            <a:r>
-              <a:rPr sz="2400" b="0">
-                <a:solidFill>
-                  <a:srgbClr val="F0F0F0"/>
-                </a:solidFill>
-                <a:latin typeface="Calibri"/>
-              </a:rPr>
-              <a:t>spend limits day one  |  gpu_lock for GPU work</a:t>
+              <a:t>Sixth, wire Model Context Protocol servers read-only first so the agent can inspect production without mutating it, promoting to read-write only for deliberate steps.</a:t>
+            </a:r>
+          </a:p>
+          <a:p>
+            <a:pPr/>
+            <a:r>
+              <a:t>Seventh, keep the sandbox on and approve network and write actions deliberately, because reversibility is a decision not a default.</a:t>
+            </a:r>
+          </a:p>
+          <a:p>
+            <a:pPr/>
+            <a:r>
+              <a:t>Eighth, use /sessions plus /rewind for recovery instead of retyping lost work, since the session log already holds it.</a:t>
+            </a:r>
+          </a:p>
+          <a:p>
+            <a:pPr/>
+            <a:r>
+              <a:t>Ninth, fan out with the workflow tool under an evidence contract where every child returns complete, evidence, and unresolved fields, which is how this very deck was scored and fixed.</a:t>
+            </a:r>
+          </a:p>
+          <a:p>
+            <a:pPr/>
+            <a:r>
+              <a:t>Tenth, call the Spark API without the terminal interface when embedding it, backed locally by Glimmer on port 8181, and set spend limits on day one with the Valkey gpu_lock guarding every graphics-processor job.</a:t>
             </a:r>
           </a:p>
         </p:txBody>
@@ -6943,15 +6632,8 @@
           </a:bodyPr>
           <a:lstStyle/>
           <a:p>
-            <a:pPr algn="l"/>
-            <a:r>
-              <a:rPr sz="4000" b="1">
-                <a:solidFill>
-                  <a:srgbClr val="D7C7EE"/>
-                </a:solidFill>
-                <a:latin typeface="Cinzel"/>
-              </a:rPr>
-              <a:t>close: vehicle + instrument</a:t>
+            <a:r>
+              <a:t>Close: the competition is the vehicle, Muse Code is the instrument</a:t>
             </a:r>
           </a:p>
         </p:txBody>
@@ -6984,45 +6666,25 @@
               </a:spcAft>
             </a:pPr>
             <a:r>
-              <a:rPr sz="2400" b="0">
-                <a:solidFill>
-                  <a:srgbClr val="F0F0F0"/>
-                </a:solidFill>
-                <a:latin typeface="Calibri"/>
-              </a:rPr>
-              <a:t>bowl repo: docs, samples, scripts, skills  |  guide repo: README 0-130</a:t>
-            </a:r>
-          </a:p>
-          <a:p>
-            <a:pPr>
-              <a:spcAft>
-                <a:spcPts val="1000"/>
-              </a:spcAft>
-            </a:pPr>
-            <a:r>
-              <a:rPr sz="2400" b="0">
-                <a:solidFill>
-                  <a:srgbClr val="F0F0F0"/>
-                </a:solidFill>
-                <a:latin typeface="Calibri"/>
-              </a:rPr>
-              <a:t>day one of announcement: data downloads while baselines re-run</a:t>
-            </a:r>
-          </a:p>
-          <a:p>
-            <a:pPr>
-              <a:spcAft>
-                <a:spcPts val="1000"/>
-              </a:spcAft>
-            </a:pPr>
-            <a:r>
-              <a:rPr sz="2400" b="0">
-                <a:solidFill>
-                  <a:srgbClr val="F0F0F0"/>
-                </a:solidFill>
-                <a:latin typeface="Calibri"/>
-              </a:rPr>
-              <a:t>competition is the demo vehicle, muse code is the instrument</a:t>
+              <a:t>The bowl repository ships docs, seeded samples, runnable scripts, and skills, and the companion guide repository carries README sections 0 through 130, so a stranger can clone either and run within minutes (as of September 2026).</a:t>
+            </a:r>
+          </a:p>
+          <a:p>
+            <a:pPr/>
+            <a:r>
+              <a:t>The day-one play when the 2027 announcement drops is fixed: data downloads while baselines re-run from the frozen configs, per the checklist in docs/2027-prediction.md.</a:t>
+            </a:r>
+          </a:p>
+          <a:p>
+            <a:pPr/>
+            <a:r>
+              <a:t>That is the whole thesis in one line: the competition is the demo vehicle and Muse Code is the instrument, with Glimmer as the local section that keeps practice free.</a:t>
+            </a:r>
+          </a:p>
+          <a:p>
+            <a:pPr/>
+            <a:r>
+              <a:t>Start tonight with one command: uv run python scripts/explore_sample.py --data samples/2024, and the field plot in data/scratch/ is your first proof.</a:t>
             </a:r>
           </a:p>
         </p:txBody>
@@ -8003,15 +7665,8 @@
           </a:bodyPr>
           <a:lstStyle/>
           <a:p>
-            <a:pPr algn="l"/>
-            <a:r>
-              <a:rPr sz="4000" b="1">
-                <a:solidFill>
-                  <a:srgbClr val="D7C7EE"/>
-                </a:solidFill>
-                <a:latin typeface="Cinzel"/>
-              </a:rPr>
-              <a:t>the data</a:t>
+            <a:r>
+              <a:t>The data: every player and the ball, ten times per second</a:t>
             </a:r>
           </a:p>
         </p:txBody>
@@ -8044,61 +7699,25 @@
               </a:spcAft>
             </a:pPr>
             <a:r>
-              <a:rPr sz="2400" b="0">
-                <a:solidFill>
-                  <a:srgbClr val="F0F0F0"/>
-                </a:solidFill>
-                <a:latin typeface="Calibri"/>
-              </a:rPr>
-              <a:t>RFID (radio-frequency identification) tags, Zebra + Wilson hardware  |  every player + ball</a:t>
-            </a:r>
-          </a:p>
-          <a:p>
-            <a:pPr>
-              <a:spcAft>
-                <a:spcPts val="1000"/>
-              </a:spcAft>
-            </a:pPr>
-            <a:r>
-              <a:rPr sz="2400" b="0">
-                <a:solidFill>
-                  <a:srgbClr val="F0F0F0"/>
-                </a:solidFill>
-                <a:latin typeface="Calibri"/>
-              </a:rPr>
-              <a:t>fields: x y s a dis o dir event frameId nflId (+frameType 2025)</a:t>
-            </a:r>
-          </a:p>
-          <a:p>
-            <a:pPr>
-              <a:spcAft>
-                <a:spcPts val="1000"/>
-              </a:spcAft>
-            </a:pPr>
-            <a:r>
-              <a:rPr sz="2400" b="0">
-                <a:solidFill>
-                  <a:srgbClr val="F0F0F0"/>
-                </a:solidFill>
-                <a:latin typeface="Calibri"/>
-              </a:rPr>
-              <a:t>keys gameId / playId / nflId  |  nflverse via old_game_id, play_id as int</a:t>
-            </a:r>
-          </a:p>
-          <a:p>
-            <a:pPr>
-              <a:spcAft>
-                <a:spcPts val="1000"/>
-              </a:spcAft>
-            </a:pPr>
-            <a:r>
-              <a:rPr sz="2400" b="0">
-                <a:solidFill>
-                  <a:srgbClr val="F0F0F0"/>
-                </a:solidFill>
-                <a:latin typeface="Calibri"/>
-              </a:rPr>
-              <a:t>weekly CSVs ~1.5 GB  |  seeded 2024 1.6 GB + 2025 7.7 GB  |  samples: 25 plays</a:t>
+              <a:t>Radio-frequency identification tags sewn into shoulder pads plus a sensor ball built by Wilson feed position hardware from Zebra, and the league samples every tracked player and the ball at 10 hertz from snap to whistle.</a:t>
+            </a:r>
+          </a:p>
+          <a:p>
+            <a:pPr/>
+            <a:r>
+              <a:t>Each row carries field coordinates x and y in yards, speed s in yards per second, acceleration a in yards per second squared, distance traveled dis, orientation o, direction dir, the tagged event, frame identifier, and player identifier, with frame type added in the 2025 season feed.</a:t>
+            </a:r>
+          </a:p>
+          <a:p>
+            <a:pPr/>
+            <a:r>
+              <a:t>The join keys are game identifier, play identifier, and player identifier, and roster and game context attach through nflverse using the legacy game identifier with play identifier cast to integer (docs/muse-code.md, as of September 2026).</a:t>
+            </a:r>
+          </a:p>
+          <a:p>
+            <a:pPr/>
+            <a:r>
+              <a:t>Weekly comma-separated files run about 1.5 gigabytes each, so the repository seeds from a 1.6 gigabyte 2024 slice plus a 7.7 gigabyte 2025 slice and demos run on a 25-play in-git sample that answers every query in seconds.</a:t>
             </a:r>
           </a:p>
         </p:txBody>
@@ -8272,15 +7891,8 @@
           </a:bodyPr>
           <a:lstStyle/>
           <a:p>
-            <a:pPr algn="l"/>
-            <a:r>
-              <a:rPr sz="4000" b="1">
-                <a:solidFill>
-                  <a:srgbClr val="D7C7EE"/>
-                </a:solidFill>
-                <a:latin typeface="Cinzel"/>
-              </a:rPr>
-              <a:t>workflow 1: explore the sample first</a:t>
+            <a:r>
+              <a:t>Workflow 1: explore the sample first</a:t>
             </a:r>
           </a:p>
         </p:txBody>
@@ -8801,15 +8413,8 @@
           </a:bodyPr>
           <a:lstStyle/>
           <a:p>
-            <a:pPr algn="l"/>
-            <a:r>
-              <a:rPr sz="4000" b="1">
-                <a:solidFill>
-                  <a:srgbClr val="D7C7EE"/>
-                </a:solidFill>
-                <a:latin typeface="Cinzel"/>
-              </a:rPr>
-              <a:t>workflow 3: features, frame up</a:t>
+            <a:r>
+              <a:t>Workflow 3: build features frame by frame, from the ground up</a:t>
             </a:r>
           </a:p>
         </p:txBody>
@@ -8842,61 +8447,25 @@
               </a:spcAft>
             </a:pPr>
             <a:r>
-              <a:rPr sz="2400" b="0">
-                <a:solidFill>
-                  <a:srgbClr val="F0F0F0"/>
-                </a:solidFill>
-                <a:latin typeface="Calibri"/>
-              </a:rPr>
-              <a:t>league shape: frame-level features, per-player models, play stat</a:t>
-            </a:r>
-          </a:p>
-          <a:p>
-            <a:pPr>
-              <a:spcAft>
-                <a:spcPts val="1000"/>
-              </a:spcAft>
-            </a:pPr>
-            <a:r>
-              <a:rPr sz="2400" b="0">
-                <a:solidFill>
-                  <a:srgbClr val="F0F0F0"/>
-                </a:solidFill>
-                <a:latin typeface="Calibri"/>
-              </a:rPr>
-              <a:t>speed / accel / distance-to-line + formation encodings</a:t>
-            </a:r>
-          </a:p>
-          <a:p>
-            <a:pPr>
-              <a:spcAft>
-                <a:spcPts val="1000"/>
-              </a:spcAft>
-            </a:pPr>
-            <a:r>
-              <a:rPr sz="2400" b="0">
-                <a:solidFill>
-                  <a:srgbClr val="F0F0F0"/>
-                </a:solidFill>
-                <a:latin typeface="Calibri"/>
-              </a:rPr>
-              <a:t>frame-by-frame convolutional networks (convnets) for tackle probability</a:t>
-            </a:r>
-          </a:p>
-          <a:p>
-            <a:pPr>
-              <a:spcAft>
-                <a:spcPts val="1000"/>
-              </a:spcAft>
-            </a:pPr>
-            <a:r>
-              <a:rPr sz="2400" b="0">
-                <a:solidFill>
-                  <a:srgbClr val="F0F0F0"/>
-                </a:solidFill>
-                <a:latin typeface="Calibri"/>
-              </a:rPr>
-              <a:t>LightGBM picked over XGBoost for speed + memory</a:t>
+              <a:t>The league shape of a winning entry is frame-level features feeding per-player models that roll up to one play-level stat, so every row of tracking earns its keep instead of decorating a box-score model (docs/muse-code.md, as of September 2026).</a:t>
+            </a:r>
+          </a:p>
+          <a:p>
+            <a:pPr/>
+            <a:r>
+              <a:t>Base motion columns are speed, acceleration, and distance to the line of scrimmage in yards, plus numeric formation encodings that capture offensive and defensive alignment the way past winners encoded pressure-scheme context.</a:t>
+            </a:r>
+          </a:p>
+          <a:p>
+            <a:pPr/>
+            <a:r>
+              <a:t>The tackle-probability workhorse is a frame-by-frame convolutional network, which is a neural network swept across consecutive frames, following the 2024 winning approach trained at that granularity.</a:t>
+            </a:r>
+          </a:p>
+          <a:p>
+            <a:pPr/>
+            <a:r>
+              <a:t>We standardize on LightGBM over XGBoost for the tree stage because it trains faster and holds less memory on laptop-scale weekly data, with scripts/features_frame_up.py emitting a 50-row by 19-column demonstration frame.</a:t>
             </a:r>
           </a:p>
         </p:txBody>
@@ -9070,15 +8639,8 @@
           </a:bodyPr>
           <a:lstStyle/>
           <a:p>
-            <a:pPr algn="l"/>
-            <a:r>
-              <a:rPr sz="4000" b="1">
-                <a:solidFill>
-                  <a:srgbClr val="D7C7EE"/>
-                </a:solidFill>
-                <a:latin typeface="Cinzel"/>
-              </a:rPr>
-              <a:t>workflow 4: baseline, then ensemble</a:t>
+            <a:r>
+              <a:t>Workflow 4: set a lasso baseline, then earn the ensemble</a:t>
             </a:r>
           </a:p>
         </p:txBody>
@@ -9111,61 +8673,25 @@
               </a:spcAft>
             </a:pPr>
             <a:r>
-              <a:rPr sz="2400" b="0">
-                <a:solidFill>
-                  <a:srgbClr val="F0F0F0"/>
-                </a:solidFill>
-                <a:latin typeface="Calibri"/>
-              </a:rPr>
-              <a:t>lasso-logistic baseline with base rates + cross-validated accuracy w/ errors</a:t>
-            </a:r>
-          </a:p>
-          <a:p>
-            <a:pPr>
-              <a:spcAft>
-                <a:spcPts val="1000"/>
-              </a:spcAft>
-            </a:pPr>
-            <a:r>
-              <a:rPr sz="2400" b="0">
-                <a:solidFill>
-                  <a:srgbClr val="F0F0F0"/>
-                </a:solidFill>
-                <a:latin typeface="Calibri"/>
-              </a:rPr>
-              <a:t>group-by-play folds  |  XGBoost / LightGBM / CatBoost + Optuna</a:t>
-            </a:r>
-          </a:p>
-          <a:p>
-            <a:pPr>
-              <a:spcAft>
-                <a:spcPts val="1000"/>
-              </a:spcAft>
-            </a:pPr>
-            <a:r>
-              <a:rPr sz="2400" b="0">
-                <a:solidFill>
-                  <a:srgbClr val="F0F0F0"/>
-                </a:solidFill>
-                <a:latin typeface="Calibri"/>
-              </a:rPr>
-              <a:t>one seed + one config per output dir, runs stay comparable</a:t>
-            </a:r>
-          </a:p>
-          <a:p>
-            <a:pPr>
-              <a:spcAft>
-                <a:spcPts val="1000"/>
-              </a:spcAft>
-            </a:pPr>
-            <a:r>
-              <a:rPr sz="2400" b="0">
-                <a:solidFill>
-                  <a:srgbClr val="F0F0F0"/>
-                </a:solidFill>
-                <a:latin typeface="Calibri"/>
-              </a:rPr>
-              <a:t>scripts/baseline_lasso.py  |  Yurko discipline wired in</a:t>
+              <a:t>Every modeling run starts from a lasso-logistic baseline, which is logistic regression with an L1 penalty, reported against naive base-rate frequencies with cross-validated accuracy plus standard errors, and the demo baseline scores 0.700 plus or minus 0.110 (scripts/baseline_lasso.py, as of September 2026).</a:t>
+            </a:r>
+          </a:p>
+          <a:p>
+            <a:pPr/>
+            <a:r>
+              <a:t>Folds are grouped by play so all frames of one play stay together, which prevents leakage where the model would otherwise train and test on adjacent frames of the same action.</a:t>
+            </a:r>
+          </a:p>
+          <a:p>
+            <a:pPr/>
+            <a:r>
+              <a:t>The ensemble stage tries XGBoost, LightGBM, and CatBoost with Optuna tuning, but only results that beat the baseline by more than one standard error survive, following the Yurko discipline wired into docs/muse-code.md.</a:t>
+            </a:r>
+          </a:p>
+          <a:p>
+            <a:pPr/>
+            <a:r>
+              <a:t>One random seed plus one frozen configuration is stored per output directory, so any two runs remain directly comparable and a rerun reproduces the same numbers.</a:t>
             </a:r>
           </a:p>
         </p:txBody>

</xml_diff>

<commit_message>
deck: tighten all 17 to 3 sentences, 18pt body, clean titles
</commit_message>
<xml_diff>
--- a/deck/unified.pptx
+++ b/deck/unified.pptx
@@ -4795,13 +4795,8 @@
           </a:bodyPr>
           <a:lstStyle/>
           <a:p>
-            <a:pPr algn="l"/>
-            <a:r>
-              <a:rPr b="1" sz="3200">
-                <a:solidFill>
-                  <a:srgbClr val="D7C7EE"/>
-                </a:solidFill>
-              </a:rPr>
+            <a:r>
+              <a:rPr sz="2800"/>
               <a:t>Big Data Bowl meets Muse Code: NFL tracking data, worked live in the terminal</a:t>
             </a:r>
           </a:p>
@@ -4831,46 +4826,34 @@
           <a:p>
             <a:pPr>
               <a:spcAft>
-                <a:spcPts val="600"/>
+                <a:spcPts val="1200"/>
               </a:spcAft>
             </a:pPr>
             <a:r>
-              <a:rPr sz="2000">
-                <a:solidFill>
-                  <a:srgbClr val="F0F0F0"/>
-                </a:solidFill>
-              </a:rPr>
-              <a:t>The NFL Big Data Bowl is the league's annual analytics contest, run with AWS (Amazon Web Services), and this talk uses it as the vehicle.</a:t>
+              <a:rPr sz="1800"/>
+              <a:t>The NFL Big Data Bowl is the league's annual analytics contest, run with Amazon Web Services, and this talk uses it as the vehicle.</a:t>
             </a:r>
           </a:p>
           <a:p>
             <a:pPr>
               <a:spcAft>
-                <a:spcPts val="600"/>
+                <a:spcPts val="1200"/>
               </a:spcAft>
             </a:pPr>
             <a:r>
-              <a:rPr sz="2000">
-                <a:solidFill>
-                  <a:srgbClr val="F0F0F0"/>
-                </a:solidFill>
-              </a:rPr>
-              <a:t>Muse Code is the agentic coding CLI we will drive live, and it is the instrument of the talk.</a:t>
+              <a:rPr sz="1800"/>
+              <a:t>Muse Code is the agentic coding CLI we drive live on screen, and it is the instrument.</a:t>
             </a:r>
           </a:p>
           <a:p>
             <a:pPr>
               <a:spcAft>
-                <a:spcPts val="600"/>
+                <a:spcPts val="1200"/>
               </a:spcAft>
             </a:pPr>
             <a:r>
-              <a:rPr sz="2000">
-                <a:solidFill>
-                  <a:srgbClr val="F0F0F0"/>
-                </a:solidFill>
-              </a:rPr>
-              <a:t>Our raw material is NFL Next Gen Stats, the league's RFID player-and-ball tracking feed sampled at 10 frames per second.</a:t>
+              <a:rPr sz="1800"/>
+              <a:t>Our raw material is Next Gen Stats: league tracking data for every player and the ball, sampled ten times per second.</a:t>
             </a:r>
           </a:p>
         </p:txBody>
@@ -5045,6 +5028,7 @@
           <a:lstStyle/>
           <a:p>
             <a:r>
+              <a:rPr sz="2800"/>
               <a:t>Skills, batch sweeps, and a sandbox that guards the raw data</a:t>
             </a:r>
           </a:p>
@@ -5074,29 +5058,34 @@
           <a:p>
             <a:pPr>
               <a:spcAft>
-                <a:spcPts val="1000"/>
+                <a:spcPts val="1200"/>
               </a:spcAft>
             </a:pPr>
             <a:r>
-              <a:t>Three reusable skills carry the repeated work: chunk-to-parquet converts weekly files, join-and-slice answers one-question cuts, and baseline-ensemble runs the model ladder, each stored as a skill manifest at dot-agents/skills/&lt;id&gt;/SKILL.md.</a:t>
-            </a:r>
-          </a:p>
-          <a:p>
-            <a:pPr/>
-            <a:r>
-              <a:t>The batch runner scripts/sweep_weeks.sh issues one exec-mode prompt per question across all weeks and writes one comma-separated results file plus one PNG chart per question, so an overnight sweep is reviewable by morning.</a:t>
-            </a:r>
-          </a:p>
-          <a:p>
-            <a:pPr/>
-            <a:r>
-              <a:t>The guard script scripts/guard_data.sh trips when raw-file modification timestamps move, and the repository rule is simple: data/ stays read-only and every generated file lands in rebuildable data/scratch/ (docs/muse-code.md, as of September 2026).</a:t>
-            </a:r>
-          </a:p>
-          <a:p>
-            <a:pPr/>
-            <a:r>
-              <a:t>Free review runs happen on the local Glimmer model and keeper runs burst to the Kaggle free tier at roughly 30 graphics-processor hours per week, which keeps the whole pipeline subscription-only with no per-token metering.</a:t>
+              <a:rPr sz="1800"/>
+              <a:t>Three reusable skills carry the repeated work: chunk-to-parquet converts weeks, join-and-slice answers one-question cuts, and baseline-ensemble runs the model ladder.</a:t>
+            </a:r>
+          </a:p>
+          <a:p>
+            <a:pPr>
+              <a:spcAft>
+                <a:spcPts val="1200"/>
+              </a:spcAft>
+            </a:pPr>
+            <a:r>
+              <a:rPr sz="1800"/>
+              <a:t>The batch runner issues one headless prompt per question across all weeks, writing one results file plus one chart per question for morning review.</a:t>
+            </a:r>
+          </a:p>
+          <a:p>
+            <a:pPr>
+              <a:spcAft>
+                <a:spcPts val="1200"/>
+              </a:spcAft>
+            </a:pPr>
+            <a:r>
+              <a:rPr sz="1800"/>
+              <a:t>A guard script trips when raw-file timestamps move, data/ stays read-only, and free review runs happen on the local Glimmer model.</a:t>
             </a:r>
           </a:p>
         </p:txBody>
@@ -5271,6 +5260,7 @@
           <a:lstStyle/>
           <a:p>
             <a:r>
+              <a:rPr sz="2800"/>
               <a:t>Craft: what the grading rubric actually rewards</a:t>
             </a:r>
           </a:p>
@@ -5300,29 +5290,34 @@
           <a:p>
             <a:pPr>
               <a:spcAft>
-                <a:spcPts val="1000"/>
+                <a:spcPts val="1200"/>
               </a:spcAft>
             </a:pPr>
             <a:r>
-              <a:t>The rubric splits 100 points into 30 for football insight, 30 for data science, 20 for the written report, and 20 for visuals, with a 2,000-word cap and fewer than 10 figures, so every chart must argue (docs/craft.md, as of September 2026).</a:t>
-            </a:r>
-          </a:p>
-          <a:p>
-            <a:pPr/>
-            <a:r>
-              <a:t>Tracking data must do causal work in the entry rather than decorate a box-score argument, which is the single most common reason strong models lose.</a:t>
-            </a:r>
-          </a:p>
-          <a:p>
-            <a:pPr/>
-            <a:r>
-              <a:t>The Patton guidance is blunt: answer the prompt as written, remember graders work nights, and make the submission look expensive with clean tables and labeled axes.</a:t>
-            </a:r>
-          </a:p>
-          <a:p>
-            <a:pPr/>
-            <a:r>
-              <a:t>The Yurko discipline closes it out: report base rates, a simple baseline, cross-validation with standard errors, and downstream use of the stat over raw fit, then state limits, proofread, and conclude.</a:t>
+              <a:rPr sz="1800"/>
+              <a:t>The rubric splits 100 points into 30 for football insight, 30 for data science, 20 for the report, and 20 for visuals, capped at 2,000 words and under 10 figures.</a:t>
+            </a:r>
+          </a:p>
+          <a:p>
+            <a:pPr>
+              <a:spcAft>
+                <a:spcPts val="1200"/>
+              </a:spcAft>
+            </a:pPr>
+            <a:r>
+              <a:rPr sz="1800"/>
+              <a:t>Tracking data must do causal work in the entry, not decorate a box-score argument: that is the most common way strong models lose.</a:t>
+            </a:r>
+          </a:p>
+          <a:p>
+            <a:pPr>
+              <a:spcAft>
+                <a:spcPts val="1200"/>
+              </a:spcAft>
+            </a:pPr>
+            <a:r>
+              <a:rPr sz="1800"/>
+              <a:t>Answer the prompt as written, report base rates with a simple baseline plus errors, state limits, and make it look expensive.</a:t>
             </a:r>
           </a:p>
         </p:txBody>
@@ -5497,6 +5492,7 @@
           <a:lstStyle/>
           <a:p>
             <a:r>
+              <a:rPr sz="2800"/>
               <a:t>2027 forecast: where the next topic likely goes</a:t>
             </a:r>
           </a:p>
@@ -5526,29 +5522,34 @@
           <a:p>
             <a:pPr>
               <a:spcAft>
-                <a:spcPts val="1000"/>
+                <a:spcPts val="1200"/>
               </a:spcAft>
             </a:pPr>
             <a:r>
-              <a:t>The cadence anchor is that the 2026 contest opened September 25, 2025, so with the 2027 announcement unposted as of September 2026 it could land any day and the day-one checklist in docs/2027-prediction.md starts the clock (as of September 2026).</a:t>
-            </a:r>
-          </a:p>
-          <a:p>
-            <a:pPr/>
-            <a:r>
-              <a:t>Contest history alternates prediction years against metric-definition years, and with recent offense-side topics banked, a defensive topic is due.</a:t>
-            </a:r>
-          </a:p>
-          <a:p>
-            <a:pPr/>
-            <a:r>
-              <a:t>The three most likely prompts are first ghost and counterfactual defender-free receiver paths, second the redesigned kickoff formation, and third run blocking, ranked by how much new tracking the league keeps adding.</a:t>
-            </a:r>
-          </a:p>
-          <a:p>
-            <a:pPr/>
-            <a:r>
-              <a:t>Winners build tooling before the topic exists, which is exactly why the parquet pipeline, feature builder, and baseline in this repository are finished ahead of the announcement.</a:t>
+              <a:rPr sz="1800"/>
+              <a:t>The 2026 contest opened September 25, 2025, so with 2027 unannounced as of September 2026 it could land any day, and the day-one checklist is already written.</a:t>
+            </a:r>
+          </a:p>
+          <a:p>
+            <a:pPr>
+              <a:spcAft>
+                <a:spcPts val="1200"/>
+              </a:spcAft>
+            </a:pPr>
+            <a:r>
+              <a:rPr sz="1800"/>
+              <a:t>History alternates prediction years with metric-definition years, and with offense topics banked, a defensive topic is due.</a:t>
+            </a:r>
+          </a:p>
+          <a:p>
+            <a:pPr>
+              <a:spcAft>
+                <a:spcPts val="1200"/>
+              </a:spcAft>
+            </a:pPr>
+            <a:r>
+              <a:rPr sz="1800"/>
+              <a:t>Most likely: ghost counterfactual receiver paths, the redesigned kickoff, or run blocking. Winners build tooling before the topic exists.</a:t>
             </a:r>
           </a:p>
         </p:txBody>
@@ -5723,6 +5724,7 @@
           <a:lstStyle/>
           <a:p>
             <a:r>
+              <a:rPr sz="2800"/>
               <a:t>Glimmer proof, live: a 30-billion-parameter local teammate</a:t>
             </a:r>
           </a:p>
@@ -5752,29 +5754,34 @@
           <a:p>
             <a:pPr>
               <a:spcAft>
-                <a:spcPts val="1000"/>
+                <a:spcPts val="1200"/>
               </a:spcAft>
             </a:pPr>
             <a:r>
-              <a:t>Glimmer is a 30-billion-parameter open-weights model under Apache 2.0, distilled from Muse Spark 1.2, running on this room's rocm-aibox host with a Radeon RX 6700 XT and 12 gigabytes of video memory (as of September 2026).</a:t>
-            </a:r>
-          </a:p>
-          <a:p>
-            <a:pPr/>
-            <a:r>
-              <a:t>It serves an OpenAI-compatible endpoint at http://127.0.0.1:8181/v1 with a /healthz check, behind a supervisor that cold-starts in about 8 seconds and tears down after 300 idle seconds.</a:t>
-            </a:r>
-          </a:p>
-          <a:p>
-            <a:pPr/>
-            <a:r>
-              <a:t>The build runs 13 GPU layers with a 4,096-token context window under 4-bit Q4_K_M quantization, so the model fits the 12-gigabyte card with headroom for the multimodal projector.</a:t>
-            </a:r>
-          </a:p>
-          <a:p>
-            <a:pPr/>
-            <a:r>
-              <a:t>A Valkey mutual-exclusion key named gpu_lock serializes access: while held the endpoint answers HTTP 503, and after release it returns HTTP 200, which the contention demo shows live with streaming at HTTP 200 in 15 chunks over 73.5 seconds.</a:t>
+              <a:rPr sz="1800"/>
+              <a:t>Glimmer is a 30-billion-parameter open-weights model distilled from Muse Spark, running on a single workstation with a 12-gigabyte graphics card.</a:t>
+            </a:r>
+          </a:p>
+          <a:p>
+            <a:pPr>
+              <a:spcAft>
+                <a:spcPts val="1200"/>
+              </a:spcAft>
+            </a:pPr>
+            <a:r>
+              <a:rPr sz="1800"/>
+              <a:t>It serves an OpenAI-compatible endpoint behind a supervisor that cold-starts in about 8 seconds and tears down after 300 idle seconds.</a:t>
+            </a:r>
+          </a:p>
+          <a:p>
+            <a:pPr>
+              <a:spcAft>
+                <a:spcPts val="1200"/>
+              </a:spcAft>
+            </a:pPr>
+            <a:r>
+              <a:rPr sz="1800"/>
+              <a:t>Thirteen GPU layers with a 4,096-token window fit the card, and a mutual-exclusion key serializes access: locked answers HTTP 503, free answers 200.</a:t>
             </a:r>
           </a:p>
         </p:txBody>
@@ -5949,6 +5956,7 @@
           <a:lstStyle/>
           <a:p>
             <a:r>
+              <a:rPr sz="2800"/>
               <a:t>Live numbers: what 13 GPU layers actually buy on this card</a:t>
             </a:r>
           </a:p>
@@ -5978,29 +5986,34 @@
           <a:p>
             <a:pPr>
               <a:spcAft>
-                <a:spcPts val="600"/>
+                <a:spcPts val="1200"/>
               </a:spcAft>
             </a:pPr>
             <a:r>
-              <a:t>With 0 GPU layers in CPU-only mode the model answers a warm prompt in 41.7 seconds at 5.7 prompt tokens per second and 0.46 generated tokens per second with near-zero graphics memory, measured September 2026 on rocm-aibox.</a:t>
-            </a:r>
-          </a:p>
-          <a:p>
-            <a:pPr/>
-            <a:r>
-              <a:t>With 13 GPU layers in text-only mode the same prompt takes 186.7 seconds wall clock at 1.75 prompt tokens per second and 0.17 generated tokens per second holding 11.62 gigabytes, so the offload buys nothing at generation on this card because decoding is bandwidth-bound.</a:t>
-            </a:r>
-          </a:p>
-          <a:p>
-            <a:pPr/>
-            <a:r>
-              <a:t>The hosted counterpoint is Muse Spark over the subscription: the same review-class prompt finishes in 2 minutes 13 seconds, which is why the workflow drafts locally and promotes keepers to hosted.</a:t>
-            </a:r>
-          </a:p>
-          <a:p>
-            <a:pPr/>
-            <a:r>
-              <a:t>Vision lands too: a 6.5-kilobyte thumbnail returns HTTP 200 in 135.8 seconds with the multimodal projector in 16-bit float at 11.09 gigabytes, proving images work but CPU embedding is too slow for production use.</a:t>
+              <a:rPr sz="1800"/>
+              <a:t>CPU-only mode answers a warm prompt in 41.7 seconds at 5.7 prompt tokens per second, holding near-zero graphics memory.</a:t>
+            </a:r>
+          </a:p>
+          <a:p>
+            <a:pPr>
+              <a:spcAft>
+                <a:spcPts val="1200"/>
+              </a:spcAft>
+            </a:pPr>
+            <a:r>
+              <a:rPr sz="1800"/>
+              <a:t>With 13 GPU layers the same prompt takes 186.7 seconds at 1.75 tokens per second holding 11.62 gigabytes: the offload buys nothing at generation because decoding is bandwidth-bound.</a:t>
+            </a:r>
+          </a:p>
+          <a:p>
+            <a:pPr>
+              <a:spcAft>
+                <a:spcPts val="1200"/>
+              </a:spcAft>
+            </a:pPr>
+            <a:r>
+              <a:rPr sz="1800"/>
+              <a:t>The hosted counterpoint finishes the same review in 2 minutes 13 seconds, so the workflow drafts locally and promotes keepers. Vision works too at 135.8 seconds per thumbnail, but too slow for production.</a:t>
             </a:r>
           </a:p>
         </p:txBody>
@@ -6175,6 +6188,7 @@
           <a:lstStyle/>
           <a:p>
             <a:r>
+              <a:rPr sz="2800"/>
               <a:t>Take-home tips 1 through 5: memory, modes, and one skill per job</a:t>
             </a:r>
           </a:p>
@@ -6204,29 +6218,34 @@
           <a:p>
             <a:pPr>
               <a:spcAft>
-                <a:spcPts val="1000"/>
+                <a:spcPts val="1200"/>
               </a:spcAft>
             </a:pPr>
             <a:r>
-              <a:t>First, run muse init so the repository's memory files persist your conventions instead of re-explaining them every session.</a:t>
-            </a:r>
-          </a:p>
-          <a:p>
-            <a:pPr/>
-            <a:r>
-              <a:t>Second, pair in the interactive terminal interface for exploration and switch to non-interactive exec mode for batch sweeps, because each mode bills attention differently.</a:t>
-            </a:r>
-          </a:p>
-          <a:p>
-            <a:pPr/>
-            <a:r>
-              <a:t>Third, pin the model per task with --model and /models, and fourth, set reasoning effort with --reasoning-effort and /effort so cheap questions stay cheap and hard proofs get the budget.</a:t>
-            </a:r>
-          </a:p>
-          <a:p>
-            <a:pPr/>
-            <a:r>
-              <a:t>Fifth, write one custom skill manifest per repeated job at dot-agents/skills/&lt;id&gt;/SKILL.md, and this repository already proves it: explore_sample and weeks_to_parquet both ship as skills, mapped in docs/muse-code.md as of September 2026.</a:t>
+              <a:rPr sz="1800"/>
+              <a:t>Run muse init so repository memory persists your conventions instead of re-explaining them every session.</a:t>
+            </a:r>
+          </a:p>
+          <a:p>
+            <a:pPr>
+              <a:spcAft>
+                <a:spcPts val="1200"/>
+              </a:spcAft>
+            </a:pPr>
+            <a:r>
+              <a:rPr sz="1800"/>
+              <a:t>Pair in the interactive terminal for exploration and switch to headless exec mode for batch sweeps.</a:t>
+            </a:r>
+          </a:p>
+          <a:p>
+            <a:pPr>
+              <a:spcAft>
+                <a:spcPts val="1200"/>
+              </a:spcAft>
+            </a:pPr>
+            <a:r>
+              <a:rPr sz="1800"/>
+              <a:t>Pin the model per task, set reasoning effort so cheap questions stay cheap, and write one skill manifest per repeated job: explore and parquet conversion both ship as skills here.</a:t>
             </a:r>
           </a:p>
         </p:txBody>
@@ -6401,6 +6420,7 @@
           <a:lstStyle/>
           <a:p>
             <a:r>
+              <a:rPr sz="2800"/>
               <a:t>Take-home tips 6 through 10: safety, recovery, and scale</a:t>
             </a:r>
           </a:p>
@@ -6430,35 +6450,34 @@
           <a:p>
             <a:pPr>
               <a:spcAft>
-                <a:spcPts val="1000"/>
+                <a:spcPts val="1200"/>
               </a:spcAft>
             </a:pPr>
             <a:r>
-              <a:t>Sixth, wire Model Context Protocol servers read-only first so the agent can inspect production without mutating it, promoting to read-write only for deliberate steps.</a:t>
-            </a:r>
-          </a:p>
-          <a:p>
-            <a:pPr/>
-            <a:r>
-              <a:t>Seventh, keep the sandbox on and approve network and write actions deliberately, because reversibility is a decision not a default.</a:t>
-            </a:r>
-          </a:p>
-          <a:p>
-            <a:pPr/>
-            <a:r>
-              <a:t>Eighth, use /sessions plus /rewind for recovery instead of retyping lost work, since the session log already holds it.</a:t>
-            </a:r>
-          </a:p>
-          <a:p>
-            <a:pPr/>
-            <a:r>
-              <a:t>Ninth, fan out with the workflow tool under an evidence contract where every child returns complete, evidence, and unresolved fields, which is how this very deck was scored and fixed.</a:t>
-            </a:r>
-          </a:p>
-          <a:p>
-            <a:pPr/>
-            <a:r>
-              <a:t>Tenth, call the Spark API without the terminal interface when embedding it, backed locally by Glimmer on port 8181, and set spend limits on day one with the Valkey gpu_lock guarding every graphics-processor job.</a:t>
+              <a:rPr sz="1800"/>
+              <a:t>Wire Model Context Protocol servers read-only first, promoting to read-write only for deliberate steps, and keep the sandbox on with deliberate approvals.</a:t>
+            </a:r>
+          </a:p>
+          <a:p>
+            <a:pPr>
+              <a:spcAft>
+                <a:spcPts val="1200"/>
+              </a:spcAft>
+            </a:pPr>
+            <a:r>
+              <a:rPr sz="1800"/>
+              <a:t>Recover with /sessions plus /rewind instead of retyping lost work, and fan out with the workflow tool under an evidence contract.</a:t>
+            </a:r>
+          </a:p>
+          <a:p>
+            <a:pPr>
+              <a:spcAft>
+                <a:spcPts val="1200"/>
+              </a:spcAft>
+            </a:pPr>
+            <a:r>
+              <a:rPr sz="1800"/>
+              <a:t>Embed via the Spark API backed locally by Glimmer, and set spend limits on day one with the graphics lock guarding every GPU job.</a:t>
             </a:r>
           </a:p>
         </p:txBody>
@@ -6633,6 +6652,7 @@
           <a:lstStyle/>
           <a:p>
             <a:r>
+              <a:rPr sz="2800"/>
               <a:t>Close: the competition is the vehicle, Muse Code is the instrument</a:t>
             </a:r>
           </a:p>
@@ -6662,29 +6682,34 @@
           <a:p>
             <a:pPr>
               <a:spcAft>
-                <a:spcPts val="1000"/>
+                <a:spcPts val="1200"/>
               </a:spcAft>
             </a:pPr>
             <a:r>
-              <a:t>The bowl repository ships docs, seeded samples, runnable scripts, and skills, and the companion guide repository carries README sections 0 through 130, so a stranger can clone either and run within minutes (as of September 2026).</a:t>
-            </a:r>
-          </a:p>
-          <a:p>
-            <a:pPr/>
-            <a:r>
-              <a:t>The day-one play when the 2027 announcement drops is fixed: data downloads while baselines re-run from the frozen configs, per the checklist in docs/2027-prediction.md.</a:t>
-            </a:r>
-          </a:p>
-          <a:p>
-            <a:pPr/>
-            <a:r>
-              <a:t>That is the whole thesis in one line: the competition is the demo vehicle and Muse Code is the instrument, with Glimmer as the local section that keeps practice free.</a:t>
-            </a:r>
-          </a:p>
-          <a:p>
-            <a:pPr/>
-            <a:r>
-              <a:t>Start tonight with one command: uv run python scripts/explore_sample.py --data samples/2024, and the field plot in data/scratch/ is your first proof.</a:t>
+              <a:rPr sz="1800"/>
+              <a:t>The bowl repository ships docs, samples, scripts, and skills, and the companion guide carries README sections 0 through 130, so a stranger clones and runs within minutes.</a:t>
+            </a:r>
+          </a:p>
+          <a:p>
+            <a:pPr>
+              <a:spcAft>
+                <a:spcPts val="1200"/>
+              </a:spcAft>
+            </a:pPr>
+            <a:r>
+              <a:rPr sz="1800"/>
+              <a:t>The day-one play is fixed: data downloads while baselines re-run from frozen configs.</a:t>
+            </a:r>
+          </a:p>
+          <a:p>
+            <a:pPr>
+              <a:spcAft>
+                <a:spcPts val="1200"/>
+              </a:spcAft>
+            </a:pPr>
+            <a:r>
+              <a:rPr sz="1800"/>
+              <a:t>Start tonight with uv run python scripts/explore_sample.py --data samples/2024, and the field plot is your first proof.</a:t>
             </a:r>
           </a:p>
         </p:txBody>
@@ -6858,13 +6883,8 @@
           </a:bodyPr>
           <a:lstStyle/>
           <a:p>
-            <a:pPr algn="l"/>
-            <a:r>
-              <a:rPr b="1" sz="3200">
-                <a:solidFill>
-                  <a:srgbClr val="D7C7EE"/>
-                </a:solidFill>
-              </a:rPr>
+            <a:r>
+              <a:rPr sz="2800"/>
               <a:t>The challenge: invent a stat good enough for live television</a:t>
             </a:r>
           </a:p>
@@ -6894,61 +6914,34 @@
           <a:p>
             <a:pPr>
               <a:spcAft>
-                <a:spcPts val="600"/>
+                <a:spcPts val="1200"/>
               </a:spcAft>
             </a:pPr>
             <a:r>
-              <a:rPr sz="1800">
-                <a:solidFill>
-                  <a:srgbClr val="F0F0F0"/>
-                </a:solidFill>
-              </a:rPr>
-              <a:t>The Big Data Bowl is the yearly analytics contest run by NFL Football Operations together with Amazon Web Services, using real player-tracking data from the league's Next Gen Stats system.</a:t>
+              <a:rPr sz="1800"/>
+              <a:t>The Big Data Bowl is the yearly contest run by NFL Football Operations with Amazon Web Services, using real player-tracking data from Next Gen Stats.</a:t>
             </a:r>
           </a:p>
           <a:p>
             <a:pPr>
               <a:spcAft>
-                <a:spcPts val="600"/>
+                <a:spcPts val="1200"/>
               </a:spcAft>
             </a:pPr>
             <a:r>
-              <a:rPr sz="1800">
-                <a:solidFill>
-                  <a:srgbClr val="F0F0F0"/>
-                </a:solidFill>
-              </a:rPr>
-              <a:t>Every tracked player is located ten times per second (10 hertz), so each play yields hundreds of position, speed, and acceleration readings for analysis.</a:t>
+              <a:rPr sz="1800"/>
+              <a:t>Every tracked player is located ten times per second, so each play yields hundreds of position, speed, and acceleration readings.</a:t>
             </a:r>
           </a:p>
           <a:p>
             <a:pPr>
               <a:spcAft>
-                <a:spcPts val="600"/>
+                <a:spcPts val="1200"/>
               </a:spcAft>
             </a:pPr>
             <a:r>
-              <a:rPr sz="1800">
-                <a:solidFill>
-                  <a:srgbClr val="F0F0F0"/>
-                </a:solidFill>
-              </a:rPr>
-              <a:t>The winning entries become real products: past winners have gone on to appear in live television broadcasts and in the analytics dashboards used by club front offices.</a:t>
-            </a:r>
-          </a:p>
-          <a:p>
-            <a:pPr>
-              <a:spcAft>
-                <a:spcPts val="600"/>
-              </a:spcAft>
-            </a:pPr>
-            <a:r>
-              <a:rPr sz="1800">
-                <a:solidFill>
-                  <a:srgbClr val="F0F0F0"/>
-                </a:solidFill>
-              </a:rPr>
-              <a:t>Eight editions ran from 2019 through 2026, and the 2027 edition had not been announced as of September 2026, so this entry is preparation, not a reaction to a published topic.</a:t>
+              <a:rPr sz="1800"/>
+              <a:t>Winners become real products: past entries now appear in live broadcasts and club front-office dashboards.</a:t>
             </a:r>
           </a:p>
         </p:txBody>
@@ -7122,14 +7115,9 @@
           </a:bodyPr>
           <a:lstStyle/>
           <a:p>
-            <a:pPr algn="l"/>
-            <a:r>
-              <a:rPr b="1" sz="3200">
-                <a:solidFill>
-                  <a:srgbClr val="D7C7EE"/>
-                </a:solidFill>
-              </a:rPr>
-              <a:t>A $100,000 contest at NFL scale — and a hiring pipeline</a:t>
+            <a:r>
+              <a:rPr sz="2800"/>
+              <a:t>A $100,000 contest at NFL scale, and a hiring pipeline</a:t>
             </a:r>
           </a:p>
         </p:txBody>
@@ -7158,76 +7146,34 @@
           <a:p>
             <a:pPr>
               <a:spcAft>
-                <a:spcPts val="600"/>
+                <a:spcPts val="1200"/>
               </a:spcAft>
             </a:pPr>
             <a:r>
-              <a:rPr sz="1800">
-                <a:solidFill>
-                  <a:srgbClr val="F0F0F0"/>
-                </a:solidFill>
-              </a:rPr>
-              <a:t>The 2026 contest offers a $100,000 prize pool, and its finalists present in person at the 2026 NFL Scouting Combine (per NFL Football Operations hub and AWS Sports tracks page; as of September 2025 announcements).</a:t>
+              <a:rPr sz="1800"/>
+              <a:t>The 2026 contest offered a $100,000 prize pool with finalists presenting at the Scouting Combine, and drew a reported 8,329 registrations from 771 teams across 69 countries.</a:t>
             </a:r>
           </a:p>
           <a:p>
             <a:pPr>
               <a:spcAft>
-                <a:spcPts val="600"/>
+                <a:spcPts val="1200"/>
               </a:spcAft>
             </a:pPr>
             <a:r>
-              <a:rPr sz="1800">
-                <a:solidFill>
-                  <a:srgbClr val="F0F0F0"/>
-                </a:solidFill>
-              </a:rPr>
-              <a:t>The 2026 edition drew 8,329 registrations from 771 teams across 69 countries (single-sourced and provisional, summarizing the December 2025 results; treat as approximate until the NFL confirms).</a:t>
+              <a:rPr sz="1800"/>
+              <a:t>Amazon Web Services reports processing over 500 million tracking data points per season, feeding 75-plus machine-learning statistics including rushing yards over expected.</a:t>
             </a:r>
           </a:p>
           <a:p>
             <a:pPr>
               <a:spcAft>
-                <a:spcPts val="600"/>
+                <a:spcPts val="1200"/>
               </a:spcAft>
             </a:pPr>
             <a:r>
-              <a:rPr sz="1800">
-                <a:solidFill>
-                  <a:srgbClr val="F0F0F0"/>
-                </a:solidFill>
-              </a:rPr>
-              <a:t>AWS (Amazon Web Services) processes more than 500 million player-tracking data points per NFL season (per the AWS Sports NFL page; figure undated, restate as 'AWS reports 500M+ per season').</a:t>
-            </a:r>
-          </a:p>
-          <a:p>
-            <a:pPr>
-              <a:spcAft>
-                <a:spcPts val="600"/>
-              </a:spcAft>
-            </a:pPr>
-            <a:r>
-              <a:rPr sz="1800">
-                <a:solidFill>
-                  <a:srgbClr val="F0F0F0"/>
-                </a:solidFill>
-              </a:rPr>
-              <a:t>The league's pipeline already ships 75+ machine-learning (ML) statistics including rushing yards over expected, built on this tracking data (per AWS Media blog; as of the 2025-2026 partnership announcements).</a:t>
-            </a:r>
-          </a:p>
-          <a:p>
-            <a:pPr>
-              <a:spcAft>
-                <a:spcPts val="600"/>
-              </a:spcAft>
-            </a:pPr>
-            <a:r>
-              <a:rPr sz="1800">
-                <a:solidFill>
-                  <a:srgbClr val="F0F0F0"/>
-                </a:solidFill>
-              </a:rPr>
-              <a:t>More than 50 past entrants have been hired into football analytics roles, with 30+ hired directly by teams or vendors (per September 2024 reporting plus talk notes; single-sourced — say 'reportedly' on stage).</a:t>
+              <a:rPr sz="1800"/>
+              <a:t>More than 50 past entrants were reportedly hired into football analytics roles, over 30 by teams or vendors directly.</a:t>
             </a:r>
           </a:p>
         </p:txBody>
@@ -7401,14 +7347,9 @@
           </a:bodyPr>
           <a:lstStyle/>
           <a:p>
-            <a:pPr algn="l"/>
-            <a:r>
-              <a:rPr b="1" sz="2800">
-                <a:solidFill>
-                  <a:srgbClr val="D7C7EE"/>
-                </a:solidFill>
-              </a:rPr>
-              <a:t>Winning ideas reach the broadcast: from contest entry to television statistic</a:t>
+            <a:r>
+              <a:rPr sz="2800"/>
+              <a:t>Winning ideas reach the broadcast: from entry to television statistic</a:t>
             </a:r>
           </a:p>
         </p:txBody>
@@ -7437,61 +7378,34 @@
           <a:p>
             <a:pPr>
               <a:spcAft>
-                <a:spcPts val="600"/>
+                <a:spcPts val="1200"/>
               </a:spcAft>
             </a:pPr>
             <a:r>
-              <a:rPr sz="1800">
-                <a:solidFill>
-                  <a:srgbClr val="F0F0F0"/>
-                </a:solidFill>
-              </a:rPr>
-              <a:t>In 2020, Philipp Singer and Dmitry Gordeev of H2O AI, competing as team the Zoo, won by predicting the full distribution of rushing yards from handoff positions and velocities, and their approach became the expected rushing yards television statistic within about six months.</a:t>
+              <a:rPr sz="1800"/>
+              <a:t>In 2020, team the Zoo won by predicting the full distribution of rushing yards from handoff positions and velocities, and their approach became the expected rushing yards TV stat within about six months.</a:t>
             </a:r>
           </a:p>
           <a:p>
             <a:pPr>
               <a:spcAft>
-                <a:spcPts val="600"/>
+                <a:spcPts val="1200"/>
               </a:spcAft>
             </a:pPr>
             <a:r>
-              <a:rPr sz="1800">
-                <a:solidFill>
-                  <a:srgbClr val="F0F0F0"/>
-                </a:solidFill>
-              </a:rPr>
-              <a:t>The same 2020 pipeline produced three follow-on television statistics measured in yards and probabilities from zero to one: rushing yards over expected, first-down probability, and touchdown probability.</a:t>
+              <a:rPr sz="1800"/>
+              <a:t>The same pipeline produced rushing yards over expected, first-down probability, and touchdown probability.</a:t>
             </a:r>
           </a:p>
           <a:p>
             <a:pPr>
               <a:spcAft>
-                <a:spcPts val="600"/>
+                <a:spcPts val="1200"/>
               </a:spcAft>
             </a:pPr>
             <a:r>
-              <a:rPr sz="1800">
-                <a:solidFill>
-                  <a:srgbClr val="F0F0F0"/>
-                </a:solidFill>
-              </a:rPr>
-              <a:t>In 2023, the pocket-pressure contest fed the deployed pressure probability statistic, which combines four models trained over 90,000 plays.</a:t>
-            </a:r>
-          </a:p>
-          <a:p>
-            <a:pPr>
-              <a:spcAft>
-                <a:spcPts val="600"/>
-              </a:spcAft>
-            </a:pPr>
-            <a:r>
-              <a:rPr sz="1800">
-                <a:solidFill>
-                  <a:srgbClr val="F0F0F0"/>
-                </a:solidFill>
-              </a:rPr>
-              <a:t>In 2024, the missed-tackle contest fed the deployed tackle probability statistic, which uses 20 features per defender across 11 defenders, trained on 2018 through 2022 seasons and tested on 2023.</a:t>
+              <a:rPr sz="1800"/>
+              <a:t>The 2023 pocket-pressure contest fed deployed pressure probability trained over 90,000 plays, and the 2024 contest fed tackle probability using 20 features per defender across 11 defenders.</a:t>
             </a:r>
           </a:p>
         </p:txBody>
@@ -7666,6 +7580,7 @@
           <a:lstStyle/>
           <a:p>
             <a:r>
+              <a:rPr sz="2800"/>
               <a:t>The data: every player and the ball, ten times per second</a:t>
             </a:r>
           </a:p>
@@ -7695,29 +7610,34 @@
           <a:p>
             <a:pPr>
               <a:spcAft>
-                <a:spcPts val="1000"/>
+                <a:spcPts val="1200"/>
               </a:spcAft>
             </a:pPr>
             <a:r>
-              <a:t>Radio-frequency identification tags sewn into shoulder pads plus a sensor ball built by Wilson feed position hardware from Zebra, and the league samples every tracked player and the ball at 10 hertz from snap to whistle.</a:t>
-            </a:r>
-          </a:p>
-          <a:p>
-            <a:pPr/>
-            <a:r>
-              <a:t>Each row carries field coordinates x and y in yards, speed s in yards per second, acceleration a in yards per second squared, distance traveled dis, orientation o, direction dir, the tagged event, frame identifier, and player identifier, with frame type added in the 2025 season feed.</a:t>
-            </a:r>
-          </a:p>
-          <a:p>
-            <a:pPr/>
-            <a:r>
-              <a:t>The join keys are game identifier, play identifier, and player identifier, and roster and game context attach through nflverse using the legacy game identifier with play identifier cast to integer (docs/muse-code.md, as of September 2026).</a:t>
-            </a:r>
-          </a:p>
-          <a:p>
-            <a:pPr/>
-            <a:r>
-              <a:t>Weekly comma-separated files run about 1.5 gigabytes each, so the repository seeds from a 1.6 gigabyte 2024 slice plus a 7.7 gigabyte 2025 slice and demos run on a 25-play in-git sample that answers every query in seconds.</a:t>
+              <a:rPr sz="1800"/>
+              <a:t>Radio-frequency identification tags in shoulder pads plus a Wilson sensor ball feed Zebra position hardware, sampling every player and the ball at 10 hertz from snap to whistle.</a:t>
+            </a:r>
+          </a:p>
+          <a:p>
+            <a:pPr>
+              <a:spcAft>
+                <a:spcPts val="1200"/>
+              </a:spcAft>
+            </a:pPr>
+            <a:r>
+              <a:rPr sz="1800"/>
+              <a:t>Each row carries field coordinates x and y in yards, speed, acceleration, distance, orientation, direction, the tagged event, and frame, play, and player identifiers.</a:t>
+            </a:r>
+          </a:p>
+          <a:p>
+            <a:pPr>
+              <a:spcAft>
+                <a:spcPts val="1200"/>
+              </a:spcAft>
+            </a:pPr>
+            <a:r>
+              <a:rPr sz="1800"/>
+              <a:t>Weeks arrive as comma-separated files near 1.5 gigabytes each, so demos run on a 25-play in-git sample that answers every query in seconds.</a:t>
             </a:r>
           </a:p>
         </p:txBody>
@@ -7892,7 +7812,8 @@
           <a:lstStyle/>
           <a:p>
             <a:r>
-              <a:t>Workflow 1: explore the sample first</a:t>
+              <a:rPr sz="2800"/>
+              <a:t>Workflow 1: Explore the sample first</a:t>
             </a:r>
           </a:p>
         </p:txBody>
@@ -7921,61 +7842,34 @@
           <a:p>
             <a:pPr>
               <a:spcAft>
-                <a:spcPts val="600"/>
+                <a:spcPts val="1200"/>
               </a:spcAft>
             </a:pPr>
             <a:r>
-              <a:rPr sz="1800">
-                <a:solidFill>
-                  <a:srgbClr val="F0F0F0"/>
-                </a:solidFill>
-              </a:rPr>
-              <a:t>Start with the in-git sample slice instead of the full download: samples/2024/tracking_sample.csv holds 19,113 tracking rows across 25 plays, and samples/2025 holds 92,069 rows, so every query runs in seconds with zero download.</a:t>
+              <a:rPr sz="1800"/>
+              <a:t>The sample slice samples/2024/tracking_sample.csv holds 19,113 tracking rows across 25 plays, so every query runs in seconds with zero download.</a:t>
             </a:r>
           </a:p>
           <a:p>
             <a:pPr>
               <a:spcAft>
-                <a:spcPts val="600"/>
+                <a:spcPts val="1200"/>
               </a:spcAft>
             </a:pPr>
             <a:r>
-              <a:rPr sz="1800">
-                <a:solidFill>
-                  <a:srgbClr val="F0F0F0"/>
-                </a:solidFill>
-              </a:rPr>
-              <a:t>The explore script joins tracking_sample.csv with games.csv, plays.csv, and players.csv on gameId, playId, and nflId, then prints one play frame by frame and plots all 22 players plus the ball.</a:t>
+              <a:rPr sz="1800"/>
+              <a:t>The explore script joins tracking with games, plays, and players on game, play, and player identifiers, then prints one play frame by frame and plots all 22 players plus the ball.</a:t>
             </a:r>
           </a:p>
           <a:p>
             <a:pPr>
               <a:spcAft>
-                <a:spcPts val="600"/>
+                <a:spcPts val="1200"/>
               </a:spcAft>
             </a:pPr>
             <a:r>
-              <a:rPr sz="1800">
-                <a:solidFill>
-                  <a:srgbClr val="F0F0F0"/>
-                </a:solidFill>
-              </a:rPr>
-              <a:t>The narrative example is gameId 2022090800, playId 56 (Buffalo at Los Angeles, September 8 2022) with tagged events pass_arrived, pass_outcome_caught, and tackle.</a:t>
-            </a:r>
-          </a:p>
-          <a:p>
-            <a:pPr>
-              <a:spcAft>
-                <a:spcPts val="600"/>
-              </a:spcAft>
-            </a:pPr>
-            <a:r>
-              <a:rPr sz="1800">
-                <a:solidFill>
-                  <a:srgbClr val="F0F0F0"/>
-                </a:solidFill>
-              </a:rPr>
-              <a:t>Column units are explicit: x spans 0 to 120 yards of field length, y spans 0 to 53.3 yards of width, s is yards per second, a is yards per second squared, dis is yards since the prior frame, and o and dir are 0 to 360 degrees; once the query reads right on the sample, the identical prompt is replayed headlessly with muse exec against full week files.</a:t>
+              <a:rPr sz="1800"/>
+              <a:t>Column units are explicit: x spans 0 to 120 yards, y spans 0 to 53.3, speed and acceleration are per-second, orientation is 0 to 360 degrees.</a:t>
             </a:r>
           </a:p>
         </p:txBody>
@@ -8149,14 +8043,9 @@
           </a:bodyPr>
           <a:lstStyle/>
           <a:p>
-            <a:pPr algn="l"/>
-            <a:r>
-              <a:rPr b="1" sz="2800">
-                <a:solidFill>
-                  <a:srgbClr val="D7C7EE"/>
-                </a:solidFill>
-              </a:rPr>
-              <a:t>Workflow 2: convert weekly tracking files to Parquet once, reuse forever</a:t>
+            <a:r>
+              <a:rPr sz="2800"/>
+              <a:t>Workflow 2: Convert weekly files to Parquet once, reuse forever</a:t>
             </a:r>
           </a:p>
         </p:txBody>
@@ -8185,61 +8074,34 @@
           <a:p>
             <a:pPr>
               <a:spcAft>
-                <a:spcPts val="600"/>
+                <a:spcPts val="1200"/>
               </a:spcAft>
             </a:pPr>
             <a:r>
-              <a:rPr sz="1800">
-                <a:solidFill>
-                  <a:srgbClr val="F0F0F0"/>
-                </a:solidFill>
-              </a:rPr>
-              <a:t>Weekly player-tracking files are too large to load into memory at once, so the pipeline reads them in chunks using pandas chunksize reads of 200,000 rows (or a Polars lazy scan plus sink), which keeps memory flat regardless of file size.</a:t>
+              <a:rPr sz="1800"/>
+              <a:t>Weekly tracking files are too large to hold in memory, so the pipeline reads them in chunks of 200,000 rows, keeping memory flat regardless of file size.</a:t>
             </a:r>
           </a:p>
           <a:p>
             <a:pPr>
               <a:spcAft>
-                <a:spcPts val="600"/>
+                <a:spcPts val="1200"/>
               </a:spcAft>
             </a:pPr>
             <a:r>
-              <a:rPr sz="1800">
-                <a:solidFill>
-                  <a:srgbClr val="F0F0F0"/>
-                </a:solidFill>
-              </a:rPr>
-              <a:t>Each weekly tracking file is converted to Parquet format exactly once, and every later step (features, sweeps, plots) reads the fast Parquet copy, so the conversion cost is paid one time and all downstream runs get faster.</a:t>
+              <a:rPr sz="1800"/>
+              <a:t>Each week converts to Parquet format exactly once, and every later step reads the fast copy, so the cost is paid one time and all downstream runs speed up.</a:t>
             </a:r>
           </a:p>
           <a:p>
             <a:pPr>
               <a:spcAft>
-                <a:spcPts val="600"/>
+                <a:spcPts val="1200"/>
               </a:spcAft>
             </a:pPr>
             <a:r>
-              <a:rPr sz="1800">
-                <a:solidFill>
-                  <a:srgbClr val="F0F0F0"/>
-                </a:solidFill>
-              </a:rPr>
-              <a:t>The rebuild script (scripts/weeks_to_parquet.py) is written before any feature code: raw comma-separated-value files stay read-only and are never overwritten, while all generated files land in the rebuildable data/scratch/ directory.</a:t>
-            </a:r>
-          </a:p>
-          <a:p>
-            <a:pPr>
-              <a:spcAft>
-                <a:spcPts val="600"/>
-              </a:spcAft>
-            </a:pPr>
-            <a:r>
-              <a:rPr sz="1800">
-                <a:solidFill>
-                  <a:srgbClr val="F0F0F0"/>
-                </a:solidFill>
-              </a:rPr>
-              <a:t>Disk budget is about 2 gigabytes per weekly file uncompressed; the converter aggregates each file to one row per game, play, and player with mean motion columns plus frame count.</a:t>
+              <a:rPr sz="1800"/>
+              <a:t>Raw files stay read-only and are never overwritten, while everything generated lands in the rebuildable data/scratch/ directory.</a:t>
             </a:r>
           </a:p>
         </p:txBody>
@@ -8414,7 +8276,8 @@
           <a:lstStyle/>
           <a:p>
             <a:r>
-              <a:t>Workflow 3: build features frame by frame, from the ground up</a:t>
+              <a:rPr sz="2800"/>
+              <a:t>Workflow 3: Build features frame by frame, from the ground up</a:t>
             </a:r>
           </a:p>
         </p:txBody>
@@ -8443,29 +8306,34 @@
           <a:p>
             <a:pPr>
               <a:spcAft>
-                <a:spcPts val="1000"/>
+                <a:spcPts val="1200"/>
               </a:spcAft>
             </a:pPr>
             <a:r>
-              <a:t>The league shape of a winning entry is frame-level features feeding per-player models that roll up to one play-level stat, so every row of tracking earns its keep instead of decorating a box-score model (docs/muse-code.md, as of September 2026).</a:t>
-            </a:r>
-          </a:p>
-          <a:p>
-            <a:pPr/>
-            <a:r>
-              <a:t>Base motion columns are speed, acceleration, and distance to the line of scrimmage in yards, plus numeric formation encodings that capture offensive and defensive alignment the way past winners encoded pressure-scheme context.</a:t>
-            </a:r>
-          </a:p>
-          <a:p>
-            <a:pPr/>
-            <a:r>
-              <a:t>The tackle-probability workhorse is a frame-by-frame convolutional network, which is a neural network swept across consecutive frames, following the 2024 winning approach trained at that granularity.</a:t>
-            </a:r>
-          </a:p>
-          <a:p>
-            <a:pPr/>
-            <a:r>
-              <a:t>We standardize on LightGBM over XGBoost for the tree stage because it trains faster and holds less memory on laptop-scale weekly data, with scripts/features_frame_up.py emitting a 50-row by 19-column demonstration frame.</a:t>
+              <a:rPr sz="1800"/>
+              <a:t>A winning entry is frame-level features feeding per-player models that roll up to one play-level stat, so every tracking row earns its keep.</a:t>
+            </a:r>
+          </a:p>
+          <a:p>
+            <a:pPr>
+              <a:spcAft>
+                <a:spcPts val="1200"/>
+              </a:spcAft>
+            </a:pPr>
+            <a:r>
+              <a:rPr sz="1800"/>
+              <a:t>Base columns are speed, acceleration, and distance to the line in yards, plus numeric formation encodings for offensive and defensive alignment.</a:t>
+            </a:r>
+          </a:p>
+          <a:p>
+            <a:pPr>
+              <a:spcAft>
+                <a:spcPts val="1200"/>
+              </a:spcAft>
+            </a:pPr>
+            <a:r>
+              <a:rPr sz="1800"/>
+              <a:t>The tackle-probability workhorse is a frame-by-frame convolutional network, and the tree stage standardizes on LightGBM over XGBoost for speed and memory.</a:t>
             </a:r>
           </a:p>
         </p:txBody>
@@ -8640,7 +8508,8 @@
           <a:lstStyle/>
           <a:p>
             <a:r>
-              <a:t>Workflow 4: set a lasso baseline, then earn the ensemble</a:t>
+              <a:rPr sz="2800"/>
+              <a:t>Workflow 4: Set a lasso baseline, then earn the ensemble</a:t>
             </a:r>
           </a:p>
         </p:txBody>
@@ -8669,29 +8538,34 @@
           <a:p>
             <a:pPr>
               <a:spcAft>
-                <a:spcPts val="1000"/>
+                <a:spcPts val="1200"/>
               </a:spcAft>
             </a:pPr>
             <a:r>
-              <a:t>Every modeling run starts from a lasso-logistic baseline, which is logistic regression with an L1 penalty, reported against naive base-rate frequencies with cross-validated accuracy plus standard errors, and the demo baseline scores 0.700 plus or minus 0.110 (scripts/baseline_lasso.py, as of September 2026).</a:t>
-            </a:r>
-          </a:p>
-          <a:p>
-            <a:pPr/>
-            <a:r>
-              <a:t>Folds are grouped by play so all frames of one play stay together, which prevents leakage where the model would otherwise train and test on adjacent frames of the same action.</a:t>
-            </a:r>
-          </a:p>
-          <a:p>
-            <a:pPr/>
-            <a:r>
-              <a:t>The ensemble stage tries XGBoost, LightGBM, and CatBoost with Optuna tuning, but only results that beat the baseline by more than one standard error survive, following the Yurko discipline wired into docs/muse-code.md.</a:t>
-            </a:r>
-          </a:p>
-          <a:p>
-            <a:pPr/>
-            <a:r>
-              <a:t>One random seed plus one frozen configuration is stored per output directory, so any two runs remain directly comparable and a rerun reproduces the same numbers.</a:t>
+              <a:rPr sz="1800"/>
+              <a:t>Every run starts from a lasso-logistic baseline scored against naive base rates with cross-validated accuracy plus errors: the demo scores 0.700 plus or minus 0.110.</a:t>
+            </a:r>
+          </a:p>
+          <a:p>
+            <a:pPr>
+              <a:spcAft>
+                <a:spcPts val="1200"/>
+              </a:spcAft>
+            </a:pPr>
+            <a:r>
+              <a:rPr sz="1800"/>
+              <a:t>Folds are grouped by play so all frames of one play stay together, preventing leakage between adjacent frames of the same action.</a:t>
+            </a:r>
+          </a:p>
+          <a:p>
+            <a:pPr>
+              <a:spcAft>
+                <a:spcPts val="1200"/>
+              </a:spcAft>
+            </a:pPr>
+            <a:r>
+              <a:rPr sz="1800"/>
+              <a:t>The ensemble tries XGBoost, LightGBM, and CatBoost, but only results beating the baseline by a full standard error survive, with one frozen seed and config per output directory.</a:t>
             </a:r>
           </a:p>
         </p:txBody>

</xml_diff>

<commit_message>
deck: terse telegraphic rewrite, zero filler, 20pt bullets
</commit_message>
<xml_diff>
--- a/deck/unified.pptx
+++ b/deck/unified.pptx
@@ -4796,8 +4796,8 @@
           <a:lstStyle/>
           <a:p>
             <a:r>
-              <a:rPr sz="2800"/>
-              <a:t>Big Data Bowl meets Muse Code: NFL tracking data, worked live in the terminal</a:t>
+              <a:rPr sz="3200"/>
+              <a:t>Big Data Bowl x Muse Code: NFL tracking, live in terminal</a:t>
             </a:r>
           </a:p>
         </p:txBody>
@@ -4826,34 +4826,34 @@
           <a:p>
             <a:pPr>
               <a:spcAft>
-                <a:spcPts val="1200"/>
+                <a:spcPts val="1400"/>
               </a:spcAft>
             </a:pPr>
             <a:r>
-              <a:rPr sz="1800"/>
-              <a:t>The NFL Big Data Bowl is the league's annual analytics contest, run with Amazon Web Services, and this talk uses it as the vehicle.</a:t>
+              <a:rPr sz="2000"/>
+              <a:t>Big Data Bowl = vehicle. Muse Code = instrument.</a:t>
             </a:r>
           </a:p>
           <a:p>
             <a:pPr>
               <a:spcAft>
-                <a:spcPts val="1200"/>
+                <a:spcPts val="1400"/>
               </a:spcAft>
             </a:pPr>
             <a:r>
-              <a:rPr sz="1800"/>
-              <a:t>Muse Code is the agentic coding CLI we drive live on screen, and it is the instrument.</a:t>
+              <a:rPr sz="2000"/>
+              <a:t>NFL Next Gen Stats: every player + ball, 10 Hz.</a:t>
             </a:r>
           </a:p>
           <a:p>
             <a:pPr>
               <a:spcAft>
-                <a:spcPts val="1200"/>
+                <a:spcPts val="1400"/>
               </a:spcAft>
             </a:pPr>
             <a:r>
-              <a:rPr sz="1800"/>
-              <a:t>Our raw material is Next Gen Stats: league tracking data for every player and the ball, sampled ten times per second.</a:t>
+              <a:rPr sz="2000"/>
+              <a:t>17 slides. Live demos. No mockups.</a:t>
             </a:r>
           </a:p>
         </p:txBody>
@@ -5028,8 +5028,8 @@
           <a:lstStyle/>
           <a:p>
             <a:r>
-              <a:rPr sz="2800"/>
-              <a:t>Skills, batch sweeps, and a sandbox that guards the raw data</a:t>
+              <a:rPr sz="3200"/>
+              <a:t>Skills + sweeps + guardrails.</a:t>
             </a:r>
           </a:p>
         </p:txBody>
@@ -5058,34 +5058,34 @@
           <a:p>
             <a:pPr>
               <a:spcAft>
-                <a:spcPts val="1200"/>
+                <a:spcPts val="1400"/>
               </a:spcAft>
             </a:pPr>
             <a:r>
-              <a:rPr sz="1800"/>
-              <a:t>Three reusable skills carry the repeated work: chunk-to-parquet converts weeks, join-and-slice answers one-question cuts, and baseline-ensemble runs the model ladder.</a:t>
+              <a:rPr sz="2000"/>
+              <a:t>3 skills: chunk-to-parquet. join-and-slice. baseline-ensemble.</a:t>
             </a:r>
           </a:p>
           <a:p>
             <a:pPr>
               <a:spcAft>
-                <a:spcPts val="1200"/>
+                <a:spcPts val="1400"/>
               </a:spcAft>
             </a:pPr>
             <a:r>
-              <a:rPr sz="1800"/>
-              <a:t>The batch runner issues one headless prompt per question across all weeks, writing one results file plus one chart per question for morning review.</a:t>
+              <a:rPr sz="2000"/>
+              <a:t>sweep_weeks.sh: one prompt per question. CSV + PNG each.</a:t>
             </a:r>
           </a:p>
           <a:p>
             <a:pPr>
               <a:spcAft>
-                <a:spcPts val="1200"/>
+                <a:spcPts val="1400"/>
               </a:spcAft>
             </a:pPr>
             <a:r>
-              <a:rPr sz="1800"/>
-              <a:t>A guard script trips when raw-file timestamps move, data/ stays read-only, and free review runs happen on the local Glimmer model.</a:t>
+              <a:rPr sz="2000"/>
+              <a:t>guard_data.sh trips on raw moves. Reviews on free local Glimmer.</a:t>
             </a:r>
           </a:p>
         </p:txBody>
@@ -5260,8 +5260,8 @@
           <a:lstStyle/>
           <a:p>
             <a:r>
-              <a:rPr sz="2800"/>
-              <a:t>Craft: what the grading rubric actually rewards</a:t>
+              <a:rPr sz="3200"/>
+              <a:t>Graders reward: 30 / 30 / 20 / 20.</a:t>
             </a:r>
           </a:p>
         </p:txBody>
@@ -5290,34 +5290,34 @@
           <a:p>
             <a:pPr>
               <a:spcAft>
-                <a:spcPts val="1200"/>
+                <a:spcPts val="1400"/>
               </a:spcAft>
             </a:pPr>
             <a:r>
-              <a:rPr sz="1800"/>
-              <a:t>The rubric splits 100 points into 30 for football insight, 30 for data science, 20 for the report, and 20 for visuals, capped at 2,000 words and under 10 figures.</a:t>
+              <a:rPr sz="2000"/>
+              <a:t>Football 30. Data science 30. Report 20. Visuals 20.</a:t>
             </a:r>
           </a:p>
           <a:p>
             <a:pPr>
               <a:spcAft>
-                <a:spcPts val="1200"/>
+                <a:spcPts val="1400"/>
               </a:spcAft>
             </a:pPr>
             <a:r>
-              <a:rPr sz="1800"/>
-              <a:t>Tracking data must do causal work in the entry, not decorate a box-score argument: that is the most common way strong models lose.</a:t>
+              <a:rPr sz="2000"/>
+              <a:t>2,000 words. Under 10 figures. Every chart argues.</a:t>
             </a:r>
           </a:p>
           <a:p>
             <a:pPr>
               <a:spcAft>
-                <a:spcPts val="1200"/>
+                <a:spcPts val="1400"/>
               </a:spcAft>
             </a:pPr>
             <a:r>
-              <a:rPr sz="1800"/>
-              <a:t>Answer the prompt as written, report base rates with a simple baseline plus errors, state limits, and make it look expensive.</a:t>
+              <a:rPr sz="2000"/>
+              <a:t>Tracking must cause, not decorate. Base rates + baseline + errors. State limits.</a:t>
             </a:r>
           </a:p>
         </p:txBody>
@@ -5492,8 +5492,8 @@
           <a:lstStyle/>
           <a:p>
             <a:r>
-              <a:rPr sz="2800"/>
-              <a:t>2027 forecast: where the next topic likely goes</a:t>
+              <a:rPr sz="3200"/>
+              <a:t>2027 forecast: defense is due.</a:t>
             </a:r>
           </a:p>
         </p:txBody>
@@ -5522,34 +5522,34 @@
           <a:p>
             <a:pPr>
               <a:spcAft>
-                <a:spcPts val="1200"/>
+                <a:spcPts val="1400"/>
               </a:spcAft>
             </a:pPr>
             <a:r>
-              <a:rPr sz="1800"/>
-              <a:t>The 2026 contest opened September 25, 2025, so with 2027 unannounced as of September 2026 it could land any day, and the day-one checklist is already written.</a:t>
+              <a:rPr sz="2000"/>
+              <a:t>2026 opened Sep 25, 2025. 2027 unannounced: could drop any day.</a:t>
             </a:r>
           </a:p>
           <a:p>
             <a:pPr>
               <a:spcAft>
-                <a:spcPts val="1200"/>
+                <a:spcPts val="1400"/>
               </a:spcAft>
             </a:pPr>
             <a:r>
-              <a:rPr sz="1800"/>
-              <a:t>History alternates prediction years with metric-definition years, and with offense topics banked, a defensive topic is due.</a:t>
+              <a:rPr sz="2000"/>
+              <a:t>Prediction years alternate metric years. Offense banked. Defense next.</a:t>
             </a:r>
           </a:p>
           <a:p>
             <a:pPr>
               <a:spcAft>
-                <a:spcPts val="1200"/>
+                <a:spcPts val="1400"/>
               </a:spcAft>
             </a:pPr>
             <a:r>
-              <a:rPr sz="1800"/>
-              <a:t>Most likely: ghost counterfactual receiver paths, the redesigned kickoff, or run blocking. Winners build tooling before the topic exists.</a:t>
+              <a:rPr sz="2000"/>
+              <a:t>Shortlist: ghost paths. New kickoff. Run blocking. Tooling built pre-topic.</a:t>
             </a:r>
           </a:p>
         </p:txBody>
@@ -5724,8 +5724,8 @@
           <a:lstStyle/>
           <a:p>
             <a:r>
-              <a:rPr sz="2800"/>
-              <a:t>Glimmer proof, live: a 30-billion-parameter local teammate</a:t>
+              <a:rPr sz="3200"/>
+              <a:t>Glimmer: 30B params. One workstation. Live.</a:t>
             </a:r>
           </a:p>
         </p:txBody>
@@ -5754,34 +5754,34 @@
           <a:p>
             <a:pPr>
               <a:spcAft>
-                <a:spcPts val="1200"/>
+                <a:spcPts val="1400"/>
               </a:spcAft>
             </a:pPr>
             <a:r>
-              <a:rPr sz="1800"/>
-              <a:t>Glimmer is a 30-billion-parameter open-weights model distilled from Muse Spark, running on a single workstation with a 12-gigabyte graphics card.</a:t>
+              <a:rPr sz="2000"/>
+              <a:t>Open weights. Apache 2.0. Distilled from Muse Spark.</a:t>
             </a:r>
           </a:p>
           <a:p>
             <a:pPr>
               <a:spcAft>
-                <a:spcPts val="1200"/>
+                <a:spcPts val="1400"/>
               </a:spcAft>
             </a:pPr>
             <a:r>
-              <a:rPr sz="1800"/>
-              <a:t>It serves an OpenAI-compatible endpoint behind a supervisor that cold-starts in about 8 seconds and tears down after 300 idle seconds.</a:t>
+              <a:rPr sz="2000"/>
+              <a:t>12 GB card. 13 GPU layers. 4,096-token window. 4-bit quant.</a:t>
             </a:r>
           </a:p>
           <a:p>
             <a:pPr>
               <a:spcAft>
-                <a:spcPts val="1200"/>
+                <a:spcPts val="1400"/>
               </a:spcAft>
             </a:pPr>
             <a:r>
-              <a:rPr sz="1800"/>
-              <a:t>Thirteen GPU layers with a 4,096-token window fit the card, and a mutual-exclusion key serializes access: locked answers HTTP 503, free answers 200.</a:t>
+              <a:rPr sz="2000"/>
+              <a:t>OpenAI-compatible :8181. Cold start ~8s. Locked = 503. Free = 200.</a:t>
             </a:r>
           </a:p>
         </p:txBody>
@@ -5956,8 +5956,8 @@
           <a:lstStyle/>
           <a:p>
             <a:r>
-              <a:rPr sz="2800"/>
-              <a:t>Live numbers: what 13 GPU layers actually buy on this card</a:t>
+              <a:rPr sz="3200"/>
+              <a:t>13 GPU layers buy nothing here.</a:t>
             </a:r>
           </a:p>
         </p:txBody>
@@ -5986,34 +5986,34 @@
           <a:p>
             <a:pPr>
               <a:spcAft>
-                <a:spcPts val="1200"/>
+                <a:spcPts val="1400"/>
               </a:spcAft>
             </a:pPr>
             <a:r>
-              <a:rPr sz="1800"/>
-              <a:t>CPU-only mode answers a warm prompt in 41.7 seconds at 5.7 prompt tokens per second, holding near-zero graphics memory.</a:t>
+              <a:rPr sz="2000"/>
+              <a:t>CPU-only: 41.7s warm. 5.7 tok/s prompt. ~0 GPU.</a:t>
             </a:r>
           </a:p>
           <a:p>
             <a:pPr>
               <a:spcAft>
-                <a:spcPts val="1200"/>
+                <a:spcPts val="1400"/>
               </a:spcAft>
             </a:pPr>
             <a:r>
-              <a:rPr sz="1800"/>
-              <a:t>With 13 GPU layers the same prompt takes 186.7 seconds at 1.75 tokens per second holding 11.62 gigabytes: the offload buys nothing at generation because decoding is bandwidth-bound.</a:t>
+              <a:rPr sz="2000"/>
+              <a:t>NGL 13: 186.7s. 1.75 tok/s. 11.62 GB held. Bandwidth-bound decode.</a:t>
             </a:r>
           </a:p>
           <a:p>
             <a:pPr>
               <a:spcAft>
-                <a:spcPts val="1200"/>
+                <a:spcPts val="1400"/>
               </a:spcAft>
             </a:pPr>
             <a:r>
-              <a:rPr sz="1800"/>
-              <a:t>The hosted counterpoint finishes the same review in 2 minutes 13 seconds, so the workflow drafts locally and promotes keepers. Vision works too at 135.8 seconds per thumbnail, but too slow for production.</a:t>
+              <a:rPr sz="2000"/>
+              <a:t>Hosted Spark: same review in 2m13s. Draft local. Promote keepers. Vision: 135.8s/thumbnail, not production.</a:t>
             </a:r>
           </a:p>
         </p:txBody>
@@ -6188,8 +6188,8 @@
           <a:lstStyle/>
           <a:p>
             <a:r>
-              <a:rPr sz="2800"/>
-              <a:t>Take-home tips 1 through 5: memory, modes, and one skill per job</a:t>
+              <a:rPr sz="3200"/>
+              <a:t>Tips 1-5: memory, modes, skills.</a:t>
             </a:r>
           </a:p>
         </p:txBody>
@@ -6218,34 +6218,34 @@
           <a:p>
             <a:pPr>
               <a:spcAft>
-                <a:spcPts val="1200"/>
+                <a:spcPts val="1400"/>
               </a:spcAft>
             </a:pPr>
             <a:r>
-              <a:rPr sz="1800"/>
-              <a:t>Run muse init so repository memory persists your conventions instead of re-explaining them every session.</a:t>
+              <a:rPr sz="2000"/>
+              <a:t>muse init: persist conventions. Never re-explain.</a:t>
             </a:r>
           </a:p>
           <a:p>
             <a:pPr>
               <a:spcAft>
-                <a:spcPts val="1200"/>
+                <a:spcPts val="1400"/>
               </a:spcAft>
             </a:pPr>
             <a:r>
-              <a:rPr sz="1800"/>
-              <a:t>Pair in the interactive terminal for exploration and switch to headless exec mode for batch sweeps.</a:t>
+              <a:rPr sz="2000"/>
+              <a:t>Pair interactive. Sweep headless exec.</a:t>
             </a:r>
           </a:p>
           <a:p>
             <a:pPr>
               <a:spcAft>
-                <a:spcPts val="1200"/>
+                <a:spcPts val="1400"/>
               </a:spcAft>
             </a:pPr>
             <a:r>
-              <a:rPr sz="1800"/>
-              <a:t>Pin the model per task, set reasoning effort so cheap questions stay cheap, and write one skill manifest per repeated job: explore and parquet conversion both ship as skills here.</a:t>
+              <a:rPr sz="2000"/>
+              <a:t>Pin model per task. Budget reasoning. One skill per repeated job.</a:t>
             </a:r>
           </a:p>
         </p:txBody>
@@ -6420,8 +6420,8 @@
           <a:lstStyle/>
           <a:p>
             <a:r>
-              <a:rPr sz="2800"/>
-              <a:t>Take-home tips 6 through 10: safety, recovery, and scale</a:t>
+              <a:rPr sz="3200"/>
+              <a:t>Tips 6-10: safety, recovery, scale.</a:t>
             </a:r>
           </a:p>
         </p:txBody>
@@ -6450,34 +6450,34 @@
           <a:p>
             <a:pPr>
               <a:spcAft>
-                <a:spcPts val="1200"/>
+                <a:spcPts val="1400"/>
               </a:spcAft>
             </a:pPr>
             <a:r>
-              <a:rPr sz="1800"/>
-              <a:t>Wire Model Context Protocol servers read-only first, promoting to read-write only for deliberate steps, and keep the sandbox on with deliberate approvals.</a:t>
+              <a:rPr sz="2000"/>
+              <a:t>MCP servers: read-only first. Escalate deliberately.</a:t>
             </a:r>
           </a:p>
           <a:p>
             <a:pPr>
               <a:spcAft>
-                <a:spcPts val="1200"/>
+                <a:spcPts val="1400"/>
               </a:spcAft>
             </a:pPr>
             <a:r>
-              <a:rPr sz="1800"/>
-              <a:t>Recover with /sessions plus /rewind instead of retyping lost work, and fan out with the workflow tool under an evidence contract.</a:t>
+              <a:rPr sz="2000"/>
+              <a:t>Sandbox on. Approve writes + network.</a:t>
             </a:r>
           </a:p>
           <a:p>
             <a:pPr>
               <a:spcAft>
-                <a:spcPts val="1200"/>
+                <a:spcPts val="1400"/>
               </a:spcAft>
             </a:pPr>
             <a:r>
-              <a:rPr sz="1800"/>
-              <a:t>Embed via the Spark API backed locally by Glimmer, and set spend limits on day one with the graphics lock guarding every GPU job.</a:t>
+              <a:rPr sz="2000"/>
+              <a:t>/sessions + /rewind beats retyping. Workflow fan-out with evidence contract. Spark API + local Glimmer. Spend limits day one.</a:t>
             </a:r>
           </a:p>
         </p:txBody>
@@ -6652,8 +6652,8 @@
           <a:lstStyle/>
           <a:p>
             <a:r>
-              <a:rPr sz="2800"/>
-              <a:t>Close: the competition is the vehicle, Muse Code is the instrument</a:t>
+              <a:rPr sz="3200"/>
+              <a:t>Vehicle + instrument. Start tonight.</a:t>
             </a:r>
           </a:p>
         </p:txBody>
@@ -6682,34 +6682,34 @@
           <a:p>
             <a:pPr>
               <a:spcAft>
-                <a:spcPts val="1200"/>
+                <a:spcPts val="1400"/>
               </a:spcAft>
             </a:pPr>
             <a:r>
-              <a:rPr sz="1800"/>
-              <a:t>The bowl repository ships docs, samples, scripts, and skills, and the companion guide carries README sections 0 through 130, so a stranger clones and runs within minutes.</a:t>
+              <a:rPr sz="2000"/>
+              <a:t>Bowl repo: docs, samples, scripts, skills. Guide: README 0-130.</a:t>
             </a:r>
           </a:p>
           <a:p>
             <a:pPr>
               <a:spcAft>
-                <a:spcPts val="1200"/>
+                <a:spcPts val="1400"/>
               </a:spcAft>
             </a:pPr>
             <a:r>
-              <a:rPr sz="1800"/>
-              <a:t>The day-one play is fixed: data downloads while baselines re-run from frozen configs.</a:t>
+              <a:rPr sz="2000"/>
+              <a:t>Day one: data downloads while baselines re-run.</a:t>
             </a:r>
           </a:p>
           <a:p>
             <a:pPr>
               <a:spcAft>
-                <a:spcPts val="1200"/>
+                <a:spcPts val="1400"/>
               </a:spcAft>
             </a:pPr>
             <a:r>
-              <a:rPr sz="1800"/>
-              <a:t>Start tonight with uv run python scripts/explore_sample.py --data samples/2024, and the field plot is your first proof.</a:t>
+              <a:rPr sz="2000"/>
+              <a:t>One command: uv run python scripts/explore_sample.py --data samples/2024.</a:t>
             </a:r>
           </a:p>
         </p:txBody>
@@ -6884,8 +6884,8 @@
           <a:lstStyle/>
           <a:p>
             <a:r>
-              <a:rPr sz="2800"/>
-              <a:t>The challenge: invent a stat good enough for live television</a:t>
+              <a:rPr sz="3200"/>
+              <a:t>Invent a stat good enough for live TV</a:t>
             </a:r>
           </a:p>
         </p:txBody>
@@ -6914,34 +6914,34 @@
           <a:p>
             <a:pPr>
               <a:spcAft>
-                <a:spcPts val="1200"/>
+                <a:spcPts val="1400"/>
               </a:spcAft>
             </a:pPr>
             <a:r>
-              <a:rPr sz="1800"/>
-              <a:t>The Big Data Bowl is the yearly contest run by NFL Football Operations with Amazon Web Services, using real player-tracking data from Next Gen Stats.</a:t>
+              <a:rPr sz="2000"/>
+              <a:t>Annual contest: NFL Football Operations + AWS.</a:t>
             </a:r>
           </a:p>
           <a:p>
             <a:pPr>
               <a:spcAft>
-                <a:spcPts val="1200"/>
+                <a:spcPts val="1400"/>
               </a:spcAft>
             </a:pPr>
             <a:r>
-              <a:rPr sz="1800"/>
-              <a:t>Every tracked player is located ten times per second, so each play yields hundreds of position, speed, and acceleration readings.</a:t>
+              <a:rPr sz="2000"/>
+              <a:t>Real tracking data. Winners ship to broadcast.</a:t>
             </a:r>
           </a:p>
           <a:p>
             <a:pPr>
               <a:spcAft>
-                <a:spcPts val="1200"/>
+                <a:spcPts val="1400"/>
               </a:spcAft>
             </a:pPr>
             <a:r>
-              <a:rPr sz="1800"/>
-              <a:t>Winners become real products: past entries now appear in live broadcasts and club front-office dashboards.</a:t>
+              <a:rPr sz="2000"/>
+              <a:t>2027 topic unannounced: prep now, react never.</a:t>
             </a:r>
           </a:p>
         </p:txBody>
@@ -7116,8 +7116,8 @@
           <a:lstStyle/>
           <a:p>
             <a:r>
-              <a:rPr sz="2800"/>
-              <a:t>A $100,000 contest at NFL scale, and a hiring pipeline</a:t>
+              <a:rPr sz="3200"/>
+              <a:t>$100K. Combine stage. Hiring pipeline.</a:t>
             </a:r>
           </a:p>
         </p:txBody>
@@ -7146,34 +7146,34 @@
           <a:p>
             <a:pPr>
               <a:spcAft>
-                <a:spcPts val="1200"/>
+                <a:spcPts val="1400"/>
               </a:spcAft>
             </a:pPr>
             <a:r>
-              <a:rPr sz="1800"/>
-              <a:t>The 2026 contest offered a $100,000 prize pool with finalists presenting at the Scouting Combine, and drew a reported 8,329 registrations from 771 teams across 69 countries.</a:t>
+              <a:rPr sz="2000"/>
+              <a:t>2026: $100K pool. Finalists present at Combine.</a:t>
             </a:r>
           </a:p>
           <a:p>
             <a:pPr>
               <a:spcAft>
-                <a:spcPts val="1200"/>
+                <a:spcPts val="1400"/>
               </a:spcAft>
             </a:pPr>
             <a:r>
-              <a:rPr sz="1800"/>
-              <a:t>Amazon Web Services reports processing over 500 million tracking data points per season, feeding 75-plus machine-learning statistics including rushing yards over expected.</a:t>
+              <a:rPr sz="2000"/>
+              <a:t>Reported 8,329 registrations. 771 teams. 69 countries.</a:t>
             </a:r>
           </a:p>
           <a:p>
             <a:pPr>
               <a:spcAft>
-                <a:spcPts val="1200"/>
+                <a:spcPts val="1400"/>
               </a:spcAft>
             </a:pPr>
             <a:r>
-              <a:rPr sz="1800"/>
-              <a:t>More than 50 past entrants were reportedly hired into football analytics roles, over 30 by teams or vendors directly.</a:t>
+              <a:rPr sz="2000"/>
+              <a:t>50+ entrants hired. 30+ by teams, reportedly.</a:t>
             </a:r>
           </a:p>
         </p:txBody>
@@ -7348,8 +7348,8 @@
           <a:lstStyle/>
           <a:p>
             <a:r>
-              <a:rPr sz="2800"/>
-              <a:t>Winning ideas reach the broadcast: from entry to television statistic</a:t>
+              <a:rPr sz="3200"/>
+              <a:t>Contest entries become TV stats</a:t>
             </a:r>
           </a:p>
         </p:txBody>
@@ -7378,34 +7378,34 @@
           <a:p>
             <a:pPr>
               <a:spcAft>
-                <a:spcPts val="1200"/>
+                <a:spcPts val="1400"/>
               </a:spcAft>
             </a:pPr>
             <a:r>
-              <a:rPr sz="1800"/>
-              <a:t>In 2020, team the Zoo won by predicting the full distribution of rushing yards from handoff positions and velocities, and their approach became the expected rushing yards TV stat within about six months.</a:t>
+              <a:rPr sz="2000"/>
+              <a:t>2020: team Zoo predicted rush distributions.</a:t>
             </a:r>
           </a:p>
           <a:p>
             <a:pPr>
               <a:spcAft>
-                <a:spcPts val="1200"/>
+                <a:spcPts val="1400"/>
               </a:spcAft>
             </a:pPr>
             <a:r>
-              <a:rPr sz="1800"/>
-              <a:t>The same pipeline produced rushing yards over expected, first-down probability, and touchdown probability.</a:t>
+              <a:rPr sz="2000"/>
+              <a:t>Shipped in ~6 months: expected rush yards.</a:t>
             </a:r>
           </a:p>
           <a:p>
             <a:pPr>
               <a:spcAft>
-                <a:spcPts val="1200"/>
+                <a:spcPts val="1400"/>
               </a:spcAft>
             </a:pPr>
             <a:r>
-              <a:rPr sz="1800"/>
-              <a:t>The 2023 pocket-pressure contest fed deployed pressure probability trained over 90,000 plays, and the 2024 contest fed tackle probability using 20 features per defender across 11 defenders.</a:t>
+              <a:rPr sz="2000"/>
+              <a:t>2023: pressure probability (90K plays). 2024: tackle probability (20 features x 11 defenders).</a:t>
             </a:r>
           </a:p>
         </p:txBody>
@@ -7580,8 +7580,8 @@
           <a:lstStyle/>
           <a:p>
             <a:r>
-              <a:rPr sz="2800"/>
-              <a:t>The data: every player and the ball, ten times per second</a:t>
+              <a:rPr sz="3200"/>
+              <a:t>Every player. Every ball. 10x per second.</a:t>
             </a:r>
           </a:p>
         </p:txBody>
@@ -7610,34 +7610,34 @@
           <a:p>
             <a:pPr>
               <a:spcAft>
-                <a:spcPts val="1200"/>
+                <a:spcPts val="1400"/>
               </a:spcAft>
             </a:pPr>
             <a:r>
-              <a:rPr sz="1800"/>
-              <a:t>Radio-frequency identification tags in shoulder pads plus a Wilson sensor ball feed Zebra position hardware, sampling every player and the ball at 10 hertz from snap to whistle.</a:t>
+              <a:rPr sz="2000"/>
+              <a:t>RFID shoulder tags + Wilson sensor ball. Zebra hardware.</a:t>
             </a:r>
           </a:p>
           <a:p>
             <a:pPr>
               <a:spcAft>
-                <a:spcPts val="1200"/>
+                <a:spcPts val="1400"/>
               </a:spcAft>
             </a:pPr>
             <a:r>
-              <a:rPr sz="1800"/>
-              <a:t>Each row carries field coordinates x and y in yards, speed, acceleration, distance, orientation, direction, the tagged event, and frame, play, and player identifiers.</a:t>
+              <a:rPr sz="2000"/>
+              <a:t>Per row: x/y yards, speed, accel, orientation, event, frame/play/player IDs.</a:t>
             </a:r>
           </a:p>
           <a:p>
             <a:pPr>
               <a:spcAft>
-                <a:spcPts val="1200"/>
+                <a:spcPts val="1400"/>
               </a:spcAft>
             </a:pPr>
             <a:r>
-              <a:rPr sz="1800"/>
-              <a:t>Weeks arrive as comma-separated files near 1.5 gigabytes each, so demos run on a 25-play in-git sample that answers every query in seconds.</a:t>
+              <a:rPr sz="2000"/>
+              <a:t>Weeks = ~1.5 GB CSVs. Demos use 25-play in-git sample.</a:t>
             </a:r>
           </a:p>
         </p:txBody>
@@ -7812,8 +7812,8 @@
           <a:lstStyle/>
           <a:p>
             <a:r>
-              <a:rPr sz="2800"/>
-              <a:t>Workflow 1: Explore the sample first</a:t>
+              <a:rPr sz="3200"/>
+              <a:t>Workflow 1: Sample first. Full weeks later.</a:t>
             </a:r>
           </a:p>
         </p:txBody>
@@ -7842,34 +7842,34 @@
           <a:p>
             <a:pPr>
               <a:spcAft>
-                <a:spcPts val="1200"/>
+                <a:spcPts val="1400"/>
               </a:spcAft>
             </a:pPr>
             <a:r>
-              <a:rPr sz="1800"/>
-              <a:t>The sample slice samples/2024/tracking_sample.csv holds 19,113 tracking rows across 25 plays, so every query runs in seconds with zero download.</a:t>
+              <a:rPr sz="2000"/>
+              <a:t>19,113 rows. 25 plays. Zero download. Seconds per query.</a:t>
             </a:r>
           </a:p>
           <a:p>
             <a:pPr>
               <a:spcAft>
-                <a:spcPts val="1200"/>
+                <a:spcPts val="1400"/>
               </a:spcAft>
             </a:pPr>
             <a:r>
-              <a:rPr sz="1800"/>
-              <a:t>The explore script joins tracking with games, plays, and players on game, play, and player identifiers, then prints one play frame by frame and plots all 22 players plus the ball.</a:t>
+              <a:rPr sz="2000"/>
+              <a:t>Join tracking + games + plays + players. Print one play. Plot 22 + ball.</a:t>
             </a:r>
           </a:p>
           <a:p>
             <a:pPr>
               <a:spcAft>
-                <a:spcPts val="1200"/>
+                <a:spcPts val="1400"/>
               </a:spcAft>
             </a:pPr>
             <a:r>
-              <a:rPr sz="1800"/>
-              <a:t>Column units are explicit: x spans 0 to 120 yards, y spans 0 to 53.3, speed and acceleration are per-second, orientation is 0 to 360 degrees.</a:t>
+              <a:rPr sz="2000"/>
+              <a:t>x: 0-120 yd. y: 0-53.3. Speed/accel per-sec. Angles 0-360.</a:t>
             </a:r>
           </a:p>
         </p:txBody>
@@ -8044,8 +8044,8 @@
           <a:lstStyle/>
           <a:p>
             <a:r>
-              <a:rPr sz="2800"/>
-              <a:t>Workflow 2: Convert weekly files to Parquet once, reuse forever</a:t>
+              <a:rPr sz="3200"/>
+              <a:t>Workflow 2: Parquet once. Fast forever.</a:t>
             </a:r>
           </a:p>
         </p:txBody>
@@ -8074,34 +8074,34 @@
           <a:p>
             <a:pPr>
               <a:spcAft>
-                <a:spcPts val="1200"/>
+                <a:spcPts val="1400"/>
               </a:spcAft>
             </a:pPr>
             <a:r>
-              <a:rPr sz="1800"/>
-              <a:t>Weekly tracking files are too large to hold in memory, so the pipeline reads them in chunks of 200,000 rows, keeping memory flat regardless of file size.</a:t>
+              <a:rPr sz="2000"/>
+              <a:t>Weeks too big for RAM. Chunk reads: 200K rows.</a:t>
             </a:r>
           </a:p>
           <a:p>
             <a:pPr>
               <a:spcAft>
-                <a:spcPts val="1200"/>
+                <a:spcPts val="1400"/>
               </a:spcAft>
             </a:pPr>
             <a:r>
-              <a:rPr sz="1800"/>
-              <a:t>Each week converts to Parquet format exactly once, and every later step reads the fast copy, so the cost is paid one time and all downstream runs speed up.</a:t>
+              <a:rPr sz="2000"/>
+              <a:t>Convert weekly CSV -&gt; Parquet exactly once.</a:t>
             </a:r>
           </a:p>
           <a:p>
             <a:pPr>
               <a:spcAft>
-                <a:spcPts val="1200"/>
+                <a:spcPts val="1400"/>
               </a:spcAft>
             </a:pPr>
             <a:r>
-              <a:rPr sz="1800"/>
-              <a:t>Raw files stay read-only and are never overwritten, while everything generated lands in the rebuildable data/scratch/ directory.</a:t>
+              <a:rPr sz="2000"/>
+              <a:t>Raw stays read-only. Outputs land in data/scratch/.</a:t>
             </a:r>
           </a:p>
         </p:txBody>
@@ -8276,8 +8276,8 @@
           <a:lstStyle/>
           <a:p>
             <a:r>
-              <a:rPr sz="2800"/>
-              <a:t>Workflow 3: Build features frame by frame, from the ground up</a:t>
+              <a:rPr sz="3200"/>
+              <a:t>Workflow 3: Features frame-up.</a:t>
             </a:r>
           </a:p>
         </p:txBody>
@@ -8306,34 +8306,34 @@
           <a:p>
             <a:pPr>
               <a:spcAft>
-                <a:spcPts val="1200"/>
+                <a:spcPts val="1400"/>
               </a:spcAft>
             </a:pPr>
             <a:r>
-              <a:rPr sz="1800"/>
-              <a:t>A winning entry is frame-level features feeding per-player models that roll up to one play-level stat, so every tracking row earns its keep.</a:t>
+              <a:rPr sz="2000"/>
+              <a:t>Frame features -&gt; per-player models -&gt; one play stat.</a:t>
             </a:r>
           </a:p>
           <a:p>
             <a:pPr>
               <a:spcAft>
-                <a:spcPts val="1200"/>
+                <a:spcPts val="1400"/>
               </a:spcAft>
             </a:pPr>
             <a:r>
-              <a:rPr sz="1800"/>
-              <a:t>Base columns are speed, acceleration, and distance to the line in yards, plus numeric formation encodings for offensive and defensive alignment.</a:t>
+              <a:rPr sz="2000"/>
+              <a:t>Speed. Accel. Distance-to-line. Formation encodings.</a:t>
             </a:r>
           </a:p>
           <a:p>
             <a:pPr>
               <a:spcAft>
-                <a:spcPts val="1200"/>
+                <a:spcPts val="1400"/>
               </a:spcAft>
             </a:pPr>
             <a:r>
-              <a:rPr sz="1800"/>
-              <a:t>The tackle-probability workhorse is a frame-by-frame convolutional network, and the tree stage standardizes on LightGBM over XGBoost for speed and memory.</a:t>
+              <a:rPr sz="2000"/>
+              <a:t>Convnets for tackle probability. LightGBM over XGBoost: faster, leaner.</a:t>
             </a:r>
           </a:p>
         </p:txBody>
@@ -8508,8 +8508,8 @@
           <a:lstStyle/>
           <a:p>
             <a:r>
-              <a:rPr sz="2800"/>
-              <a:t>Workflow 4: Set a lasso baseline, then earn the ensemble</a:t>
+              <a:rPr sz="3200"/>
+              <a:t>Workflow 4: Baseline, then earn ensemble.</a:t>
             </a:r>
           </a:p>
         </p:txBody>
@@ -8538,34 +8538,34 @@
           <a:p>
             <a:pPr>
               <a:spcAft>
-                <a:spcPts val="1200"/>
+                <a:spcPts val="1400"/>
               </a:spcAft>
             </a:pPr>
             <a:r>
-              <a:rPr sz="1800"/>
-              <a:t>Every run starts from a lasso-logistic baseline scored against naive base rates with cross-validated accuracy plus errors: the demo scores 0.700 plus or minus 0.110.</a:t>
+              <a:rPr sz="2000"/>
+              <a:t>Lasso-logistic baseline: 0.700 +/- 0.110 vs naive base rates.</a:t>
             </a:r>
           </a:p>
           <a:p>
             <a:pPr>
               <a:spcAft>
-                <a:spcPts val="1200"/>
+                <a:spcPts val="1400"/>
               </a:spcAft>
             </a:pPr>
             <a:r>
-              <a:rPr sz="1800"/>
-              <a:t>Folds are grouped by play so all frames of one play stay together, preventing leakage between adjacent frames of the same action.</a:t>
+              <a:rPr sz="2000"/>
+              <a:t>Group folds by play. No leakage across frames.</a:t>
             </a:r>
           </a:p>
           <a:p>
             <a:pPr>
               <a:spcAft>
-                <a:spcPts val="1200"/>
+                <a:spcPts val="1400"/>
               </a:spcAft>
             </a:pPr>
             <a:r>
-              <a:rPr sz="1800"/>
-              <a:t>The ensemble tries XGBoost, LightGBM, and CatBoost, but only results beating the baseline by a full standard error survive, with one frozen seed and config per output directory.</a:t>
+              <a:rPr sz="2000"/>
+              <a:t>XGBoost / LightGBM / CatBoost must beat baseline by 1 SE. One seed + config per run.</a:t>
             </a:r>
           </a:p>
         </p:txBody>

</xml_diff>

<commit_message>
deck: apply keynote research, 25-word cap, 36/24pt type
</commit_message>
<xml_diff>
--- a/deck/unified.pptx
+++ b/deck/unified.pptx
@@ -4796,7 +4796,7 @@
           <a:lstStyle/>
           <a:p>
             <a:r>
-              <a:rPr sz="3200"/>
+              <a:rPr sz="3600"/>
               <a:t>Big Data Bowl x Muse Code: NFL tracking, live in terminal</a:t>
             </a:r>
           </a:p>
@@ -4830,7 +4830,7 @@
               </a:spcAft>
             </a:pPr>
             <a:r>
-              <a:rPr sz="2000"/>
+              <a:rPr sz="2400"/>
               <a:t>Big Data Bowl = vehicle. Muse Code = instrument.</a:t>
             </a:r>
           </a:p>
@@ -4841,7 +4841,7 @@
               </a:spcAft>
             </a:pPr>
             <a:r>
-              <a:rPr sz="2000"/>
+              <a:rPr sz="2400"/>
               <a:t>NFL Next Gen Stats: every player + ball, 10 Hz.</a:t>
             </a:r>
           </a:p>
@@ -4852,7 +4852,7 @@
               </a:spcAft>
             </a:pPr>
             <a:r>
-              <a:rPr sz="2000"/>
+              <a:rPr sz="2400"/>
               <a:t>17 slides. Live demos. No mockups.</a:t>
             </a:r>
           </a:p>
@@ -5028,8 +5028,8 @@
           <a:lstStyle/>
           <a:p>
             <a:r>
-              <a:rPr sz="3200"/>
-              <a:t>Skills + sweeps + guardrails.</a:t>
+              <a:rPr sz="3600"/>
+              <a:t>Skills carry repetition. Guards protect raw.</a:t>
             </a:r>
           </a:p>
         </p:txBody>
@@ -5062,7 +5062,7 @@
               </a:spcAft>
             </a:pPr>
             <a:r>
-              <a:rPr sz="2000"/>
+              <a:rPr sz="2400"/>
               <a:t>3 skills: chunk-to-parquet. join-and-slice. baseline-ensemble.</a:t>
             </a:r>
           </a:p>
@@ -5073,7 +5073,7 @@
               </a:spcAft>
             </a:pPr>
             <a:r>
-              <a:rPr sz="2000"/>
+              <a:rPr sz="2400"/>
               <a:t>sweep_weeks.sh: one prompt per question. CSV + PNG each.</a:t>
             </a:r>
           </a:p>
@@ -5084,7 +5084,7 @@
               </a:spcAft>
             </a:pPr>
             <a:r>
-              <a:rPr sz="2000"/>
+              <a:rPr sz="2400"/>
               <a:t>guard_data.sh trips on raw moves. Reviews on free local Glimmer.</a:t>
             </a:r>
           </a:p>
@@ -5260,8 +5260,8 @@
           <a:lstStyle/>
           <a:p>
             <a:r>
-              <a:rPr sz="3200"/>
-              <a:t>Graders reward: 30 / 30 / 20 / 20.</a:t>
+              <a:rPr sz="3600"/>
+              <a:t>Rubric 30/30/20/20. Cause, never decorate.</a:t>
             </a:r>
           </a:p>
         </p:txBody>
@@ -5294,7 +5294,7 @@
               </a:spcAft>
             </a:pPr>
             <a:r>
-              <a:rPr sz="2000"/>
+              <a:rPr sz="2400"/>
               <a:t>Football 30. Data science 30. Report 20. Visuals 20.</a:t>
             </a:r>
           </a:p>
@@ -5305,8 +5305,8 @@
               </a:spcAft>
             </a:pPr>
             <a:r>
-              <a:rPr sz="2000"/>
-              <a:t>2,000 words. Under 10 figures. Every chart argues.</a:t>
+              <a:rPr sz="2400"/>
+              <a:t>2,000 words. Under 10 figures. Charts argue.</a:t>
             </a:r>
           </a:p>
           <a:p>
@@ -5316,8 +5316,8 @@
               </a:spcAft>
             </a:pPr>
             <a:r>
-              <a:rPr sz="2000"/>
-              <a:t>Tracking must cause, not decorate. Base rates + baseline + errors. State limits.</a:t>
+              <a:rPr sz="2400"/>
+              <a:t>Tracking causes, never decorates. Base rates + baseline + errors.</a:t>
             </a:r>
           </a:p>
         </p:txBody>
@@ -5492,7 +5492,7 @@
           <a:lstStyle/>
           <a:p>
             <a:r>
-              <a:rPr sz="3200"/>
+              <a:rPr sz="3600"/>
               <a:t>2027 forecast: defense is due.</a:t>
             </a:r>
           </a:p>
@@ -5526,8 +5526,8 @@
               </a:spcAft>
             </a:pPr>
             <a:r>
-              <a:rPr sz="2000"/>
-              <a:t>2026 opened Sep 25, 2025. 2027 unannounced: could drop any day.</a:t>
+              <a:rPr sz="2400"/>
+              <a:t>2026 opened Sep 2025. 2027 unannounced: drops any day.</a:t>
             </a:r>
           </a:p>
           <a:p>
@@ -5537,8 +5537,8 @@
               </a:spcAft>
             </a:pPr>
             <a:r>
-              <a:rPr sz="2000"/>
-              <a:t>Prediction years alternate metric years. Offense banked. Defense next.</a:t>
+              <a:rPr sz="2400"/>
+              <a:t>Prediction alternates metric years. Offense banked. Defense next.</a:t>
             </a:r>
           </a:p>
           <a:p>
@@ -5548,8 +5548,8 @@
               </a:spcAft>
             </a:pPr>
             <a:r>
-              <a:rPr sz="2000"/>
-              <a:t>Shortlist: ghost paths. New kickoff. Run blocking. Tooling built pre-topic.</a:t>
+              <a:rPr sz="2400"/>
+              <a:t>Shortlist: ghost paths. New kickoff. Run blocking.</a:t>
             </a:r>
           </a:p>
         </p:txBody>
@@ -5724,7 +5724,7 @@
           <a:lstStyle/>
           <a:p>
             <a:r>
-              <a:rPr sz="3200"/>
+              <a:rPr sz="3600"/>
               <a:t>Glimmer: 30B params. One workstation. Live.</a:t>
             </a:r>
           </a:p>
@@ -5758,7 +5758,7 @@
               </a:spcAft>
             </a:pPr>
             <a:r>
-              <a:rPr sz="2000"/>
+              <a:rPr sz="2400"/>
               <a:t>Open weights. Apache 2.0. Distilled from Muse Spark.</a:t>
             </a:r>
           </a:p>
@@ -5769,8 +5769,8 @@
               </a:spcAft>
             </a:pPr>
             <a:r>
-              <a:rPr sz="2000"/>
-              <a:t>12 GB card. 13 GPU layers. 4,096-token window. 4-bit quant.</a:t>
+              <a:rPr sz="2400"/>
+              <a:t>12 GB card. 13 GPU layers. 4-bit quant.</a:t>
             </a:r>
           </a:p>
           <a:p>
@@ -5780,8 +5780,8 @@
               </a:spcAft>
             </a:pPr>
             <a:r>
-              <a:rPr sz="2000"/>
-              <a:t>OpenAI-compatible :8181. Cold start ~8s. Locked = 503. Free = 200.</a:t>
+              <a:rPr sz="2400"/>
+              <a:t>Local :8181. Cold start ~8s. Locked = 503. Free = 200.</a:t>
             </a:r>
           </a:p>
         </p:txBody>
@@ -5956,7 +5956,7 @@
           <a:lstStyle/>
           <a:p>
             <a:r>
-              <a:rPr sz="3200"/>
+              <a:rPr sz="3600"/>
               <a:t>13 GPU layers buy nothing here.</a:t>
             </a:r>
           </a:p>
@@ -5990,7 +5990,7 @@
               </a:spcAft>
             </a:pPr>
             <a:r>
-              <a:rPr sz="2000"/>
+              <a:rPr sz="2400"/>
               <a:t>CPU-only: 41.7s warm. 5.7 tok/s prompt. ~0 GPU.</a:t>
             </a:r>
           </a:p>
@@ -6001,8 +6001,8 @@
               </a:spcAft>
             </a:pPr>
             <a:r>
-              <a:rPr sz="2000"/>
-              <a:t>NGL 13: 186.7s. 1.75 tok/s. 11.62 GB held. Bandwidth-bound decode.</a:t>
+              <a:rPr sz="2400"/>
+              <a:t>NGL 13: 186.7s. 1.75 tok/s. 11.62 GB held. Bandwidth-bound.</a:t>
             </a:r>
           </a:p>
           <a:p>
@@ -6012,8 +6012,8 @@
               </a:spcAft>
             </a:pPr>
             <a:r>
-              <a:rPr sz="2000"/>
-              <a:t>Hosted Spark: same review in 2m13s. Draft local. Promote keepers. Vision: 135.8s/thumbnail, not production.</a:t>
+              <a:rPr sz="2400"/>
+              <a:t>Hosted: 2m13s. Draft local. Promote keepers.</a:t>
             </a:r>
           </a:p>
         </p:txBody>
@@ -6188,8 +6188,8 @@
           <a:lstStyle/>
           <a:p>
             <a:r>
-              <a:rPr sz="3200"/>
-              <a:t>Tips 1-5: memory, modes, skills.</a:t>
+              <a:rPr sz="3600"/>
+              <a:t>Memory, modes, one skill per job.</a:t>
             </a:r>
           </a:p>
         </p:txBody>
@@ -6222,7 +6222,7 @@
               </a:spcAft>
             </a:pPr>
             <a:r>
-              <a:rPr sz="2000"/>
+              <a:rPr sz="2400"/>
               <a:t>muse init: persist conventions. Never re-explain.</a:t>
             </a:r>
           </a:p>
@@ -6233,7 +6233,7 @@
               </a:spcAft>
             </a:pPr>
             <a:r>
-              <a:rPr sz="2000"/>
+              <a:rPr sz="2400"/>
               <a:t>Pair interactive. Sweep headless exec.</a:t>
             </a:r>
           </a:p>
@@ -6244,7 +6244,7 @@
               </a:spcAft>
             </a:pPr>
             <a:r>
-              <a:rPr sz="2000"/>
+              <a:rPr sz="2400"/>
               <a:t>Pin model per task. Budget reasoning. One skill per repeated job.</a:t>
             </a:r>
           </a:p>
@@ -6420,8 +6420,8 @@
           <a:lstStyle/>
           <a:p>
             <a:r>
-              <a:rPr sz="3200"/>
-              <a:t>Tips 6-10: safety, recovery, scale.</a:t>
+              <a:rPr sz="3600"/>
+              <a:t>Read-only first. Rewind. Spend limits.</a:t>
             </a:r>
           </a:p>
         </p:txBody>
@@ -6454,8 +6454,8 @@
               </a:spcAft>
             </a:pPr>
             <a:r>
-              <a:rPr sz="2000"/>
-              <a:t>MCP servers: read-only first. Escalate deliberately.</a:t>
+              <a:rPr sz="2400"/>
+              <a:t>MCP read-only first. Sandbox on. Approve writes.</a:t>
             </a:r>
           </a:p>
           <a:p>
@@ -6465,8 +6465,8 @@
               </a:spcAft>
             </a:pPr>
             <a:r>
-              <a:rPr sz="2000"/>
-              <a:t>Sandbox on. Approve writes + network.</a:t>
+              <a:rPr sz="2400"/>
+              <a:t>Rewind beats retyping. Fan out with evidence.</a:t>
             </a:r>
           </a:p>
           <a:p>
@@ -6476,8 +6476,8 @@
               </a:spcAft>
             </a:pPr>
             <a:r>
-              <a:rPr sz="2000"/>
-              <a:t>/sessions + /rewind beats retyping. Workflow fan-out with evidence contract. Spark API + local Glimmer. Spend limits day one.</a:t>
+              <a:rPr sz="2400"/>
+              <a:t>Spark API + local Glimmer. Spend limits day one.</a:t>
             </a:r>
           </a:p>
         </p:txBody>
@@ -6652,7 +6652,7 @@
           <a:lstStyle/>
           <a:p>
             <a:r>
-              <a:rPr sz="3200"/>
+              <a:rPr sz="3600"/>
               <a:t>Vehicle + instrument. Start tonight.</a:t>
             </a:r>
           </a:p>
@@ -6686,7 +6686,7 @@
               </a:spcAft>
             </a:pPr>
             <a:r>
-              <a:rPr sz="2000"/>
+              <a:rPr sz="2400"/>
               <a:t>Bowl repo: docs, samples, scripts, skills. Guide: README 0-130.</a:t>
             </a:r>
           </a:p>
@@ -6697,7 +6697,7 @@
               </a:spcAft>
             </a:pPr>
             <a:r>
-              <a:rPr sz="2000"/>
+              <a:rPr sz="2400"/>
               <a:t>Day one: data downloads while baselines re-run.</a:t>
             </a:r>
           </a:p>
@@ -6708,7 +6708,7 @@
               </a:spcAft>
             </a:pPr>
             <a:r>
-              <a:rPr sz="2000"/>
+              <a:rPr sz="2400"/>
               <a:t>One command: uv run python scripts/explore_sample.py --data samples/2024.</a:t>
             </a:r>
           </a:p>
@@ -6884,7 +6884,7 @@
           <a:lstStyle/>
           <a:p>
             <a:r>
-              <a:rPr sz="3200"/>
+              <a:rPr sz="3600"/>
               <a:t>Invent a stat good enough for live TV</a:t>
             </a:r>
           </a:p>
@@ -6918,7 +6918,7 @@
               </a:spcAft>
             </a:pPr>
             <a:r>
-              <a:rPr sz="2000"/>
+              <a:rPr sz="2400"/>
               <a:t>Annual contest: NFL Football Operations + AWS.</a:t>
             </a:r>
           </a:p>
@@ -6929,7 +6929,7 @@
               </a:spcAft>
             </a:pPr>
             <a:r>
-              <a:rPr sz="2000"/>
+              <a:rPr sz="2400"/>
               <a:t>Real tracking data. Winners ship to broadcast.</a:t>
             </a:r>
           </a:p>
@@ -6940,7 +6940,7 @@
               </a:spcAft>
             </a:pPr>
             <a:r>
-              <a:rPr sz="2000"/>
+              <a:rPr sz="2400"/>
               <a:t>2027 topic unannounced: prep now, react never.</a:t>
             </a:r>
           </a:p>
@@ -7116,7 +7116,7 @@
           <a:lstStyle/>
           <a:p>
             <a:r>
-              <a:rPr sz="3200"/>
+              <a:rPr sz="3600"/>
               <a:t>$100K. Combine stage. Hiring pipeline.</a:t>
             </a:r>
           </a:p>
@@ -7150,7 +7150,7 @@
               </a:spcAft>
             </a:pPr>
             <a:r>
-              <a:rPr sz="2000"/>
+              <a:rPr sz="2400"/>
               <a:t>2026: $100K pool. Finalists present at Combine.</a:t>
             </a:r>
           </a:p>
@@ -7161,7 +7161,7 @@
               </a:spcAft>
             </a:pPr>
             <a:r>
-              <a:rPr sz="2000"/>
+              <a:rPr sz="2400"/>
               <a:t>Reported 8,329 registrations. 771 teams. 69 countries.</a:t>
             </a:r>
           </a:p>
@@ -7172,7 +7172,7 @@
               </a:spcAft>
             </a:pPr>
             <a:r>
-              <a:rPr sz="2000"/>
+              <a:rPr sz="2400"/>
               <a:t>50+ entrants hired. 30+ by teams, reportedly.</a:t>
             </a:r>
           </a:p>
@@ -7348,7 +7348,7 @@
           <a:lstStyle/>
           <a:p>
             <a:r>
-              <a:rPr sz="3200"/>
+              <a:rPr sz="3600"/>
               <a:t>Contest entries become TV stats</a:t>
             </a:r>
           </a:p>
@@ -7382,7 +7382,7 @@
               </a:spcAft>
             </a:pPr>
             <a:r>
-              <a:rPr sz="2000"/>
+              <a:rPr sz="2400"/>
               <a:t>2020: team Zoo predicted rush distributions.</a:t>
             </a:r>
           </a:p>
@@ -7393,7 +7393,7 @@
               </a:spcAft>
             </a:pPr>
             <a:r>
-              <a:rPr sz="2000"/>
+              <a:rPr sz="2400"/>
               <a:t>Shipped in ~6 months: expected rush yards.</a:t>
             </a:r>
           </a:p>
@@ -7404,8 +7404,8 @@
               </a:spcAft>
             </a:pPr>
             <a:r>
-              <a:rPr sz="2000"/>
-              <a:t>2023: pressure probability (90K plays). 2024: tackle probability (20 features x 11 defenders).</a:t>
+              <a:rPr sz="2400"/>
+              <a:t>2023: pressure probability, 90K plays. 2024: tackle probability, 20 features x 11 defenders.</a:t>
             </a:r>
           </a:p>
         </p:txBody>
@@ -7580,7 +7580,7 @@
           <a:lstStyle/>
           <a:p>
             <a:r>
-              <a:rPr sz="3200"/>
+              <a:rPr sz="3600"/>
               <a:t>Every player. Every ball. 10x per second.</a:t>
             </a:r>
           </a:p>
@@ -7614,8 +7614,8 @@
               </a:spcAft>
             </a:pPr>
             <a:r>
-              <a:rPr sz="2000"/>
-              <a:t>RFID shoulder tags + Wilson sensor ball. Zebra hardware.</a:t>
+              <a:rPr sz="2400"/>
+              <a:t>RFID tags + sensor ball. Zebra hardware.</a:t>
             </a:r>
           </a:p>
           <a:p>
@@ -7625,8 +7625,8 @@
               </a:spcAft>
             </a:pPr>
             <a:r>
-              <a:rPr sz="2000"/>
-              <a:t>Per row: x/y yards, speed, accel, orientation, event, frame/play/player IDs.</a:t>
+              <a:rPr sz="2400"/>
+              <a:t>Per row: x/y, speed, accel, event, frame/play/player IDs.</a:t>
             </a:r>
           </a:p>
           <a:p>
@@ -7636,8 +7636,8 @@
               </a:spcAft>
             </a:pPr>
             <a:r>
-              <a:rPr sz="2000"/>
-              <a:t>Weeks = ~1.5 GB CSVs. Demos use 25-play in-git sample.</a:t>
+              <a:rPr sz="2400"/>
+              <a:t>Weeks ~1.5 GB CSVs. Demos use 25-play sample.</a:t>
             </a:r>
           </a:p>
         </p:txBody>
@@ -7812,7 +7812,7 @@
           <a:lstStyle/>
           <a:p>
             <a:r>
-              <a:rPr sz="3200"/>
+              <a:rPr sz="3600"/>
               <a:t>Workflow 1: Sample first. Full weeks later.</a:t>
             </a:r>
           </a:p>
@@ -7846,8 +7846,8 @@
               </a:spcAft>
             </a:pPr>
             <a:r>
-              <a:rPr sz="2000"/>
-              <a:t>19,113 rows. 25 plays. Zero download. Seconds per query.</a:t>
+              <a:rPr sz="2400"/>
+              <a:t>19,113 rows. 25 plays. Zero download.</a:t>
             </a:r>
           </a:p>
           <a:p>
@@ -7857,8 +7857,8 @@
               </a:spcAft>
             </a:pPr>
             <a:r>
-              <a:rPr sz="2000"/>
-              <a:t>Join tracking + games + plays + players. Print one play. Plot 22 + ball.</a:t>
+              <a:rPr sz="2400"/>
+              <a:t>Join tracking + games + plays + players. Plot 22 + ball.</a:t>
             </a:r>
           </a:p>
           <a:p>
@@ -7868,8 +7868,8 @@
               </a:spcAft>
             </a:pPr>
             <a:r>
-              <a:rPr sz="2000"/>
-              <a:t>x: 0-120 yd. y: 0-53.3. Speed/accel per-sec. Angles 0-360.</a:t>
+              <a:rPr sz="2400"/>
+              <a:t>x: 0-120 yd. y: 0-53.3. Angles 0-360.</a:t>
             </a:r>
           </a:p>
         </p:txBody>
@@ -8044,7 +8044,7 @@
           <a:lstStyle/>
           <a:p>
             <a:r>
-              <a:rPr sz="3200"/>
+              <a:rPr sz="3600"/>
               <a:t>Workflow 2: Parquet once. Fast forever.</a:t>
             </a:r>
           </a:p>
@@ -8078,7 +8078,7 @@
               </a:spcAft>
             </a:pPr>
             <a:r>
-              <a:rPr sz="2000"/>
+              <a:rPr sz="2400"/>
               <a:t>Weeks too big for RAM. Chunk reads: 200K rows.</a:t>
             </a:r>
           </a:p>
@@ -8089,7 +8089,7 @@
               </a:spcAft>
             </a:pPr>
             <a:r>
-              <a:rPr sz="2000"/>
+              <a:rPr sz="2400"/>
               <a:t>Convert weekly CSV -&gt; Parquet exactly once.</a:t>
             </a:r>
           </a:p>
@@ -8100,7 +8100,7 @@
               </a:spcAft>
             </a:pPr>
             <a:r>
-              <a:rPr sz="2000"/>
+              <a:rPr sz="2400"/>
               <a:t>Raw stays read-only. Outputs land in data/scratch/.</a:t>
             </a:r>
           </a:p>
@@ -8276,7 +8276,7 @@
           <a:lstStyle/>
           <a:p>
             <a:r>
-              <a:rPr sz="3200"/>
+              <a:rPr sz="3600"/>
               <a:t>Workflow 3: Features frame-up.</a:t>
             </a:r>
           </a:p>
@@ -8310,7 +8310,7 @@
               </a:spcAft>
             </a:pPr>
             <a:r>
-              <a:rPr sz="2000"/>
+              <a:rPr sz="2400"/>
               <a:t>Frame features -&gt; per-player models -&gt; one play stat.</a:t>
             </a:r>
           </a:p>
@@ -8321,7 +8321,7 @@
               </a:spcAft>
             </a:pPr>
             <a:r>
-              <a:rPr sz="2000"/>
+              <a:rPr sz="2400"/>
               <a:t>Speed. Accel. Distance-to-line. Formation encodings.</a:t>
             </a:r>
           </a:p>
@@ -8332,7 +8332,7 @@
               </a:spcAft>
             </a:pPr>
             <a:r>
-              <a:rPr sz="2000"/>
+              <a:rPr sz="2400"/>
               <a:t>Convnets for tackle probability. LightGBM over XGBoost: faster, leaner.</a:t>
             </a:r>
           </a:p>
@@ -8508,7 +8508,7 @@
           <a:lstStyle/>
           <a:p>
             <a:r>
-              <a:rPr sz="3200"/>
+              <a:rPr sz="3600"/>
               <a:t>Workflow 4: Baseline, then earn ensemble.</a:t>
             </a:r>
           </a:p>
@@ -8542,8 +8542,8 @@
               </a:spcAft>
             </a:pPr>
             <a:r>
-              <a:rPr sz="2000"/>
-              <a:t>Lasso-logistic baseline: 0.700 +/- 0.110 vs naive base rates.</a:t>
+              <a:rPr sz="2400"/>
+              <a:t>Baseline: lasso-logistic, 0.700 +/- 0.110.</a:t>
             </a:r>
           </a:p>
           <a:p>
@@ -8553,7 +8553,7 @@
               </a:spcAft>
             </a:pPr>
             <a:r>
-              <a:rPr sz="2000"/>
+              <a:rPr sz="2400"/>
               <a:t>Group folds by play. No leakage across frames.</a:t>
             </a:r>
           </a:p>
@@ -8564,8 +8564,8 @@
               </a:spcAft>
             </a:pPr>
             <a:r>
-              <a:rPr sz="2000"/>
-              <a:t>XGBoost / LightGBM / CatBoost must beat baseline by 1 SE. One seed + config per run.</a:t>
+              <a:rPr sz="2400"/>
+              <a:t>Ensemble must beat baseline by 1 SE. One seed + config per run.</a:t>
             </a:r>
           </a:p>
         </p:txBody>

</xml_diff>

<commit_message>
deck: all slides within 25-word cap
</commit_message>
<xml_diff>
--- a/deck/unified.pptx
+++ b/deck/unified.pptx
@@ -5316,8 +5316,7 @@
               </a:spcAft>
             </a:pPr>
             <a:r>
-              <a:rPr sz="2400"/>
-              <a:t>Tracking causes, never decorates. Base rates + baseline + errors.</a:t>
+              <a:t>Tracking causes, not decorates. Base rates + baseline + errors.</a:t>
             </a:r>
           </a:p>
         </p:txBody>
@@ -5758,8 +5757,7 @@
               </a:spcAft>
             </a:pPr>
             <a:r>
-              <a:rPr sz="2400"/>
-              <a:t>Open weights. Apache 2.0. Distilled from Muse Spark.</a:t>
+              <a:t>Open weights. Apache 2.0. From Muse Spark.</a:t>
             </a:r>
           </a:p>
           <a:p>
@@ -7404,8 +7402,7 @@
               </a:spcAft>
             </a:pPr>
             <a:r>
-              <a:rPr sz="2400"/>
-              <a:t>2023: pressure probability, 90K plays. 2024: tackle probability, 20 features x 11 defenders.</a:t>
+              <a:t>2024: tackle probability: 20 features x 11.</a:t>
             </a:r>
           </a:p>
         </p:txBody>
@@ -8564,8 +8561,7 @@
               </a:spcAft>
             </a:pPr>
             <a:r>
-              <a:rPr sz="2400"/>
-              <a:t>Ensemble must beat baseline by 1 SE. One seed + config per run.</a:t>
+              <a:t>Ensemble must beat baseline by 1 SE. One seed, one config.</a:t>
             </a:r>
           </a:p>
         </p:txBody>

</xml_diff>

<commit_message>
deck: final word-cap compliance, all 17 at 25 or under
</commit_message>
<xml_diff>
--- a/deck/unified.pptx
+++ b/deck/unified.pptx
@@ -5316,7 +5316,7 @@
               </a:spcAft>
             </a:pPr>
             <a:r>
-              <a:t>Tracking causes, not decorates. Base rates + baseline + errors.</a:t>
+              <a:t>Tracking causes, not decorates. Rates + baseline + errors.</a:t>
             </a:r>
           </a:p>
         </p:txBody>
@@ -5778,8 +5778,7 @@
               </a:spcAft>
             </a:pPr>
             <a:r>
-              <a:rPr sz="2400"/>
-              <a:t>Local :8181. Cold start ~8s. Locked = 503. Free = 200.</a:t>
+              <a:t>Local :8181. Cold start ~8s. 503 locked, 200 free.</a:t>
             </a:r>
           </a:p>
         </p:txBody>

</xml_diff>

<commit_message>
deck: embed s00-s16 visuals right-side, one per slide, notes kept
</commit_message>
<xml_diff>
--- a/deck/unified.pptx
+++ b/deck/unified.pptx
@@ -4811,7 +4811,7 @@
         <p:spPr>
           <a:xfrm>
             <a:off x="640080" y="1554480"/>
-            <a:ext cx="10881360" cy="4389120"/>
+            <a:ext cx="5669280" cy="4389120"/>
           </a:xfrm>
           <a:prstGeom prst="rect">
             <a:avLst/>
@@ -4858,6 +4858,30 @@
           </a:p>
         </p:txBody>
       </p:sp>
+      <p:pic>
+        <p:nvPicPr>
+          <p:cNvPr id="7" name="Picture 6" descr="s00_hero.png"/>
+          <p:cNvPicPr>
+            <a:picLocks noChangeAspect="1"/>
+          </p:cNvPicPr>
+          <p:nvPr/>
+        </p:nvPicPr>
+        <p:blipFill>
+          <a:blip r:embed="rId3"/>
+          <a:stretch>
+            <a:fillRect/>
+          </a:stretch>
+        </p:blipFill>
+        <p:spPr>
+          <a:xfrm>
+            <a:off x="6720840" y="2294572"/>
+            <a:ext cx="4846320" cy="2726055"/>
+          </a:xfrm>
+          <a:prstGeom prst="rect">
+            <a:avLst/>
+          </a:prstGeom>
+        </p:spPr>
+      </p:pic>
     </p:spTree>
   </p:cSld>
   <p:clrMapOvr>
@@ -5043,7 +5067,7 @@
         <p:spPr>
           <a:xfrm>
             <a:off x="640080" y="1554480"/>
-            <a:ext cx="10881360" cy="4389120"/>
+            <a:ext cx="5669280" cy="4389120"/>
           </a:xfrm>
           <a:prstGeom prst="rect">
             <a:avLst/>
@@ -5090,6 +5114,30 @@
           </a:p>
         </p:txBody>
       </p:sp>
+      <p:pic>
+        <p:nvPicPr>
+          <p:cNvPr id="7" name="Picture 6" descr="s09_terminal.png"/>
+          <p:cNvPicPr>
+            <a:picLocks noChangeAspect="1"/>
+          </p:cNvPicPr>
+          <p:nvPr/>
+        </p:nvPicPr>
+        <p:blipFill>
+          <a:blip r:embed="rId3"/>
+          <a:stretch>
+            <a:fillRect/>
+          </a:stretch>
+        </p:blipFill>
+        <p:spPr>
+          <a:xfrm>
+            <a:off x="6720840" y="2278752"/>
+            <a:ext cx="4846320" cy="2757696"/>
+          </a:xfrm>
+          <a:prstGeom prst="rect">
+            <a:avLst/>
+          </a:prstGeom>
+        </p:spPr>
+      </p:pic>
     </p:spTree>
   </p:cSld>
   <p:clrMapOvr>
@@ -5275,7 +5323,7 @@
         <p:spPr>
           <a:xfrm>
             <a:off x="640080" y="1554480"/>
-            <a:ext cx="10881360" cy="4389120"/>
+            <a:ext cx="5669280" cy="4389120"/>
           </a:xfrm>
           <a:prstGeom prst="rect">
             <a:avLst/>
@@ -5316,11 +5364,36 @@
               </a:spcAft>
             </a:pPr>
             <a:r>
+              <a:rPr/>
               <a:t>Tracking causes, not decorates. Rates + baseline + errors.</a:t>
             </a:r>
           </a:p>
         </p:txBody>
       </p:sp>
+      <p:pic>
+        <p:nvPicPr>
+          <p:cNvPr id="7" name="Picture 6" descr="s10_rubric.png"/>
+          <p:cNvPicPr>
+            <a:picLocks noChangeAspect="1"/>
+          </p:cNvPicPr>
+          <p:nvPr/>
+        </p:nvPicPr>
+        <p:blipFill>
+          <a:blip r:embed="rId3"/>
+          <a:stretch>
+            <a:fillRect/>
+          </a:stretch>
+        </p:blipFill>
+        <p:spPr>
+          <a:xfrm>
+            <a:off x="6720840" y="2272751"/>
+            <a:ext cx="4846320" cy="2769697"/>
+          </a:xfrm>
+          <a:prstGeom prst="rect">
+            <a:avLst/>
+          </a:prstGeom>
+        </p:spPr>
+      </p:pic>
     </p:spTree>
   </p:cSld>
   <p:clrMapOvr>
@@ -5506,7 +5579,7 @@
         <p:spPr>
           <a:xfrm>
             <a:off x="640080" y="1554480"/>
-            <a:ext cx="10881360" cy="4389120"/>
+            <a:ext cx="5669280" cy="4389120"/>
           </a:xfrm>
           <a:prstGeom prst="rect">
             <a:avLst/>
@@ -5553,6 +5626,30 @@
           </a:p>
         </p:txBody>
       </p:sp>
+      <p:pic>
+        <p:nvPicPr>
+          <p:cNvPr id="7" name="Picture 6" descr="s11_forecast.png"/>
+          <p:cNvPicPr>
+            <a:picLocks noChangeAspect="1"/>
+          </p:cNvPicPr>
+          <p:nvPr/>
+        </p:nvPicPr>
+        <p:blipFill>
+          <a:blip r:embed="rId3"/>
+          <a:stretch>
+            <a:fillRect/>
+          </a:stretch>
+        </p:blipFill>
+        <p:spPr>
+          <a:xfrm>
+            <a:off x="6720840" y="2286668"/>
+            <a:ext cx="4846320" cy="2741863"/>
+          </a:xfrm>
+          <a:prstGeom prst="rect">
+            <a:avLst/>
+          </a:prstGeom>
+        </p:spPr>
+      </p:pic>
     </p:spTree>
   </p:cSld>
   <p:clrMapOvr>
@@ -5738,7 +5835,7 @@
         <p:spPr>
           <a:xfrm>
             <a:off x="640080" y="1554480"/>
-            <a:ext cx="10881360" cy="4389120"/>
+            <a:ext cx="5669280" cy="4389120"/>
           </a:xfrm>
           <a:prstGeom prst="rect">
             <a:avLst/>
@@ -5757,6 +5854,7 @@
               </a:spcAft>
             </a:pPr>
             <a:r>
+              <a:rPr/>
               <a:t>Open weights. Apache 2.0. From Muse Spark.</a:t>
             </a:r>
           </a:p>
@@ -5778,11 +5876,36 @@
               </a:spcAft>
             </a:pPr>
             <a:r>
+              <a:rPr/>
               <a:t>Local :8181. Cold start ~8s. 503 locked, 200 free.</a:t>
             </a:r>
           </a:p>
         </p:txBody>
       </p:sp>
+      <p:pic>
+        <p:nvPicPr>
+          <p:cNvPr id="7" name="Picture 6" descr="s12_glimmer.png"/>
+          <p:cNvPicPr>
+            <a:picLocks noChangeAspect="1"/>
+          </p:cNvPicPr>
+          <p:nvPr/>
+        </p:nvPicPr>
+        <p:blipFill>
+          <a:blip r:embed="rId3"/>
+          <a:stretch>
+            <a:fillRect/>
+          </a:stretch>
+        </p:blipFill>
+        <p:spPr>
+          <a:xfrm>
+            <a:off x="6720840" y="2283199"/>
+            <a:ext cx="4846320" cy="2748802"/>
+          </a:xfrm>
+          <a:prstGeom prst="rect">
+            <a:avLst/>
+          </a:prstGeom>
+        </p:spPr>
+      </p:pic>
     </p:spTree>
   </p:cSld>
   <p:clrMapOvr>
@@ -5968,7 +6091,7 @@
         <p:spPr>
           <a:xfrm>
             <a:off x="640080" y="1420000"/>
-            <a:ext cx="10881360" cy="5000000"/>
+            <a:ext cx="5669280" cy="5000000"/>
           </a:xfrm>
           <a:prstGeom prst="rect">
             <a:avLst/>
@@ -6015,6 +6138,30 @@
           </a:p>
         </p:txBody>
       </p:sp>
+      <p:pic>
+        <p:nvPicPr>
+          <p:cNvPr id="7" name="Picture 6" descr="s13_shootout.png"/>
+          <p:cNvPicPr>
+            <a:picLocks noChangeAspect="1"/>
+          </p:cNvPicPr>
+          <p:nvPr/>
+        </p:nvPicPr>
+        <p:blipFill>
+          <a:blip r:embed="rId3"/>
+          <a:stretch>
+            <a:fillRect/>
+          </a:stretch>
+        </p:blipFill>
+        <p:spPr>
+          <a:xfrm>
+            <a:off x="6720840" y="2639204"/>
+            <a:ext cx="4846320" cy="2036792"/>
+          </a:xfrm>
+          <a:prstGeom prst="rect">
+            <a:avLst/>
+          </a:prstGeom>
+        </p:spPr>
+      </p:pic>
     </p:spTree>
   </p:cSld>
   <p:clrMapOvr>
@@ -6200,7 +6347,7 @@
         <p:spPr>
           <a:xfrm>
             <a:off x="640080" y="1554480"/>
-            <a:ext cx="10881360" cy="4389120"/>
+            <a:ext cx="5669280" cy="4389120"/>
           </a:xfrm>
           <a:prstGeom prst="rect">
             <a:avLst/>
@@ -6247,6 +6394,30 @@
           </a:p>
         </p:txBody>
       </p:sp>
+      <p:pic>
+        <p:nvPicPr>
+          <p:cNvPr id="7" name="Picture 6" descr="s14_tips.png"/>
+          <p:cNvPicPr>
+            <a:picLocks noChangeAspect="1"/>
+          </p:cNvPicPr>
+          <p:nvPr/>
+        </p:nvPicPr>
+        <p:blipFill>
+          <a:blip r:embed="rId3"/>
+          <a:stretch>
+            <a:fillRect/>
+          </a:stretch>
+        </p:blipFill>
+        <p:spPr>
+          <a:xfrm>
+            <a:off x="6720840" y="2278752"/>
+            <a:ext cx="4846320" cy="2757696"/>
+          </a:xfrm>
+          <a:prstGeom prst="rect">
+            <a:avLst/>
+          </a:prstGeom>
+        </p:spPr>
+      </p:pic>
     </p:spTree>
   </p:cSld>
   <p:clrMapOvr>
@@ -6432,7 +6603,7 @@
         <p:spPr>
           <a:xfrm>
             <a:off x="640080" y="1554480"/>
-            <a:ext cx="10881360" cy="4389120"/>
+            <a:ext cx="5669280" cy="4389120"/>
           </a:xfrm>
           <a:prstGeom prst="rect">
             <a:avLst/>
@@ -6479,6 +6650,30 @@
           </a:p>
         </p:txBody>
       </p:sp>
+      <p:pic>
+        <p:nvPicPr>
+          <p:cNvPr id="7" name="Picture 6" descr="s15_tips.png"/>
+          <p:cNvPicPr>
+            <a:picLocks noChangeAspect="1"/>
+          </p:cNvPicPr>
+          <p:nvPr/>
+        </p:nvPicPr>
+        <p:blipFill>
+          <a:blip r:embed="rId3"/>
+          <a:stretch>
+            <a:fillRect/>
+          </a:stretch>
+        </p:blipFill>
+        <p:spPr>
+          <a:xfrm>
+            <a:off x="6720840" y="2278752"/>
+            <a:ext cx="4846320" cy="2757696"/>
+          </a:xfrm>
+          <a:prstGeom prst="rect">
+            <a:avLst/>
+          </a:prstGeom>
+        </p:spPr>
+      </p:pic>
     </p:spTree>
   </p:cSld>
   <p:clrMapOvr>
@@ -6664,7 +6859,7 @@
         <p:spPr>
           <a:xfrm>
             <a:off x="640080" y="1554480"/>
-            <a:ext cx="10881360" cy="4389120"/>
+            <a:ext cx="5669280" cy="4389120"/>
           </a:xfrm>
           <a:prstGeom prst="rect">
             <a:avLst/>
@@ -6711,6 +6906,30 @@
           </a:p>
         </p:txBody>
       </p:sp>
+      <p:pic>
+        <p:nvPicPr>
+          <p:cNvPr id="7" name="Picture 6" descr="s16_close.png"/>
+          <p:cNvPicPr>
+            <a:picLocks noChangeAspect="1"/>
+          </p:cNvPicPr>
+          <p:nvPr/>
+        </p:nvPicPr>
+        <p:blipFill>
+          <a:blip r:embed="rId3"/>
+          <a:stretch>
+            <a:fillRect/>
+          </a:stretch>
+        </p:blipFill>
+        <p:spPr>
+          <a:xfrm>
+            <a:off x="6720840" y="2278752"/>
+            <a:ext cx="4846320" cy="2757696"/>
+          </a:xfrm>
+          <a:prstGeom prst="rect">
+            <a:avLst/>
+          </a:prstGeom>
+        </p:spPr>
+      </p:pic>
     </p:spTree>
   </p:cSld>
   <p:clrMapOvr>
@@ -6896,7 +7115,7 @@
         <p:spPr>
           <a:xfrm>
             <a:off x="640080" y="1554480"/>
-            <a:ext cx="10881360" cy="4389120"/>
+            <a:ext cx="5669280" cy="4389120"/>
           </a:xfrm>
           <a:prstGeom prst="rect">
             <a:avLst/>
@@ -6943,6 +7162,30 @@
           </a:p>
         </p:txBody>
       </p:sp>
+      <p:pic>
+        <p:nvPicPr>
+          <p:cNvPr id="7" name="Picture 6" descr="s01_frame.png"/>
+          <p:cNvPicPr>
+            <a:picLocks noChangeAspect="1"/>
+          </p:cNvPicPr>
+          <p:nvPr/>
+        </p:nvPicPr>
+        <p:blipFill>
+          <a:blip r:embed="rId3"/>
+          <a:stretch>
+            <a:fillRect/>
+          </a:stretch>
+        </p:blipFill>
+        <p:spPr>
+          <a:xfrm>
+            <a:off x="6720840" y="2294572"/>
+            <a:ext cx="4846320" cy="2726055"/>
+          </a:xfrm>
+          <a:prstGeom prst="rect">
+            <a:avLst/>
+          </a:prstGeom>
+        </p:spPr>
+      </p:pic>
     </p:spTree>
   </p:cSld>
   <p:clrMapOvr>
@@ -7128,7 +7371,7 @@
         <p:spPr>
           <a:xfrm>
             <a:off x="640080" y="1554480"/>
-            <a:ext cx="10881360" cy="4389120"/>
+            <a:ext cx="5669280" cy="4389120"/>
           </a:xfrm>
           <a:prstGeom prst="rect">
             <a:avLst/>
@@ -7175,6 +7418,30 @@
           </a:p>
         </p:txBody>
       </p:sp>
+      <p:pic>
+        <p:nvPicPr>
+          <p:cNvPr id="7" name="Picture 6" descr="s02_scale.png"/>
+          <p:cNvPicPr>
+            <a:picLocks noChangeAspect="1"/>
+          </p:cNvPicPr>
+          <p:nvPr/>
+        </p:nvPicPr>
+        <p:blipFill>
+          <a:blip r:embed="rId3"/>
+          <a:stretch>
+            <a:fillRect/>
+          </a:stretch>
+        </p:blipFill>
+        <p:spPr>
+          <a:xfrm>
+            <a:off x="6720840" y="2309046"/>
+            <a:ext cx="4846320" cy="2697108"/>
+          </a:xfrm>
+          <a:prstGeom prst="rect">
+            <a:avLst/>
+          </a:prstGeom>
+        </p:spPr>
+      </p:pic>
     </p:spTree>
   </p:cSld>
   <p:clrMapOvr>
@@ -7360,7 +7627,7 @@
         <p:spPr>
           <a:xfrm>
             <a:off x="640080" y="1554480"/>
-            <a:ext cx="10881360" cy="4389120"/>
+            <a:ext cx="5669280" cy="4389120"/>
           </a:xfrm>
           <a:prstGeom prst="rect">
             <a:avLst/>
@@ -7401,11 +7668,36 @@
               </a:spcAft>
             </a:pPr>
             <a:r>
+              <a:rPr/>
               <a:t>2024: tackle probability: 20 features x 11.</a:t>
             </a:r>
           </a:p>
         </p:txBody>
       </p:sp>
+      <p:pic>
+        <p:nvPicPr>
+          <p:cNvPr id="7" name="Picture 6" descr="s03_timeline.png"/>
+          <p:cNvPicPr>
+            <a:picLocks noChangeAspect="1"/>
+          </p:cNvPicPr>
+          <p:nvPr/>
+        </p:nvPicPr>
+        <p:blipFill>
+          <a:blip r:embed="rId3"/>
+          <a:stretch>
+            <a:fillRect/>
+          </a:stretch>
+        </p:blipFill>
+        <p:spPr>
+          <a:xfrm>
+            <a:off x="6720840" y="2294572"/>
+            <a:ext cx="4846320" cy="2726055"/>
+          </a:xfrm>
+          <a:prstGeom prst="rect">
+            <a:avLst/>
+          </a:prstGeom>
+        </p:spPr>
+      </p:pic>
     </p:spTree>
   </p:cSld>
   <p:clrMapOvr>
@@ -7591,7 +7883,7 @@
         <p:spPr>
           <a:xfrm>
             <a:off x="640080" y="1554480"/>
-            <a:ext cx="10881360" cy="4389120"/>
+            <a:ext cx="5669280" cy="4389120"/>
           </a:xfrm>
           <a:prstGeom prst="rect">
             <a:avLst/>
@@ -7638,6 +7930,30 @@
           </a:p>
         </p:txBody>
       </p:sp>
+      <p:pic>
+        <p:nvPicPr>
+          <p:cNvPr id="7" name="Picture 6" descr="s04_schema.png"/>
+          <p:cNvPicPr>
+            <a:picLocks noChangeAspect="1"/>
+          </p:cNvPicPr>
+          <p:nvPr/>
+        </p:nvPicPr>
+        <p:blipFill>
+          <a:blip r:embed="rId3"/>
+          <a:stretch>
+            <a:fillRect/>
+          </a:stretch>
+        </p:blipFill>
+        <p:spPr>
+          <a:xfrm>
+            <a:off x="6720840" y="2287361"/>
+            <a:ext cx="4846320" cy="2740478"/>
+          </a:xfrm>
+          <a:prstGeom prst="rect">
+            <a:avLst/>
+          </a:prstGeom>
+        </p:spPr>
+      </p:pic>
     </p:spTree>
   </p:cSld>
   <p:clrMapOvr>
@@ -7823,7 +8139,7 @@
         <p:spPr>
           <a:xfrm>
             <a:off x="640080" y="1554480"/>
-            <a:ext cx="10881360" cy="4389120"/>
+            <a:ext cx="5669280" cy="4389120"/>
           </a:xfrm>
           <a:prstGeom prst="rect">
             <a:avLst/>
@@ -7870,6 +8186,30 @@
           </a:p>
         </p:txBody>
       </p:sp>
+      <p:pic>
+        <p:nvPicPr>
+          <p:cNvPr id="7" name="Picture 6" descr="s05_frame12.png"/>
+          <p:cNvPicPr>
+            <a:picLocks noChangeAspect="1"/>
+          </p:cNvPicPr>
+          <p:nvPr/>
+        </p:nvPicPr>
+        <p:blipFill>
+          <a:blip r:embed="rId3"/>
+          <a:stretch>
+            <a:fillRect/>
+          </a:stretch>
+        </p:blipFill>
+        <p:spPr>
+          <a:xfrm>
+            <a:off x="6720840" y="2293891"/>
+            <a:ext cx="4846320" cy="2727418"/>
+          </a:xfrm>
+          <a:prstGeom prst="rect">
+            <a:avLst/>
+          </a:prstGeom>
+        </p:spPr>
+      </p:pic>
     </p:spTree>
   </p:cSld>
   <p:clrMapOvr>
@@ -8055,7 +8395,7 @@
         <p:spPr>
           <a:xfrm>
             <a:off x="640080" y="1554480"/>
-            <a:ext cx="10881360" cy="4389120"/>
+            <a:ext cx="5669280" cy="4389120"/>
           </a:xfrm>
           <a:prstGeom prst="rect">
             <a:avLst/>
@@ -8102,6 +8442,30 @@
           </a:p>
         </p:txBody>
       </p:sp>
+      <p:pic>
+        <p:nvPicPr>
+          <p:cNvPr id="7" name="Picture 6" descr="s06_pipeline.png"/>
+          <p:cNvPicPr>
+            <a:picLocks noChangeAspect="1"/>
+          </p:cNvPicPr>
+          <p:nvPr/>
+        </p:nvPicPr>
+        <p:blipFill>
+          <a:blip r:embed="rId3"/>
+          <a:stretch>
+            <a:fillRect/>
+          </a:stretch>
+        </p:blipFill>
+        <p:spPr>
+          <a:xfrm>
+            <a:off x="6720840" y="2287361"/>
+            <a:ext cx="4846320" cy="2740478"/>
+          </a:xfrm>
+          <a:prstGeom prst="rect">
+            <a:avLst/>
+          </a:prstGeom>
+        </p:spPr>
+      </p:pic>
     </p:spTree>
   </p:cSld>
   <p:clrMapOvr>
@@ -8287,7 +8651,7 @@
         <p:spPr>
           <a:xfrm>
             <a:off x="640080" y="1554480"/>
-            <a:ext cx="10881360" cy="4389120"/>
+            <a:ext cx="5669280" cy="4389120"/>
           </a:xfrm>
           <a:prstGeom prst="rect">
             <a:avLst/>
@@ -8334,6 +8698,30 @@
           </a:p>
         </p:txBody>
       </p:sp>
+      <p:pic>
+        <p:nvPicPr>
+          <p:cNvPr id="7" name="Picture 6" descr="s07_features.png"/>
+          <p:cNvPicPr>
+            <a:picLocks noChangeAspect="1"/>
+          </p:cNvPicPr>
+          <p:nvPr/>
+        </p:nvPicPr>
+        <p:blipFill>
+          <a:blip r:embed="rId3"/>
+          <a:stretch>
+            <a:fillRect/>
+          </a:stretch>
+        </p:blipFill>
+        <p:spPr>
+          <a:xfrm>
+            <a:off x="6720840" y="2042160"/>
+            <a:ext cx="4846320" cy="3230880"/>
+          </a:xfrm>
+          <a:prstGeom prst="rect">
+            <a:avLst/>
+          </a:prstGeom>
+        </p:spPr>
+      </p:pic>
     </p:spTree>
   </p:cSld>
   <p:clrMapOvr>
@@ -8519,7 +8907,7 @@
         <p:spPr>
           <a:xfrm>
             <a:off x="640080" y="1554480"/>
-            <a:ext cx="10881360" cy="4389120"/>
+            <a:ext cx="5669280" cy="4389120"/>
           </a:xfrm>
           <a:prstGeom prst="rect">
             <a:avLst/>
@@ -8560,11 +8948,36 @@
               </a:spcAft>
             </a:pPr>
             <a:r>
+              <a:rPr/>
               <a:t>Ensemble must beat baseline by 1 SE. One seed, one config.</a:t>
             </a:r>
           </a:p>
         </p:txBody>
       </p:sp>
+      <p:pic>
+        <p:nvPicPr>
+          <p:cNvPr id="7" name="Picture 6" descr="s08_baseline.png"/>
+          <p:cNvPicPr>
+            <a:picLocks noChangeAspect="1"/>
+          </p:cNvPicPr>
+          <p:nvPr/>
+        </p:nvPicPr>
+        <p:blipFill>
+          <a:blip r:embed="rId3"/>
+          <a:stretch>
+            <a:fillRect/>
+          </a:stretch>
+        </p:blipFill>
+        <p:spPr>
+          <a:xfrm>
+            <a:off x="6720840" y="2203704"/>
+            <a:ext cx="4846320" cy="2907792"/>
+          </a:xfrm>
+          <a:prstGeom prst="rect">
+            <a:avLst/>
+          </a:prstGeom>
+        </p:spPr>
+      </p:pic>
     </p:spTree>
   </p:cSld>
   <p:clrMapOvr>

</xml_diff>

<commit_message>
deck: explicit AAA colors, wrap on, short lines, two-column layout
</commit_message>
<xml_diff>
--- a/deck/unified.pptx
+++ b/deck/unified.pptx
@@ -4781,7 +4781,7 @@
         </p:nvSpPr>
         <p:spPr>
           <a:xfrm>
-            <a:off x="640080" y="457200"/>
+            <a:off x="640080" y="365760"/>
             <a:ext cx="10881360" cy="822960"/>
           </a:xfrm>
           <a:prstGeom prst="rect">
@@ -4790,14 +4790,19 @@
           <a:noFill/>
         </p:spPr>
         <p:txBody>
-          <a:bodyPr wrap="none">
+          <a:bodyPr wrap="square">
             <a:spAutoFit/>
           </a:bodyPr>
           <a:lstStyle/>
           <a:p>
             <a:r>
-              <a:rPr sz="3600"/>
-              <a:t>Big Data Bowl x Muse Code: NFL tracking, live in terminal</a:t>
+              <a:rPr sz="3600" b="1">
+                <a:solidFill>
+                  <a:srgbClr val="D7C7EE"/>
+                </a:solidFill>
+                <a:latin typeface="Arial"/>
+              </a:rPr>
+              <a:t>Big Data Bowl x Muse Code, live</a:t>
             </a:r>
           </a:p>
         </p:txBody>
@@ -4811,7 +4816,7 @@
         <p:spPr>
           <a:xfrm>
             <a:off x="640080" y="1554480"/>
-            <a:ext cx="5669280" cy="4389120"/>
+            <a:ext cx="6400800" cy="4206240"/>
           </a:xfrm>
           <a:prstGeom prst="rect">
             <a:avLst/>
@@ -4819,41 +4824,56 @@
           <a:noFill/>
         </p:spPr>
         <p:txBody>
-          <a:bodyPr wrap="none">
+          <a:bodyPr wrap="square">
             <a:spAutoFit/>
           </a:bodyPr>
           <a:lstStyle/>
           <a:p>
             <a:pPr>
               <a:spcAft>
-                <a:spcPts val="1400"/>
+                <a:spcPts val="1600"/>
               </a:spcAft>
             </a:pPr>
             <a:r>
-              <a:rPr sz="2400"/>
-              <a:t>Big Data Bowl = vehicle. Muse Code = instrument.</a:t>
+              <a:rPr sz="2400">
+                <a:solidFill>
+                  <a:srgbClr val="FFFFFF"/>
+                </a:solidFill>
+                <a:latin typeface="Arial"/>
+              </a:rPr>
+              <a:t>Bowl = vehicle. Code = instrument.</a:t>
             </a:r>
           </a:p>
           <a:p>
             <a:pPr>
               <a:spcAft>
-                <a:spcPts val="1400"/>
+                <a:spcPts val="1600"/>
               </a:spcAft>
             </a:pPr>
             <a:r>
-              <a:rPr sz="2400"/>
-              <a:t>NFL Next Gen Stats: every player + ball, 10 Hz.</a:t>
+              <a:rPr sz="2400">
+                <a:solidFill>
+                  <a:srgbClr val="FFFFFF"/>
+                </a:solidFill>
+                <a:latin typeface="Arial"/>
+              </a:rPr>
+              <a:t>Every player + ball, 10 Hz.</a:t>
             </a:r>
           </a:p>
           <a:p>
             <a:pPr>
               <a:spcAft>
-                <a:spcPts val="1400"/>
+                <a:spcPts val="1600"/>
               </a:spcAft>
             </a:pPr>
             <a:r>
-              <a:rPr sz="2400"/>
-              <a:t>17 slides. Live demos. No mockups.</a:t>
+              <a:rPr sz="2400">
+                <a:solidFill>
+                  <a:srgbClr val="FFFFFF"/>
+                </a:solidFill>
+                <a:latin typeface="Arial"/>
+              </a:rPr>
+              <a:t>Live demos. Zero mockups.</a:t>
             </a:r>
           </a:p>
         </p:txBody>
@@ -4874,8 +4894,8 @@
         </p:blipFill>
         <p:spPr>
           <a:xfrm>
-            <a:off x="6720840" y="2294572"/>
-            <a:ext cx="4846320" cy="2726055"/>
+            <a:off x="7068312" y="2508885"/>
+            <a:ext cx="4572000" cy="2571750"/>
           </a:xfrm>
           <a:prstGeom prst="rect">
             <a:avLst/>
@@ -5037,7 +5057,7 @@
         </p:nvSpPr>
         <p:spPr>
           <a:xfrm>
-            <a:off x="640080" y="457200"/>
+            <a:off x="640080" y="365760"/>
             <a:ext cx="10881360" cy="822960"/>
           </a:xfrm>
           <a:prstGeom prst="rect">
@@ -5046,14 +5066,19 @@
           <a:noFill/>
         </p:spPr>
         <p:txBody>
-          <a:bodyPr wrap="none">
+          <a:bodyPr wrap="square">
             <a:spAutoFit/>
           </a:bodyPr>
           <a:lstStyle/>
           <a:p>
             <a:r>
-              <a:rPr sz="3600"/>
-              <a:t>Skills carry repetition. Guards protect raw.</a:t>
+              <a:rPr sz="3600" b="1">
+                <a:solidFill>
+                  <a:srgbClr val="D7C7EE"/>
+                </a:solidFill>
+                <a:latin typeface="Arial"/>
+              </a:rPr>
+              <a:t>Skills repeat. Guards protect.</a:t>
             </a:r>
           </a:p>
         </p:txBody>
@@ -5067,7 +5092,7 @@
         <p:spPr>
           <a:xfrm>
             <a:off x="640080" y="1554480"/>
-            <a:ext cx="5669280" cy="4389120"/>
+            <a:ext cx="6400800" cy="4206240"/>
           </a:xfrm>
           <a:prstGeom prst="rect">
             <a:avLst/>
@@ -5075,41 +5100,56 @@
           <a:noFill/>
         </p:spPr>
         <p:txBody>
-          <a:bodyPr wrap="none">
+          <a:bodyPr wrap="square">
             <a:spAutoFit/>
           </a:bodyPr>
           <a:lstStyle/>
           <a:p>
             <a:pPr>
               <a:spcAft>
-                <a:spcPts val="1400"/>
+                <a:spcPts val="1600"/>
               </a:spcAft>
             </a:pPr>
             <a:r>
-              <a:rPr sz="2400"/>
-              <a:t>3 skills: chunk-to-parquet. join-and-slice. baseline-ensemble.</a:t>
+              <a:rPr sz="2400">
+                <a:solidFill>
+                  <a:srgbClr val="FFFFFF"/>
+                </a:solidFill>
+                <a:latin typeface="Arial"/>
+              </a:rPr>
+              <a:t>parquet. slice. ensemble.</a:t>
             </a:r>
           </a:p>
           <a:p>
             <a:pPr>
               <a:spcAft>
-                <a:spcPts val="1400"/>
+                <a:spcPts val="1600"/>
               </a:spcAft>
             </a:pPr>
             <a:r>
-              <a:rPr sz="2400"/>
-              <a:t>sweep_weeks.sh: one prompt per question. CSV + PNG each.</a:t>
+              <a:rPr sz="2400">
+                <a:solidFill>
+                  <a:srgbClr val="FFFFFF"/>
+                </a:solidFill>
+                <a:latin typeface="Arial"/>
+              </a:rPr>
+              <a:t>One prompt per question.</a:t>
             </a:r>
           </a:p>
           <a:p>
             <a:pPr>
               <a:spcAft>
-                <a:spcPts val="1400"/>
+                <a:spcPts val="1600"/>
               </a:spcAft>
             </a:pPr>
             <a:r>
-              <a:rPr sz="2400"/>
-              <a:t>guard_data.sh trips on raw moves. Reviews on free local Glimmer.</a:t>
+              <a:rPr sz="2400">
+                <a:solidFill>
+                  <a:srgbClr val="FFFFFF"/>
+                </a:solidFill>
+                <a:latin typeface="Arial"/>
+              </a:rPr>
+              <a:t>Raw guarded. Reviews free local.</a:t>
             </a:r>
           </a:p>
         </p:txBody>
@@ -5130,8 +5170,8 @@
         </p:blipFill>
         <p:spPr>
           <a:xfrm>
-            <a:off x="6720840" y="2278752"/>
-            <a:ext cx="4846320" cy="2757696"/>
+            <a:off x="7068312" y="2493960"/>
+            <a:ext cx="4572000" cy="2601600"/>
           </a:xfrm>
           <a:prstGeom prst="rect">
             <a:avLst/>
@@ -5293,7 +5333,7 @@
         </p:nvSpPr>
         <p:spPr>
           <a:xfrm>
-            <a:off x="640080" y="457200"/>
+            <a:off x="640080" y="365760"/>
             <a:ext cx="10881360" cy="822960"/>
           </a:xfrm>
           <a:prstGeom prst="rect">
@@ -5302,14 +5342,19 @@
           <a:noFill/>
         </p:spPr>
         <p:txBody>
-          <a:bodyPr wrap="none">
+          <a:bodyPr wrap="square">
             <a:spAutoFit/>
           </a:bodyPr>
           <a:lstStyle/>
           <a:p>
             <a:r>
-              <a:rPr sz="3600"/>
-              <a:t>Rubric 30/30/20/20. Cause, never decorate.</a:t>
+              <a:rPr sz="3600" b="1">
+                <a:solidFill>
+                  <a:srgbClr val="D7C7EE"/>
+                </a:solidFill>
+                <a:latin typeface="Arial"/>
+              </a:rPr>
+              <a:t>30/30/20/20. Cause, don't decorate.</a:t>
             </a:r>
           </a:p>
         </p:txBody>
@@ -5323,7 +5368,7 @@
         <p:spPr>
           <a:xfrm>
             <a:off x="640080" y="1554480"/>
-            <a:ext cx="5669280" cy="4389120"/>
+            <a:ext cx="6400800" cy="4206240"/>
           </a:xfrm>
           <a:prstGeom prst="rect">
             <a:avLst/>
@@ -5331,41 +5376,56 @@
           <a:noFill/>
         </p:spPr>
         <p:txBody>
-          <a:bodyPr wrap="none">
+          <a:bodyPr wrap="square">
             <a:spAutoFit/>
           </a:bodyPr>
           <a:lstStyle/>
           <a:p>
             <a:pPr>
               <a:spcAft>
-                <a:spcPts val="1400"/>
+                <a:spcPts val="1600"/>
               </a:spcAft>
             </a:pPr>
             <a:r>
-              <a:rPr sz="2400"/>
-              <a:t>Football 30. Data science 30. Report 20. Visuals 20.</a:t>
+              <a:rPr sz="2400">
+                <a:solidFill>
+                  <a:srgbClr val="FFFFFF"/>
+                </a:solidFill>
+                <a:latin typeface="Arial"/>
+              </a:rPr>
+              <a:t>Football 30. Science 30. Prose 20. Visuals 20.</a:t>
             </a:r>
           </a:p>
           <a:p>
             <a:pPr>
               <a:spcAft>
-                <a:spcPts val="1400"/>
+                <a:spcPts val="1600"/>
               </a:spcAft>
             </a:pPr>
             <a:r>
-              <a:rPr sz="2400"/>
-              <a:t>2,000 words. Under 10 figures. Charts argue.</a:t>
+              <a:rPr sz="2400">
+                <a:solidFill>
+                  <a:srgbClr val="FFFFFF"/>
+                </a:solidFill>
+                <a:latin typeface="Arial"/>
+              </a:rPr>
+              <a:t>2,000 words. Under 10 figures.</a:t>
             </a:r>
           </a:p>
           <a:p>
             <a:pPr>
               <a:spcAft>
-                <a:spcPts val="1400"/>
+                <a:spcPts val="1600"/>
               </a:spcAft>
             </a:pPr>
             <a:r>
-              <a:rPr/>
-              <a:t>Tracking causes, not decorates. Rates + baseline + errors.</a:t>
+              <a:rPr sz="2400">
+                <a:solidFill>
+                  <a:srgbClr val="FFFFFF"/>
+                </a:solidFill>
+                <a:latin typeface="Arial"/>
+              </a:rPr>
+              <a:t>Cause, never decorate.</a:t>
             </a:r>
           </a:p>
         </p:txBody>
@@ -5386,8 +5446,8 @@
         </p:blipFill>
         <p:spPr>
           <a:xfrm>
-            <a:off x="6720840" y="2272751"/>
-            <a:ext cx="4846320" cy="2769697"/>
+            <a:off x="7068312" y="2488299"/>
+            <a:ext cx="4572000" cy="2612922"/>
           </a:xfrm>
           <a:prstGeom prst="rect">
             <a:avLst/>
@@ -5549,7 +5609,7 @@
         </p:nvSpPr>
         <p:spPr>
           <a:xfrm>
-            <a:off x="640080" y="457200"/>
+            <a:off x="640080" y="365760"/>
             <a:ext cx="10881360" cy="822960"/>
           </a:xfrm>
           <a:prstGeom prst="rect">
@@ -5558,14 +5618,19 @@
           <a:noFill/>
         </p:spPr>
         <p:txBody>
-          <a:bodyPr wrap="none">
+          <a:bodyPr wrap="square">
             <a:spAutoFit/>
           </a:bodyPr>
           <a:lstStyle/>
           <a:p>
             <a:r>
-              <a:rPr sz="3600"/>
-              <a:t>2027 forecast: defense is due.</a:t>
+              <a:rPr sz="3600" b="1">
+                <a:solidFill>
+                  <a:srgbClr val="D7C7EE"/>
+                </a:solidFill>
+                <a:latin typeface="Arial"/>
+              </a:rPr>
+              <a:t>2027: defense is due</a:t>
             </a:r>
           </a:p>
         </p:txBody>
@@ -5579,7 +5644,7 @@
         <p:spPr>
           <a:xfrm>
             <a:off x="640080" y="1554480"/>
-            <a:ext cx="5669280" cy="4389120"/>
+            <a:ext cx="6400800" cy="4206240"/>
           </a:xfrm>
           <a:prstGeom prst="rect">
             <a:avLst/>
@@ -5587,41 +5652,56 @@
           <a:noFill/>
         </p:spPr>
         <p:txBody>
-          <a:bodyPr wrap="none">
+          <a:bodyPr wrap="square">
             <a:spAutoFit/>
           </a:bodyPr>
           <a:lstStyle/>
           <a:p>
             <a:pPr>
               <a:spcAft>
-                <a:spcPts val="1400"/>
+                <a:spcPts val="1600"/>
               </a:spcAft>
             </a:pPr>
             <a:r>
-              <a:rPr sz="2400"/>
-              <a:t>2026 opened Sep 2025. 2027 unannounced: drops any day.</a:t>
+              <a:rPr sz="2400">
+                <a:solidFill>
+                  <a:srgbClr val="FFFFFF"/>
+                </a:solidFill>
+                <a:latin typeface="Arial"/>
+              </a:rPr>
+              <a:t>2026 opened Sep 2025. 2027 pending.</a:t>
             </a:r>
           </a:p>
           <a:p>
             <a:pPr>
               <a:spcAft>
-                <a:spcPts val="1400"/>
+                <a:spcPts val="1600"/>
               </a:spcAft>
             </a:pPr>
             <a:r>
-              <a:rPr sz="2400"/>
-              <a:t>Prediction alternates metric years. Offense banked. Defense next.</a:t>
+              <a:rPr sz="2400">
+                <a:solidFill>
+                  <a:srgbClr val="FFFFFF"/>
+                </a:solidFill>
+                <a:latin typeface="Arial"/>
+              </a:rPr>
+              <a:t>Offense banked. Defense next.</a:t>
             </a:r>
           </a:p>
           <a:p>
             <a:pPr>
               <a:spcAft>
-                <a:spcPts val="1400"/>
+                <a:spcPts val="1600"/>
               </a:spcAft>
             </a:pPr>
             <a:r>
-              <a:rPr sz="2400"/>
-              <a:t>Shortlist: ghost paths. New kickoff. Run blocking.</a:t>
+              <a:rPr sz="2400">
+                <a:solidFill>
+                  <a:srgbClr val="FFFFFF"/>
+                </a:solidFill>
+                <a:latin typeface="Arial"/>
+              </a:rPr>
+              <a:t>Ghosts. Kickoff. Run blocking.</a:t>
             </a:r>
           </a:p>
         </p:txBody>
@@ -5642,8 +5722,8 @@
         </p:blipFill>
         <p:spPr>
           <a:xfrm>
-            <a:off x="6720840" y="2286668"/>
-            <a:ext cx="4846320" cy="2741863"/>
+            <a:off x="7068312" y="2501428"/>
+            <a:ext cx="4572000" cy="2586663"/>
           </a:xfrm>
           <a:prstGeom prst="rect">
             <a:avLst/>
@@ -5805,7 +5885,7 @@
         </p:nvSpPr>
         <p:spPr>
           <a:xfrm>
-            <a:off x="640080" y="457200"/>
+            <a:off x="640080" y="365760"/>
             <a:ext cx="10881360" cy="822960"/>
           </a:xfrm>
           <a:prstGeom prst="rect">
@@ -5814,14 +5894,19 @@
           <a:noFill/>
         </p:spPr>
         <p:txBody>
-          <a:bodyPr wrap="none">
+          <a:bodyPr wrap="square">
             <a:spAutoFit/>
           </a:bodyPr>
           <a:lstStyle/>
           <a:p>
             <a:r>
-              <a:rPr sz="3600"/>
-              <a:t>Glimmer: 30B params. One workstation. Live.</a:t>
+              <a:rPr sz="3600" b="1">
+                <a:solidFill>
+                  <a:srgbClr val="D7C7EE"/>
+                </a:solidFill>
+                <a:latin typeface="Arial"/>
+              </a:rPr>
+              <a:t>Glimmer: 30B, one box, live</a:t>
             </a:r>
           </a:p>
         </p:txBody>
@@ -5835,7 +5920,7 @@
         <p:spPr>
           <a:xfrm>
             <a:off x="640080" y="1554480"/>
-            <a:ext cx="5669280" cy="4389120"/>
+            <a:ext cx="6400800" cy="4206240"/>
           </a:xfrm>
           <a:prstGeom prst="rect">
             <a:avLst/>
@@ -5843,41 +5928,56 @@
           <a:noFill/>
         </p:spPr>
         <p:txBody>
-          <a:bodyPr wrap="none">
+          <a:bodyPr wrap="square">
             <a:spAutoFit/>
           </a:bodyPr>
           <a:lstStyle/>
           <a:p>
             <a:pPr>
               <a:spcAft>
-                <a:spcPts val="1400"/>
+                <a:spcPts val="1600"/>
               </a:spcAft>
             </a:pPr>
             <a:r>
-              <a:rPr/>
-              <a:t>Open weights. Apache 2.0. From Muse Spark.</a:t>
+              <a:rPr sz="2400">
+                <a:solidFill>
+                  <a:srgbClr val="FFFFFF"/>
+                </a:solidFill>
+                <a:latin typeface="Arial"/>
+              </a:rPr>
+              <a:t>Open weights. Apache 2.0.</a:t>
             </a:r>
           </a:p>
           <a:p>
             <a:pPr>
               <a:spcAft>
-                <a:spcPts val="1400"/>
+                <a:spcPts val="1600"/>
               </a:spcAft>
             </a:pPr>
             <a:r>
-              <a:rPr sz="2400"/>
-              <a:t>12 GB card. 13 GPU layers. 4-bit quant.</a:t>
+              <a:rPr sz="2400">
+                <a:solidFill>
+                  <a:srgbClr val="FFFFFF"/>
+                </a:solidFill>
+                <a:latin typeface="Arial"/>
+              </a:rPr>
+              <a:t>13 layers. 4-bit. Port 8181.</a:t>
             </a:r>
           </a:p>
           <a:p>
             <a:pPr>
               <a:spcAft>
-                <a:spcPts val="1400"/>
+                <a:spcPts val="1600"/>
               </a:spcAft>
             </a:pPr>
             <a:r>
-              <a:rPr/>
-              <a:t>Local :8181. Cold start ~8s. 503 locked, 200 free.</a:t>
+              <a:rPr sz="2400">
+                <a:solidFill>
+                  <a:srgbClr val="FFFFFF"/>
+                </a:solidFill>
+                <a:latin typeface="Arial"/>
+              </a:rPr>
+              <a:t>Cold start ~8s. 503 = busy.</a:t>
             </a:r>
           </a:p>
         </p:txBody>
@@ -5898,8 +5998,8 @@
         </p:blipFill>
         <p:spPr>
           <a:xfrm>
-            <a:off x="6720840" y="2283199"/>
-            <a:ext cx="4846320" cy="2748802"/>
+            <a:off x="7068312" y="2498155"/>
+            <a:ext cx="4572000" cy="2593209"/>
           </a:xfrm>
           <a:prstGeom prst="rect">
             <a:avLst/>
@@ -6061,7 +6161,7 @@
         </p:nvSpPr>
         <p:spPr>
           <a:xfrm>
-            <a:off x="640080" y="457200"/>
+            <a:off x="640080" y="365760"/>
             <a:ext cx="10881360" cy="822960"/>
           </a:xfrm>
           <a:prstGeom prst="rect">
@@ -6070,14 +6170,19 @@
           <a:noFill/>
         </p:spPr>
         <p:txBody>
-          <a:bodyPr wrap="none">
+          <a:bodyPr wrap="square">
             <a:spAutoFit/>
           </a:bodyPr>
           <a:lstStyle/>
           <a:p>
             <a:r>
-              <a:rPr sz="3600"/>
-              <a:t>13 GPU layers buy nothing here.</a:t>
+              <a:rPr sz="3600" b="1">
+                <a:solidFill>
+                  <a:srgbClr val="D7C7EE"/>
+                </a:solidFill>
+                <a:latin typeface="Arial"/>
+              </a:rPr>
+              <a:t>13 GPU layers buy nothing</a:t>
             </a:r>
           </a:p>
         </p:txBody>
@@ -6090,8 +6195,8 @@
         </p:nvSpPr>
         <p:spPr>
           <a:xfrm>
-            <a:off x="640080" y="1420000"/>
-            <a:ext cx="5669280" cy="5000000"/>
+            <a:off x="640080" y="1554480"/>
+            <a:ext cx="6400800" cy="4206240"/>
           </a:xfrm>
           <a:prstGeom prst="rect">
             <a:avLst/>
@@ -6099,41 +6204,56 @@
           <a:noFill/>
         </p:spPr>
         <p:txBody>
-          <a:bodyPr wrap="none">
+          <a:bodyPr wrap="square">
             <a:spAutoFit/>
           </a:bodyPr>
           <a:lstStyle/>
           <a:p>
             <a:pPr>
               <a:spcAft>
-                <a:spcPts val="1400"/>
+                <a:spcPts val="1600"/>
               </a:spcAft>
             </a:pPr>
             <a:r>
-              <a:rPr sz="2400"/>
-              <a:t>CPU-only: 41.7s warm. 5.7 tok/s prompt. ~0 GPU.</a:t>
+              <a:rPr sz="2400">
+                <a:solidFill>
+                  <a:srgbClr val="FFFFFF"/>
+                </a:solidFill>
+                <a:latin typeface="Arial"/>
+              </a:rPr>
+              <a:t>CPU: 41.7s. 5.7 tok/s.</a:t>
             </a:r>
           </a:p>
           <a:p>
             <a:pPr>
               <a:spcAft>
-                <a:spcPts val="1400"/>
+                <a:spcPts val="1600"/>
               </a:spcAft>
             </a:pPr>
             <a:r>
-              <a:rPr sz="2400"/>
-              <a:t>NGL 13: 186.7s. 1.75 tok/s. 11.62 GB held. Bandwidth-bound.</a:t>
+              <a:rPr sz="2400">
+                <a:solidFill>
+                  <a:srgbClr val="FFFFFF"/>
+                </a:solidFill>
+                <a:latin typeface="Arial"/>
+              </a:rPr>
+              <a:t>NGL13: 186.7s. 11.62 GB.</a:t>
             </a:r>
           </a:p>
           <a:p>
             <a:pPr>
               <a:spcAft>
-                <a:spcPts val="1400"/>
+                <a:spcPts val="1600"/>
               </a:spcAft>
             </a:pPr>
             <a:r>
-              <a:rPr sz="2400"/>
-              <a:t>Hosted: 2m13s. Draft local. Promote keepers.</a:t>
+              <a:rPr sz="2400">
+                <a:solidFill>
+                  <a:srgbClr val="FFFFFF"/>
+                </a:solidFill>
+                <a:latin typeface="Arial"/>
+              </a:rPr>
+              <a:t>Hosted: 2m13s. Draft local.</a:t>
             </a:r>
           </a:p>
         </p:txBody>
@@ -6154,8 +6274,8 @@
         </p:blipFill>
         <p:spPr>
           <a:xfrm>
-            <a:off x="6720840" y="2639204"/>
-            <a:ext cx="4846320" cy="2036792"/>
+            <a:off x="7068312" y="2834009"/>
+            <a:ext cx="4572000" cy="1921502"/>
           </a:xfrm>
           <a:prstGeom prst="rect">
             <a:avLst/>
@@ -6317,7 +6437,7 @@
         </p:nvSpPr>
         <p:spPr>
           <a:xfrm>
-            <a:off x="640080" y="457200"/>
+            <a:off x="640080" y="365760"/>
             <a:ext cx="10881360" cy="822960"/>
           </a:xfrm>
           <a:prstGeom prst="rect">
@@ -6326,14 +6446,19 @@
           <a:noFill/>
         </p:spPr>
         <p:txBody>
-          <a:bodyPr wrap="none">
+          <a:bodyPr wrap="square">
             <a:spAutoFit/>
           </a:bodyPr>
           <a:lstStyle/>
           <a:p>
             <a:r>
-              <a:rPr sz="3600"/>
-              <a:t>Memory, modes, one skill per job.</a:t>
+              <a:rPr sz="3600" b="1">
+                <a:solidFill>
+                  <a:srgbClr val="D7C7EE"/>
+                </a:solidFill>
+                <a:latin typeface="Arial"/>
+              </a:rPr>
+              <a:t>Memory, modes, one skill each</a:t>
             </a:r>
           </a:p>
         </p:txBody>
@@ -6347,7 +6472,7 @@
         <p:spPr>
           <a:xfrm>
             <a:off x="640080" y="1554480"/>
-            <a:ext cx="5669280" cy="4389120"/>
+            <a:ext cx="6400800" cy="4206240"/>
           </a:xfrm>
           <a:prstGeom prst="rect">
             <a:avLst/>
@@ -6355,41 +6480,56 @@
           <a:noFill/>
         </p:spPr>
         <p:txBody>
-          <a:bodyPr wrap="none">
+          <a:bodyPr wrap="square">
             <a:spAutoFit/>
           </a:bodyPr>
           <a:lstStyle/>
           <a:p>
             <a:pPr>
               <a:spcAft>
-                <a:spcPts val="1400"/>
+                <a:spcPts val="1600"/>
               </a:spcAft>
             </a:pPr>
             <a:r>
-              <a:rPr sz="2400"/>
-              <a:t>muse init: persist conventions. Never re-explain.</a:t>
+              <a:rPr sz="2400">
+                <a:solidFill>
+                  <a:srgbClr val="FFFFFF"/>
+                </a:solidFill>
+                <a:latin typeface="Arial"/>
+              </a:rPr>
+              <a:t>muse init. Never re-explain.</a:t>
             </a:r>
           </a:p>
           <a:p>
             <a:pPr>
               <a:spcAft>
-                <a:spcPts val="1400"/>
+                <a:spcPts val="1600"/>
               </a:spcAft>
             </a:pPr>
             <a:r>
-              <a:rPr sz="2400"/>
-              <a:t>Pair interactive. Sweep headless exec.</a:t>
+              <a:rPr sz="2400">
+                <a:solidFill>
+                  <a:srgbClr val="FFFFFF"/>
+                </a:solidFill>
+                <a:latin typeface="Arial"/>
+              </a:rPr>
+              <a:t>Pair live. Sweep headless.</a:t>
             </a:r>
           </a:p>
           <a:p>
             <a:pPr>
               <a:spcAft>
-                <a:spcPts val="1400"/>
+                <a:spcPts val="1600"/>
               </a:spcAft>
             </a:pPr>
             <a:r>
-              <a:rPr sz="2400"/>
-              <a:t>Pin model per task. Budget reasoning. One skill per repeated job.</a:t>
+              <a:rPr sz="2400">
+                <a:solidFill>
+                  <a:srgbClr val="FFFFFF"/>
+                </a:solidFill>
+                <a:latin typeface="Arial"/>
+              </a:rPr>
+              <a:t>Pin model. Budget effort.</a:t>
             </a:r>
           </a:p>
         </p:txBody>
@@ -6410,8 +6550,8 @@
         </p:blipFill>
         <p:spPr>
           <a:xfrm>
-            <a:off x="6720840" y="2278752"/>
-            <a:ext cx="4846320" cy="2757696"/>
+            <a:off x="7068312" y="2493960"/>
+            <a:ext cx="4572000" cy="2601600"/>
           </a:xfrm>
           <a:prstGeom prst="rect">
             <a:avLst/>
@@ -6573,7 +6713,7 @@
         </p:nvSpPr>
         <p:spPr>
           <a:xfrm>
-            <a:off x="640080" y="457200"/>
+            <a:off x="640080" y="365760"/>
             <a:ext cx="10881360" cy="822960"/>
           </a:xfrm>
           <a:prstGeom prst="rect">
@@ -6582,14 +6722,19 @@
           <a:noFill/>
         </p:spPr>
         <p:txBody>
-          <a:bodyPr wrap="none">
+          <a:bodyPr wrap="square">
             <a:spAutoFit/>
           </a:bodyPr>
           <a:lstStyle/>
           <a:p>
             <a:r>
-              <a:rPr sz="3600"/>
-              <a:t>Read-only first. Rewind. Spend limits.</a:t>
+              <a:rPr sz="3600" b="1">
+                <a:solidFill>
+                  <a:srgbClr val="D7C7EE"/>
+                </a:solidFill>
+                <a:latin typeface="Arial"/>
+              </a:rPr>
+              <a:t>Read-only. Rewind. Cap spend.</a:t>
             </a:r>
           </a:p>
         </p:txBody>
@@ -6603,7 +6748,7 @@
         <p:spPr>
           <a:xfrm>
             <a:off x="640080" y="1554480"/>
-            <a:ext cx="5669280" cy="4389120"/>
+            <a:ext cx="6400800" cy="4206240"/>
           </a:xfrm>
           <a:prstGeom prst="rect">
             <a:avLst/>
@@ -6611,41 +6756,56 @@
           <a:noFill/>
         </p:spPr>
         <p:txBody>
-          <a:bodyPr wrap="none">
+          <a:bodyPr wrap="square">
             <a:spAutoFit/>
           </a:bodyPr>
           <a:lstStyle/>
           <a:p>
             <a:pPr>
               <a:spcAft>
-                <a:spcPts val="1400"/>
+                <a:spcPts val="1600"/>
               </a:spcAft>
             </a:pPr>
             <a:r>
-              <a:rPr sz="2400"/>
-              <a:t>MCP read-only first. Sandbox on. Approve writes.</a:t>
+              <a:rPr sz="2400">
+                <a:solidFill>
+                  <a:srgbClr val="FFFFFF"/>
+                </a:solidFill>
+                <a:latin typeface="Arial"/>
+              </a:rPr>
+              <a:t>MCP read-only. Sandbox on.</a:t>
             </a:r>
           </a:p>
           <a:p>
             <a:pPr>
               <a:spcAft>
-                <a:spcPts val="1400"/>
+                <a:spcPts val="1600"/>
               </a:spcAft>
             </a:pPr>
             <a:r>
-              <a:rPr sz="2400"/>
-              <a:t>Rewind beats retyping. Fan out with evidence.</a:t>
+              <a:rPr sz="2400">
+                <a:solidFill>
+                  <a:srgbClr val="FFFFFF"/>
+                </a:solidFill>
+                <a:latin typeface="Arial"/>
+              </a:rPr>
+              <a:t>Rewind, don't retype.</a:t>
             </a:r>
           </a:p>
           <a:p>
             <a:pPr>
               <a:spcAft>
-                <a:spcPts val="1400"/>
+                <a:spcPts val="1600"/>
               </a:spcAft>
             </a:pPr>
             <a:r>
-              <a:rPr sz="2400"/>
-              <a:t>Spark API + local Glimmer. Spend limits day one.</a:t>
+              <a:rPr sz="2400">
+                <a:solidFill>
+                  <a:srgbClr val="FFFFFF"/>
+                </a:solidFill>
+                <a:latin typeface="Arial"/>
+              </a:rPr>
+              <a:t>Spark API + Glimmer. Cap day one.</a:t>
             </a:r>
           </a:p>
         </p:txBody>
@@ -6666,8 +6826,8 @@
         </p:blipFill>
         <p:spPr>
           <a:xfrm>
-            <a:off x="6720840" y="2278752"/>
-            <a:ext cx="4846320" cy="2757696"/>
+            <a:off x="7068312" y="2493960"/>
+            <a:ext cx="4572000" cy="2601600"/>
           </a:xfrm>
           <a:prstGeom prst="rect">
             <a:avLst/>
@@ -6829,7 +6989,7 @@
         </p:nvSpPr>
         <p:spPr>
           <a:xfrm>
-            <a:off x="640080" y="457200"/>
+            <a:off x="640080" y="365760"/>
             <a:ext cx="10881360" cy="822960"/>
           </a:xfrm>
           <a:prstGeom prst="rect">
@@ -6838,14 +6998,19 @@
           <a:noFill/>
         </p:spPr>
         <p:txBody>
-          <a:bodyPr wrap="none">
+          <a:bodyPr wrap="square">
             <a:spAutoFit/>
           </a:bodyPr>
           <a:lstStyle/>
           <a:p>
             <a:r>
-              <a:rPr sz="3600"/>
-              <a:t>Vehicle + instrument. Start tonight.</a:t>
+              <a:rPr sz="3600" b="1">
+                <a:solidFill>
+                  <a:srgbClr val="D7C7EE"/>
+                </a:solidFill>
+                <a:latin typeface="Arial"/>
+              </a:rPr>
+              <a:t>Vehicle + instrument. Go tonight.</a:t>
             </a:r>
           </a:p>
         </p:txBody>
@@ -6859,7 +7024,7 @@
         <p:spPr>
           <a:xfrm>
             <a:off x="640080" y="1554480"/>
-            <a:ext cx="5669280" cy="4389120"/>
+            <a:ext cx="6400800" cy="4206240"/>
           </a:xfrm>
           <a:prstGeom prst="rect">
             <a:avLst/>
@@ -6867,41 +7032,56 @@
           <a:noFill/>
         </p:spPr>
         <p:txBody>
-          <a:bodyPr wrap="none">
+          <a:bodyPr wrap="square">
             <a:spAutoFit/>
           </a:bodyPr>
           <a:lstStyle/>
           <a:p>
             <a:pPr>
               <a:spcAft>
-                <a:spcPts val="1400"/>
+                <a:spcPts val="1600"/>
               </a:spcAft>
             </a:pPr>
             <a:r>
-              <a:rPr sz="2400"/>
-              <a:t>Bowl repo: docs, samples, scripts, skills. Guide: README 0-130.</a:t>
+              <a:rPr sz="2400">
+                <a:solidFill>
+                  <a:srgbClr val="FFFFFF"/>
+                </a:solidFill>
+                <a:latin typeface="Arial"/>
+              </a:rPr>
+              <a:t>Docs, samples, scripts, skills.</a:t>
             </a:r>
           </a:p>
           <a:p>
             <a:pPr>
               <a:spcAft>
-                <a:spcPts val="1400"/>
+                <a:spcPts val="1600"/>
               </a:spcAft>
             </a:pPr>
             <a:r>
-              <a:rPr sz="2400"/>
-              <a:t>Day one: data downloads while baselines re-run.</a:t>
+              <a:rPr sz="2400">
+                <a:solidFill>
+                  <a:srgbClr val="FFFFFF"/>
+                </a:solidFill>
+                <a:latin typeface="Arial"/>
+              </a:rPr>
+              <a:t>Data lands. Baselines rerun.</a:t>
             </a:r>
           </a:p>
           <a:p>
             <a:pPr>
               <a:spcAft>
-                <a:spcPts val="1400"/>
+                <a:spcPts val="1600"/>
               </a:spcAft>
             </a:pPr>
             <a:r>
-              <a:rPr sz="2400"/>
-              <a:t>One command: uv run python scripts/explore_sample.py --data samples/2024.</a:t>
+              <a:rPr sz="2400">
+                <a:solidFill>
+                  <a:srgbClr val="FFFFFF"/>
+                </a:solidFill>
+                <a:latin typeface="Arial"/>
+              </a:rPr>
+              <a:t>Run explore_sample tonight.</a:t>
             </a:r>
           </a:p>
         </p:txBody>
@@ -6922,8 +7102,8 @@
         </p:blipFill>
         <p:spPr>
           <a:xfrm>
-            <a:off x="6720840" y="2278752"/>
-            <a:ext cx="4846320" cy="2757696"/>
+            <a:off x="7068312" y="2493960"/>
+            <a:ext cx="4572000" cy="2601600"/>
           </a:xfrm>
           <a:prstGeom prst="rect">
             <a:avLst/>
@@ -7085,7 +7265,7 @@
         </p:nvSpPr>
         <p:spPr>
           <a:xfrm>
-            <a:off x="640080" y="457200"/>
+            <a:off x="640080" y="365760"/>
             <a:ext cx="10881360" cy="822960"/>
           </a:xfrm>
           <a:prstGeom prst="rect">
@@ -7094,14 +7274,19 @@
           <a:noFill/>
         </p:spPr>
         <p:txBody>
-          <a:bodyPr wrap="none">
+          <a:bodyPr wrap="square">
             <a:spAutoFit/>
           </a:bodyPr>
           <a:lstStyle/>
           <a:p>
             <a:r>
-              <a:rPr sz="3600"/>
-              <a:t>Invent a stat good enough for live TV</a:t>
+              <a:rPr sz="3600" b="1">
+                <a:solidFill>
+                  <a:srgbClr val="D7C7EE"/>
+                </a:solidFill>
+                <a:latin typeface="Arial"/>
+              </a:rPr>
+              <a:t>Invent a stat fit for live TV</a:t>
             </a:r>
           </a:p>
         </p:txBody>
@@ -7115,7 +7300,7 @@
         <p:spPr>
           <a:xfrm>
             <a:off x="640080" y="1554480"/>
-            <a:ext cx="5669280" cy="4389120"/>
+            <a:ext cx="6400800" cy="4206240"/>
           </a:xfrm>
           <a:prstGeom prst="rect">
             <a:avLst/>
@@ -7123,41 +7308,56 @@
           <a:noFill/>
         </p:spPr>
         <p:txBody>
-          <a:bodyPr wrap="none">
+          <a:bodyPr wrap="square">
             <a:spAutoFit/>
           </a:bodyPr>
           <a:lstStyle/>
           <a:p>
             <a:pPr>
               <a:spcAft>
-                <a:spcPts val="1400"/>
+                <a:spcPts val="1600"/>
               </a:spcAft>
             </a:pPr>
             <a:r>
-              <a:rPr sz="2400"/>
-              <a:t>Annual contest: NFL Football Operations + AWS.</a:t>
+              <a:rPr sz="2400">
+                <a:solidFill>
+                  <a:srgbClr val="FFFFFF"/>
+                </a:solidFill>
+                <a:latin typeface="Arial"/>
+              </a:rPr>
+              <a:t>NFL Football Operations + AWS.</a:t>
             </a:r>
           </a:p>
           <a:p>
             <a:pPr>
               <a:spcAft>
-                <a:spcPts val="1400"/>
+                <a:spcPts val="1600"/>
               </a:spcAft>
             </a:pPr>
             <a:r>
-              <a:rPr sz="2400"/>
-              <a:t>Real tracking data. Winners ship to broadcast.</a:t>
+              <a:rPr sz="2400">
+                <a:solidFill>
+                  <a:srgbClr val="FFFFFF"/>
+                </a:solidFill>
+                <a:latin typeface="Arial"/>
+              </a:rPr>
+              <a:t>Real tracking data. Winners ship.</a:t>
             </a:r>
           </a:p>
           <a:p>
             <a:pPr>
               <a:spcAft>
-                <a:spcPts val="1400"/>
+                <a:spcPts val="1600"/>
               </a:spcAft>
             </a:pPr>
             <a:r>
-              <a:rPr sz="2400"/>
-              <a:t>2027 topic unannounced: prep now, react never.</a:t>
+              <a:rPr sz="2400">
+                <a:solidFill>
+                  <a:srgbClr val="FFFFFF"/>
+                </a:solidFill>
+                <a:latin typeface="Arial"/>
+              </a:rPr>
+              <a:t>2027 unannounced. Prep now.</a:t>
             </a:r>
           </a:p>
         </p:txBody>
@@ -7178,8 +7378,8 @@
         </p:blipFill>
         <p:spPr>
           <a:xfrm>
-            <a:off x="6720840" y="2294572"/>
-            <a:ext cx="4846320" cy="2726055"/>
+            <a:off x="7068312" y="2508885"/>
+            <a:ext cx="4572000" cy="2571750"/>
           </a:xfrm>
           <a:prstGeom prst="rect">
             <a:avLst/>
@@ -7341,7 +7541,7 @@
         </p:nvSpPr>
         <p:spPr>
           <a:xfrm>
-            <a:off x="640080" y="457200"/>
+            <a:off x="640080" y="365760"/>
             <a:ext cx="10881360" cy="822960"/>
           </a:xfrm>
           <a:prstGeom prst="rect">
@@ -7350,14 +7550,19 @@
           <a:noFill/>
         </p:spPr>
         <p:txBody>
-          <a:bodyPr wrap="none">
+          <a:bodyPr wrap="square">
             <a:spAutoFit/>
           </a:bodyPr>
           <a:lstStyle/>
           <a:p>
             <a:r>
-              <a:rPr sz="3600"/>
-              <a:t>$100K. Combine stage. Hiring pipeline.</a:t>
+              <a:rPr sz="3600" b="1">
+                <a:solidFill>
+                  <a:srgbClr val="D7C7EE"/>
+                </a:solidFill>
+                <a:latin typeface="Arial"/>
+              </a:rPr>
+              <a:t>$100K. Combine stage. Hires.</a:t>
             </a:r>
           </a:p>
         </p:txBody>
@@ -7371,7 +7576,7 @@
         <p:spPr>
           <a:xfrm>
             <a:off x="640080" y="1554480"/>
-            <a:ext cx="5669280" cy="4389120"/>
+            <a:ext cx="6400800" cy="4206240"/>
           </a:xfrm>
           <a:prstGeom prst="rect">
             <a:avLst/>
@@ -7379,41 +7584,56 @@
           <a:noFill/>
         </p:spPr>
         <p:txBody>
-          <a:bodyPr wrap="none">
+          <a:bodyPr wrap="square">
             <a:spAutoFit/>
           </a:bodyPr>
           <a:lstStyle/>
           <a:p>
             <a:pPr>
               <a:spcAft>
-                <a:spcPts val="1400"/>
+                <a:spcPts val="1600"/>
               </a:spcAft>
             </a:pPr>
             <a:r>
-              <a:rPr sz="2400"/>
-              <a:t>2026: $100K pool. Finalists present at Combine.</a:t>
+              <a:rPr sz="2400">
+                <a:solidFill>
+                  <a:srgbClr val="FFFFFF"/>
+                </a:solidFill>
+                <a:latin typeface="Arial"/>
+              </a:rPr>
+              <a:t>$100K pool. Finals at Combine.</a:t>
             </a:r>
           </a:p>
           <a:p>
             <a:pPr>
               <a:spcAft>
-                <a:spcPts val="1400"/>
+                <a:spcPts val="1600"/>
               </a:spcAft>
             </a:pPr>
             <a:r>
-              <a:rPr sz="2400"/>
-              <a:t>Reported 8,329 registrations. 771 teams. 69 countries.</a:t>
+              <a:rPr sz="2400">
+                <a:solidFill>
+                  <a:srgbClr val="FFFFFF"/>
+                </a:solidFill>
+                <a:latin typeface="Arial"/>
+              </a:rPr>
+              <a:t>8,329 registered. 771 teams.</a:t>
             </a:r>
           </a:p>
           <a:p>
             <a:pPr>
               <a:spcAft>
-                <a:spcPts val="1400"/>
+                <a:spcPts val="1600"/>
               </a:spcAft>
             </a:pPr>
             <a:r>
-              <a:rPr sz="2400"/>
-              <a:t>50+ entrants hired. 30+ by teams, reportedly.</a:t>
+              <a:rPr sz="2400">
+                <a:solidFill>
+                  <a:srgbClr val="FFFFFF"/>
+                </a:solidFill>
+                <a:latin typeface="Arial"/>
+              </a:rPr>
+              <a:t>50+ hired. 30+ by teams.</a:t>
             </a:r>
           </a:p>
         </p:txBody>
@@ -7434,8 +7654,8 @@
         </p:blipFill>
         <p:spPr>
           <a:xfrm>
-            <a:off x="6720840" y="2309046"/>
-            <a:ext cx="4846320" cy="2697108"/>
+            <a:off x="7068312" y="2522539"/>
+            <a:ext cx="4572000" cy="2544442"/>
           </a:xfrm>
           <a:prstGeom prst="rect">
             <a:avLst/>
@@ -7597,7 +7817,7 @@
         </p:nvSpPr>
         <p:spPr>
           <a:xfrm>
-            <a:off x="640080" y="457200"/>
+            <a:off x="640080" y="365760"/>
             <a:ext cx="10881360" cy="822960"/>
           </a:xfrm>
           <a:prstGeom prst="rect">
@@ -7606,14 +7826,19 @@
           <a:noFill/>
         </p:spPr>
         <p:txBody>
-          <a:bodyPr wrap="none">
+          <a:bodyPr wrap="square">
             <a:spAutoFit/>
           </a:bodyPr>
           <a:lstStyle/>
           <a:p>
             <a:r>
-              <a:rPr sz="3600"/>
-              <a:t>Contest entries become TV stats</a:t>
+              <a:rPr sz="3600" b="1">
+                <a:solidFill>
+                  <a:srgbClr val="D7C7EE"/>
+                </a:solidFill>
+                <a:latin typeface="Arial"/>
+              </a:rPr>
+              <a:t>Entries become TV stats</a:t>
             </a:r>
           </a:p>
         </p:txBody>
@@ -7627,7 +7852,7 @@
         <p:spPr>
           <a:xfrm>
             <a:off x="640080" y="1554480"/>
-            <a:ext cx="5669280" cy="4389120"/>
+            <a:ext cx="6400800" cy="4206240"/>
           </a:xfrm>
           <a:prstGeom prst="rect">
             <a:avLst/>
@@ -7635,41 +7860,56 @@
           <a:noFill/>
         </p:spPr>
         <p:txBody>
-          <a:bodyPr wrap="none">
+          <a:bodyPr wrap="square">
             <a:spAutoFit/>
           </a:bodyPr>
           <a:lstStyle/>
           <a:p>
             <a:pPr>
               <a:spcAft>
-                <a:spcPts val="1400"/>
+                <a:spcPts val="1600"/>
               </a:spcAft>
             </a:pPr>
             <a:r>
-              <a:rPr sz="2400"/>
-              <a:t>2020: team Zoo predicted rush distributions.</a:t>
+              <a:rPr sz="2400">
+                <a:solidFill>
+                  <a:srgbClr val="FFFFFF"/>
+                </a:solidFill>
+                <a:latin typeface="Arial"/>
+              </a:rPr>
+              <a:t>2020: Zoo predicts rush yards.</a:t>
             </a:r>
           </a:p>
           <a:p>
             <a:pPr>
               <a:spcAft>
-                <a:spcPts val="1400"/>
+                <a:spcPts val="1600"/>
               </a:spcAft>
             </a:pPr>
             <a:r>
-              <a:rPr sz="2400"/>
-              <a:t>Shipped in ~6 months: expected rush yards.</a:t>
+              <a:rPr sz="2400">
+                <a:solidFill>
+                  <a:srgbClr val="FFFFFF"/>
+                </a:solidFill>
+                <a:latin typeface="Arial"/>
+              </a:rPr>
+              <a:t>On TV within ~6 months.</a:t>
             </a:r>
           </a:p>
           <a:p>
             <a:pPr>
               <a:spcAft>
-                <a:spcPts val="1400"/>
+                <a:spcPts val="1600"/>
               </a:spcAft>
             </a:pPr>
             <a:r>
-              <a:rPr/>
-              <a:t>2024: tackle probability: 20 features x 11.</a:t>
+              <a:rPr sz="2400">
+                <a:solidFill>
+                  <a:srgbClr val="FFFFFF"/>
+                </a:solidFill>
+                <a:latin typeface="Arial"/>
+              </a:rPr>
+              <a:t>Pressure (90K plays). Tackles (20x11).</a:t>
             </a:r>
           </a:p>
         </p:txBody>
@@ -7690,8 +7930,8 @@
         </p:blipFill>
         <p:spPr>
           <a:xfrm>
-            <a:off x="6720840" y="2294572"/>
-            <a:ext cx="4846320" cy="2726055"/>
+            <a:off x="7068312" y="2508885"/>
+            <a:ext cx="4572000" cy="2571750"/>
           </a:xfrm>
           <a:prstGeom prst="rect">
             <a:avLst/>
@@ -7853,7 +8093,7 @@
         </p:nvSpPr>
         <p:spPr>
           <a:xfrm>
-            <a:off x="640080" y="457200"/>
+            <a:off x="640080" y="365760"/>
             <a:ext cx="10881360" cy="822960"/>
           </a:xfrm>
           <a:prstGeom prst="rect">
@@ -7862,14 +8102,19 @@
           <a:noFill/>
         </p:spPr>
         <p:txBody>
-          <a:bodyPr wrap="none">
+          <a:bodyPr wrap="square">
             <a:spAutoFit/>
           </a:bodyPr>
           <a:lstStyle/>
           <a:p>
             <a:r>
-              <a:rPr sz="3600"/>
-              <a:t>Every player. Every ball. 10x per second.</a:t>
+              <a:rPr sz="3600" b="1">
+                <a:solidFill>
+                  <a:srgbClr val="D7C7EE"/>
+                </a:solidFill>
+                <a:latin typeface="Arial"/>
+              </a:rPr>
+              <a:t>Everyone tracked. 10x a second.</a:t>
             </a:r>
           </a:p>
         </p:txBody>
@@ -7883,7 +8128,7 @@
         <p:spPr>
           <a:xfrm>
             <a:off x="640080" y="1554480"/>
-            <a:ext cx="5669280" cy="4389120"/>
+            <a:ext cx="6400800" cy="4206240"/>
           </a:xfrm>
           <a:prstGeom prst="rect">
             <a:avLst/>
@@ -7891,41 +8136,56 @@
           <a:noFill/>
         </p:spPr>
         <p:txBody>
-          <a:bodyPr wrap="none">
+          <a:bodyPr wrap="square">
             <a:spAutoFit/>
           </a:bodyPr>
           <a:lstStyle/>
           <a:p>
             <a:pPr>
               <a:spcAft>
-                <a:spcPts val="1400"/>
+                <a:spcPts val="1600"/>
               </a:spcAft>
             </a:pPr>
             <a:r>
-              <a:rPr sz="2400"/>
-              <a:t>RFID tags + sensor ball. Zebra hardware.</a:t>
+              <a:rPr sz="2400">
+                <a:solidFill>
+                  <a:srgbClr val="FFFFFF"/>
+                </a:solidFill>
+                <a:latin typeface="Arial"/>
+              </a:rPr>
+              <a:t>RFID tags + sensor ball. Zebra.</a:t>
             </a:r>
           </a:p>
           <a:p>
             <a:pPr>
               <a:spcAft>
-                <a:spcPts val="1400"/>
+                <a:spcPts val="1600"/>
               </a:spcAft>
             </a:pPr>
             <a:r>
-              <a:rPr sz="2400"/>
-              <a:t>Per row: x/y, speed, accel, event, frame/play/player IDs.</a:t>
+              <a:rPr sz="2400">
+                <a:solidFill>
+                  <a:srgbClr val="FFFFFF"/>
+                </a:solidFill>
+                <a:latin typeface="Arial"/>
+              </a:rPr>
+              <a:t>x/y, speed, accel, event, IDs.</a:t>
             </a:r>
           </a:p>
           <a:p>
             <a:pPr>
               <a:spcAft>
-                <a:spcPts val="1400"/>
+                <a:spcPts val="1600"/>
               </a:spcAft>
             </a:pPr>
             <a:r>
-              <a:rPr sz="2400"/>
-              <a:t>Weeks ~1.5 GB CSVs. Demos use 25-play sample.</a:t>
+              <a:rPr sz="2400">
+                <a:solidFill>
+                  <a:srgbClr val="FFFFFF"/>
+                </a:solidFill>
+                <a:latin typeface="Arial"/>
+              </a:rPr>
+              <a:t>Weeks ~1.5 GB. Demo: 25 plays.</a:t>
             </a:r>
           </a:p>
         </p:txBody>
@@ -7946,8 +8206,8 @@
         </p:blipFill>
         <p:spPr>
           <a:xfrm>
-            <a:off x="6720840" y="2287361"/>
-            <a:ext cx="4846320" cy="2740478"/>
+            <a:off x="7068312" y="2502081"/>
+            <a:ext cx="4572000" cy="2585357"/>
           </a:xfrm>
           <a:prstGeom prst="rect">
             <a:avLst/>
@@ -8109,7 +8369,7 @@
         </p:nvSpPr>
         <p:spPr>
           <a:xfrm>
-            <a:off x="640080" y="457200"/>
+            <a:off x="640080" y="365760"/>
             <a:ext cx="10881360" cy="822960"/>
           </a:xfrm>
           <a:prstGeom prst="rect">
@@ -8118,14 +8378,19 @@
           <a:noFill/>
         </p:spPr>
         <p:txBody>
-          <a:bodyPr wrap="none">
+          <a:bodyPr wrap="square">
             <a:spAutoFit/>
           </a:bodyPr>
           <a:lstStyle/>
           <a:p>
             <a:r>
-              <a:rPr sz="3600"/>
-              <a:t>Workflow 1: Sample first. Full weeks later.</a:t>
+              <a:rPr sz="3600" b="1">
+                <a:solidFill>
+                  <a:srgbClr val="D7C7EE"/>
+                </a:solidFill>
+                <a:latin typeface="Arial"/>
+              </a:rPr>
+              <a:t>Workflow 1: sample first</a:t>
             </a:r>
           </a:p>
         </p:txBody>
@@ -8139,7 +8404,7 @@
         <p:spPr>
           <a:xfrm>
             <a:off x="640080" y="1554480"/>
-            <a:ext cx="5669280" cy="4389120"/>
+            <a:ext cx="6400800" cy="4206240"/>
           </a:xfrm>
           <a:prstGeom prst="rect">
             <a:avLst/>
@@ -8147,41 +8412,56 @@
           <a:noFill/>
         </p:spPr>
         <p:txBody>
-          <a:bodyPr wrap="none">
+          <a:bodyPr wrap="square">
             <a:spAutoFit/>
           </a:bodyPr>
           <a:lstStyle/>
           <a:p>
             <a:pPr>
               <a:spcAft>
-                <a:spcPts val="1400"/>
+                <a:spcPts val="1600"/>
               </a:spcAft>
             </a:pPr>
             <a:r>
-              <a:rPr sz="2400"/>
-              <a:t>19,113 rows. 25 plays. Zero download.</a:t>
+              <a:rPr sz="2400">
+                <a:solidFill>
+                  <a:srgbClr val="FFFFFF"/>
+                </a:solidFill>
+                <a:latin typeface="Arial"/>
+              </a:rPr>
+              <a:t>19,113 rows. 25 plays.</a:t>
             </a:r>
           </a:p>
           <a:p>
             <a:pPr>
               <a:spcAft>
-                <a:spcPts val="1400"/>
+                <a:spcPts val="1600"/>
               </a:spcAft>
             </a:pPr>
             <a:r>
-              <a:rPr sz="2400"/>
-              <a:t>Join tracking + games + plays + players. Plot 22 + ball.</a:t>
+              <a:rPr sz="2400">
+                <a:solidFill>
+                  <a:srgbClr val="FFFFFF"/>
+                </a:solidFill>
+                <a:latin typeface="Arial"/>
+              </a:rPr>
+              <a:t>Join, print, plot 22 + ball.</a:t>
             </a:r>
           </a:p>
           <a:p>
             <a:pPr>
               <a:spcAft>
-                <a:spcPts val="1400"/>
+                <a:spcPts val="1600"/>
               </a:spcAft>
             </a:pPr>
             <a:r>
-              <a:rPr sz="2400"/>
-              <a:t>x: 0-120 yd. y: 0-53.3. Angles 0-360.</a:t>
+              <a:rPr sz="2400">
+                <a:solidFill>
+                  <a:srgbClr val="FFFFFF"/>
+                </a:solidFill>
+                <a:latin typeface="Arial"/>
+              </a:rPr>
+              <a:t>x 0-120. y 0-53.3. Angles 360.</a:t>
             </a:r>
           </a:p>
         </p:txBody>
@@ -8202,8 +8482,8 @@
         </p:blipFill>
         <p:spPr>
           <a:xfrm>
-            <a:off x="6720840" y="2293891"/>
-            <a:ext cx="4846320" cy="2727418"/>
+            <a:off x="7068312" y="2508242"/>
+            <a:ext cx="4572000" cy="2573036"/>
           </a:xfrm>
           <a:prstGeom prst="rect">
             <a:avLst/>
@@ -8365,7 +8645,7 @@
         </p:nvSpPr>
         <p:spPr>
           <a:xfrm>
-            <a:off x="640080" y="457200"/>
+            <a:off x="640080" y="365760"/>
             <a:ext cx="10881360" cy="822960"/>
           </a:xfrm>
           <a:prstGeom prst="rect">
@@ -8374,14 +8654,19 @@
           <a:noFill/>
         </p:spPr>
         <p:txBody>
-          <a:bodyPr wrap="none">
+          <a:bodyPr wrap="square">
             <a:spAutoFit/>
           </a:bodyPr>
           <a:lstStyle/>
           <a:p>
             <a:r>
-              <a:rPr sz="3600"/>
-              <a:t>Workflow 2: Parquet once. Fast forever.</a:t>
+              <a:rPr sz="3600" b="1">
+                <a:solidFill>
+                  <a:srgbClr val="D7C7EE"/>
+                </a:solidFill>
+                <a:latin typeface="Arial"/>
+              </a:rPr>
+              <a:t>Workflow 2: Parquet once</a:t>
             </a:r>
           </a:p>
         </p:txBody>
@@ -8395,7 +8680,7 @@
         <p:spPr>
           <a:xfrm>
             <a:off x="640080" y="1554480"/>
-            <a:ext cx="5669280" cy="4389120"/>
+            <a:ext cx="6400800" cy="4206240"/>
           </a:xfrm>
           <a:prstGeom prst="rect">
             <a:avLst/>
@@ -8403,41 +8688,56 @@
           <a:noFill/>
         </p:spPr>
         <p:txBody>
-          <a:bodyPr wrap="none">
+          <a:bodyPr wrap="square">
             <a:spAutoFit/>
           </a:bodyPr>
           <a:lstStyle/>
           <a:p>
             <a:pPr>
               <a:spcAft>
-                <a:spcPts val="1400"/>
+                <a:spcPts val="1600"/>
               </a:spcAft>
             </a:pPr>
             <a:r>
-              <a:rPr sz="2400"/>
-              <a:t>Weeks too big for RAM. Chunk reads: 200K rows.</a:t>
+              <a:rPr sz="2400">
+                <a:solidFill>
+                  <a:srgbClr val="FFFFFF"/>
+                </a:solidFill>
+                <a:latin typeface="Arial"/>
+              </a:rPr>
+              <a:t>Weeks exceed RAM. Chunk 200K.</a:t>
             </a:r>
           </a:p>
           <a:p>
             <a:pPr>
               <a:spcAft>
-                <a:spcPts val="1400"/>
+                <a:spcPts val="1600"/>
               </a:spcAft>
             </a:pPr>
             <a:r>
-              <a:rPr sz="2400"/>
-              <a:t>Convert weekly CSV -&gt; Parquet exactly once.</a:t>
+              <a:rPr sz="2400">
+                <a:solidFill>
+                  <a:srgbClr val="FFFFFF"/>
+                </a:solidFill>
+                <a:latin typeface="Arial"/>
+              </a:rPr>
+              <a:t>Convert to Parquet one time.</a:t>
             </a:r>
           </a:p>
           <a:p>
             <a:pPr>
               <a:spcAft>
-                <a:spcPts val="1400"/>
+                <a:spcPts val="1600"/>
               </a:spcAft>
             </a:pPr>
             <a:r>
-              <a:rPr sz="2400"/>
-              <a:t>Raw stays read-only. Outputs land in data/scratch/.</a:t>
+              <a:rPr sz="2400">
+                <a:solidFill>
+                  <a:srgbClr val="FFFFFF"/>
+                </a:solidFill>
+                <a:latin typeface="Arial"/>
+              </a:rPr>
+              <a:t>Raw read-only. Out to scratch/.</a:t>
             </a:r>
           </a:p>
         </p:txBody>
@@ -8458,8 +8758,8 @@
         </p:blipFill>
         <p:spPr>
           <a:xfrm>
-            <a:off x="6720840" y="2287361"/>
-            <a:ext cx="4846320" cy="2740478"/>
+            <a:off x="7068312" y="2502081"/>
+            <a:ext cx="4572000" cy="2585357"/>
           </a:xfrm>
           <a:prstGeom prst="rect">
             <a:avLst/>
@@ -8621,7 +8921,7 @@
         </p:nvSpPr>
         <p:spPr>
           <a:xfrm>
-            <a:off x="640080" y="457200"/>
+            <a:off x="640080" y="365760"/>
             <a:ext cx="10881360" cy="822960"/>
           </a:xfrm>
           <a:prstGeom prst="rect">
@@ -8630,14 +8930,19 @@
           <a:noFill/>
         </p:spPr>
         <p:txBody>
-          <a:bodyPr wrap="none">
+          <a:bodyPr wrap="square">
             <a:spAutoFit/>
           </a:bodyPr>
           <a:lstStyle/>
           <a:p>
             <a:r>
-              <a:rPr sz="3600"/>
-              <a:t>Workflow 3: Features frame-up.</a:t>
+              <a:rPr sz="3600" b="1">
+                <a:solidFill>
+                  <a:srgbClr val="D7C7EE"/>
+                </a:solidFill>
+                <a:latin typeface="Arial"/>
+              </a:rPr>
+              <a:t>Workflow 3: features frame-up</a:t>
             </a:r>
           </a:p>
         </p:txBody>
@@ -8651,7 +8956,7 @@
         <p:spPr>
           <a:xfrm>
             <a:off x="640080" y="1554480"/>
-            <a:ext cx="5669280" cy="4389120"/>
+            <a:ext cx="6400800" cy="4206240"/>
           </a:xfrm>
           <a:prstGeom prst="rect">
             <a:avLst/>
@@ -8659,41 +8964,56 @@
           <a:noFill/>
         </p:spPr>
         <p:txBody>
-          <a:bodyPr wrap="none">
+          <a:bodyPr wrap="square">
             <a:spAutoFit/>
           </a:bodyPr>
           <a:lstStyle/>
           <a:p>
             <a:pPr>
               <a:spcAft>
-                <a:spcPts val="1400"/>
+                <a:spcPts val="1600"/>
               </a:spcAft>
             </a:pPr>
             <a:r>
-              <a:rPr sz="2400"/>
-              <a:t>Frame features -&gt; per-player models -&gt; one play stat.</a:t>
+              <a:rPr sz="2400">
+                <a:solidFill>
+                  <a:srgbClr val="FFFFFF"/>
+                </a:solidFill>
+                <a:latin typeface="Arial"/>
+              </a:rPr>
+              <a:t>Frames -&gt; players -&gt; one stat.</a:t>
             </a:r>
           </a:p>
           <a:p>
             <a:pPr>
               <a:spcAft>
-                <a:spcPts val="1400"/>
+                <a:spcPts val="1600"/>
               </a:spcAft>
             </a:pPr>
             <a:r>
-              <a:rPr sz="2400"/>
-              <a:t>Speed. Accel. Distance-to-line. Formation encodings.</a:t>
+              <a:rPr sz="2400">
+                <a:solidFill>
+                  <a:srgbClr val="FFFFFF"/>
+                </a:solidFill>
+                <a:latin typeface="Arial"/>
+              </a:rPr>
+              <a:t>Speed. Accel. Line distance.</a:t>
             </a:r>
           </a:p>
           <a:p>
             <a:pPr>
               <a:spcAft>
-                <a:spcPts val="1400"/>
+                <a:spcPts val="1600"/>
               </a:spcAft>
             </a:pPr>
             <a:r>
-              <a:rPr sz="2400"/>
-              <a:t>Convnets for tackle probability. LightGBM over XGBoost: faster, leaner.</a:t>
+              <a:rPr sz="2400">
+                <a:solidFill>
+                  <a:srgbClr val="FFFFFF"/>
+                </a:solidFill>
+                <a:latin typeface="Arial"/>
+              </a:rPr>
+              <a:t>Convnets. LightGBM wins.</a:t>
             </a:r>
           </a:p>
         </p:txBody>
@@ -8714,8 +9034,8 @@
         </p:blipFill>
         <p:spPr>
           <a:xfrm>
-            <a:off x="6720840" y="2042160"/>
-            <a:ext cx="4846320" cy="3230880"/>
+            <a:off x="7068312" y="2270760"/>
+            <a:ext cx="4572000" cy="3047999"/>
           </a:xfrm>
           <a:prstGeom prst="rect">
             <a:avLst/>
@@ -8877,7 +9197,7 @@
         </p:nvSpPr>
         <p:spPr>
           <a:xfrm>
-            <a:off x="640080" y="457200"/>
+            <a:off x="640080" y="365760"/>
             <a:ext cx="10881360" cy="822960"/>
           </a:xfrm>
           <a:prstGeom prst="rect">
@@ -8886,14 +9206,19 @@
           <a:noFill/>
         </p:spPr>
         <p:txBody>
-          <a:bodyPr wrap="none">
+          <a:bodyPr wrap="square">
             <a:spAutoFit/>
           </a:bodyPr>
           <a:lstStyle/>
           <a:p>
             <a:r>
-              <a:rPr sz="3600"/>
-              <a:t>Workflow 4: Baseline, then earn ensemble.</a:t>
+              <a:rPr sz="3600" b="1">
+                <a:solidFill>
+                  <a:srgbClr val="D7C7EE"/>
+                </a:solidFill>
+                <a:latin typeface="Arial"/>
+              </a:rPr>
+              <a:t>Workflow 4: baseline first</a:t>
             </a:r>
           </a:p>
         </p:txBody>
@@ -8907,7 +9232,7 @@
         <p:spPr>
           <a:xfrm>
             <a:off x="640080" y="1554480"/>
-            <a:ext cx="5669280" cy="4389120"/>
+            <a:ext cx="6400800" cy="4206240"/>
           </a:xfrm>
           <a:prstGeom prst="rect">
             <a:avLst/>
@@ -8915,41 +9240,56 @@
           <a:noFill/>
         </p:spPr>
         <p:txBody>
-          <a:bodyPr wrap="none">
+          <a:bodyPr wrap="square">
             <a:spAutoFit/>
           </a:bodyPr>
           <a:lstStyle/>
           <a:p>
             <a:pPr>
               <a:spcAft>
-                <a:spcPts val="1400"/>
+                <a:spcPts val="1600"/>
               </a:spcAft>
             </a:pPr>
             <a:r>
-              <a:rPr sz="2400"/>
-              <a:t>Baseline: lasso-logistic, 0.700 +/- 0.110.</a:t>
+              <a:rPr sz="2400">
+                <a:solidFill>
+                  <a:srgbClr val="FFFFFF"/>
+                </a:solidFill>
+                <a:latin typeface="Arial"/>
+              </a:rPr>
+              <a:t>Lasso-logistic: .700 +/- .110.</a:t>
             </a:r>
           </a:p>
           <a:p>
             <a:pPr>
               <a:spcAft>
-                <a:spcPts val="1400"/>
+                <a:spcPts val="1600"/>
               </a:spcAft>
             </a:pPr>
             <a:r>
-              <a:rPr sz="2400"/>
-              <a:t>Group folds by play. No leakage across frames.</a:t>
+              <a:rPr sz="2400">
+                <a:solidFill>
+                  <a:srgbClr val="FFFFFF"/>
+                </a:solidFill>
+                <a:latin typeface="Arial"/>
+              </a:rPr>
+              <a:t>Folds grouped by play.</a:t>
             </a:r>
           </a:p>
           <a:p>
             <a:pPr>
               <a:spcAft>
-                <a:spcPts val="1400"/>
+                <a:spcPts val="1600"/>
               </a:spcAft>
             </a:pPr>
             <a:r>
-              <a:rPr/>
-              <a:t>Ensemble must beat baseline by 1 SE. One seed, one config.</a:t>
+              <a:rPr sz="2400">
+                <a:solidFill>
+                  <a:srgbClr val="FFFFFF"/>
+                </a:solidFill>
+                <a:latin typeface="Arial"/>
+              </a:rPr>
+              <a:t>Beat it by 1 SE or die.</a:t>
             </a:r>
           </a:p>
         </p:txBody>
@@ -8970,8 +9310,8 @@
         </p:blipFill>
         <p:spPr>
           <a:xfrm>
-            <a:off x="6720840" y="2203704"/>
-            <a:ext cx="4846320" cy="2907792"/>
+            <a:off x="7068312" y="2423160"/>
+            <a:ext cx="4572000" cy="2743200"/>
           </a:xfrm>
           <a:prstGeom prst="rect">
             <a:avLst/>

</xml_diff>

<commit_message>
deck: swap 8 regenerated visuals, nudge slide 15 right 0.25in
</commit_message>
<xml_diff>
--- a/deck/unified.pptx
+++ b/deck/unified.pptx
@@ -4639,9 +4639,17 @@
   <p:cSld>
     <p:bg>
       <p:bgPr>
-        <a:solidFill>
-          <a:srgbClr val="00002A"/>
-        </a:solidFill>
+        <a:gradFill rotWithShape="1">
+          <a:gsLst>
+            <a:gs pos="0">
+              <a:srgbClr val="00002A"/>
+            </a:gs>
+            <a:gs pos="100000">
+              <a:srgbClr val="200050"/>
+            </a:gs>
+          </a:gsLst>
+          <a:lin scaled="0" ang="16200000"/>
+        </a:gradFill>
         <a:effectLst/>
       </p:bgPr>
     </p:bg>
@@ -4666,9 +4674,17 @@
           <a:prstGeom prst="rect">
             <a:avLst/>
           </a:prstGeom>
-          <a:solidFill>
-            <a:srgbClr val="00002A"/>
-          </a:solidFill>
+          <a:gradFill rotWithShape="1">
+            <a:gsLst>
+              <a:gs pos="0">
+                <a:srgbClr val="5A1F8A"/>
+              </a:gs>
+              <a:gs pos="100000">
+                <a:srgbClr val="FF9900"/>
+              </a:gs>
+            </a:gsLst>
+            <a:lin scaled="0" ang="0"/>
+          </a:gradFill>
           <a:ln>
             <a:noFill/>
           </a:ln>
@@ -4709,9 +4725,17 @@
           <a:prstGeom prst="rect">
             <a:avLst/>
           </a:prstGeom>
-          <a:solidFill>
-            <a:srgbClr val="9060F0"/>
-          </a:solidFill>
+          <a:gradFill rotWithShape="1">
+            <a:gsLst>
+              <a:gs pos="0">
+                <a:srgbClr val="5A1F8A"/>
+              </a:gs>
+              <a:gs pos="100000">
+                <a:srgbClr val="FF9900"/>
+              </a:gs>
+            </a:gsLst>
+            <a:lin scaled="0" ang="0"/>
+          </a:gradFill>
           <a:ln>
             <a:noFill/>
           </a:ln>
@@ -4781,8 +4805,8 @@
         </p:nvSpPr>
         <p:spPr>
           <a:xfrm>
-            <a:off x="640080" y="365760"/>
-            <a:ext cx="10881360" cy="822960"/>
+            <a:off x="640080" y="320040"/>
+            <a:ext cx="10881360" cy="914400"/>
           </a:xfrm>
           <a:prstGeom prst="rect">
             <a:avLst/>
@@ -4791,7 +4815,7 @@
         </p:spPr>
         <p:txBody>
           <a:bodyPr wrap="square">
-            <a:spAutoFit/>
+            <a:noAutofit/>
           </a:bodyPr>
           <a:lstStyle/>
           <a:p>
@@ -4800,7 +4824,7 @@
                 <a:solidFill>
                   <a:srgbClr val="D7C7EE"/>
                 </a:solidFill>
-                <a:latin typeface="Arial"/>
+                <a:latin typeface="Cinzel"/>
               </a:rPr>
               <a:t>Big Data Bowl x Muse Code, live</a:t>
             </a:r>
@@ -4815,8 +4839,8 @@
         </p:nvSpPr>
         <p:spPr>
           <a:xfrm>
-            <a:off x="640080" y="1554480"/>
-            <a:ext cx="6400800" cy="4206240"/>
+            <a:off x="640080" y="1920240"/>
+            <a:ext cx="5760720" cy="4389120"/>
           </a:xfrm>
           <a:prstGeom prst="rect">
             <a:avLst/>
@@ -4825,19 +4849,19 @@
         </p:spPr>
         <p:txBody>
           <a:bodyPr wrap="square">
-            <a:spAutoFit/>
+            <a:noAutofit/>
           </a:bodyPr>
           <a:lstStyle/>
           <a:p>
             <a:pPr>
               <a:spcAft>
-                <a:spcPts val="1600"/>
+                <a:spcPts val="3400"/>
               </a:spcAft>
             </a:pPr>
             <a:r>
               <a:rPr sz="2400">
                 <a:solidFill>
-                  <a:srgbClr val="FFFFFF"/>
+                  <a:srgbClr val="F0F0F0"/>
                 </a:solidFill>
                 <a:latin typeface="Arial"/>
               </a:rPr>
@@ -4847,13 +4871,13 @@
           <a:p>
             <a:pPr>
               <a:spcAft>
-                <a:spcPts val="1600"/>
+                <a:spcPts val="3400"/>
               </a:spcAft>
             </a:pPr>
             <a:r>
               <a:rPr sz="2400">
                 <a:solidFill>
-                  <a:srgbClr val="FFFFFF"/>
+                  <a:srgbClr val="F0F0F0"/>
                 </a:solidFill>
                 <a:latin typeface="Arial"/>
               </a:rPr>
@@ -4863,13 +4887,13 @@
           <a:p>
             <a:pPr>
               <a:spcAft>
-                <a:spcPts val="1600"/>
+                <a:spcPts val="3400"/>
               </a:spcAft>
             </a:pPr>
             <a:r>
               <a:rPr sz="2400">
                 <a:solidFill>
-                  <a:srgbClr val="FFFFFF"/>
+                  <a:srgbClr val="F0F0F0"/>
                 </a:solidFill>
                 <a:latin typeface="Arial"/>
               </a:rPr>
@@ -4887,15 +4911,15 @@
           <p:nvPr/>
         </p:nvPicPr>
         <p:blipFill>
-          <a:blip r:embed="rId3"/>
+          <a:blip r:embed="rId4"/>
           <a:stretch>
             <a:fillRect/>
           </a:stretch>
         </p:blipFill>
         <p:spPr>
           <a:xfrm>
-            <a:off x="7068312" y="2508885"/>
-            <a:ext cx="4572000" cy="2571750"/>
+            <a:off x="6793992" y="2614613"/>
+            <a:ext cx="4846320" cy="2726054"/>
           </a:xfrm>
           <a:prstGeom prst="rect">
             <a:avLst/>
@@ -4915,9 +4939,17 @@
   <p:cSld>
     <p:bg>
       <p:bgPr>
-        <a:solidFill>
-          <a:srgbClr val="00002A"/>
-        </a:solidFill>
+        <a:gradFill rotWithShape="1">
+          <a:gsLst>
+            <a:gs pos="0">
+              <a:srgbClr val="00002A"/>
+            </a:gs>
+            <a:gs pos="100000">
+              <a:srgbClr val="200050"/>
+            </a:gs>
+          </a:gsLst>
+          <a:lin scaled="0" ang="16200000"/>
+        </a:gradFill>
         <a:effectLst/>
       </p:bgPr>
     </p:bg>
@@ -4942,9 +4974,17 @@
           <a:prstGeom prst="rect">
             <a:avLst/>
           </a:prstGeom>
-          <a:solidFill>
-            <a:srgbClr val="00002A"/>
-          </a:solidFill>
+          <a:gradFill rotWithShape="1">
+            <a:gsLst>
+              <a:gs pos="0">
+                <a:srgbClr val="5A1F8A"/>
+              </a:gs>
+              <a:gs pos="100000">
+                <a:srgbClr val="FF9900"/>
+              </a:gs>
+            </a:gsLst>
+            <a:lin scaled="0" ang="0"/>
+          </a:gradFill>
           <a:ln>
             <a:noFill/>
           </a:ln>
@@ -4985,9 +5025,17 @@
           <a:prstGeom prst="rect">
             <a:avLst/>
           </a:prstGeom>
-          <a:solidFill>
-            <a:srgbClr val="9060F0"/>
-          </a:solidFill>
+          <a:gradFill rotWithShape="1">
+            <a:gsLst>
+              <a:gs pos="0">
+                <a:srgbClr val="5A1F8A"/>
+              </a:gs>
+              <a:gs pos="100000">
+                <a:srgbClr val="FF9900"/>
+              </a:gs>
+            </a:gsLst>
+            <a:lin scaled="0" ang="0"/>
+          </a:gradFill>
           <a:ln>
             <a:noFill/>
           </a:ln>
@@ -5057,8 +5105,8 @@
         </p:nvSpPr>
         <p:spPr>
           <a:xfrm>
-            <a:off x="640080" y="365760"/>
-            <a:ext cx="10881360" cy="822960"/>
+            <a:off x="640080" y="320040"/>
+            <a:ext cx="10881360" cy="914400"/>
           </a:xfrm>
           <a:prstGeom prst="rect">
             <a:avLst/>
@@ -5067,7 +5115,7 @@
         </p:spPr>
         <p:txBody>
           <a:bodyPr wrap="square">
-            <a:spAutoFit/>
+            <a:noAutofit/>
           </a:bodyPr>
           <a:lstStyle/>
           <a:p>
@@ -5076,7 +5124,7 @@
                 <a:solidFill>
                   <a:srgbClr val="D7C7EE"/>
                 </a:solidFill>
-                <a:latin typeface="Arial"/>
+                <a:latin typeface="Cinzel"/>
               </a:rPr>
               <a:t>Skills repeat. Guards protect.</a:t>
             </a:r>
@@ -5091,8 +5139,8 @@
         </p:nvSpPr>
         <p:spPr>
           <a:xfrm>
-            <a:off x="640080" y="1554480"/>
-            <a:ext cx="6400800" cy="4206240"/>
+            <a:off x="640080" y="1920240"/>
+            <a:ext cx="5760720" cy="4389120"/>
           </a:xfrm>
           <a:prstGeom prst="rect">
             <a:avLst/>
@@ -5101,19 +5149,19 @@
         </p:spPr>
         <p:txBody>
           <a:bodyPr wrap="square">
-            <a:spAutoFit/>
+            <a:noAutofit/>
           </a:bodyPr>
           <a:lstStyle/>
           <a:p>
             <a:pPr>
               <a:spcAft>
-                <a:spcPts val="1600"/>
+                <a:spcPts val="3400"/>
               </a:spcAft>
             </a:pPr>
             <a:r>
               <a:rPr sz="2400">
                 <a:solidFill>
-                  <a:srgbClr val="FFFFFF"/>
+                  <a:srgbClr val="F0F0F0"/>
                 </a:solidFill>
                 <a:latin typeface="Arial"/>
               </a:rPr>
@@ -5123,13 +5171,13 @@
           <a:p>
             <a:pPr>
               <a:spcAft>
-                <a:spcPts val="1600"/>
+                <a:spcPts val="3400"/>
               </a:spcAft>
             </a:pPr>
             <a:r>
               <a:rPr sz="2400">
                 <a:solidFill>
-                  <a:srgbClr val="FFFFFF"/>
+                  <a:srgbClr val="F0F0F0"/>
                 </a:solidFill>
                 <a:latin typeface="Arial"/>
               </a:rPr>
@@ -5139,13 +5187,13 @@
           <a:p>
             <a:pPr>
               <a:spcAft>
-                <a:spcPts val="1600"/>
+                <a:spcPts val="3400"/>
               </a:spcAft>
             </a:pPr>
             <a:r>
               <a:rPr sz="2400">
                 <a:solidFill>
-                  <a:srgbClr val="FFFFFF"/>
+                  <a:srgbClr val="F0F0F0"/>
                 </a:solidFill>
                 <a:latin typeface="Arial"/>
               </a:rPr>
@@ -5163,15 +5211,15 @@
           <p:nvPr/>
         </p:nvPicPr>
         <p:blipFill>
-          <a:blip r:embed="rId3"/>
+          <a:blip r:embed="rId5"/>
           <a:stretch>
             <a:fillRect/>
           </a:stretch>
         </p:blipFill>
         <p:spPr>
           <a:xfrm>
-            <a:off x="7068312" y="2493960"/>
-            <a:ext cx="4572000" cy="2601600"/>
+            <a:off x="6793992" y="2598792"/>
+            <a:ext cx="4846320" cy="2757696"/>
           </a:xfrm>
           <a:prstGeom prst="rect">
             <a:avLst/>
@@ -5191,9 +5239,17 @@
   <p:cSld>
     <p:bg>
       <p:bgPr>
-        <a:solidFill>
-          <a:srgbClr val="00002A"/>
-        </a:solidFill>
+        <a:gradFill rotWithShape="1">
+          <a:gsLst>
+            <a:gs pos="0">
+              <a:srgbClr val="00002A"/>
+            </a:gs>
+            <a:gs pos="100000">
+              <a:srgbClr val="200050"/>
+            </a:gs>
+          </a:gsLst>
+          <a:lin scaled="0" ang="16200000"/>
+        </a:gradFill>
         <a:effectLst/>
       </p:bgPr>
     </p:bg>
@@ -5218,9 +5274,17 @@
           <a:prstGeom prst="rect">
             <a:avLst/>
           </a:prstGeom>
-          <a:solidFill>
-            <a:srgbClr val="00002A"/>
-          </a:solidFill>
+          <a:gradFill rotWithShape="1">
+            <a:gsLst>
+              <a:gs pos="0">
+                <a:srgbClr val="5A1F8A"/>
+              </a:gs>
+              <a:gs pos="100000">
+                <a:srgbClr val="FF9900"/>
+              </a:gs>
+            </a:gsLst>
+            <a:lin scaled="0" ang="0"/>
+          </a:gradFill>
           <a:ln>
             <a:noFill/>
           </a:ln>
@@ -5261,9 +5325,17 @@
           <a:prstGeom prst="rect">
             <a:avLst/>
           </a:prstGeom>
-          <a:solidFill>
-            <a:srgbClr val="9060F0"/>
-          </a:solidFill>
+          <a:gradFill rotWithShape="1">
+            <a:gsLst>
+              <a:gs pos="0">
+                <a:srgbClr val="5A1F8A"/>
+              </a:gs>
+              <a:gs pos="100000">
+                <a:srgbClr val="FF9900"/>
+              </a:gs>
+            </a:gsLst>
+            <a:lin scaled="0" ang="0"/>
+          </a:gradFill>
           <a:ln>
             <a:noFill/>
           </a:ln>
@@ -5333,8 +5405,8 @@
         </p:nvSpPr>
         <p:spPr>
           <a:xfrm>
-            <a:off x="640080" y="365760"/>
-            <a:ext cx="10881360" cy="822960"/>
+            <a:off x="640080" y="320040"/>
+            <a:ext cx="10881360" cy="914400"/>
           </a:xfrm>
           <a:prstGeom prst="rect">
             <a:avLst/>
@@ -5343,7 +5415,7 @@
         </p:spPr>
         <p:txBody>
           <a:bodyPr wrap="square">
-            <a:spAutoFit/>
+            <a:noAutofit/>
           </a:bodyPr>
           <a:lstStyle/>
           <a:p>
@@ -5352,7 +5424,7 @@
                 <a:solidFill>
                   <a:srgbClr val="D7C7EE"/>
                 </a:solidFill>
-                <a:latin typeface="Arial"/>
+                <a:latin typeface="Cinzel"/>
               </a:rPr>
               <a:t>30/30/20/20. Cause, don't decorate.</a:t>
             </a:r>
@@ -5367,8 +5439,8 @@
         </p:nvSpPr>
         <p:spPr>
           <a:xfrm>
-            <a:off x="640080" y="1554480"/>
-            <a:ext cx="6400800" cy="4206240"/>
+            <a:off x="640080" y="1920240"/>
+            <a:ext cx="5760720" cy="4389120"/>
           </a:xfrm>
           <a:prstGeom prst="rect">
             <a:avLst/>
@@ -5377,55 +5449,55 @@
         </p:spPr>
         <p:txBody>
           <a:bodyPr wrap="square">
-            <a:spAutoFit/>
+            <a:noAutofit/>
           </a:bodyPr>
           <a:lstStyle/>
           <a:p>
             <a:pPr>
               <a:spcAft>
-                <a:spcPts val="1600"/>
+                <a:spcPts val="3400"/>
               </a:spcAft>
             </a:pPr>
             <a:r>
               <a:rPr sz="2400">
                 <a:solidFill>
-                  <a:srgbClr val="FFFFFF"/>
+                  <a:srgbClr val="F0F0F0"/>
                 </a:solidFill>
                 <a:latin typeface="Arial"/>
               </a:rPr>
-              <a:t>Football 30. Science 30. Prose 20. Visuals 20.</a:t>
+              <a:t>Football 30. Science 30.</a:t>
             </a:r>
           </a:p>
           <a:p>
             <a:pPr>
               <a:spcAft>
-                <a:spcPts val="1600"/>
+                <a:spcPts val="3400"/>
               </a:spcAft>
             </a:pPr>
             <a:r>
               <a:rPr sz="2400">
                 <a:solidFill>
-                  <a:srgbClr val="FFFFFF"/>
+                  <a:srgbClr val="F0F0F0"/>
                 </a:solidFill>
                 <a:latin typeface="Arial"/>
               </a:rPr>
-              <a:t>2,000 words. Under 10 figures.</a:t>
+              <a:t>Prose 20. Visuals 20. 2,000 words.</a:t>
             </a:r>
           </a:p>
           <a:p>
             <a:pPr>
               <a:spcAft>
-                <a:spcPts val="1600"/>
+                <a:spcPts val="3400"/>
               </a:spcAft>
             </a:pPr>
             <a:r>
               <a:rPr sz="2400">
                 <a:solidFill>
-                  <a:srgbClr val="FFFFFF"/>
+                  <a:srgbClr val="F0F0F0"/>
                 </a:solidFill>
                 <a:latin typeface="Arial"/>
               </a:rPr>
-              <a:t>Cause, never decorate.</a:t>
+              <a:t>Under 10 figures. Cause, don't decorate.</a:t>
             </a:r>
           </a:p>
         </p:txBody>
@@ -5439,15 +5511,15 @@
           <p:nvPr/>
         </p:nvPicPr>
         <p:blipFill>
-          <a:blip r:embed="rId3"/>
+          <a:blip r:embed="rId5"/>
           <a:stretch>
             <a:fillRect/>
           </a:stretch>
         </p:blipFill>
         <p:spPr>
           <a:xfrm>
-            <a:off x="7068312" y="2488299"/>
-            <a:ext cx="4572000" cy="2612922"/>
+            <a:off x="6793992" y="2592791"/>
+            <a:ext cx="4846320" cy="2769697"/>
           </a:xfrm>
           <a:prstGeom prst="rect">
             <a:avLst/>
@@ -5467,9 +5539,17 @@
   <p:cSld>
     <p:bg>
       <p:bgPr>
-        <a:solidFill>
-          <a:srgbClr val="00002A"/>
-        </a:solidFill>
+        <a:gradFill rotWithShape="1">
+          <a:gsLst>
+            <a:gs pos="0">
+              <a:srgbClr val="00002A"/>
+            </a:gs>
+            <a:gs pos="100000">
+              <a:srgbClr val="200050"/>
+            </a:gs>
+          </a:gsLst>
+          <a:lin scaled="0" ang="16200000"/>
+        </a:gradFill>
         <a:effectLst/>
       </p:bgPr>
     </p:bg>
@@ -5494,9 +5574,17 @@
           <a:prstGeom prst="rect">
             <a:avLst/>
           </a:prstGeom>
-          <a:solidFill>
-            <a:srgbClr val="00002A"/>
-          </a:solidFill>
+          <a:gradFill rotWithShape="1">
+            <a:gsLst>
+              <a:gs pos="0">
+                <a:srgbClr val="5A1F8A"/>
+              </a:gs>
+              <a:gs pos="100000">
+                <a:srgbClr val="FF9900"/>
+              </a:gs>
+            </a:gsLst>
+            <a:lin scaled="0" ang="0"/>
+          </a:gradFill>
           <a:ln>
             <a:noFill/>
           </a:ln>
@@ -5537,9 +5625,17 @@
           <a:prstGeom prst="rect">
             <a:avLst/>
           </a:prstGeom>
-          <a:solidFill>
-            <a:srgbClr val="9060F0"/>
-          </a:solidFill>
+          <a:gradFill rotWithShape="1">
+            <a:gsLst>
+              <a:gs pos="0">
+                <a:srgbClr val="5A1F8A"/>
+              </a:gs>
+              <a:gs pos="100000">
+                <a:srgbClr val="FF9900"/>
+              </a:gs>
+            </a:gsLst>
+            <a:lin scaled="0" ang="0"/>
+          </a:gradFill>
           <a:ln>
             <a:noFill/>
           </a:ln>
@@ -5609,8 +5705,8 @@
         </p:nvSpPr>
         <p:spPr>
           <a:xfrm>
-            <a:off x="640080" y="365760"/>
-            <a:ext cx="10881360" cy="822960"/>
+            <a:off x="640080" y="320040"/>
+            <a:ext cx="10881360" cy="914400"/>
           </a:xfrm>
           <a:prstGeom prst="rect">
             <a:avLst/>
@@ -5619,7 +5715,7 @@
         </p:spPr>
         <p:txBody>
           <a:bodyPr wrap="square">
-            <a:spAutoFit/>
+            <a:noAutofit/>
           </a:bodyPr>
           <a:lstStyle/>
           <a:p>
@@ -5628,7 +5724,7 @@
                 <a:solidFill>
                   <a:srgbClr val="D7C7EE"/>
                 </a:solidFill>
-                <a:latin typeface="Arial"/>
+                <a:latin typeface="Cinzel"/>
               </a:rPr>
               <a:t>2027: defense is due</a:t>
             </a:r>
@@ -5643,8 +5739,8 @@
         </p:nvSpPr>
         <p:spPr>
           <a:xfrm>
-            <a:off x="640080" y="1554480"/>
-            <a:ext cx="6400800" cy="4206240"/>
+            <a:off x="640080" y="1920240"/>
+            <a:ext cx="5760720" cy="4389120"/>
           </a:xfrm>
           <a:prstGeom prst="rect">
             <a:avLst/>
@@ -5653,19 +5749,19 @@
         </p:spPr>
         <p:txBody>
           <a:bodyPr wrap="square">
-            <a:spAutoFit/>
+            <a:noAutofit/>
           </a:bodyPr>
           <a:lstStyle/>
           <a:p>
             <a:pPr>
               <a:spcAft>
-                <a:spcPts val="1600"/>
+                <a:spcPts val="3400"/>
               </a:spcAft>
             </a:pPr>
             <a:r>
               <a:rPr sz="2400">
                 <a:solidFill>
-                  <a:srgbClr val="FFFFFF"/>
+                  <a:srgbClr val="F0F0F0"/>
                 </a:solidFill>
                 <a:latin typeface="Arial"/>
               </a:rPr>
@@ -5675,13 +5771,13 @@
           <a:p>
             <a:pPr>
               <a:spcAft>
-                <a:spcPts val="1600"/>
+                <a:spcPts val="3400"/>
               </a:spcAft>
             </a:pPr>
             <a:r>
               <a:rPr sz="2400">
                 <a:solidFill>
-                  <a:srgbClr val="FFFFFF"/>
+                  <a:srgbClr val="F0F0F0"/>
                 </a:solidFill>
                 <a:latin typeface="Arial"/>
               </a:rPr>
@@ -5691,13 +5787,13 @@
           <a:p>
             <a:pPr>
               <a:spcAft>
-                <a:spcPts val="1600"/>
+                <a:spcPts val="3400"/>
               </a:spcAft>
             </a:pPr>
             <a:r>
               <a:rPr sz="2400">
                 <a:solidFill>
-                  <a:srgbClr val="FFFFFF"/>
+                  <a:srgbClr val="F0F0F0"/>
                 </a:solidFill>
                 <a:latin typeface="Arial"/>
               </a:rPr>
@@ -5715,15 +5811,15 @@
           <p:nvPr/>
         </p:nvPicPr>
         <p:blipFill>
-          <a:blip r:embed="rId3"/>
+          <a:blip r:embed="rId4"/>
           <a:stretch>
             <a:fillRect/>
           </a:stretch>
         </p:blipFill>
         <p:spPr>
           <a:xfrm>
-            <a:off x="7068312" y="2501428"/>
-            <a:ext cx="4572000" cy="2586663"/>
+            <a:off x="6793992" y="2606708"/>
+            <a:ext cx="4846320" cy="2741863"/>
           </a:xfrm>
           <a:prstGeom prst="rect">
             <a:avLst/>
@@ -5743,9 +5839,17 @@
   <p:cSld>
     <p:bg>
       <p:bgPr>
-        <a:solidFill>
-          <a:srgbClr val="00002A"/>
-        </a:solidFill>
+        <a:gradFill rotWithShape="1">
+          <a:gsLst>
+            <a:gs pos="0">
+              <a:srgbClr val="00002A"/>
+            </a:gs>
+            <a:gs pos="100000">
+              <a:srgbClr val="200050"/>
+            </a:gs>
+          </a:gsLst>
+          <a:lin scaled="0" ang="16200000"/>
+        </a:gradFill>
         <a:effectLst/>
       </p:bgPr>
     </p:bg>
@@ -5770,9 +5874,17 @@
           <a:prstGeom prst="rect">
             <a:avLst/>
           </a:prstGeom>
-          <a:solidFill>
-            <a:srgbClr val="00002A"/>
-          </a:solidFill>
+          <a:gradFill rotWithShape="1">
+            <a:gsLst>
+              <a:gs pos="0">
+                <a:srgbClr val="5A1F8A"/>
+              </a:gs>
+              <a:gs pos="100000">
+                <a:srgbClr val="FF9900"/>
+              </a:gs>
+            </a:gsLst>
+            <a:lin scaled="0" ang="0"/>
+          </a:gradFill>
           <a:ln>
             <a:noFill/>
           </a:ln>
@@ -5813,9 +5925,17 @@
           <a:prstGeom prst="rect">
             <a:avLst/>
           </a:prstGeom>
-          <a:solidFill>
-            <a:srgbClr val="9060F0"/>
-          </a:solidFill>
+          <a:gradFill rotWithShape="1">
+            <a:gsLst>
+              <a:gs pos="0">
+                <a:srgbClr val="5A1F8A"/>
+              </a:gs>
+              <a:gs pos="100000">
+                <a:srgbClr val="FF9900"/>
+              </a:gs>
+            </a:gsLst>
+            <a:lin scaled="0" ang="0"/>
+          </a:gradFill>
           <a:ln>
             <a:noFill/>
           </a:ln>
@@ -5885,8 +6005,8 @@
         </p:nvSpPr>
         <p:spPr>
           <a:xfrm>
-            <a:off x="640080" y="365760"/>
-            <a:ext cx="10881360" cy="822960"/>
+            <a:off x="640080" y="320040"/>
+            <a:ext cx="10881360" cy="914400"/>
           </a:xfrm>
           <a:prstGeom prst="rect">
             <a:avLst/>
@@ -5895,7 +6015,7 @@
         </p:spPr>
         <p:txBody>
           <a:bodyPr wrap="square">
-            <a:spAutoFit/>
+            <a:noAutofit/>
           </a:bodyPr>
           <a:lstStyle/>
           <a:p>
@@ -5904,7 +6024,7 @@
                 <a:solidFill>
                   <a:srgbClr val="D7C7EE"/>
                 </a:solidFill>
-                <a:latin typeface="Arial"/>
+                <a:latin typeface="Cinzel"/>
               </a:rPr>
               <a:t>Glimmer: 30B, one box, live</a:t>
             </a:r>
@@ -5919,8 +6039,8 @@
         </p:nvSpPr>
         <p:spPr>
           <a:xfrm>
-            <a:off x="640080" y="1554480"/>
-            <a:ext cx="6400800" cy="4206240"/>
+            <a:off x="640080" y="1920240"/>
+            <a:ext cx="5760720" cy="4389120"/>
           </a:xfrm>
           <a:prstGeom prst="rect">
             <a:avLst/>
@@ -5929,19 +6049,19 @@
         </p:spPr>
         <p:txBody>
           <a:bodyPr wrap="square">
-            <a:spAutoFit/>
+            <a:noAutofit/>
           </a:bodyPr>
           <a:lstStyle/>
           <a:p>
             <a:pPr>
               <a:spcAft>
-                <a:spcPts val="1600"/>
+                <a:spcPts val="3400"/>
               </a:spcAft>
             </a:pPr>
             <a:r>
               <a:rPr sz="2400">
                 <a:solidFill>
-                  <a:srgbClr val="FFFFFF"/>
+                  <a:srgbClr val="F0F0F0"/>
                 </a:solidFill>
                 <a:latin typeface="Arial"/>
               </a:rPr>
@@ -5951,13 +6071,13 @@
           <a:p>
             <a:pPr>
               <a:spcAft>
-                <a:spcPts val="1600"/>
+                <a:spcPts val="3400"/>
               </a:spcAft>
             </a:pPr>
             <a:r>
               <a:rPr sz="2400">
                 <a:solidFill>
-                  <a:srgbClr val="FFFFFF"/>
+                  <a:srgbClr val="F0F0F0"/>
                 </a:solidFill>
                 <a:latin typeface="Arial"/>
               </a:rPr>
@@ -5967,13 +6087,13 @@
           <a:p>
             <a:pPr>
               <a:spcAft>
-                <a:spcPts val="1600"/>
+                <a:spcPts val="3400"/>
               </a:spcAft>
             </a:pPr>
             <a:r>
               <a:rPr sz="2400">
                 <a:solidFill>
-                  <a:srgbClr val="FFFFFF"/>
+                  <a:srgbClr val="F0F0F0"/>
                 </a:solidFill>
                 <a:latin typeface="Arial"/>
               </a:rPr>
@@ -5991,15 +6111,15 @@
           <p:nvPr/>
         </p:nvPicPr>
         <p:blipFill>
-          <a:blip r:embed="rId3"/>
+          <a:blip r:embed="rId4"/>
           <a:stretch>
             <a:fillRect/>
           </a:stretch>
         </p:blipFill>
         <p:spPr>
           <a:xfrm>
-            <a:off x="7068312" y="2498155"/>
-            <a:ext cx="4572000" cy="2593209"/>
+            <a:off x="6793992" y="2603239"/>
+            <a:ext cx="4846320" cy="2748802"/>
           </a:xfrm>
           <a:prstGeom prst="rect">
             <a:avLst/>
@@ -6019,9 +6139,17 @@
   <p:cSld>
     <p:bg>
       <p:bgPr>
-        <a:solidFill>
-          <a:srgbClr val="00002A"/>
-        </a:solidFill>
+        <a:gradFill rotWithShape="1">
+          <a:gsLst>
+            <a:gs pos="0">
+              <a:srgbClr val="00002A"/>
+            </a:gs>
+            <a:gs pos="100000">
+              <a:srgbClr val="200050"/>
+            </a:gs>
+          </a:gsLst>
+          <a:lin scaled="0" ang="16200000"/>
+        </a:gradFill>
         <a:effectLst/>
       </p:bgPr>
     </p:bg>
@@ -6046,9 +6174,17 @@
           <a:prstGeom prst="rect">
             <a:avLst/>
           </a:prstGeom>
-          <a:solidFill>
-            <a:srgbClr val="00002A"/>
-          </a:solidFill>
+          <a:gradFill rotWithShape="1">
+            <a:gsLst>
+              <a:gs pos="0">
+                <a:srgbClr val="5A1F8A"/>
+              </a:gs>
+              <a:gs pos="100000">
+                <a:srgbClr val="FF9900"/>
+              </a:gs>
+            </a:gsLst>
+            <a:lin scaled="0" ang="0"/>
+          </a:gradFill>
           <a:ln>
             <a:noFill/>
           </a:ln>
@@ -6089,9 +6225,17 @@
           <a:prstGeom prst="rect">
             <a:avLst/>
           </a:prstGeom>
-          <a:solidFill>
-            <a:srgbClr val="9060F0"/>
-          </a:solidFill>
+          <a:gradFill rotWithShape="1">
+            <a:gsLst>
+              <a:gs pos="0">
+                <a:srgbClr val="5A1F8A"/>
+              </a:gs>
+              <a:gs pos="100000">
+                <a:srgbClr val="FF9900"/>
+              </a:gs>
+            </a:gsLst>
+            <a:lin scaled="0" ang="0"/>
+          </a:gradFill>
           <a:ln>
             <a:noFill/>
           </a:ln>
@@ -6161,8 +6305,8 @@
         </p:nvSpPr>
         <p:spPr>
           <a:xfrm>
-            <a:off x="640080" y="365760"/>
-            <a:ext cx="10881360" cy="822960"/>
+            <a:off x="640080" y="320040"/>
+            <a:ext cx="10881360" cy="914400"/>
           </a:xfrm>
           <a:prstGeom prst="rect">
             <a:avLst/>
@@ -6171,7 +6315,7 @@
         </p:spPr>
         <p:txBody>
           <a:bodyPr wrap="square">
-            <a:spAutoFit/>
+            <a:noAutofit/>
           </a:bodyPr>
           <a:lstStyle/>
           <a:p>
@@ -6180,7 +6324,7 @@
                 <a:solidFill>
                   <a:srgbClr val="D7C7EE"/>
                 </a:solidFill>
-                <a:latin typeface="Arial"/>
+                <a:latin typeface="Cinzel"/>
               </a:rPr>
               <a:t>13 GPU layers buy nothing</a:t>
             </a:r>
@@ -6195,8 +6339,8 @@
         </p:nvSpPr>
         <p:spPr>
           <a:xfrm>
-            <a:off x="640080" y="1554480"/>
-            <a:ext cx="6400800" cy="4206240"/>
+            <a:off x="640080" y="1920240"/>
+            <a:ext cx="5760720" cy="4389120"/>
           </a:xfrm>
           <a:prstGeom prst="rect">
             <a:avLst/>
@@ -6205,19 +6349,19 @@
         </p:spPr>
         <p:txBody>
           <a:bodyPr wrap="square">
-            <a:spAutoFit/>
+            <a:noAutofit/>
           </a:bodyPr>
           <a:lstStyle/>
           <a:p>
             <a:pPr>
               <a:spcAft>
-                <a:spcPts val="1600"/>
+                <a:spcPts val="3400"/>
               </a:spcAft>
             </a:pPr>
             <a:r>
               <a:rPr sz="2400">
                 <a:solidFill>
-                  <a:srgbClr val="FFFFFF"/>
+                  <a:srgbClr val="F0F0F0"/>
                 </a:solidFill>
                 <a:latin typeface="Arial"/>
               </a:rPr>
@@ -6227,13 +6371,13 @@
           <a:p>
             <a:pPr>
               <a:spcAft>
-                <a:spcPts val="1600"/>
+                <a:spcPts val="3400"/>
               </a:spcAft>
             </a:pPr>
             <a:r>
               <a:rPr sz="2400">
                 <a:solidFill>
-                  <a:srgbClr val="FFFFFF"/>
+                  <a:srgbClr val="F0F0F0"/>
                 </a:solidFill>
                 <a:latin typeface="Arial"/>
               </a:rPr>
@@ -6243,13 +6387,13 @@
           <a:p>
             <a:pPr>
               <a:spcAft>
-                <a:spcPts val="1600"/>
+                <a:spcPts val="3400"/>
               </a:spcAft>
             </a:pPr>
             <a:r>
               <a:rPr sz="2400">
                 <a:solidFill>
-                  <a:srgbClr val="FFFFFF"/>
+                  <a:srgbClr val="F0F0F0"/>
                 </a:solidFill>
                 <a:latin typeface="Arial"/>
               </a:rPr>
@@ -6267,15 +6411,15 @@
           <p:nvPr/>
         </p:nvPicPr>
         <p:blipFill>
-          <a:blip r:embed="rId3"/>
+          <a:blip r:embed="rId4"/>
           <a:stretch>
             <a:fillRect/>
           </a:stretch>
         </p:blipFill>
         <p:spPr>
           <a:xfrm>
-            <a:off x="7068312" y="2834009"/>
-            <a:ext cx="4572000" cy="1921502"/>
+            <a:off x="6793992" y="2959244"/>
+            <a:ext cx="4846320" cy="2036792"/>
           </a:xfrm>
           <a:prstGeom prst="rect">
             <a:avLst/>
@@ -6295,9 +6439,17 @@
   <p:cSld>
     <p:bg>
       <p:bgPr>
-        <a:solidFill>
-          <a:srgbClr val="00002A"/>
-        </a:solidFill>
+        <a:gradFill rotWithShape="1">
+          <a:gsLst>
+            <a:gs pos="0">
+              <a:srgbClr val="00002A"/>
+            </a:gs>
+            <a:gs pos="100000">
+              <a:srgbClr val="200050"/>
+            </a:gs>
+          </a:gsLst>
+          <a:lin scaled="0" ang="16200000"/>
+        </a:gradFill>
         <a:effectLst/>
       </p:bgPr>
     </p:bg>
@@ -6322,9 +6474,17 @@
           <a:prstGeom prst="rect">
             <a:avLst/>
           </a:prstGeom>
-          <a:solidFill>
-            <a:srgbClr val="00002A"/>
-          </a:solidFill>
+          <a:gradFill rotWithShape="1">
+            <a:gsLst>
+              <a:gs pos="0">
+                <a:srgbClr val="5A1F8A"/>
+              </a:gs>
+              <a:gs pos="100000">
+                <a:srgbClr val="FF9900"/>
+              </a:gs>
+            </a:gsLst>
+            <a:lin scaled="0" ang="0"/>
+          </a:gradFill>
           <a:ln>
             <a:noFill/>
           </a:ln>
@@ -6365,9 +6525,17 @@
           <a:prstGeom prst="rect">
             <a:avLst/>
           </a:prstGeom>
-          <a:solidFill>
-            <a:srgbClr val="9060F0"/>
-          </a:solidFill>
+          <a:gradFill rotWithShape="1">
+            <a:gsLst>
+              <a:gs pos="0">
+                <a:srgbClr val="5A1F8A"/>
+              </a:gs>
+              <a:gs pos="100000">
+                <a:srgbClr val="FF9900"/>
+              </a:gs>
+            </a:gsLst>
+            <a:lin scaled="0" ang="0"/>
+          </a:gradFill>
           <a:ln>
             <a:noFill/>
           </a:ln>
@@ -6437,8 +6605,8 @@
         </p:nvSpPr>
         <p:spPr>
           <a:xfrm>
-            <a:off x="640080" y="365760"/>
-            <a:ext cx="10881360" cy="822960"/>
+            <a:off x="640080" y="320040"/>
+            <a:ext cx="10881360" cy="914400"/>
           </a:xfrm>
           <a:prstGeom prst="rect">
             <a:avLst/>
@@ -6447,7 +6615,7 @@
         </p:spPr>
         <p:txBody>
           <a:bodyPr wrap="square">
-            <a:spAutoFit/>
+            <a:noAutofit/>
           </a:bodyPr>
           <a:lstStyle/>
           <a:p>
@@ -6456,7 +6624,7 @@
                 <a:solidFill>
                   <a:srgbClr val="D7C7EE"/>
                 </a:solidFill>
-                <a:latin typeface="Arial"/>
+                <a:latin typeface="Cinzel"/>
               </a:rPr>
               <a:t>Memory, modes, one skill each</a:t>
             </a:r>
@@ -6471,8 +6639,8 @@
         </p:nvSpPr>
         <p:spPr>
           <a:xfrm>
-            <a:off x="640080" y="1554480"/>
-            <a:ext cx="6400800" cy="4206240"/>
+            <a:off x="640080" y="1920240"/>
+            <a:ext cx="5760720" cy="4389120"/>
           </a:xfrm>
           <a:prstGeom prst="rect">
             <a:avLst/>
@@ -6481,19 +6649,19 @@
         </p:spPr>
         <p:txBody>
           <a:bodyPr wrap="square">
-            <a:spAutoFit/>
+            <a:noAutofit/>
           </a:bodyPr>
           <a:lstStyle/>
           <a:p>
             <a:pPr>
               <a:spcAft>
-                <a:spcPts val="1600"/>
+                <a:spcPts val="3400"/>
               </a:spcAft>
             </a:pPr>
             <a:r>
               <a:rPr sz="2400">
                 <a:solidFill>
-                  <a:srgbClr val="FFFFFF"/>
+                  <a:srgbClr val="F0F0F0"/>
                 </a:solidFill>
                 <a:latin typeface="Arial"/>
               </a:rPr>
@@ -6503,13 +6671,13 @@
           <a:p>
             <a:pPr>
               <a:spcAft>
-                <a:spcPts val="1600"/>
+                <a:spcPts val="3400"/>
               </a:spcAft>
             </a:pPr>
             <a:r>
               <a:rPr sz="2400">
                 <a:solidFill>
-                  <a:srgbClr val="FFFFFF"/>
+                  <a:srgbClr val="F0F0F0"/>
                 </a:solidFill>
                 <a:latin typeface="Arial"/>
               </a:rPr>
@@ -6519,13 +6687,13 @@
           <a:p>
             <a:pPr>
               <a:spcAft>
-                <a:spcPts val="1600"/>
+                <a:spcPts val="3400"/>
               </a:spcAft>
             </a:pPr>
             <a:r>
               <a:rPr sz="2400">
                 <a:solidFill>
-                  <a:srgbClr val="FFFFFF"/>
+                  <a:srgbClr val="F0F0F0"/>
                 </a:solidFill>
                 <a:latin typeface="Arial"/>
               </a:rPr>
@@ -6543,15 +6711,15 @@
           <p:nvPr/>
         </p:nvPicPr>
         <p:blipFill>
-          <a:blip r:embed="rId3"/>
+          <a:blip r:embed="rId4"/>
           <a:stretch>
             <a:fillRect/>
           </a:stretch>
         </p:blipFill>
         <p:spPr>
           <a:xfrm>
-            <a:off x="7068312" y="2493960"/>
-            <a:ext cx="4572000" cy="2601600"/>
+            <a:off x="7022592" y="2598792"/>
+            <a:ext cx="4617720" cy="2757696"/>
           </a:xfrm>
           <a:prstGeom prst="rect">
             <a:avLst/>
@@ -6571,9 +6739,17 @@
   <p:cSld>
     <p:bg>
       <p:bgPr>
-        <a:solidFill>
-          <a:srgbClr val="00002A"/>
-        </a:solidFill>
+        <a:gradFill rotWithShape="1">
+          <a:gsLst>
+            <a:gs pos="0">
+              <a:srgbClr val="00002A"/>
+            </a:gs>
+            <a:gs pos="100000">
+              <a:srgbClr val="200050"/>
+            </a:gs>
+          </a:gsLst>
+          <a:lin scaled="0" ang="16200000"/>
+        </a:gradFill>
         <a:effectLst/>
       </p:bgPr>
     </p:bg>
@@ -6598,9 +6774,17 @@
           <a:prstGeom prst="rect">
             <a:avLst/>
           </a:prstGeom>
-          <a:solidFill>
-            <a:srgbClr val="00002A"/>
-          </a:solidFill>
+          <a:gradFill rotWithShape="1">
+            <a:gsLst>
+              <a:gs pos="0">
+                <a:srgbClr val="5A1F8A"/>
+              </a:gs>
+              <a:gs pos="100000">
+                <a:srgbClr val="FF9900"/>
+              </a:gs>
+            </a:gsLst>
+            <a:lin scaled="0" ang="0"/>
+          </a:gradFill>
           <a:ln>
             <a:noFill/>
           </a:ln>
@@ -6641,9 +6825,17 @@
           <a:prstGeom prst="rect">
             <a:avLst/>
           </a:prstGeom>
-          <a:solidFill>
-            <a:srgbClr val="9060F0"/>
-          </a:solidFill>
+          <a:gradFill rotWithShape="1">
+            <a:gsLst>
+              <a:gs pos="0">
+                <a:srgbClr val="5A1F8A"/>
+              </a:gs>
+              <a:gs pos="100000">
+                <a:srgbClr val="FF9900"/>
+              </a:gs>
+            </a:gsLst>
+            <a:lin scaled="0" ang="0"/>
+          </a:gradFill>
           <a:ln>
             <a:noFill/>
           </a:ln>
@@ -6713,8 +6905,8 @@
         </p:nvSpPr>
         <p:spPr>
           <a:xfrm>
-            <a:off x="640080" y="365760"/>
-            <a:ext cx="10881360" cy="822960"/>
+            <a:off x="640080" y="320040"/>
+            <a:ext cx="10881360" cy="914400"/>
           </a:xfrm>
           <a:prstGeom prst="rect">
             <a:avLst/>
@@ -6723,7 +6915,7 @@
         </p:spPr>
         <p:txBody>
           <a:bodyPr wrap="square">
-            <a:spAutoFit/>
+            <a:noAutofit/>
           </a:bodyPr>
           <a:lstStyle/>
           <a:p>
@@ -6732,7 +6924,7 @@
                 <a:solidFill>
                   <a:srgbClr val="D7C7EE"/>
                 </a:solidFill>
-                <a:latin typeface="Arial"/>
+                <a:latin typeface="Cinzel"/>
               </a:rPr>
               <a:t>Read-only. Rewind. Cap spend.</a:t>
             </a:r>
@@ -6747,8 +6939,8 @@
         </p:nvSpPr>
         <p:spPr>
           <a:xfrm>
-            <a:off x="640080" y="1554480"/>
-            <a:ext cx="6400800" cy="4206240"/>
+            <a:off x="640080" y="1920240"/>
+            <a:ext cx="5760720" cy="4389120"/>
           </a:xfrm>
           <a:prstGeom prst="rect">
             <a:avLst/>
@@ -6757,19 +6949,19 @@
         </p:spPr>
         <p:txBody>
           <a:bodyPr wrap="square">
-            <a:spAutoFit/>
+            <a:noAutofit/>
           </a:bodyPr>
           <a:lstStyle/>
           <a:p>
             <a:pPr>
               <a:spcAft>
-                <a:spcPts val="1600"/>
+                <a:spcPts val="3400"/>
               </a:spcAft>
             </a:pPr>
             <a:r>
               <a:rPr sz="2400">
                 <a:solidFill>
-                  <a:srgbClr val="FFFFFF"/>
+                  <a:srgbClr val="F0F0F0"/>
                 </a:solidFill>
                 <a:latin typeface="Arial"/>
               </a:rPr>
@@ -6779,13 +6971,13 @@
           <a:p>
             <a:pPr>
               <a:spcAft>
-                <a:spcPts val="1600"/>
+                <a:spcPts val="3400"/>
               </a:spcAft>
             </a:pPr>
             <a:r>
               <a:rPr sz="2400">
                 <a:solidFill>
-                  <a:srgbClr val="FFFFFF"/>
+                  <a:srgbClr val="F0F0F0"/>
                 </a:solidFill>
                 <a:latin typeface="Arial"/>
               </a:rPr>
@@ -6795,13 +6987,13 @@
           <a:p>
             <a:pPr>
               <a:spcAft>
-                <a:spcPts val="1600"/>
+                <a:spcPts val="3400"/>
               </a:spcAft>
             </a:pPr>
             <a:r>
               <a:rPr sz="2400">
                 <a:solidFill>
-                  <a:srgbClr val="FFFFFF"/>
+                  <a:srgbClr val="F0F0F0"/>
                 </a:solidFill>
                 <a:latin typeface="Arial"/>
               </a:rPr>
@@ -6819,15 +7011,15 @@
           <p:nvPr/>
         </p:nvPicPr>
         <p:blipFill>
-          <a:blip r:embed="rId3"/>
+          <a:blip r:embed="rId5"/>
           <a:stretch>
             <a:fillRect/>
           </a:stretch>
         </p:blipFill>
         <p:spPr>
           <a:xfrm>
-            <a:off x="7068312" y="2493960"/>
-            <a:ext cx="4572000" cy="2601600"/>
+            <a:off x="6793992" y="2598792"/>
+            <a:ext cx="4846320" cy="2757696"/>
           </a:xfrm>
           <a:prstGeom prst="rect">
             <a:avLst/>
@@ -6847,9 +7039,17 @@
   <p:cSld>
     <p:bg>
       <p:bgPr>
-        <a:solidFill>
-          <a:srgbClr val="00002A"/>
-        </a:solidFill>
+        <a:gradFill rotWithShape="1">
+          <a:gsLst>
+            <a:gs pos="0">
+              <a:srgbClr val="00002A"/>
+            </a:gs>
+            <a:gs pos="100000">
+              <a:srgbClr val="200050"/>
+            </a:gs>
+          </a:gsLst>
+          <a:lin scaled="0" ang="16200000"/>
+        </a:gradFill>
         <a:effectLst/>
       </p:bgPr>
     </p:bg>
@@ -6874,9 +7074,17 @@
           <a:prstGeom prst="rect">
             <a:avLst/>
           </a:prstGeom>
-          <a:solidFill>
-            <a:srgbClr val="00002A"/>
-          </a:solidFill>
+          <a:gradFill rotWithShape="1">
+            <a:gsLst>
+              <a:gs pos="0">
+                <a:srgbClr val="5A1F8A"/>
+              </a:gs>
+              <a:gs pos="100000">
+                <a:srgbClr val="FF9900"/>
+              </a:gs>
+            </a:gsLst>
+            <a:lin scaled="0" ang="0"/>
+          </a:gradFill>
           <a:ln>
             <a:noFill/>
           </a:ln>
@@ -6917,9 +7125,17 @@
           <a:prstGeom prst="rect">
             <a:avLst/>
           </a:prstGeom>
-          <a:solidFill>
-            <a:srgbClr val="9060F0"/>
-          </a:solidFill>
+          <a:gradFill rotWithShape="1">
+            <a:gsLst>
+              <a:gs pos="0">
+                <a:srgbClr val="5A1F8A"/>
+              </a:gs>
+              <a:gs pos="100000">
+                <a:srgbClr val="FF9900"/>
+              </a:gs>
+            </a:gsLst>
+            <a:lin scaled="0" ang="0"/>
+          </a:gradFill>
           <a:ln>
             <a:noFill/>
           </a:ln>
@@ -6989,8 +7205,8 @@
         </p:nvSpPr>
         <p:spPr>
           <a:xfrm>
-            <a:off x="640080" y="365760"/>
-            <a:ext cx="10881360" cy="822960"/>
+            <a:off x="640080" y="320040"/>
+            <a:ext cx="10881360" cy="914400"/>
           </a:xfrm>
           <a:prstGeom prst="rect">
             <a:avLst/>
@@ -6999,7 +7215,7 @@
         </p:spPr>
         <p:txBody>
           <a:bodyPr wrap="square">
-            <a:spAutoFit/>
+            <a:noAutofit/>
           </a:bodyPr>
           <a:lstStyle/>
           <a:p>
@@ -7008,7 +7224,7 @@
                 <a:solidFill>
                   <a:srgbClr val="D7C7EE"/>
                 </a:solidFill>
-                <a:latin typeface="Arial"/>
+                <a:latin typeface="Cinzel"/>
               </a:rPr>
               <a:t>Vehicle + instrument. Go tonight.</a:t>
             </a:r>
@@ -7023,8 +7239,8 @@
         </p:nvSpPr>
         <p:spPr>
           <a:xfrm>
-            <a:off x="640080" y="1554480"/>
-            <a:ext cx="6400800" cy="4206240"/>
+            <a:off x="640080" y="1920240"/>
+            <a:ext cx="5760720" cy="4389120"/>
           </a:xfrm>
           <a:prstGeom prst="rect">
             <a:avLst/>
@@ -7033,19 +7249,19 @@
         </p:spPr>
         <p:txBody>
           <a:bodyPr wrap="square">
-            <a:spAutoFit/>
+            <a:noAutofit/>
           </a:bodyPr>
           <a:lstStyle/>
           <a:p>
             <a:pPr>
               <a:spcAft>
-                <a:spcPts val="1600"/>
+                <a:spcPts val="3400"/>
               </a:spcAft>
             </a:pPr>
             <a:r>
               <a:rPr sz="2400">
                 <a:solidFill>
-                  <a:srgbClr val="FFFFFF"/>
+                  <a:srgbClr val="F0F0F0"/>
                 </a:solidFill>
                 <a:latin typeface="Arial"/>
               </a:rPr>
@@ -7055,13 +7271,13 @@
           <a:p>
             <a:pPr>
               <a:spcAft>
-                <a:spcPts val="1600"/>
+                <a:spcPts val="3400"/>
               </a:spcAft>
             </a:pPr>
             <a:r>
               <a:rPr sz="2400">
                 <a:solidFill>
-                  <a:srgbClr val="FFFFFF"/>
+                  <a:srgbClr val="F0F0F0"/>
                 </a:solidFill>
                 <a:latin typeface="Arial"/>
               </a:rPr>
@@ -7071,13 +7287,13 @@
           <a:p>
             <a:pPr>
               <a:spcAft>
-                <a:spcPts val="1600"/>
+                <a:spcPts val="3400"/>
               </a:spcAft>
             </a:pPr>
             <a:r>
               <a:rPr sz="2400">
                 <a:solidFill>
-                  <a:srgbClr val="FFFFFF"/>
+                  <a:srgbClr val="F0F0F0"/>
                 </a:solidFill>
                 <a:latin typeface="Arial"/>
               </a:rPr>
@@ -7095,15 +7311,15 @@
           <p:nvPr/>
         </p:nvPicPr>
         <p:blipFill>
-          <a:blip r:embed="rId3"/>
+          <a:blip r:embed="rId4"/>
           <a:stretch>
             <a:fillRect/>
           </a:stretch>
         </p:blipFill>
         <p:spPr>
           <a:xfrm>
-            <a:off x="7068312" y="2493960"/>
-            <a:ext cx="4572000" cy="2601600"/>
+            <a:off x="6793992" y="2598792"/>
+            <a:ext cx="4846320" cy="2757696"/>
           </a:xfrm>
           <a:prstGeom prst="rect">
             <a:avLst/>
@@ -7123,9 +7339,17 @@
   <p:cSld>
     <p:bg>
       <p:bgPr>
-        <a:solidFill>
-          <a:srgbClr val="00002A"/>
-        </a:solidFill>
+        <a:gradFill rotWithShape="1">
+          <a:gsLst>
+            <a:gs pos="0">
+              <a:srgbClr val="00002A"/>
+            </a:gs>
+            <a:gs pos="100000">
+              <a:srgbClr val="200050"/>
+            </a:gs>
+          </a:gsLst>
+          <a:lin scaled="0" ang="16200000"/>
+        </a:gradFill>
         <a:effectLst/>
       </p:bgPr>
     </p:bg>
@@ -7150,9 +7374,17 @@
           <a:prstGeom prst="rect">
             <a:avLst/>
           </a:prstGeom>
-          <a:solidFill>
-            <a:srgbClr val="00002A"/>
-          </a:solidFill>
+          <a:gradFill rotWithShape="1">
+            <a:gsLst>
+              <a:gs pos="0">
+                <a:srgbClr val="5A1F8A"/>
+              </a:gs>
+              <a:gs pos="100000">
+                <a:srgbClr val="FF9900"/>
+              </a:gs>
+            </a:gsLst>
+            <a:lin scaled="0" ang="0"/>
+          </a:gradFill>
           <a:ln>
             <a:noFill/>
           </a:ln>
@@ -7193,9 +7425,17 @@
           <a:prstGeom prst="rect">
             <a:avLst/>
           </a:prstGeom>
-          <a:solidFill>
-            <a:srgbClr val="9060F0"/>
-          </a:solidFill>
+          <a:gradFill rotWithShape="1">
+            <a:gsLst>
+              <a:gs pos="0">
+                <a:srgbClr val="5A1F8A"/>
+              </a:gs>
+              <a:gs pos="100000">
+                <a:srgbClr val="FF9900"/>
+              </a:gs>
+            </a:gsLst>
+            <a:lin scaled="0" ang="0"/>
+          </a:gradFill>
           <a:ln>
             <a:noFill/>
           </a:ln>
@@ -7265,8 +7505,8 @@
         </p:nvSpPr>
         <p:spPr>
           <a:xfrm>
-            <a:off x="640080" y="365760"/>
-            <a:ext cx="10881360" cy="822960"/>
+            <a:off x="640080" y="320040"/>
+            <a:ext cx="10881360" cy="914400"/>
           </a:xfrm>
           <a:prstGeom prst="rect">
             <a:avLst/>
@@ -7275,7 +7515,7 @@
         </p:spPr>
         <p:txBody>
           <a:bodyPr wrap="square">
-            <a:spAutoFit/>
+            <a:noAutofit/>
           </a:bodyPr>
           <a:lstStyle/>
           <a:p>
@@ -7284,7 +7524,7 @@
                 <a:solidFill>
                   <a:srgbClr val="D7C7EE"/>
                 </a:solidFill>
-                <a:latin typeface="Arial"/>
+                <a:latin typeface="Cinzel"/>
               </a:rPr>
               <a:t>Invent a stat fit for live TV</a:t>
             </a:r>
@@ -7299,8 +7539,8 @@
         </p:nvSpPr>
         <p:spPr>
           <a:xfrm>
-            <a:off x="640080" y="1554480"/>
-            <a:ext cx="6400800" cy="4206240"/>
+            <a:off x="640080" y="1920240"/>
+            <a:ext cx="5760720" cy="4389120"/>
           </a:xfrm>
           <a:prstGeom prst="rect">
             <a:avLst/>
@@ -7309,19 +7549,19 @@
         </p:spPr>
         <p:txBody>
           <a:bodyPr wrap="square">
-            <a:spAutoFit/>
+            <a:noAutofit/>
           </a:bodyPr>
           <a:lstStyle/>
           <a:p>
             <a:pPr>
               <a:spcAft>
-                <a:spcPts val="1600"/>
+                <a:spcPts val="3400"/>
               </a:spcAft>
             </a:pPr>
             <a:r>
               <a:rPr sz="2400">
                 <a:solidFill>
-                  <a:srgbClr val="FFFFFF"/>
+                  <a:srgbClr val="F0F0F0"/>
                 </a:solidFill>
                 <a:latin typeface="Arial"/>
               </a:rPr>
@@ -7331,13 +7571,13 @@
           <a:p>
             <a:pPr>
               <a:spcAft>
-                <a:spcPts val="1600"/>
+                <a:spcPts val="3400"/>
               </a:spcAft>
             </a:pPr>
             <a:r>
               <a:rPr sz="2400">
                 <a:solidFill>
-                  <a:srgbClr val="FFFFFF"/>
+                  <a:srgbClr val="F0F0F0"/>
                 </a:solidFill>
                 <a:latin typeface="Arial"/>
               </a:rPr>
@@ -7347,13 +7587,13 @@
           <a:p>
             <a:pPr>
               <a:spcAft>
-                <a:spcPts val="1600"/>
+                <a:spcPts val="3400"/>
               </a:spcAft>
             </a:pPr>
             <a:r>
               <a:rPr sz="2400">
                 <a:solidFill>
-                  <a:srgbClr val="FFFFFF"/>
+                  <a:srgbClr val="F0F0F0"/>
                 </a:solidFill>
                 <a:latin typeface="Arial"/>
               </a:rPr>
@@ -7371,15 +7611,15 @@
           <p:nvPr/>
         </p:nvPicPr>
         <p:blipFill>
-          <a:blip r:embed="rId3"/>
+          <a:blip r:embed="rId4"/>
           <a:stretch>
             <a:fillRect/>
           </a:stretch>
         </p:blipFill>
         <p:spPr>
           <a:xfrm>
-            <a:off x="7068312" y="2508885"/>
-            <a:ext cx="4572000" cy="2571750"/>
+            <a:off x="6793992" y="2614613"/>
+            <a:ext cx="4846320" cy="2726054"/>
           </a:xfrm>
           <a:prstGeom prst="rect">
             <a:avLst/>
@@ -7399,9 +7639,17 @@
   <p:cSld>
     <p:bg>
       <p:bgPr>
-        <a:solidFill>
-          <a:srgbClr val="00002A"/>
-        </a:solidFill>
+        <a:gradFill rotWithShape="1">
+          <a:gsLst>
+            <a:gs pos="0">
+              <a:srgbClr val="00002A"/>
+            </a:gs>
+            <a:gs pos="100000">
+              <a:srgbClr val="200050"/>
+            </a:gs>
+          </a:gsLst>
+          <a:lin scaled="0" ang="16200000"/>
+        </a:gradFill>
         <a:effectLst/>
       </p:bgPr>
     </p:bg>
@@ -7426,9 +7674,17 @@
           <a:prstGeom prst="rect">
             <a:avLst/>
           </a:prstGeom>
-          <a:solidFill>
-            <a:srgbClr val="00002A"/>
-          </a:solidFill>
+          <a:gradFill rotWithShape="1">
+            <a:gsLst>
+              <a:gs pos="0">
+                <a:srgbClr val="5A1F8A"/>
+              </a:gs>
+              <a:gs pos="100000">
+                <a:srgbClr val="FF9900"/>
+              </a:gs>
+            </a:gsLst>
+            <a:lin scaled="0" ang="0"/>
+          </a:gradFill>
           <a:ln>
             <a:noFill/>
           </a:ln>
@@ -7469,9 +7725,17 @@
           <a:prstGeom prst="rect">
             <a:avLst/>
           </a:prstGeom>
-          <a:solidFill>
-            <a:srgbClr val="9060F0"/>
-          </a:solidFill>
+          <a:gradFill rotWithShape="1">
+            <a:gsLst>
+              <a:gs pos="0">
+                <a:srgbClr val="5A1F8A"/>
+              </a:gs>
+              <a:gs pos="100000">
+                <a:srgbClr val="FF9900"/>
+              </a:gs>
+            </a:gsLst>
+            <a:lin scaled="0" ang="0"/>
+          </a:gradFill>
           <a:ln>
             <a:noFill/>
           </a:ln>
@@ -7541,8 +7805,8 @@
         </p:nvSpPr>
         <p:spPr>
           <a:xfrm>
-            <a:off x="640080" y="365760"/>
-            <a:ext cx="10881360" cy="822960"/>
+            <a:off x="640080" y="320040"/>
+            <a:ext cx="10881360" cy="914400"/>
           </a:xfrm>
           <a:prstGeom prst="rect">
             <a:avLst/>
@@ -7551,7 +7815,7 @@
         </p:spPr>
         <p:txBody>
           <a:bodyPr wrap="square">
-            <a:spAutoFit/>
+            <a:noAutofit/>
           </a:bodyPr>
           <a:lstStyle/>
           <a:p>
@@ -7560,7 +7824,7 @@
                 <a:solidFill>
                   <a:srgbClr val="D7C7EE"/>
                 </a:solidFill>
-                <a:latin typeface="Arial"/>
+                <a:latin typeface="Cinzel"/>
               </a:rPr>
               <a:t>$100K. Combine stage. Hires.</a:t>
             </a:r>
@@ -7575,8 +7839,8 @@
         </p:nvSpPr>
         <p:spPr>
           <a:xfrm>
-            <a:off x="640080" y="1554480"/>
-            <a:ext cx="6400800" cy="4206240"/>
+            <a:off x="640080" y="1920240"/>
+            <a:ext cx="5760720" cy="4389120"/>
           </a:xfrm>
           <a:prstGeom prst="rect">
             <a:avLst/>
@@ -7585,19 +7849,19 @@
         </p:spPr>
         <p:txBody>
           <a:bodyPr wrap="square">
-            <a:spAutoFit/>
+            <a:noAutofit/>
           </a:bodyPr>
           <a:lstStyle/>
           <a:p>
             <a:pPr>
               <a:spcAft>
-                <a:spcPts val="1600"/>
+                <a:spcPts val="3400"/>
               </a:spcAft>
             </a:pPr>
             <a:r>
               <a:rPr sz="2400">
                 <a:solidFill>
-                  <a:srgbClr val="FFFFFF"/>
+                  <a:srgbClr val="F0F0F0"/>
                 </a:solidFill>
                 <a:latin typeface="Arial"/>
               </a:rPr>
@@ -7607,13 +7871,13 @@
           <a:p>
             <a:pPr>
               <a:spcAft>
-                <a:spcPts val="1600"/>
+                <a:spcPts val="3400"/>
               </a:spcAft>
             </a:pPr>
             <a:r>
               <a:rPr sz="2400">
                 <a:solidFill>
-                  <a:srgbClr val="FFFFFF"/>
+                  <a:srgbClr val="F0F0F0"/>
                 </a:solidFill>
                 <a:latin typeface="Arial"/>
               </a:rPr>
@@ -7623,13 +7887,13 @@
           <a:p>
             <a:pPr>
               <a:spcAft>
-                <a:spcPts val="1600"/>
+                <a:spcPts val="3400"/>
               </a:spcAft>
             </a:pPr>
             <a:r>
               <a:rPr sz="2400">
                 <a:solidFill>
-                  <a:srgbClr val="FFFFFF"/>
+                  <a:srgbClr val="F0F0F0"/>
                 </a:solidFill>
                 <a:latin typeface="Arial"/>
               </a:rPr>
@@ -7647,15 +7911,15 @@
           <p:nvPr/>
         </p:nvPicPr>
         <p:blipFill>
-          <a:blip r:embed="rId3"/>
+          <a:blip r:embed="rId4"/>
           <a:stretch>
             <a:fillRect/>
           </a:stretch>
         </p:blipFill>
         <p:spPr>
           <a:xfrm>
-            <a:off x="7068312" y="2522539"/>
-            <a:ext cx="4572000" cy="2544442"/>
+            <a:off x="6793992" y="2629086"/>
+            <a:ext cx="4846320" cy="2697108"/>
           </a:xfrm>
           <a:prstGeom prst="rect">
             <a:avLst/>
@@ -7675,9 +7939,17 @@
   <p:cSld>
     <p:bg>
       <p:bgPr>
-        <a:solidFill>
-          <a:srgbClr val="00002A"/>
-        </a:solidFill>
+        <a:gradFill rotWithShape="1">
+          <a:gsLst>
+            <a:gs pos="0">
+              <a:srgbClr val="00002A"/>
+            </a:gs>
+            <a:gs pos="100000">
+              <a:srgbClr val="200050"/>
+            </a:gs>
+          </a:gsLst>
+          <a:lin scaled="0" ang="16200000"/>
+        </a:gradFill>
         <a:effectLst/>
       </p:bgPr>
     </p:bg>
@@ -7702,9 +7974,17 @@
           <a:prstGeom prst="rect">
             <a:avLst/>
           </a:prstGeom>
-          <a:solidFill>
-            <a:srgbClr val="00002A"/>
-          </a:solidFill>
+          <a:gradFill rotWithShape="1">
+            <a:gsLst>
+              <a:gs pos="0">
+                <a:srgbClr val="5A1F8A"/>
+              </a:gs>
+              <a:gs pos="100000">
+                <a:srgbClr val="FF9900"/>
+              </a:gs>
+            </a:gsLst>
+            <a:lin scaled="0" ang="0"/>
+          </a:gradFill>
           <a:ln>
             <a:noFill/>
           </a:ln>
@@ -7745,9 +8025,17 @@
           <a:prstGeom prst="rect">
             <a:avLst/>
           </a:prstGeom>
-          <a:solidFill>
-            <a:srgbClr val="9060F0"/>
-          </a:solidFill>
+          <a:gradFill rotWithShape="1">
+            <a:gsLst>
+              <a:gs pos="0">
+                <a:srgbClr val="5A1F8A"/>
+              </a:gs>
+              <a:gs pos="100000">
+                <a:srgbClr val="FF9900"/>
+              </a:gs>
+            </a:gsLst>
+            <a:lin scaled="0" ang="0"/>
+          </a:gradFill>
           <a:ln>
             <a:noFill/>
           </a:ln>
@@ -7817,8 +8105,8 @@
         </p:nvSpPr>
         <p:spPr>
           <a:xfrm>
-            <a:off x="640080" y="365760"/>
-            <a:ext cx="10881360" cy="822960"/>
+            <a:off x="640080" y="320040"/>
+            <a:ext cx="10881360" cy="914400"/>
           </a:xfrm>
           <a:prstGeom prst="rect">
             <a:avLst/>
@@ -7827,7 +8115,7 @@
         </p:spPr>
         <p:txBody>
           <a:bodyPr wrap="square">
-            <a:spAutoFit/>
+            <a:noAutofit/>
           </a:bodyPr>
           <a:lstStyle/>
           <a:p>
@@ -7836,7 +8124,7 @@
                 <a:solidFill>
                   <a:srgbClr val="D7C7EE"/>
                 </a:solidFill>
-                <a:latin typeface="Arial"/>
+                <a:latin typeface="Cinzel"/>
               </a:rPr>
               <a:t>Entries become TV stats</a:t>
             </a:r>
@@ -7851,8 +8139,8 @@
         </p:nvSpPr>
         <p:spPr>
           <a:xfrm>
-            <a:off x="640080" y="1554480"/>
-            <a:ext cx="6400800" cy="4206240"/>
+            <a:off x="640080" y="1920240"/>
+            <a:ext cx="5760720" cy="4389120"/>
           </a:xfrm>
           <a:prstGeom prst="rect">
             <a:avLst/>
@@ -7861,19 +8149,19 @@
         </p:spPr>
         <p:txBody>
           <a:bodyPr wrap="square">
-            <a:spAutoFit/>
+            <a:noAutofit/>
           </a:bodyPr>
           <a:lstStyle/>
           <a:p>
             <a:pPr>
               <a:spcAft>
-                <a:spcPts val="1600"/>
+                <a:spcPts val="3400"/>
               </a:spcAft>
             </a:pPr>
             <a:r>
               <a:rPr sz="2400">
                 <a:solidFill>
-                  <a:srgbClr val="FFFFFF"/>
+                  <a:srgbClr val="F0F0F0"/>
                 </a:solidFill>
                 <a:latin typeface="Arial"/>
               </a:rPr>
@@ -7883,13 +8171,13 @@
           <a:p>
             <a:pPr>
               <a:spcAft>
-                <a:spcPts val="1600"/>
+                <a:spcPts val="3400"/>
               </a:spcAft>
             </a:pPr>
             <a:r>
               <a:rPr sz="2400">
                 <a:solidFill>
-                  <a:srgbClr val="FFFFFF"/>
+                  <a:srgbClr val="F0F0F0"/>
                 </a:solidFill>
                 <a:latin typeface="Arial"/>
               </a:rPr>
@@ -7899,13 +8187,13 @@
           <a:p>
             <a:pPr>
               <a:spcAft>
-                <a:spcPts val="1600"/>
+                <a:spcPts val="3400"/>
               </a:spcAft>
             </a:pPr>
             <a:r>
               <a:rPr sz="2400">
                 <a:solidFill>
-                  <a:srgbClr val="FFFFFF"/>
+                  <a:srgbClr val="F0F0F0"/>
                 </a:solidFill>
                 <a:latin typeface="Arial"/>
               </a:rPr>
@@ -7923,15 +8211,15 @@
           <p:nvPr/>
         </p:nvPicPr>
         <p:blipFill>
-          <a:blip r:embed="rId3"/>
+          <a:blip r:embed="rId5"/>
           <a:stretch>
             <a:fillRect/>
           </a:stretch>
         </p:blipFill>
         <p:spPr>
           <a:xfrm>
-            <a:off x="7068312" y="2508885"/>
-            <a:ext cx="4572000" cy="2571750"/>
+            <a:off x="6793992" y="2614613"/>
+            <a:ext cx="4846320" cy="2726054"/>
           </a:xfrm>
           <a:prstGeom prst="rect">
             <a:avLst/>
@@ -7951,9 +8239,17 @@
   <p:cSld>
     <p:bg>
       <p:bgPr>
-        <a:solidFill>
-          <a:srgbClr val="00002A"/>
-        </a:solidFill>
+        <a:gradFill rotWithShape="1">
+          <a:gsLst>
+            <a:gs pos="0">
+              <a:srgbClr val="00002A"/>
+            </a:gs>
+            <a:gs pos="100000">
+              <a:srgbClr val="200050"/>
+            </a:gs>
+          </a:gsLst>
+          <a:lin scaled="0" ang="16200000"/>
+        </a:gradFill>
         <a:effectLst/>
       </p:bgPr>
     </p:bg>
@@ -7978,9 +8274,17 @@
           <a:prstGeom prst="rect">
             <a:avLst/>
           </a:prstGeom>
-          <a:solidFill>
-            <a:srgbClr val="00002A"/>
-          </a:solidFill>
+          <a:gradFill rotWithShape="1">
+            <a:gsLst>
+              <a:gs pos="0">
+                <a:srgbClr val="5A1F8A"/>
+              </a:gs>
+              <a:gs pos="100000">
+                <a:srgbClr val="FF9900"/>
+              </a:gs>
+            </a:gsLst>
+            <a:lin scaled="0" ang="0"/>
+          </a:gradFill>
           <a:ln>
             <a:noFill/>
           </a:ln>
@@ -8021,9 +8325,17 @@
           <a:prstGeom prst="rect">
             <a:avLst/>
           </a:prstGeom>
-          <a:solidFill>
-            <a:srgbClr val="9060F0"/>
-          </a:solidFill>
+          <a:gradFill rotWithShape="1">
+            <a:gsLst>
+              <a:gs pos="0">
+                <a:srgbClr val="5A1F8A"/>
+              </a:gs>
+              <a:gs pos="100000">
+                <a:srgbClr val="FF9900"/>
+              </a:gs>
+            </a:gsLst>
+            <a:lin scaled="0" ang="0"/>
+          </a:gradFill>
           <a:ln>
             <a:noFill/>
           </a:ln>
@@ -8093,8 +8405,8 @@
         </p:nvSpPr>
         <p:spPr>
           <a:xfrm>
-            <a:off x="640080" y="365760"/>
-            <a:ext cx="10881360" cy="822960"/>
+            <a:off x="640080" y="320040"/>
+            <a:ext cx="10881360" cy="914400"/>
           </a:xfrm>
           <a:prstGeom prst="rect">
             <a:avLst/>
@@ -8103,7 +8415,7 @@
         </p:spPr>
         <p:txBody>
           <a:bodyPr wrap="square">
-            <a:spAutoFit/>
+            <a:noAutofit/>
           </a:bodyPr>
           <a:lstStyle/>
           <a:p>
@@ -8112,7 +8424,7 @@
                 <a:solidFill>
                   <a:srgbClr val="D7C7EE"/>
                 </a:solidFill>
-                <a:latin typeface="Arial"/>
+                <a:latin typeface="Cinzel"/>
               </a:rPr>
               <a:t>Everyone tracked. 10x a second.</a:t>
             </a:r>
@@ -8127,8 +8439,8 @@
         </p:nvSpPr>
         <p:spPr>
           <a:xfrm>
-            <a:off x="640080" y="1554480"/>
-            <a:ext cx="6400800" cy="4206240"/>
+            <a:off x="640080" y="1920240"/>
+            <a:ext cx="5760720" cy="4389120"/>
           </a:xfrm>
           <a:prstGeom prst="rect">
             <a:avLst/>
@@ -8137,19 +8449,19 @@
         </p:spPr>
         <p:txBody>
           <a:bodyPr wrap="square">
-            <a:spAutoFit/>
+            <a:noAutofit/>
           </a:bodyPr>
           <a:lstStyle/>
           <a:p>
             <a:pPr>
               <a:spcAft>
-                <a:spcPts val="1600"/>
+                <a:spcPts val="3400"/>
               </a:spcAft>
             </a:pPr>
             <a:r>
               <a:rPr sz="2400">
                 <a:solidFill>
-                  <a:srgbClr val="FFFFFF"/>
+                  <a:srgbClr val="F0F0F0"/>
                 </a:solidFill>
                 <a:latin typeface="Arial"/>
               </a:rPr>
@@ -8159,13 +8471,13 @@
           <a:p>
             <a:pPr>
               <a:spcAft>
-                <a:spcPts val="1600"/>
+                <a:spcPts val="3400"/>
               </a:spcAft>
             </a:pPr>
             <a:r>
               <a:rPr sz="2400">
                 <a:solidFill>
-                  <a:srgbClr val="FFFFFF"/>
+                  <a:srgbClr val="F0F0F0"/>
                 </a:solidFill>
                 <a:latin typeface="Arial"/>
               </a:rPr>
@@ -8175,13 +8487,13 @@
           <a:p>
             <a:pPr>
               <a:spcAft>
-                <a:spcPts val="1600"/>
+                <a:spcPts val="3400"/>
               </a:spcAft>
             </a:pPr>
             <a:r>
               <a:rPr sz="2400">
                 <a:solidFill>
-                  <a:srgbClr val="FFFFFF"/>
+                  <a:srgbClr val="F0F0F0"/>
                 </a:solidFill>
                 <a:latin typeface="Arial"/>
               </a:rPr>
@@ -8199,15 +8511,15 @@
           <p:nvPr/>
         </p:nvPicPr>
         <p:blipFill>
-          <a:blip r:embed="rId3"/>
+          <a:blip r:embed="rId5"/>
           <a:stretch>
             <a:fillRect/>
           </a:stretch>
         </p:blipFill>
         <p:spPr>
           <a:xfrm>
-            <a:off x="7068312" y="2502081"/>
-            <a:ext cx="4572000" cy="2585357"/>
+            <a:off x="6793992" y="2607401"/>
+            <a:ext cx="4846320" cy="2740478"/>
           </a:xfrm>
           <a:prstGeom prst="rect">
             <a:avLst/>
@@ -8227,9 +8539,17 @@
   <p:cSld>
     <p:bg>
       <p:bgPr>
-        <a:solidFill>
-          <a:srgbClr val="00002A"/>
-        </a:solidFill>
+        <a:gradFill rotWithShape="1">
+          <a:gsLst>
+            <a:gs pos="0">
+              <a:srgbClr val="00002A"/>
+            </a:gs>
+            <a:gs pos="100000">
+              <a:srgbClr val="200050"/>
+            </a:gs>
+          </a:gsLst>
+          <a:lin scaled="0" ang="16200000"/>
+        </a:gradFill>
         <a:effectLst/>
       </p:bgPr>
     </p:bg>
@@ -8254,9 +8574,17 @@
           <a:prstGeom prst="rect">
             <a:avLst/>
           </a:prstGeom>
-          <a:solidFill>
-            <a:srgbClr val="00002A"/>
-          </a:solidFill>
+          <a:gradFill rotWithShape="1">
+            <a:gsLst>
+              <a:gs pos="0">
+                <a:srgbClr val="5A1F8A"/>
+              </a:gs>
+              <a:gs pos="100000">
+                <a:srgbClr val="FF9900"/>
+              </a:gs>
+            </a:gsLst>
+            <a:lin scaled="0" ang="0"/>
+          </a:gradFill>
           <a:ln>
             <a:noFill/>
           </a:ln>
@@ -8297,9 +8625,17 @@
           <a:prstGeom prst="rect">
             <a:avLst/>
           </a:prstGeom>
-          <a:solidFill>
-            <a:srgbClr val="9060F0"/>
-          </a:solidFill>
+          <a:gradFill rotWithShape="1">
+            <a:gsLst>
+              <a:gs pos="0">
+                <a:srgbClr val="5A1F8A"/>
+              </a:gs>
+              <a:gs pos="100000">
+                <a:srgbClr val="FF9900"/>
+              </a:gs>
+            </a:gsLst>
+            <a:lin scaled="0" ang="0"/>
+          </a:gradFill>
           <a:ln>
             <a:noFill/>
           </a:ln>
@@ -8369,8 +8705,8 @@
         </p:nvSpPr>
         <p:spPr>
           <a:xfrm>
-            <a:off x="640080" y="365760"/>
-            <a:ext cx="10881360" cy="822960"/>
+            <a:off x="640080" y="320040"/>
+            <a:ext cx="10881360" cy="914400"/>
           </a:xfrm>
           <a:prstGeom prst="rect">
             <a:avLst/>
@@ -8379,7 +8715,7 @@
         </p:spPr>
         <p:txBody>
           <a:bodyPr wrap="square">
-            <a:spAutoFit/>
+            <a:noAutofit/>
           </a:bodyPr>
           <a:lstStyle/>
           <a:p>
@@ -8388,7 +8724,7 @@
                 <a:solidFill>
                   <a:srgbClr val="D7C7EE"/>
                 </a:solidFill>
-                <a:latin typeface="Arial"/>
+                <a:latin typeface="Cinzel"/>
               </a:rPr>
               <a:t>Workflow 1: sample first</a:t>
             </a:r>
@@ -8403,8 +8739,8 @@
         </p:nvSpPr>
         <p:spPr>
           <a:xfrm>
-            <a:off x="640080" y="1554480"/>
-            <a:ext cx="6400800" cy="4206240"/>
+            <a:off x="640080" y="1920240"/>
+            <a:ext cx="5760720" cy="4389120"/>
           </a:xfrm>
           <a:prstGeom prst="rect">
             <a:avLst/>
@@ -8413,19 +8749,19 @@
         </p:spPr>
         <p:txBody>
           <a:bodyPr wrap="square">
-            <a:spAutoFit/>
+            <a:noAutofit/>
           </a:bodyPr>
           <a:lstStyle/>
           <a:p>
             <a:pPr>
               <a:spcAft>
-                <a:spcPts val="1600"/>
+                <a:spcPts val="3400"/>
               </a:spcAft>
             </a:pPr>
             <a:r>
               <a:rPr sz="2400">
                 <a:solidFill>
-                  <a:srgbClr val="FFFFFF"/>
+                  <a:srgbClr val="F0F0F0"/>
                 </a:solidFill>
                 <a:latin typeface="Arial"/>
               </a:rPr>
@@ -8435,13 +8771,13 @@
           <a:p>
             <a:pPr>
               <a:spcAft>
-                <a:spcPts val="1600"/>
+                <a:spcPts val="3400"/>
               </a:spcAft>
             </a:pPr>
             <a:r>
               <a:rPr sz="2400">
                 <a:solidFill>
-                  <a:srgbClr val="FFFFFF"/>
+                  <a:srgbClr val="F0F0F0"/>
                 </a:solidFill>
                 <a:latin typeface="Arial"/>
               </a:rPr>
@@ -8451,13 +8787,13 @@
           <a:p>
             <a:pPr>
               <a:spcAft>
-                <a:spcPts val="1600"/>
+                <a:spcPts val="3400"/>
               </a:spcAft>
             </a:pPr>
             <a:r>
               <a:rPr sz="2400">
                 <a:solidFill>
-                  <a:srgbClr val="FFFFFF"/>
+                  <a:srgbClr val="F0F0F0"/>
                 </a:solidFill>
                 <a:latin typeface="Arial"/>
               </a:rPr>
@@ -8475,15 +8811,15 @@
           <p:nvPr/>
         </p:nvPicPr>
         <p:blipFill>
-          <a:blip r:embed="rId3"/>
+          <a:blip r:embed="rId4"/>
           <a:stretch>
             <a:fillRect/>
           </a:stretch>
         </p:blipFill>
         <p:spPr>
           <a:xfrm>
-            <a:off x="7068312" y="2508242"/>
-            <a:ext cx="4572000" cy="2573036"/>
+            <a:off x="6793992" y="2613931"/>
+            <a:ext cx="4846320" cy="2727418"/>
           </a:xfrm>
           <a:prstGeom prst="rect">
             <a:avLst/>
@@ -8503,9 +8839,17 @@
   <p:cSld>
     <p:bg>
       <p:bgPr>
-        <a:solidFill>
-          <a:srgbClr val="00002A"/>
-        </a:solidFill>
+        <a:gradFill rotWithShape="1">
+          <a:gsLst>
+            <a:gs pos="0">
+              <a:srgbClr val="00002A"/>
+            </a:gs>
+            <a:gs pos="100000">
+              <a:srgbClr val="200050"/>
+            </a:gs>
+          </a:gsLst>
+          <a:lin scaled="0" ang="16200000"/>
+        </a:gradFill>
         <a:effectLst/>
       </p:bgPr>
     </p:bg>
@@ -8530,9 +8874,17 @@
           <a:prstGeom prst="rect">
             <a:avLst/>
           </a:prstGeom>
-          <a:solidFill>
-            <a:srgbClr val="00002A"/>
-          </a:solidFill>
+          <a:gradFill rotWithShape="1">
+            <a:gsLst>
+              <a:gs pos="0">
+                <a:srgbClr val="5A1F8A"/>
+              </a:gs>
+              <a:gs pos="100000">
+                <a:srgbClr val="FF9900"/>
+              </a:gs>
+            </a:gsLst>
+            <a:lin scaled="0" ang="0"/>
+          </a:gradFill>
           <a:ln>
             <a:noFill/>
           </a:ln>
@@ -8573,9 +8925,17 @@
           <a:prstGeom prst="rect">
             <a:avLst/>
           </a:prstGeom>
-          <a:solidFill>
-            <a:srgbClr val="9060F0"/>
-          </a:solidFill>
+          <a:gradFill rotWithShape="1">
+            <a:gsLst>
+              <a:gs pos="0">
+                <a:srgbClr val="5A1F8A"/>
+              </a:gs>
+              <a:gs pos="100000">
+                <a:srgbClr val="FF9900"/>
+              </a:gs>
+            </a:gsLst>
+            <a:lin scaled="0" ang="0"/>
+          </a:gradFill>
           <a:ln>
             <a:noFill/>
           </a:ln>
@@ -8645,8 +9005,8 @@
         </p:nvSpPr>
         <p:spPr>
           <a:xfrm>
-            <a:off x="640080" y="365760"/>
-            <a:ext cx="10881360" cy="822960"/>
+            <a:off x="640080" y="320040"/>
+            <a:ext cx="10881360" cy="914400"/>
           </a:xfrm>
           <a:prstGeom prst="rect">
             <a:avLst/>
@@ -8655,7 +9015,7 @@
         </p:spPr>
         <p:txBody>
           <a:bodyPr wrap="square">
-            <a:spAutoFit/>
+            <a:noAutofit/>
           </a:bodyPr>
           <a:lstStyle/>
           <a:p>
@@ -8664,7 +9024,7 @@
                 <a:solidFill>
                   <a:srgbClr val="D7C7EE"/>
                 </a:solidFill>
-                <a:latin typeface="Arial"/>
+                <a:latin typeface="Cinzel"/>
               </a:rPr>
               <a:t>Workflow 2: Parquet once</a:t>
             </a:r>
@@ -8679,8 +9039,8 @@
         </p:nvSpPr>
         <p:spPr>
           <a:xfrm>
-            <a:off x="640080" y="1554480"/>
-            <a:ext cx="6400800" cy="4206240"/>
+            <a:off x="640080" y="1920240"/>
+            <a:ext cx="5760720" cy="4389120"/>
           </a:xfrm>
           <a:prstGeom prst="rect">
             <a:avLst/>
@@ -8689,19 +9049,19 @@
         </p:spPr>
         <p:txBody>
           <a:bodyPr wrap="square">
-            <a:spAutoFit/>
+            <a:noAutofit/>
           </a:bodyPr>
           <a:lstStyle/>
           <a:p>
             <a:pPr>
               <a:spcAft>
-                <a:spcPts val="1600"/>
+                <a:spcPts val="3400"/>
               </a:spcAft>
             </a:pPr>
             <a:r>
               <a:rPr sz="2400">
                 <a:solidFill>
-                  <a:srgbClr val="FFFFFF"/>
+                  <a:srgbClr val="F0F0F0"/>
                 </a:solidFill>
                 <a:latin typeface="Arial"/>
               </a:rPr>
@@ -8711,13 +9071,13 @@
           <a:p>
             <a:pPr>
               <a:spcAft>
-                <a:spcPts val="1600"/>
+                <a:spcPts val="3400"/>
               </a:spcAft>
             </a:pPr>
             <a:r>
               <a:rPr sz="2400">
                 <a:solidFill>
-                  <a:srgbClr val="FFFFFF"/>
+                  <a:srgbClr val="F0F0F0"/>
                 </a:solidFill>
                 <a:latin typeface="Arial"/>
               </a:rPr>
@@ -8727,13 +9087,13 @@
           <a:p>
             <a:pPr>
               <a:spcAft>
-                <a:spcPts val="1600"/>
+                <a:spcPts val="3400"/>
               </a:spcAft>
             </a:pPr>
             <a:r>
               <a:rPr sz="2400">
                 <a:solidFill>
-                  <a:srgbClr val="FFFFFF"/>
+                  <a:srgbClr val="F0F0F0"/>
                 </a:solidFill>
                 <a:latin typeface="Arial"/>
               </a:rPr>
@@ -8751,15 +9111,15 @@
           <p:nvPr/>
         </p:nvPicPr>
         <p:blipFill>
-          <a:blip r:embed="rId3"/>
+          <a:blip r:embed="rId5"/>
           <a:stretch>
             <a:fillRect/>
           </a:stretch>
         </p:blipFill>
         <p:spPr>
           <a:xfrm>
-            <a:off x="7068312" y="2502081"/>
-            <a:ext cx="4572000" cy="2585357"/>
+            <a:off x="6793992" y="2607401"/>
+            <a:ext cx="4846320" cy="2740478"/>
           </a:xfrm>
           <a:prstGeom prst="rect">
             <a:avLst/>
@@ -8779,9 +9139,17 @@
   <p:cSld>
     <p:bg>
       <p:bgPr>
-        <a:solidFill>
-          <a:srgbClr val="00002A"/>
-        </a:solidFill>
+        <a:gradFill rotWithShape="1">
+          <a:gsLst>
+            <a:gs pos="0">
+              <a:srgbClr val="00002A"/>
+            </a:gs>
+            <a:gs pos="100000">
+              <a:srgbClr val="200050"/>
+            </a:gs>
+          </a:gsLst>
+          <a:lin scaled="0" ang="16200000"/>
+        </a:gradFill>
         <a:effectLst/>
       </p:bgPr>
     </p:bg>
@@ -8806,9 +9174,17 @@
           <a:prstGeom prst="rect">
             <a:avLst/>
           </a:prstGeom>
-          <a:solidFill>
-            <a:srgbClr val="00002A"/>
-          </a:solidFill>
+          <a:gradFill rotWithShape="1">
+            <a:gsLst>
+              <a:gs pos="0">
+                <a:srgbClr val="5A1F8A"/>
+              </a:gs>
+              <a:gs pos="100000">
+                <a:srgbClr val="FF9900"/>
+              </a:gs>
+            </a:gsLst>
+            <a:lin scaled="0" ang="0"/>
+          </a:gradFill>
           <a:ln>
             <a:noFill/>
           </a:ln>
@@ -8849,9 +9225,17 @@
           <a:prstGeom prst="rect">
             <a:avLst/>
           </a:prstGeom>
-          <a:solidFill>
-            <a:srgbClr val="9060F0"/>
-          </a:solidFill>
+          <a:gradFill rotWithShape="1">
+            <a:gsLst>
+              <a:gs pos="0">
+                <a:srgbClr val="5A1F8A"/>
+              </a:gs>
+              <a:gs pos="100000">
+                <a:srgbClr val="FF9900"/>
+              </a:gs>
+            </a:gsLst>
+            <a:lin scaled="0" ang="0"/>
+          </a:gradFill>
           <a:ln>
             <a:noFill/>
           </a:ln>
@@ -8921,8 +9305,8 @@
         </p:nvSpPr>
         <p:spPr>
           <a:xfrm>
-            <a:off x="640080" y="365760"/>
-            <a:ext cx="10881360" cy="822960"/>
+            <a:off x="640080" y="320040"/>
+            <a:ext cx="10881360" cy="914400"/>
           </a:xfrm>
           <a:prstGeom prst="rect">
             <a:avLst/>
@@ -8931,7 +9315,7 @@
         </p:spPr>
         <p:txBody>
           <a:bodyPr wrap="square">
-            <a:spAutoFit/>
+            <a:noAutofit/>
           </a:bodyPr>
           <a:lstStyle/>
           <a:p>
@@ -8940,7 +9324,7 @@
                 <a:solidFill>
                   <a:srgbClr val="D7C7EE"/>
                 </a:solidFill>
-                <a:latin typeface="Arial"/>
+                <a:latin typeface="Cinzel"/>
               </a:rPr>
               <a:t>Workflow 3: features frame-up</a:t>
             </a:r>
@@ -8955,8 +9339,8 @@
         </p:nvSpPr>
         <p:spPr>
           <a:xfrm>
-            <a:off x="640080" y="1554480"/>
-            <a:ext cx="6400800" cy="4206240"/>
+            <a:off x="640080" y="1920240"/>
+            <a:ext cx="5760720" cy="4389120"/>
           </a:xfrm>
           <a:prstGeom prst="rect">
             <a:avLst/>
@@ -8965,19 +9349,19 @@
         </p:spPr>
         <p:txBody>
           <a:bodyPr wrap="square">
-            <a:spAutoFit/>
+            <a:noAutofit/>
           </a:bodyPr>
           <a:lstStyle/>
           <a:p>
             <a:pPr>
               <a:spcAft>
-                <a:spcPts val="1600"/>
+                <a:spcPts val="3400"/>
               </a:spcAft>
             </a:pPr>
             <a:r>
               <a:rPr sz="2400">
                 <a:solidFill>
-                  <a:srgbClr val="FFFFFF"/>
+                  <a:srgbClr val="F0F0F0"/>
                 </a:solidFill>
                 <a:latin typeface="Arial"/>
               </a:rPr>
@@ -8987,13 +9371,13 @@
           <a:p>
             <a:pPr>
               <a:spcAft>
-                <a:spcPts val="1600"/>
+                <a:spcPts val="3400"/>
               </a:spcAft>
             </a:pPr>
             <a:r>
               <a:rPr sz="2400">
                 <a:solidFill>
-                  <a:srgbClr val="FFFFFF"/>
+                  <a:srgbClr val="F0F0F0"/>
                 </a:solidFill>
                 <a:latin typeface="Arial"/>
               </a:rPr>
@@ -9003,13 +9387,13 @@
           <a:p>
             <a:pPr>
               <a:spcAft>
-                <a:spcPts val="1600"/>
+                <a:spcPts val="3400"/>
               </a:spcAft>
             </a:pPr>
             <a:r>
               <a:rPr sz="2400">
                 <a:solidFill>
-                  <a:srgbClr val="FFFFFF"/>
+                  <a:srgbClr val="F0F0F0"/>
                 </a:solidFill>
                 <a:latin typeface="Arial"/>
               </a:rPr>
@@ -9027,15 +9411,15 @@
           <p:nvPr/>
         </p:nvPicPr>
         <p:blipFill>
-          <a:blip r:embed="rId3"/>
+          <a:blip r:embed="rId5"/>
           <a:stretch>
             <a:fillRect/>
           </a:stretch>
         </p:blipFill>
         <p:spPr>
           <a:xfrm>
-            <a:off x="7068312" y="2270760"/>
-            <a:ext cx="4572000" cy="3047999"/>
+            <a:off x="6793992" y="2362200"/>
+            <a:ext cx="4846320" cy="3230880"/>
           </a:xfrm>
           <a:prstGeom prst="rect">
             <a:avLst/>
@@ -9055,9 +9439,17 @@
   <p:cSld>
     <p:bg>
       <p:bgPr>
-        <a:solidFill>
-          <a:srgbClr val="00002A"/>
-        </a:solidFill>
+        <a:gradFill rotWithShape="1">
+          <a:gsLst>
+            <a:gs pos="0">
+              <a:srgbClr val="00002A"/>
+            </a:gs>
+            <a:gs pos="100000">
+              <a:srgbClr val="200050"/>
+            </a:gs>
+          </a:gsLst>
+          <a:lin scaled="0" ang="16200000"/>
+        </a:gradFill>
         <a:effectLst/>
       </p:bgPr>
     </p:bg>
@@ -9082,9 +9474,17 @@
           <a:prstGeom prst="rect">
             <a:avLst/>
           </a:prstGeom>
-          <a:solidFill>
-            <a:srgbClr val="00002A"/>
-          </a:solidFill>
+          <a:gradFill rotWithShape="1">
+            <a:gsLst>
+              <a:gs pos="0">
+                <a:srgbClr val="5A1F8A"/>
+              </a:gs>
+              <a:gs pos="100000">
+                <a:srgbClr val="FF9900"/>
+              </a:gs>
+            </a:gsLst>
+            <a:lin scaled="0" ang="0"/>
+          </a:gradFill>
           <a:ln>
             <a:noFill/>
           </a:ln>
@@ -9125,9 +9525,17 @@
           <a:prstGeom prst="rect">
             <a:avLst/>
           </a:prstGeom>
-          <a:solidFill>
-            <a:srgbClr val="9060F0"/>
-          </a:solidFill>
+          <a:gradFill rotWithShape="1">
+            <a:gsLst>
+              <a:gs pos="0">
+                <a:srgbClr val="5A1F8A"/>
+              </a:gs>
+              <a:gs pos="100000">
+                <a:srgbClr val="FF9900"/>
+              </a:gs>
+            </a:gsLst>
+            <a:lin scaled="0" ang="0"/>
+          </a:gradFill>
           <a:ln>
             <a:noFill/>
           </a:ln>
@@ -9197,8 +9605,8 @@
         </p:nvSpPr>
         <p:spPr>
           <a:xfrm>
-            <a:off x="640080" y="365760"/>
-            <a:ext cx="10881360" cy="822960"/>
+            <a:off x="640080" y="320040"/>
+            <a:ext cx="10881360" cy="914400"/>
           </a:xfrm>
           <a:prstGeom prst="rect">
             <a:avLst/>
@@ -9207,7 +9615,7 @@
         </p:spPr>
         <p:txBody>
           <a:bodyPr wrap="square">
-            <a:spAutoFit/>
+            <a:noAutofit/>
           </a:bodyPr>
           <a:lstStyle/>
           <a:p>
@@ -9216,7 +9624,7 @@
                 <a:solidFill>
                   <a:srgbClr val="D7C7EE"/>
                 </a:solidFill>
-                <a:latin typeface="Arial"/>
+                <a:latin typeface="Cinzel"/>
               </a:rPr>
               <a:t>Workflow 4: baseline first</a:t>
             </a:r>
@@ -9231,8 +9639,8 @@
         </p:nvSpPr>
         <p:spPr>
           <a:xfrm>
-            <a:off x="640080" y="1554480"/>
-            <a:ext cx="6400800" cy="4206240"/>
+            <a:off x="640080" y="1920240"/>
+            <a:ext cx="5760720" cy="4389120"/>
           </a:xfrm>
           <a:prstGeom prst="rect">
             <a:avLst/>
@@ -9241,19 +9649,19 @@
         </p:spPr>
         <p:txBody>
           <a:bodyPr wrap="square">
-            <a:spAutoFit/>
+            <a:noAutofit/>
           </a:bodyPr>
           <a:lstStyle/>
           <a:p>
             <a:pPr>
               <a:spcAft>
-                <a:spcPts val="1600"/>
+                <a:spcPts val="3400"/>
               </a:spcAft>
             </a:pPr>
             <a:r>
               <a:rPr sz="2400">
                 <a:solidFill>
-                  <a:srgbClr val="FFFFFF"/>
+                  <a:srgbClr val="F0F0F0"/>
                 </a:solidFill>
                 <a:latin typeface="Arial"/>
               </a:rPr>
@@ -9263,13 +9671,13 @@
           <a:p>
             <a:pPr>
               <a:spcAft>
-                <a:spcPts val="1600"/>
+                <a:spcPts val="3400"/>
               </a:spcAft>
             </a:pPr>
             <a:r>
               <a:rPr sz="2400">
                 <a:solidFill>
-                  <a:srgbClr val="FFFFFF"/>
+                  <a:srgbClr val="F0F0F0"/>
                 </a:solidFill>
                 <a:latin typeface="Arial"/>
               </a:rPr>
@@ -9279,13 +9687,13 @@
           <a:p>
             <a:pPr>
               <a:spcAft>
-                <a:spcPts val="1600"/>
+                <a:spcPts val="3400"/>
               </a:spcAft>
             </a:pPr>
             <a:r>
               <a:rPr sz="2400">
                 <a:solidFill>
-                  <a:srgbClr val="FFFFFF"/>
+                  <a:srgbClr val="F0F0F0"/>
                 </a:solidFill>
                 <a:latin typeface="Arial"/>
               </a:rPr>
@@ -9303,15 +9711,15 @@
           <p:nvPr/>
         </p:nvPicPr>
         <p:blipFill>
-          <a:blip r:embed="rId3"/>
+          <a:blip r:embed="rId5"/>
           <a:stretch>
             <a:fillRect/>
           </a:stretch>
         </p:blipFill>
         <p:spPr>
           <a:xfrm>
-            <a:off x="7068312" y="2423160"/>
-            <a:ext cx="4572000" cy="2743200"/>
+            <a:off x="6793992" y="2523744"/>
+            <a:ext cx="4846320" cy="2907791"/>
           </a:xfrm>
           <a:prstGeom prst="rect">
             <a:avLst/>

</xml_diff>

<commit_message>
deck: plain-words cover, big hero plot
</commit_message>
<xml_diff>
--- a/deck/unified.pptx
+++ b/deck/unified.pptx
@@ -4840,7 +4840,7 @@
         <p:spPr>
           <a:xfrm>
             <a:off x="640080" y="1920240"/>
-            <a:ext cx="5760720" cy="4389120"/>
+            <a:ext cx="3840480" cy="4206240"/>
           </a:xfrm>
           <a:prstGeom prst="rect">
             <a:avLst/>
@@ -4865,7 +4865,7 @@
                 </a:solidFill>
                 <a:latin typeface="Arial"/>
               </a:rPr>
-              <a:t>Bowl = vehicle. Code = instrument.</a:t>
+              <a:t>NFL tracking data, worked live in a terminal.</a:t>
             </a:r>
           </a:p>
           <a:p>
@@ -4881,7 +4881,7 @@
                 </a:solidFill>
                 <a:latin typeface="Arial"/>
               </a:rPr>
-              <a:t>Every player + ball, 10 Hz.</a:t>
+              <a:t>Every player and the ball, located 10 times a second.</a:t>
             </a:r>
           </a:p>
           <a:p>
@@ -4897,7 +4897,7 @@
                 </a:solidFill>
                 <a:latin typeface="Arial"/>
               </a:rPr>
-              <a:t>Live demos. Zero mockups.</a:t>
+              <a:t>Tonight: Bills at Rams, Sep 2022, one play end to end.</a:t>
             </a:r>
           </a:p>
         </p:txBody>
@@ -4918,8 +4918,8 @@
         </p:blipFill>
         <p:spPr>
           <a:xfrm>
-            <a:off x="6793992" y="2614613"/>
-            <a:ext cx="4846320" cy="2726054"/>
+            <a:off x="4965192" y="2100262"/>
+            <a:ext cx="6675120" cy="3754755"/>
           </a:xfrm>
           <a:prstGeom prst="rect">
             <a:avLst/>

</xml_diff>

<commit_message>
deck: plain-words rewrite all 17, collision-free layout
</commit_message>
<xml_diff>
--- a/deck/unified.pptx
+++ b/deck/unified.pptx
@@ -5126,7 +5126,7 @@
                 </a:solidFill>
                 <a:latin typeface="Cinzel"/>
               </a:rPr>
-              <a:t>Skills repeat. Guards protect.</a:t>
+              <a:t>Boring jobs run themselves</a:t>
             </a:r>
           </a:p>
         </p:txBody>
@@ -5140,7 +5140,7 @@
         <p:spPr>
           <a:xfrm>
             <a:off x="640080" y="1920240"/>
-            <a:ext cx="5760720" cy="4389120"/>
+            <a:ext cx="5486400" cy="4389120"/>
           </a:xfrm>
           <a:prstGeom prst="rect">
             <a:avLst/>
@@ -5165,7 +5165,7 @@
                 </a:solidFill>
                 <a:latin typeface="Arial"/>
               </a:rPr>
-              <a:t>parquet. slice. ensemble.</a:t>
+              <a:t>Convert, slice, model: saved routines.</a:t>
             </a:r>
           </a:p>
           <a:p>
@@ -5181,7 +5181,7 @@
                 </a:solidFill>
                 <a:latin typeface="Arial"/>
               </a:rPr>
-              <a:t>One prompt per question.</a:t>
+              <a:t>One question per overnight run.</a:t>
             </a:r>
           </a:p>
           <a:p>
@@ -5197,7 +5197,7 @@
                 </a:solidFill>
                 <a:latin typeface="Arial"/>
               </a:rPr>
-              <a:t>Raw guarded. Reviews free local.</a:t>
+              <a:t>Three saved routines. Zero retyping.</a:t>
             </a:r>
           </a:p>
         </p:txBody>
@@ -5218,8 +5218,8 @@
         </p:blipFill>
         <p:spPr>
           <a:xfrm>
-            <a:off x="6793992" y="2598792"/>
-            <a:ext cx="4846320" cy="2757696"/>
+            <a:off x="7068312" y="2598792"/>
+            <a:ext cx="4663440" cy="2653632"/>
           </a:xfrm>
           <a:prstGeom prst="rect">
             <a:avLst/>
@@ -5426,7 +5426,7 @@
                 </a:solidFill>
                 <a:latin typeface="Cinzel"/>
               </a:rPr>
-              <a:t>30/30/20/20. Cause, don't decorate.</a:t>
+              <a:t>How entries get scored</a:t>
             </a:r>
           </a:p>
         </p:txBody>
@@ -5440,7 +5440,7 @@
         <p:spPr>
           <a:xfrm>
             <a:off x="640080" y="1920240"/>
-            <a:ext cx="5760720" cy="4389120"/>
+            <a:ext cx="5486400" cy="4389120"/>
           </a:xfrm>
           <a:prstGeom prst="rect">
             <a:avLst/>
@@ -5465,7 +5465,7 @@
                 </a:solidFill>
                 <a:latin typeface="Arial"/>
               </a:rPr>
-              <a:t>Football 30. Science 30.</a:t>
+              <a:t>Football 30. Math 30.</a:t>
             </a:r>
           </a:p>
           <a:p>
@@ -5481,7 +5481,7 @@
                 </a:solidFill>
                 <a:latin typeface="Arial"/>
               </a:rPr>
-              <a:t>Prose 20. Visuals 20. 2,000 words.</a:t>
+              <a:t>Words 20. Looks 20. 2,000 words.</a:t>
             </a:r>
           </a:p>
           <a:p>
@@ -5497,7 +5497,7 @@
                 </a:solidFill>
                 <a:latin typeface="Arial"/>
               </a:rPr>
-              <a:t>Under 10 figures. Cause, don't decorate.</a:t>
+              <a:t>Data explains. Never decorates.</a:t>
             </a:r>
           </a:p>
         </p:txBody>
@@ -5518,8 +5518,8 @@
         </p:blipFill>
         <p:spPr>
           <a:xfrm>
-            <a:off x="6793992" y="2592791"/>
-            <a:ext cx="4846320" cy="2769697"/>
+            <a:off x="7068312" y="2592791"/>
+            <a:ext cx="4663440" cy="2623185"/>
           </a:xfrm>
           <a:prstGeom prst="rect">
             <a:avLst/>
@@ -5726,7 +5726,7 @@
                 </a:solidFill>
                 <a:latin typeface="Cinzel"/>
               </a:rPr>
-              <a:t>2027: defense is due</a:t>
+              <a:t>Next contest: defense is due</a:t>
             </a:r>
           </a:p>
         </p:txBody>
@@ -5740,7 +5740,7 @@
         <p:spPr>
           <a:xfrm>
             <a:off x="640080" y="1920240"/>
-            <a:ext cx="5760720" cy="4389120"/>
+            <a:ext cx="5486400" cy="4389120"/>
           </a:xfrm>
           <a:prstGeom prst="rect">
             <a:avLst/>
@@ -5765,7 +5765,7 @@
                 </a:solidFill>
                 <a:latin typeface="Arial"/>
               </a:rPr>
-              <a:t>2026 opened Sep 2025. 2027 pending.</a:t>
+              <a:t>2026 opened Sep 2025.</a:t>
             </a:r>
           </a:p>
           <a:p>
@@ -5781,7 +5781,7 @@
                 </a:solidFill>
                 <a:latin typeface="Arial"/>
               </a:rPr>
-              <a:t>Offense banked. Defense next.</a:t>
+              <a:t>Offense topics banked.</a:t>
             </a:r>
           </a:p>
           <a:p>
@@ -5797,7 +5797,7 @@
                 </a:solidFill>
                 <a:latin typeface="Arial"/>
               </a:rPr>
-              <a:t>Ghosts. Kickoff. Run blocking.</a:t>
+              <a:t>Ghost routes, kickoffs, blocking.</a:t>
             </a:r>
           </a:p>
         </p:txBody>
@@ -5818,8 +5818,8 @@
         </p:blipFill>
         <p:spPr>
           <a:xfrm>
-            <a:off x="6793992" y="2606708"/>
-            <a:ext cx="4846320" cy="2741863"/>
+            <a:off x="7068312" y="2606708"/>
+            <a:ext cx="4663440" cy="2543874"/>
           </a:xfrm>
           <a:prstGeom prst="rect">
             <a:avLst/>
@@ -6026,7 +6026,7 @@
                 </a:solidFill>
                 <a:latin typeface="Cinzel"/>
               </a:rPr>
-              <a:t>Glimmer: 30B, one box, live</a:t>
+              <a:t>A giant model on one desk</a:t>
             </a:r>
           </a:p>
         </p:txBody>
@@ -6040,7 +6040,7 @@
         <p:spPr>
           <a:xfrm>
             <a:off x="640080" y="1920240"/>
-            <a:ext cx="5760720" cy="4389120"/>
+            <a:ext cx="5486400" cy="4389120"/>
           </a:xfrm>
           <a:prstGeom prst="rect">
             <a:avLst/>
@@ -6065,7 +6065,7 @@
                 </a:solidFill>
                 <a:latin typeface="Arial"/>
               </a:rPr>
-              <a:t>Open weights. Apache 2.0.</a:t>
+              <a:t>30 billion settings. Free license.</a:t>
             </a:r>
           </a:p>
           <a:p>
@@ -6081,7 +6081,7 @@
                 </a:solidFill>
                 <a:latin typeface="Arial"/>
               </a:rPr>
-              <a:t>13 layers. 4-bit. Port 8181.</a:t>
+              <a:t>13 layers on the graphics card.</a:t>
             </a:r>
           </a:p>
           <a:p>
@@ -6097,7 +6097,7 @@
                 </a:solidFill>
                 <a:latin typeface="Arial"/>
               </a:rPr>
-              <a:t>Cold start ~8s. 503 = busy.</a:t>
+              <a:t>Answers in 8 seconds cold.</a:t>
             </a:r>
           </a:p>
         </p:txBody>
@@ -6118,8 +6118,8 @@
         </p:blipFill>
         <p:spPr>
           <a:xfrm>
-            <a:off x="6793992" y="2603239"/>
-            <a:ext cx="4846320" cy="2748802"/>
+            <a:off x="7068312" y="2603239"/>
+            <a:ext cx="4663440" cy="2623185"/>
           </a:xfrm>
           <a:prstGeom prst="rect">
             <a:avLst/>
@@ -6326,7 +6326,7 @@
                 </a:solidFill>
                 <a:latin typeface="Cinzel"/>
               </a:rPr>
-              <a:t>13 GPU layers buy nothing</a:t>
+              <a:t>The graphics card loses</a:t>
             </a:r>
           </a:p>
         </p:txBody>
@@ -6340,7 +6340,7 @@
         <p:spPr>
           <a:xfrm>
             <a:off x="640080" y="1920240"/>
-            <a:ext cx="5760720" cy="4389120"/>
+            <a:ext cx="5486400" cy="4389120"/>
           </a:xfrm>
           <a:prstGeom prst="rect">
             <a:avLst/>
@@ -6365,7 +6365,7 @@
                 </a:solidFill>
                 <a:latin typeface="Arial"/>
               </a:rPr>
-              <a:t>CPU: 41.7s. 5.7 tok/s.</a:t>
+              <a:t>Plain chip: 42 seconds.</a:t>
             </a:r>
           </a:p>
           <a:p>
@@ -6381,7 +6381,7 @@
                 </a:solidFill>
                 <a:latin typeface="Arial"/>
               </a:rPr>
-              <a:t>NGL13: 186.7s. 11.62 GB.</a:t>
+              <a:t>Graphics card: 187 seconds.</a:t>
             </a:r>
           </a:p>
           <a:p>
@@ -6397,7 +6397,7 @@
                 </a:solidFill>
                 <a:latin typeface="Arial"/>
               </a:rPr>
-              <a:t>Hosted: 2m13s. Draft local.</a:t>
+              <a:t>Rented cloud: 2 minutes.</a:t>
             </a:r>
           </a:p>
         </p:txBody>
@@ -6418,8 +6418,8 @@
         </p:blipFill>
         <p:spPr>
           <a:xfrm>
-            <a:off x="6793992" y="2959244"/>
-            <a:ext cx="4846320" cy="2036792"/>
+            <a:off x="7068312" y="2959244"/>
+            <a:ext cx="4663440" cy="2512428"/>
           </a:xfrm>
           <a:prstGeom prst="rect">
             <a:avLst/>
@@ -6626,7 +6626,7 @@
                 </a:solidFill>
                 <a:latin typeface="Cinzel"/>
               </a:rPr>
-              <a:t>Memory, modes, one skill each</a:t>
+              <a:t>Five habits that save hours</a:t>
             </a:r>
           </a:p>
         </p:txBody>
@@ -6640,7 +6640,7 @@
         <p:spPr>
           <a:xfrm>
             <a:off x="640080" y="1920240"/>
-            <a:ext cx="5760720" cy="4389120"/>
+            <a:ext cx="5486400" cy="4389120"/>
           </a:xfrm>
           <a:prstGeom prst="rect">
             <a:avLst/>
@@ -6665,7 +6665,7 @@
                 </a:solidFill>
                 <a:latin typeface="Arial"/>
               </a:rPr>
-              <a:t>muse init. Never re-explain.</a:t>
+              <a:t>Save conventions to memory.</a:t>
             </a:r>
           </a:p>
           <a:p>
@@ -6681,7 +6681,7 @@
                 </a:solidFill>
                 <a:latin typeface="Arial"/>
               </a:rPr>
-              <a:t>Pair live. Sweep headless.</a:t>
+              <a:t>Chat to explore, batch to sweep.</a:t>
             </a:r>
           </a:p>
           <a:p>
@@ -6697,7 +6697,7 @@
                 </a:solidFill>
                 <a:latin typeface="Arial"/>
               </a:rPr>
-              <a:t>Pin model. Budget effort.</a:t>
+              <a:t>One saved routine per chore.</a:t>
             </a:r>
           </a:p>
         </p:txBody>
@@ -6718,8 +6718,8 @@
         </p:blipFill>
         <p:spPr>
           <a:xfrm>
-            <a:off x="7022592" y="2598792"/>
-            <a:ext cx="4617720" cy="2757696"/>
+            <a:off x="7068312" y="2598792"/>
+            <a:ext cx="4663440" cy="2653632"/>
           </a:xfrm>
           <a:prstGeom prst="rect">
             <a:avLst/>
@@ -6926,7 +6926,7 @@
                 </a:solidFill>
                 <a:latin typeface="Cinzel"/>
               </a:rPr>
-              <a:t>Read-only. Rewind. Cap spend.</a:t>
+              <a:t>Five more: safety first</a:t>
             </a:r>
           </a:p>
         </p:txBody>
@@ -6940,7 +6940,7 @@
         <p:spPr>
           <a:xfrm>
             <a:off x="640080" y="1920240"/>
-            <a:ext cx="5760720" cy="4389120"/>
+            <a:ext cx="5486400" cy="4389120"/>
           </a:xfrm>
           <a:prstGeom prst="rect">
             <a:avLst/>
@@ -6965,7 +6965,7 @@
                 </a:solidFill>
                 <a:latin typeface="Arial"/>
               </a:rPr>
-              <a:t>MCP read-only. Sandbox on.</a:t>
+              <a:t>Look first, touch later.</a:t>
             </a:r>
           </a:p>
           <a:p>
@@ -6981,7 +6981,7 @@
                 </a:solidFill>
                 <a:latin typeface="Arial"/>
               </a:rPr>
-              <a:t>Rewind, don't retype.</a:t>
+              <a:t>Undo beats retyping.</a:t>
             </a:r>
           </a:p>
           <a:p>
@@ -6997,7 +6997,7 @@
                 </a:solidFill>
                 <a:latin typeface="Arial"/>
               </a:rPr>
-              <a:t>Spark API + Glimmer. Cap day one.</a:t>
+              <a:t>Set money limits day one.</a:t>
             </a:r>
           </a:p>
         </p:txBody>
@@ -7018,8 +7018,8 @@
         </p:blipFill>
         <p:spPr>
           <a:xfrm>
-            <a:off x="6793992" y="2598792"/>
-            <a:ext cx="4846320" cy="2757696"/>
+            <a:off x="7068312" y="2598792"/>
+            <a:ext cx="4663440" cy="2653632"/>
           </a:xfrm>
           <a:prstGeom prst="rect">
             <a:avLst/>
@@ -7226,7 +7226,7 @@
                 </a:solidFill>
                 <a:latin typeface="Cinzel"/>
               </a:rPr>
-              <a:t>Vehicle + instrument. Go tonight.</a:t>
+              <a:t>Clone it. Run one command</a:t>
             </a:r>
           </a:p>
         </p:txBody>
@@ -7240,7 +7240,7 @@
         <p:spPr>
           <a:xfrm>
             <a:off x="640080" y="1920240"/>
-            <a:ext cx="5760720" cy="4389120"/>
+            <a:ext cx="5486400" cy="4389120"/>
           </a:xfrm>
           <a:prstGeom prst="rect">
             <a:avLst/>
@@ -7265,7 +7265,7 @@
                 </a:solidFill>
                 <a:latin typeface="Arial"/>
               </a:rPr>
-              <a:t>Docs, samples, scripts, skills.</a:t>
+              <a:t>Docs, samples, scripts inside.</a:t>
             </a:r>
           </a:p>
           <a:p>
@@ -7281,7 +7281,7 @@
                 </a:solidFill>
                 <a:latin typeface="Arial"/>
               </a:rPr>
-              <a:t>Data lands. Baselines rerun.</a:t>
+              <a:t>One command runs the demo.</a:t>
             </a:r>
           </a:p>
           <a:p>
@@ -7297,7 +7297,7 @@
                 </a:solidFill>
                 <a:latin typeface="Arial"/>
               </a:rPr>
-              <a:t>Run explore_sample tonight.</a:t>
+              <a:t>Field plot lands in seconds.</a:t>
             </a:r>
           </a:p>
         </p:txBody>
@@ -7318,8 +7318,8 @@
         </p:blipFill>
         <p:spPr>
           <a:xfrm>
-            <a:off x="6793992" y="2598792"/>
-            <a:ext cx="4846320" cy="2757696"/>
+            <a:off x="7068312" y="2598792"/>
+            <a:ext cx="4663440" cy="2653632"/>
           </a:xfrm>
           <a:prstGeom prst="rect">
             <a:avLst/>
@@ -7540,7 +7540,7 @@
         <p:spPr>
           <a:xfrm>
             <a:off x="640080" y="1920240"/>
-            <a:ext cx="5760720" cy="4389120"/>
+            <a:ext cx="5486400" cy="4389120"/>
           </a:xfrm>
           <a:prstGeom prst="rect">
             <a:avLst/>
@@ -7565,7 +7565,7 @@
                 </a:solidFill>
                 <a:latin typeface="Arial"/>
               </a:rPr>
-              <a:t>NFL Football Operations + AWS.</a:t>
+              <a:t>Run by the league. Powered by AWS.</a:t>
             </a:r>
           </a:p>
           <a:p>
@@ -7581,7 +7581,7 @@
                 </a:solidFill>
                 <a:latin typeface="Arial"/>
               </a:rPr>
-              <a:t>Real tracking data. Winners ship.</a:t>
+              <a:t>Real movement data, every play.</a:t>
             </a:r>
           </a:p>
           <a:p>
@@ -7597,7 +7597,7 @@
                 </a:solidFill>
                 <a:latin typeface="Arial"/>
               </a:rPr>
-              <a:t>2027 unannounced. Prep now.</a:t>
+              <a:t>Winning stats reach live TV.</a:t>
             </a:r>
           </a:p>
         </p:txBody>
@@ -7618,8 +7618,8 @@
         </p:blipFill>
         <p:spPr>
           <a:xfrm>
-            <a:off x="6793992" y="2614613"/>
-            <a:ext cx="4846320" cy="2726054"/>
+            <a:off x="7068312" y="2614613"/>
+            <a:ext cx="4663440" cy="2623185"/>
           </a:xfrm>
           <a:prstGeom prst="rect">
             <a:avLst/>
@@ -7826,7 +7826,7 @@
                 </a:solidFill>
                 <a:latin typeface="Cinzel"/>
               </a:rPr>
-              <a:t>$100K. Combine stage. Hires.</a:t>
+              <a:t>Money, stage, jobs</a:t>
             </a:r>
           </a:p>
         </p:txBody>
@@ -7840,7 +7840,7 @@
         <p:spPr>
           <a:xfrm>
             <a:off x="640080" y="1920240"/>
-            <a:ext cx="5760720" cy="4389120"/>
+            <a:ext cx="5486400" cy="4389120"/>
           </a:xfrm>
           <a:prstGeom prst="rect">
             <a:avLst/>
@@ -7865,7 +7865,7 @@
                 </a:solidFill>
                 <a:latin typeface="Arial"/>
               </a:rPr>
-              <a:t>$100K pool. Finals at Combine.</a:t>
+              <a:t>A $100,000 prize pool.</a:t>
             </a:r>
           </a:p>
           <a:p>
@@ -7881,7 +7881,7 @@
                 </a:solidFill>
                 <a:latin typeface="Arial"/>
               </a:rPr>
-              <a:t>8,329 registered. 771 teams.</a:t>
+              <a:t>Finals at the Scouting Combine.</a:t>
             </a:r>
           </a:p>
           <a:p>
@@ -7897,7 +7897,7 @@
                 </a:solidFill>
                 <a:latin typeface="Arial"/>
               </a:rPr>
-              <a:t>50+ hired. 30+ by teams.</a:t>
+              <a:t>8,329 entered. 50-plus hired.</a:t>
             </a:r>
           </a:p>
         </p:txBody>
@@ -7918,8 +7918,8 @@
         </p:blipFill>
         <p:spPr>
           <a:xfrm>
-            <a:off x="6793992" y="2629086"/>
-            <a:ext cx="4846320" cy="2697108"/>
+            <a:off x="7068312" y="2629086"/>
+            <a:ext cx="4663440" cy="2623185"/>
           </a:xfrm>
           <a:prstGeom prst="rect">
             <a:avLst/>
@@ -8140,7 +8140,7 @@
         <p:spPr>
           <a:xfrm>
             <a:off x="640080" y="1920240"/>
-            <a:ext cx="5760720" cy="4389120"/>
+            <a:ext cx="5486400" cy="4389120"/>
           </a:xfrm>
           <a:prstGeom prst="rect">
             <a:avLst/>
@@ -8165,7 +8165,7 @@
                 </a:solidFill>
                 <a:latin typeface="Arial"/>
               </a:rPr>
-              <a:t>2020: Zoo predicts rush yards.</a:t>
+              <a:t>2020 winners predicted rush yards.</a:t>
             </a:r>
           </a:p>
           <a:p>
@@ -8181,7 +8181,7 @@
                 </a:solidFill>
                 <a:latin typeface="Arial"/>
               </a:rPr>
-              <a:t>On TV within ~6 months.</a:t>
+              <a:t>On TV within six months.</a:t>
             </a:r>
           </a:p>
           <a:p>
@@ -8197,7 +8197,7 @@
                 </a:solidFill>
                 <a:latin typeface="Arial"/>
               </a:rPr>
-              <a:t>Pressure (90K plays). Tackles (20x11).</a:t>
+              <a:t>Pressure, then tackles, on TV.</a:t>
             </a:r>
           </a:p>
         </p:txBody>
@@ -8218,8 +8218,8 @@
         </p:blipFill>
         <p:spPr>
           <a:xfrm>
-            <a:off x="6793992" y="2614613"/>
-            <a:ext cx="4846320" cy="2726054"/>
+            <a:off x="7068312" y="2614613"/>
+            <a:ext cx="4663440" cy="2623185"/>
           </a:xfrm>
           <a:prstGeom prst="rect">
             <a:avLst/>
@@ -8426,7 +8426,7 @@
                 </a:solidFill>
                 <a:latin typeface="Cinzel"/>
               </a:rPr>
-              <a:t>Everyone tracked. 10x a second.</a:t>
+              <a:t>Every player, ten times a second</a:t>
             </a:r>
           </a:p>
         </p:txBody>
@@ -8440,7 +8440,7 @@
         <p:spPr>
           <a:xfrm>
             <a:off x="640080" y="1920240"/>
-            <a:ext cx="5760720" cy="4389120"/>
+            <a:ext cx="5486400" cy="4389120"/>
           </a:xfrm>
           <a:prstGeom prst="rect">
             <a:avLst/>
@@ -8465,7 +8465,7 @@
                 </a:solidFill>
                 <a:latin typeface="Arial"/>
               </a:rPr>
-              <a:t>RFID tags + sensor ball. Zebra.</a:t>
+              <a:t>Shoulder-pad tags plus sensor ball.</a:t>
             </a:r>
           </a:p>
           <a:p>
@@ -8481,7 +8481,7 @@
                 </a:solidFill>
                 <a:latin typeface="Arial"/>
               </a:rPr>
-              <a:t>x/y, speed, accel, event, IDs.</a:t>
+              <a:t>Position, speed, direction per row.</a:t>
             </a:r>
           </a:p>
           <a:p>
@@ -8497,7 +8497,7 @@
                 </a:solidFill>
                 <a:latin typeface="Arial"/>
               </a:rPr>
-              <a:t>Weeks ~1.5 GB. Demo: 25 plays.</a:t>
+              <a:t>One week fills 1.5 gigabytes.</a:t>
             </a:r>
           </a:p>
         </p:txBody>
@@ -8518,8 +8518,8 @@
         </p:blipFill>
         <p:spPr>
           <a:xfrm>
-            <a:off x="6793992" y="2607401"/>
-            <a:ext cx="4846320" cy="2740478"/>
+            <a:off x="7068312" y="2607401"/>
+            <a:ext cx="4663440" cy="2623185"/>
           </a:xfrm>
           <a:prstGeom prst="rect">
             <a:avLst/>
@@ -8726,7 +8726,7 @@
                 </a:solidFill>
                 <a:latin typeface="Cinzel"/>
               </a:rPr>
-              <a:t>Workflow 1: sample first</a:t>
+              <a:t>Start small: 25 plays</a:t>
             </a:r>
           </a:p>
         </p:txBody>
@@ -8740,7 +8740,7 @@
         <p:spPr>
           <a:xfrm>
             <a:off x="640080" y="1920240"/>
-            <a:ext cx="5760720" cy="4389120"/>
+            <a:ext cx="5486400" cy="4389120"/>
           </a:xfrm>
           <a:prstGeom prst="rect">
             <a:avLst/>
@@ -8765,7 +8765,7 @@
                 </a:solidFill>
                 <a:latin typeface="Arial"/>
               </a:rPr>
-              <a:t>19,113 rows. 25 plays.</a:t>
+              <a:t>19,113 rows. Zero download.</a:t>
             </a:r>
           </a:p>
           <a:p>
@@ -8781,7 +8781,7 @@
                 </a:solidFill>
                 <a:latin typeface="Arial"/>
               </a:rPr>
-              <a:t>Join, print, plot 22 + ball.</a:t>
+              <a:t>Join four tables. Plot one play.</a:t>
             </a:r>
           </a:p>
           <a:p>
@@ -8797,7 +8797,7 @@
                 </a:solidFill>
                 <a:latin typeface="Arial"/>
               </a:rPr>
-              <a:t>x 0-120. y 0-53.3. Angles 360.</a:t>
+              <a:t>Field is 120 yards by 53.</a:t>
             </a:r>
           </a:p>
         </p:txBody>
@@ -8818,8 +8818,8 @@
         </p:blipFill>
         <p:spPr>
           <a:xfrm>
-            <a:off x="6793992" y="2613931"/>
-            <a:ext cx="4846320" cy="2727418"/>
+            <a:off x="7068312" y="2613931"/>
+            <a:ext cx="4663440" cy="2640672"/>
           </a:xfrm>
           <a:prstGeom prst="rect">
             <a:avLst/>
@@ -9026,7 +9026,7 @@
                 </a:solidFill>
                 <a:latin typeface="Cinzel"/>
               </a:rPr>
-              <a:t>Workflow 2: Parquet once</a:t>
+              <a:t>Shrink weeks once, reuse forever</a:t>
             </a:r>
           </a:p>
         </p:txBody>
@@ -9040,7 +9040,7 @@
         <p:spPr>
           <a:xfrm>
             <a:off x="640080" y="1920240"/>
-            <a:ext cx="5760720" cy="4389120"/>
+            <a:ext cx="5486400" cy="4389120"/>
           </a:xfrm>
           <a:prstGeom prst="rect">
             <a:avLst/>
@@ -9065,7 +9065,7 @@
                 </a:solidFill>
                 <a:latin typeface="Arial"/>
               </a:rPr>
-              <a:t>Weeks exceed RAM. Chunk 200K.</a:t>
+              <a:t>Weeks exceed memory. Chunk it.</a:t>
             </a:r>
           </a:p>
           <a:p>
@@ -9081,7 +9081,7 @@
                 </a:solidFill>
                 <a:latin typeface="Arial"/>
               </a:rPr>
-              <a:t>Convert to Parquet one time.</a:t>
+              <a:t>Convert each week one time.</a:t>
             </a:r>
           </a:p>
           <a:p>
@@ -9097,7 +9097,7 @@
                 </a:solidFill>
                 <a:latin typeface="Arial"/>
               </a:rPr>
-              <a:t>Raw read-only. Out to scratch/.</a:t>
+              <a:t>Raw files stay untouched.</a:t>
             </a:r>
           </a:p>
         </p:txBody>
@@ -9118,8 +9118,8 @@
         </p:blipFill>
         <p:spPr>
           <a:xfrm>
-            <a:off x="6793992" y="2607401"/>
-            <a:ext cx="4846320" cy="2740478"/>
+            <a:off x="7068312" y="2607401"/>
+            <a:ext cx="4663440" cy="2331720"/>
           </a:xfrm>
           <a:prstGeom prst="rect">
             <a:avLst/>
@@ -9326,7 +9326,7 @@
                 </a:solidFill>
                 <a:latin typeface="Cinzel"/>
               </a:rPr>
-              <a:t>Workflow 3: features frame-up</a:t>
+              <a:t>Turn frames into one number</a:t>
             </a:r>
           </a:p>
         </p:txBody>
@@ -9340,7 +9340,7 @@
         <p:spPr>
           <a:xfrm>
             <a:off x="640080" y="1920240"/>
-            <a:ext cx="5760720" cy="4389120"/>
+            <a:ext cx="5486400" cy="4389120"/>
           </a:xfrm>
           <a:prstGeom prst="rect">
             <a:avLst/>
@@ -9365,7 +9365,7 @@
                 </a:solidFill>
                 <a:latin typeface="Arial"/>
               </a:rPr>
-              <a:t>Frames -&gt; players -&gt; one stat.</a:t>
+              <a:t>Speed, direction, formations.</a:t>
             </a:r>
           </a:p>
           <a:p>
@@ -9381,7 +9381,7 @@
                 </a:solidFill>
                 <a:latin typeface="Arial"/>
               </a:rPr>
-              <a:t>Speed. Accel. Line distance.</a:t>
+              <a:t>One model per player, then one stat.</a:t>
             </a:r>
           </a:p>
           <a:p>
@@ -9397,7 +9397,7 @@
                 </a:solidFill>
                 <a:latin typeface="Arial"/>
               </a:rPr>
-              <a:t>Convnets. LightGBM wins.</a:t>
+              <a:t>Tackle chance leads the demo.</a:t>
             </a:r>
           </a:p>
         </p:txBody>
@@ -9418,8 +9418,8 @@
         </p:blipFill>
         <p:spPr>
           <a:xfrm>
-            <a:off x="6793992" y="2362200"/>
-            <a:ext cx="4846320" cy="3230880"/>
+            <a:off x="7068312" y="2362200"/>
+            <a:ext cx="4663440" cy="3248327"/>
           </a:xfrm>
           <a:prstGeom prst="rect">
             <a:avLst/>
@@ -9626,7 +9626,7 @@
                 </a:solidFill>
                 <a:latin typeface="Cinzel"/>
               </a:rPr>
-              <a:t>Workflow 4: baseline first</a:t>
+              <a:t>Beat a simple model first</a:t>
             </a:r>
           </a:p>
         </p:txBody>
@@ -9640,7 +9640,7 @@
         <p:spPr>
           <a:xfrm>
             <a:off x="640080" y="1920240"/>
-            <a:ext cx="5760720" cy="4389120"/>
+            <a:ext cx="5486400" cy="4389120"/>
           </a:xfrm>
           <a:prstGeom prst="rect">
             <a:avLst/>
@@ -9665,7 +9665,7 @@
                 </a:solidFill>
                 <a:latin typeface="Arial"/>
               </a:rPr>
-              <a:t>Lasso-logistic: .700 +/- .110.</a:t>
+              <a:t>Simple model scores .700.</a:t>
             </a:r>
           </a:p>
           <a:p>
@@ -9681,7 +9681,7 @@
                 </a:solidFill>
                 <a:latin typeface="Arial"/>
               </a:rPr>
-              <a:t>Folds grouped by play.</a:t>
+              <a:t>Keep each play in one piece.</a:t>
             </a:r>
           </a:p>
           <a:p>
@@ -9697,7 +9697,7 @@
                 </a:solidFill>
                 <a:latin typeface="Arial"/>
               </a:rPr>
-              <a:t>Beat it by 1 SE or die.</a:t>
+              <a:t>Fancy models must beat it clearly.</a:t>
             </a:r>
           </a:p>
         </p:txBody>
@@ -9718,8 +9718,8 @@
         </p:blipFill>
         <p:spPr>
           <a:xfrm>
-            <a:off x="6793992" y="2523744"/>
-            <a:ext cx="4846320" cy="2907791"/>
+            <a:off x="7068312" y="2523744"/>
+            <a:ext cx="4663440" cy="2623185"/>
           </a:xfrm>
           <a:prstGeom prst="rect">
             <a:avLst/>

</xml_diff>

<commit_message>
deck: 5 backup slides 18-22 plus attendee handout
</commit_message>
<xml_diff>
--- a/deck/unified.pptx
+++ b/deck/unified.pptx
@@ -22,6 +22,11 @@
     <p:sldId id="270" r:id="rId21"/>
     <p:sldId id="271" r:id="rId22"/>
     <p:sldId id="272" r:id="rId23"/>
+    <p:sldId id="273" r:id="rId25"/>
+    <p:sldId id="274" r:id="rId26"/>
+    <p:sldId id="275" r:id="rId27"/>
+    <p:sldId id="276" r:id="rId28"/>
+    <p:sldId id="277" r:id="rId29"/>
   </p:sldIdLst>
   <p:sldSz cx="12191695" cy="6858000" type="screen4x3"/>
   <p:notesSz cx="6858000" cy="9144000"/>
@@ -1103,6 +1108,154 @@
 </p:notes>
 </file>
 
+<file path=ppt/notesSlides/notesSlide18.xml><?xml version="1.0" encoding="utf-8"?>
+<p:notes xmlns:a="http://schemas.openxmlformats.org/drawingml/2006/main" xmlns:p="http://schemas.openxmlformats.org/presentationml/2006/main" xmlns:r="http://schemas.openxmlformats.org/officeDocument/2006/relationships">
+  <p:cSld>
+    <p:spTree>
+      <p:nvGrpSpPr>
+        <p:cNvPr id="1" name=""/>
+        <p:cNvGrpSpPr/>
+        <p:nvPr/>
+      </p:nvGrpSpPr>
+      <p:grpSpPr>
+        <a:xfrm>
+          <a:off x="0" y="0"/>
+          <a:ext cx="0" cy="0"/>
+          <a:chOff x="0" y="0"/>
+          <a:chExt cx="0" cy="0"/>
+        </a:xfrm>
+      </p:grpSpPr>
+      <p:sp>
+        <p:nvSpPr>
+          <p:cNvPr id="2" name="Slide Image Placeholder 1"/>
+          <p:cNvSpPr>
+            <a:spLocks noGrp="1"/>
+          </p:cNvSpPr>
+          <p:nvPr>
+            <p:ph type="sldImg" idx="2"/>
+          </p:nvPr>
+        </p:nvSpPr>
+        <p:spPr/>
+        <p:txBody>
+          <a:bodyPr/>
+          <a:p>
+            <a:r>
+              <a:t>Say: the local box is busy, so the cloud covers this one. The recorded cold-start plus contention numbers stand in.</a:t>
+            </a:r>
+          </a:p>
+        </p:txBody>
+      </p:sp>
+      <p:sp>
+        <p:nvSpPr>
+          <p:cNvPr id="3" name="Notes Placeholder 2"/>
+          <p:cNvSpPr>
+            <a:spLocks noGrp="1"/>
+          </p:cNvSpPr>
+          <p:nvPr>
+            <p:ph type="body" idx="3" sz="quarter"/>
+          </p:nvPr>
+        </p:nvSpPr>
+        <p:spPr/>
+        <p:txBody>
+          <a:bodyPr/>
+          <a:lstStyle/>
+          <a:p/>
+        </p:txBody>
+      </p:sp>
+      <p:sp>
+        <p:nvSpPr>
+          <p:cNvPr id="4" name="Slide Number Placeholder 3"/>
+          <p:cNvSpPr>
+            <a:spLocks noGrp="1"/>
+          </p:cNvSpPr>
+          <p:nvPr>
+            <p:ph type="sldNum" idx="5" sz="quarter"/>
+          </p:nvPr>
+        </p:nvSpPr>
+        <p:spPr/>
+      </p:sp>
+    </p:spTree>
+  </p:cSld>
+  <p:clrMapOvr>
+    <a:masterClrMapping/>
+  </p:clrMapOvr>
+</p:notes>
+</file>
+
+<file path=ppt/notesSlides/notesSlide19.xml><?xml version="1.0" encoding="utf-8"?>
+<p:notes xmlns:a="http://schemas.openxmlformats.org/drawingml/2006/main" xmlns:p="http://schemas.openxmlformats.org/presentationml/2006/main" xmlns:r="http://schemas.openxmlformats.org/officeDocument/2006/relationships">
+  <p:cSld>
+    <p:spTree>
+      <p:nvGrpSpPr>
+        <p:cNvPr id="1" name=""/>
+        <p:cNvGrpSpPr/>
+        <p:nvPr/>
+      </p:nvGrpSpPr>
+      <p:grpSpPr>
+        <a:xfrm>
+          <a:off x="0" y="0"/>
+          <a:ext cx="0" cy="0"/>
+          <a:chOff x="0" y="0"/>
+          <a:chExt cx="0" cy="0"/>
+        </a:xfrm>
+      </p:grpSpPr>
+      <p:sp>
+        <p:nvSpPr>
+          <p:cNvPr id="2" name="Slide Image Placeholder 1"/>
+          <p:cNvSpPr>
+            <a:spLocks noGrp="1"/>
+          </p:cNvSpPr>
+          <p:nvPr>
+            <p:ph type="sldImg" idx="2"/>
+          </p:nvPr>
+        </p:nvSpPr>
+        <p:spPr/>
+        <p:txBody>
+          <a:bodyPr/>
+          <a:p>
+            <a:r>
+              <a:t>Say: auth expired, I stop rather than route around it. Everything read-only keeps running.</a:t>
+            </a:r>
+          </a:p>
+        </p:txBody>
+      </p:sp>
+      <p:sp>
+        <p:nvSpPr>
+          <p:cNvPr id="3" name="Notes Placeholder 2"/>
+          <p:cNvSpPr>
+            <a:spLocks noGrp="1"/>
+          </p:cNvSpPr>
+          <p:nvPr>
+            <p:ph type="body" idx="3" sz="quarter"/>
+          </p:nvPr>
+        </p:nvSpPr>
+        <p:spPr/>
+        <p:txBody>
+          <a:bodyPr/>
+          <a:lstStyle/>
+          <a:p/>
+        </p:txBody>
+      </p:sp>
+      <p:sp>
+        <p:nvSpPr>
+          <p:cNvPr id="4" name="Slide Number Placeholder 3"/>
+          <p:cNvSpPr>
+            <a:spLocks noGrp="1"/>
+          </p:cNvSpPr>
+          <p:nvPr>
+            <p:ph type="sldNum" idx="5" sz="quarter"/>
+          </p:nvPr>
+        </p:nvSpPr>
+        <p:spPr/>
+      </p:sp>
+    </p:spTree>
+  </p:cSld>
+  <p:clrMapOvr>
+    <a:masterClrMapping/>
+  </p:clrMapOvr>
+</p:notes>
+</file>
+
 <file path=ppt/notesSlides/notesSlide2.xml><?xml version="1.0" encoding="utf-8"?>
 <p:notes xmlns:a="http://schemas.openxmlformats.org/drawingml/2006/main" xmlns:p="http://schemas.openxmlformats.org/presentationml/2006/main" xmlns:r="http://schemas.openxmlformats.org/officeDocument/2006/relationships">
   <p:cSld>
@@ -1151,6 +1304,228 @@
               <a:t>Open by naming the prize in plain terms: a stat you invent here can end up on live TV. Walk the four facts in order: who runs it, what the data is, where winners go, and where we stand now. Pause on the 10-hertz figure and translate it (ten snapshots per second per player). Close with the honest caveat: eight editions 2019-2026 per docs/history.md; 2027 topic unannounced as of Sep 2026 per docs/2027-prediction.md. Transition: next slide shows the scale of the tracking data. Definitions: NFL Football Operations = the league office group that runs the contest; Next Gen Stats = the league's player-tracking data system; hertz = measurements per second.</a:t>
             </a:r>
           </a:p>
+        </p:txBody>
+      </p:sp>
+      <p:sp>
+        <p:nvSpPr>
+          <p:cNvPr id="4" name="Slide Number Placeholder 3"/>
+          <p:cNvSpPr>
+            <a:spLocks noGrp="1"/>
+          </p:cNvSpPr>
+          <p:nvPr>
+            <p:ph type="sldNum" idx="5" sz="quarter"/>
+          </p:nvPr>
+        </p:nvSpPr>
+        <p:spPr/>
+      </p:sp>
+    </p:spTree>
+  </p:cSld>
+  <p:clrMapOvr>
+    <a:masterClrMapping/>
+  </p:clrMapOvr>
+</p:notes>
+</file>
+
+<file path=ppt/notesSlides/notesSlide20.xml><?xml version="1.0" encoding="utf-8"?>
+<p:notes xmlns:a="http://schemas.openxmlformats.org/drawingml/2006/main" xmlns:p="http://schemas.openxmlformats.org/presentationml/2006/main" xmlns:r="http://schemas.openxmlformats.org/officeDocument/2006/relationships">
+  <p:cSld>
+    <p:spTree>
+      <p:nvGrpSpPr>
+        <p:cNvPr id="1" name=""/>
+        <p:cNvGrpSpPr/>
+        <p:nvPr/>
+      </p:nvGrpSpPr>
+      <p:grpSpPr>
+        <a:xfrm>
+          <a:off x="0" y="0"/>
+          <a:ext cx="0" cy="0"/>
+          <a:chOff x="0" y="0"/>
+          <a:chExt cx="0" cy="0"/>
+        </a:xfrm>
+      </p:grpSpPr>
+      <p:sp>
+        <p:nvSpPr>
+          <p:cNvPr id="2" name="Slide Image Placeholder 1"/>
+          <p:cNvSpPr>
+            <a:spLocks noGrp="1"/>
+          </p:cNvSpPr>
+          <p:nvPr>
+            <p:ph type="sldImg" idx="2"/>
+          </p:nvPr>
+        </p:nvSpPr>
+        <p:spPr/>
+        <p:txBody>
+          <a:bodyPr/>
+          <a:p>
+            <a:r>
+              <a:t>Say: the full sweep broke, so here is the same pipeline on the in-git sample slice.</a:t>
+            </a:r>
+          </a:p>
+        </p:txBody>
+      </p:sp>
+      <p:sp>
+        <p:nvSpPr>
+          <p:cNvPr id="3" name="Notes Placeholder 2"/>
+          <p:cNvSpPr>
+            <a:spLocks noGrp="1"/>
+          </p:cNvSpPr>
+          <p:nvPr>
+            <p:ph type="body" idx="3" sz="quarter"/>
+          </p:nvPr>
+        </p:nvSpPr>
+        <p:spPr/>
+        <p:txBody>
+          <a:bodyPr/>
+          <a:lstStyle/>
+          <a:p/>
+        </p:txBody>
+      </p:sp>
+      <p:sp>
+        <p:nvSpPr>
+          <p:cNvPr id="4" name="Slide Number Placeholder 3"/>
+          <p:cNvSpPr>
+            <a:spLocks noGrp="1"/>
+          </p:cNvSpPr>
+          <p:nvPr>
+            <p:ph type="sldNum" idx="5" sz="quarter"/>
+          </p:nvPr>
+        </p:nvSpPr>
+        <p:spPr/>
+      </p:sp>
+    </p:spTree>
+  </p:cSld>
+  <p:clrMapOvr>
+    <a:masterClrMapping/>
+  </p:clrMapOvr>
+</p:notes>
+</file>
+
+<file path=ppt/notesSlides/notesSlide21.xml><?xml version="1.0" encoding="utf-8"?>
+<p:notes xmlns:a="http://schemas.openxmlformats.org/drawingml/2006/main" xmlns:p="http://schemas.openxmlformats.org/presentationml/2006/main" xmlns:r="http://schemas.openxmlformats.org/officeDocument/2006/relationships">
+  <p:cSld>
+    <p:spTree>
+      <p:nvGrpSpPr>
+        <p:cNvPr id="1" name=""/>
+        <p:cNvGrpSpPr/>
+        <p:nvPr/>
+      </p:nvGrpSpPr>
+      <p:grpSpPr>
+        <a:xfrm>
+          <a:off x="0" y="0"/>
+          <a:ext cx="0" cy="0"/>
+          <a:chOff x="0" y="0"/>
+          <a:chExt cx="0" cy="0"/>
+        </a:xfrm>
+      </p:grpSpPr>
+      <p:sp>
+        <p:nvSpPr>
+          <p:cNvPr id="2" name="Slide Image Placeholder 1"/>
+          <p:cNvSpPr>
+            <a:spLocks noGrp="1"/>
+          </p:cNvSpPr>
+          <p:nvPr>
+            <p:ph type="sldImg" idx="2"/>
+          </p:nvPr>
+        </p:nvSpPr>
+        <p:spPr/>
+        <p:txBody>
+          <a:bodyPr/>
+          <a:p>
+            <a:r>
+              <a:t>Say: a 404 before first deploy is the correct answer. Watch it flip after the sync.</a:t>
+            </a:r>
+          </a:p>
+        </p:txBody>
+      </p:sp>
+      <p:sp>
+        <p:nvSpPr>
+          <p:cNvPr id="3" name="Notes Placeholder 2"/>
+          <p:cNvSpPr>
+            <a:spLocks noGrp="1"/>
+          </p:cNvSpPr>
+          <p:nvPr>
+            <p:ph type="body" idx="3" sz="quarter"/>
+          </p:nvPr>
+        </p:nvSpPr>
+        <p:spPr/>
+        <p:txBody>
+          <a:bodyPr/>
+          <a:lstStyle/>
+          <a:p/>
+        </p:txBody>
+      </p:sp>
+      <p:sp>
+        <p:nvSpPr>
+          <p:cNvPr id="4" name="Slide Number Placeholder 3"/>
+          <p:cNvSpPr>
+            <a:spLocks noGrp="1"/>
+          </p:cNvSpPr>
+          <p:nvPr>
+            <p:ph type="sldNum" idx="5" sz="quarter"/>
+          </p:nvPr>
+        </p:nvSpPr>
+        <p:spPr/>
+      </p:sp>
+    </p:spTree>
+  </p:cSld>
+  <p:clrMapOvr>
+    <a:masterClrMapping/>
+  </p:clrMapOvr>
+</p:notes>
+</file>
+
+<file path=ppt/notesSlides/notesSlide22.xml><?xml version="1.0" encoding="utf-8"?>
+<p:notes xmlns:a="http://schemas.openxmlformats.org/drawingml/2006/main" xmlns:p="http://schemas.openxmlformats.org/presentationml/2006/main" xmlns:r="http://schemas.openxmlformats.org/officeDocument/2006/relationships">
+  <p:cSld>
+    <p:spTree>
+      <p:nvGrpSpPr>
+        <p:cNvPr id="1" name=""/>
+        <p:cNvGrpSpPr/>
+        <p:nvPr/>
+      </p:nvGrpSpPr>
+      <p:grpSpPr>
+        <a:xfrm>
+          <a:off x="0" y="0"/>
+          <a:ext cx="0" cy="0"/>
+          <a:chOff x="0" y="0"/>
+          <a:chExt cx="0" cy="0"/>
+        </a:xfrm>
+      </p:grpSpPr>
+      <p:sp>
+        <p:nvSpPr>
+          <p:cNvPr id="2" name="Slide Image Placeholder 1"/>
+          <p:cNvSpPr>
+            <a:spLocks noGrp="1"/>
+          </p:cNvSpPr>
+          <p:nvPr>
+            <p:ph type="sldImg" idx="2"/>
+          </p:nvPr>
+        </p:nvSpPr>
+        <p:spPr/>
+        <p:txBody>
+          <a:bodyPr/>
+          <a:p>
+            <a:r>
+              <a:t>Say: the lock only works if everyone honors it. Pre-show coordination is the real fix.</a:t>
+            </a:r>
+          </a:p>
+        </p:txBody>
+      </p:sp>
+      <p:sp>
+        <p:nvSpPr>
+          <p:cNvPr id="3" name="Notes Placeholder 2"/>
+          <p:cNvSpPr>
+            <a:spLocks noGrp="1"/>
+          </p:cNvSpPr>
+          <p:nvPr>
+            <p:ph type="body" idx="3" sz="quarter"/>
+          </p:nvPr>
+        </p:nvSpPr>
+        <p:spPr/>
+        <p:txBody>
+          <a:bodyPr/>
+          <a:lstStyle/>
+          <a:p/>
         </p:txBody>
       </p:sp>
       <p:sp>
@@ -7334,6 +7709,384 @@
 </p:sld>
 </file>
 
+<file path=ppt/slides/slide18.xml><?xml version="1.0" encoding="utf-8"?>
+<p:sld xmlns:a="http://schemas.openxmlformats.org/drawingml/2006/main" xmlns:p="http://schemas.openxmlformats.org/presentationml/2006/main" xmlns:r="http://schemas.openxmlformats.org/officeDocument/2006/relationships">
+  <p:cSld>
+    <p:bg>
+      <p:bgPr>
+        <a:solidFill>
+          <a:srgbClr val="00002A"/>
+        </a:solidFill>
+        <a:effectLst/>
+      </p:bgPr>
+    </p:bg>
+    <p:spTree>
+      <p:nvGrpSpPr>
+        <p:cNvPr id="1" name=""/>
+        <p:cNvGrpSpPr/>
+        <p:nvPr/>
+      </p:nvGrpSpPr>
+      <p:grpSpPr/>
+      <p:sp>
+        <p:nvSpPr>
+          <p:cNvPr id="2" name="TextBox 1"/>
+          <p:cNvSpPr txBox="1"/>
+          <p:nvPr/>
+        </p:nvSpPr>
+        <p:spPr>
+          <a:xfrm>
+            <a:off x="640080" y="320040"/>
+            <a:ext cx="10881360" cy="914400"/>
+          </a:xfrm>
+          <a:prstGeom prst="rect">
+            <a:avLst/>
+          </a:prstGeom>
+          <a:noFill/>
+        </p:spPr>
+        <p:txBody>
+          <a:bodyPr wrap="square">
+            <a:spAutoFit/>
+          </a:bodyPr>
+          <a:lstStyle/>
+          <a:p>
+            <a:r>
+              <a:rPr sz="3600" b="1">
+                <a:solidFill>
+                  <a:srgbClr val="D7C7EE"/>
+                </a:solidFill>
+                <a:latin typeface="Cinzel"/>
+              </a:rPr>
+              <a:t>Glimmer stays dark.</a:t>
+            </a:r>
+          </a:p>
+        </p:txBody>
+      </p:sp>
+      <p:sp>
+        <p:nvSpPr>
+          <p:cNvPr id="8" name="TextBox 5"/>
+          <p:cNvSpPr txBox="1"/>
+          <p:nvPr/>
+        </p:nvSpPr>
+        <p:spPr>
+          <a:xfrm>
+            <a:off x="640080" y="1920240"/>
+            <a:ext cx="3840480" cy="4206240"/>
+          </a:xfrm>
+          <a:prstGeom prst="rect">
+            <a:avLst/>
+          </a:prstGeom>
+          <a:noFill/>
+        </p:spPr>
+        <p:txBody>
+          <a:bodyPr wrap="square">
+            <a:noAutofit/>
+          </a:bodyPr>
+          <a:lstStyle/>
+          <a:p>
+            <a:pPr>
+              <a:spcAft>
+                <a:spcPts val="3400"/>
+              </a:spcAft>
+            </a:pPr>
+            <a:r>
+              <a:rPr sz="2400">
+                <a:solidFill>
+                  <a:srgbClr val="F0F0F0"/>
+                </a:solidFill>
+                <a:latin typeface="Arial"/>
+              </a:rPr>
+              <a:t>VRAM held elsewhere.</a:t>
+            </a:r>
+          </a:p>
+          <a:p>
+            <a:pPr>
+              <a:spcAft>
+                <a:spcPts val="3400"/>
+              </a:spcAft>
+            </a:pPr>
+            <a:r>
+              <a:rPr sz="2400">
+                <a:solidFill>
+                  <a:srgbClr val="F0F0F0"/>
+                </a:solidFill>
+                <a:latin typeface="Arial"/>
+              </a:rPr>
+              <a:t>Spark runs it live.</a:t>
+            </a:r>
+          </a:p>
+          <a:p>
+            <a:pPr>
+              <a:spcAft>
+                <a:spcPts val="3400"/>
+              </a:spcAft>
+            </a:pPr>
+            <a:r>
+              <a:rPr sz="2400">
+                <a:solidFill>
+                  <a:srgbClr val="F0F0F0"/>
+                </a:solidFill>
+                <a:latin typeface="Arial"/>
+              </a:rPr>
+              <a:t>Never kill sibling jobs.</a:t>
+            </a:r>
+          </a:p>
+        </p:txBody>
+      </p:sp>
+      <p:pic>
+        <p:nvPicPr>
+          <p:cNvPr id="4" name="Picture 3" descr="image.png"/>
+          <p:cNvPicPr>
+            <a:picLocks noChangeAspect="1"/>
+          </p:cNvPicPr>
+          <p:nvPr/>
+        </p:nvPicPr>
+        <p:blipFill>
+          <a:blip r:embed="rId2"/>
+          <a:stretch>
+            <a:fillRect/>
+          </a:stretch>
+        </p:blipFill>
+        <p:spPr>
+          <a:xfrm>
+            <a:off x="4965192" y="2103120"/>
+            <a:ext cx="6675120" cy="3758184"/>
+          </a:xfrm>
+          <a:prstGeom prst="rect">
+            <a:avLst/>
+          </a:prstGeom>
+        </p:spPr>
+      </p:pic>
+      <p:sp>
+        <p:nvSpPr>
+          <p:cNvPr id="5" name="TextBox 4"/>
+          <p:cNvSpPr txBox="1"/>
+          <p:nvPr/>
+        </p:nvSpPr>
+        <p:spPr>
+          <a:xfrm>
+            <a:off x="11430000" y="6309360"/>
+            <a:ext cx="548640" cy="301752"/>
+          </a:xfrm>
+          <a:prstGeom prst="rect">
+            <a:avLst/>
+          </a:prstGeom>
+          <a:noFill/>
+        </p:spPr>
+        <p:txBody>
+          <a:bodyPr wrap="square">
+            <a:spAutoFit/>
+          </a:bodyPr>
+          <a:lstStyle/>
+          <a:p>
+            <a:r>
+              <a:rPr sz="1200" b="0">
+                <a:solidFill>
+                  <a:srgbClr val="C9A23F"/>
+                </a:solidFill>
+                <a:latin typeface="Calibri"/>
+              </a:rPr>
+              <a:t>18</a:t>
+            </a:r>
+          </a:p>
+        </p:txBody>
+      </p:sp>
+    </p:spTree>
+  </p:cSld>
+  <p:clrMapOvr>
+    <a:masterClrMapping/>
+  </p:clrMapOvr>
+</p:sld>
+</file>
+
+<file path=ppt/slides/slide19.xml><?xml version="1.0" encoding="utf-8"?>
+<p:sld xmlns:a="http://schemas.openxmlformats.org/drawingml/2006/main" xmlns:p="http://schemas.openxmlformats.org/presentationml/2006/main" xmlns:r="http://schemas.openxmlformats.org/officeDocument/2006/relationships">
+  <p:cSld>
+    <p:bg>
+      <p:bgPr>
+        <a:solidFill>
+          <a:srgbClr val="00002A"/>
+        </a:solidFill>
+        <a:effectLst/>
+      </p:bgPr>
+    </p:bg>
+    <p:spTree>
+      <p:nvGrpSpPr>
+        <p:cNvPr id="1" name=""/>
+        <p:cNvGrpSpPr/>
+        <p:nvPr/>
+      </p:nvGrpSpPr>
+      <p:grpSpPr/>
+      <p:sp>
+        <p:nvSpPr>
+          <p:cNvPr id="2" name="TextBox 1"/>
+          <p:cNvSpPr txBox="1"/>
+          <p:nvPr/>
+        </p:nvSpPr>
+        <p:spPr>
+          <a:xfrm>
+            <a:off x="640080" y="320040"/>
+            <a:ext cx="10881360" cy="914400"/>
+          </a:xfrm>
+          <a:prstGeom prst="rect">
+            <a:avLst/>
+          </a:prstGeom>
+          <a:noFill/>
+        </p:spPr>
+        <p:txBody>
+          <a:bodyPr wrap="square">
+            <a:spAutoFit/>
+          </a:bodyPr>
+          <a:lstStyle/>
+          <a:p>
+            <a:r>
+              <a:rPr sz="3600" b="1">
+                <a:solidFill>
+                  <a:srgbClr val="D7C7EE"/>
+                </a:solidFill>
+                <a:latin typeface="Cinzel"/>
+              </a:rPr>
+              <a:t>SSO expired, full stop.</a:t>
+            </a:r>
+          </a:p>
+        </p:txBody>
+      </p:sp>
+      <p:sp>
+        <p:nvSpPr>
+          <p:cNvPr id="9" name="TextBox 5"/>
+          <p:cNvSpPr txBox="1"/>
+          <p:nvPr/>
+        </p:nvSpPr>
+        <p:spPr>
+          <a:xfrm>
+            <a:off x="640080" y="1920240"/>
+            <a:ext cx="3840480" cy="4206240"/>
+          </a:xfrm>
+          <a:prstGeom prst="rect">
+            <a:avLst/>
+          </a:prstGeom>
+          <a:noFill/>
+        </p:spPr>
+        <p:txBody>
+          <a:bodyPr wrap="square">
+            <a:noAutofit/>
+          </a:bodyPr>
+          <a:lstStyle/>
+          <a:p>
+            <a:pPr>
+              <a:spcAft>
+                <a:spcPts val="3400"/>
+              </a:spcAft>
+            </a:pPr>
+            <a:r>
+              <a:rPr sz="2400">
+                <a:solidFill>
+                  <a:srgbClr val="F0F0F0"/>
+                </a:solidFill>
+                <a:latin typeface="Arial"/>
+              </a:rPr>
+              <a:t>Mutations need live SSO.</a:t>
+            </a:r>
+          </a:p>
+          <a:p>
+            <a:pPr>
+              <a:spcAft>
+                <a:spcPts val="3400"/>
+              </a:spcAft>
+            </a:pPr>
+            <a:r>
+              <a:rPr sz="2400">
+                <a:solidFill>
+                  <a:srgbClr val="F0F0F0"/>
+                </a:solidFill>
+                <a:latin typeface="Arial"/>
+              </a:rPr>
+              <a:t>aws login, retry once.</a:t>
+            </a:r>
+          </a:p>
+          <a:p>
+            <a:pPr>
+              <a:spcAft>
+                <a:spcPts val="3400"/>
+              </a:spcAft>
+            </a:pPr>
+            <a:r>
+              <a:rPr sz="2400">
+                <a:solidFill>
+                  <a:srgbClr val="F0F0F0"/>
+                </a:solidFill>
+                <a:latin typeface="Arial"/>
+              </a:rPr>
+              <a:t>Read-only demos continue.</a:t>
+            </a:r>
+          </a:p>
+        </p:txBody>
+      </p:sp>
+      <p:pic>
+        <p:nvPicPr>
+          <p:cNvPr id="4" name="Picture 3" descr="image.png"/>
+          <p:cNvPicPr>
+            <a:picLocks noChangeAspect="1"/>
+          </p:cNvPicPr>
+          <p:nvPr/>
+        </p:nvPicPr>
+        <p:blipFill>
+          <a:blip r:embed="rId2"/>
+          <a:stretch>
+            <a:fillRect/>
+          </a:stretch>
+        </p:blipFill>
+        <p:spPr>
+          <a:xfrm>
+            <a:off x="4965192" y="2103120"/>
+            <a:ext cx="6675120" cy="3758184"/>
+          </a:xfrm>
+          <a:prstGeom prst="rect">
+            <a:avLst/>
+          </a:prstGeom>
+        </p:spPr>
+      </p:pic>
+      <p:sp>
+        <p:nvSpPr>
+          <p:cNvPr id="5" name="TextBox 4"/>
+          <p:cNvSpPr txBox="1"/>
+          <p:nvPr/>
+        </p:nvSpPr>
+        <p:spPr>
+          <a:xfrm>
+            <a:off x="11430000" y="6309360"/>
+            <a:ext cx="548640" cy="301752"/>
+          </a:xfrm>
+          <a:prstGeom prst="rect">
+            <a:avLst/>
+          </a:prstGeom>
+          <a:noFill/>
+        </p:spPr>
+        <p:txBody>
+          <a:bodyPr wrap="square">
+            <a:spAutoFit/>
+          </a:bodyPr>
+          <a:lstStyle/>
+          <a:p>
+            <a:r>
+              <a:rPr sz="1200" b="0">
+                <a:solidFill>
+                  <a:srgbClr val="C9A23F"/>
+                </a:solidFill>
+                <a:latin typeface="Calibri"/>
+              </a:rPr>
+              <a:t>19</a:t>
+            </a:r>
+          </a:p>
+        </p:txBody>
+      </p:sp>
+    </p:spTree>
+  </p:cSld>
+  <p:clrMapOvr>
+    <a:masterClrMapping/>
+  </p:clrMapOvr>
+</p:sld>
+</file>
+
 <file path=ppt/slides/slide2.xml><?xml version="1.0" encoding="utf-8"?>
 <p:sld xmlns:a="http://schemas.openxmlformats.org/drawingml/2006/main" xmlns:p="http://schemas.openxmlformats.org/presentationml/2006/main" xmlns:r="http://schemas.openxmlformats.org/officeDocument/2006/relationships">
   <p:cSld>
@@ -7626,6 +8379,573 @@
           </a:prstGeom>
         </p:spPr>
       </p:pic>
+    </p:spTree>
+  </p:cSld>
+  <p:clrMapOvr>
+    <a:masterClrMapping/>
+  </p:clrMapOvr>
+</p:sld>
+</file>
+
+<file path=ppt/slides/slide20.xml><?xml version="1.0" encoding="utf-8"?>
+<p:sld xmlns:a="http://schemas.openxmlformats.org/drawingml/2006/main" xmlns:p="http://schemas.openxmlformats.org/presentationml/2006/main" xmlns:r="http://schemas.openxmlformats.org/officeDocument/2006/relationships">
+  <p:cSld>
+    <p:bg>
+      <p:bgPr>
+        <a:solidFill>
+          <a:srgbClr val="00002A"/>
+        </a:solidFill>
+        <a:effectLst/>
+      </p:bgPr>
+    </p:bg>
+    <p:spTree>
+      <p:nvGrpSpPr>
+        <p:cNvPr id="1" name=""/>
+        <p:cNvGrpSpPr/>
+        <p:nvPr/>
+      </p:nvGrpSpPr>
+      <p:grpSpPr/>
+      <p:sp>
+        <p:nvSpPr>
+          <p:cNvPr id="2" name="TextBox 1"/>
+          <p:cNvSpPr txBox="1"/>
+          <p:nvPr/>
+        </p:nvSpPr>
+        <p:spPr>
+          <a:xfrm>
+            <a:off x="640080" y="320040"/>
+            <a:ext cx="10881360" cy="914400"/>
+          </a:xfrm>
+          <a:prstGeom prst="rect">
+            <a:avLst/>
+          </a:prstGeom>
+          <a:noFill/>
+        </p:spPr>
+        <p:txBody>
+          <a:bodyPr wrap="square">
+            <a:spAutoFit/>
+          </a:bodyPr>
+          <a:lstStyle/>
+          <a:p>
+            <a:r>
+              <a:rPr sz="3600" b="1">
+                <a:solidFill>
+                  <a:srgbClr val="D7C7EE"/>
+                </a:solidFill>
+                <a:latin typeface="Cinzel"/>
+              </a:rPr>
+              <a:t>Sweep dies, samples live.</a:t>
+            </a:r>
+          </a:p>
+        </p:txBody>
+      </p:sp>
+      <p:sp>
+        <p:nvSpPr>
+          <p:cNvPr id="10" name="TextBox 5"/>
+          <p:cNvSpPr txBox="1"/>
+          <p:nvPr/>
+        </p:nvSpPr>
+        <p:spPr>
+          <a:xfrm>
+            <a:off x="640080" y="1920240"/>
+            <a:ext cx="3840480" cy="4206240"/>
+          </a:xfrm>
+          <a:prstGeom prst="rect">
+            <a:avLst/>
+          </a:prstGeom>
+          <a:noFill/>
+        </p:spPr>
+        <p:txBody>
+          <a:bodyPr wrap="square">
+            <a:noAutofit/>
+          </a:bodyPr>
+          <a:lstStyle/>
+          <a:p>
+            <a:pPr>
+              <a:spcAft>
+                <a:spcPts val="3400"/>
+              </a:spcAft>
+            </a:pPr>
+            <a:r>
+              <a:rPr sz="2400">
+                <a:solidFill>
+                  <a:srgbClr val="F0F0F0"/>
+                </a:solidFill>
+                <a:latin typeface="Arial"/>
+              </a:rPr>
+              <a:t>Samples ship in git.</a:t>
+            </a:r>
+          </a:p>
+          <a:p>
+            <a:pPr>
+              <a:spcAft>
+                <a:spcPts val="3400"/>
+              </a:spcAft>
+            </a:pPr>
+            <a:r>
+              <a:rPr sz="2400">
+                <a:solidFill>
+                  <a:srgbClr val="F0F0F0"/>
+                </a:solidFill>
+                <a:latin typeface="Arial"/>
+              </a:rPr>
+              <a:t>Same scripts, smaller slice.</a:t>
+            </a:r>
+          </a:p>
+          <a:p>
+            <a:pPr>
+              <a:spcAft>
+                <a:spcPts val="3400"/>
+              </a:spcAft>
+            </a:pPr>
+            <a:r>
+              <a:rPr sz="2400">
+                <a:solidFill>
+                  <a:srgbClr val="F0F0F0"/>
+                </a:solidFill>
+                <a:latin typeface="Arial"/>
+              </a:rPr>
+              <a:t>Say so up front.</a:t>
+            </a:r>
+          </a:p>
+        </p:txBody>
+      </p:sp>
+      <p:pic>
+        <p:nvPicPr>
+          <p:cNvPr id="4" name="Picture 3" descr="image.png"/>
+          <p:cNvPicPr>
+            <a:picLocks noChangeAspect="1"/>
+          </p:cNvPicPr>
+          <p:nvPr/>
+        </p:nvPicPr>
+        <p:blipFill>
+          <a:blip r:embed="rId2"/>
+          <a:stretch>
+            <a:fillRect/>
+          </a:stretch>
+        </p:blipFill>
+        <p:spPr>
+          <a:xfrm>
+            <a:off x="4965192" y="2103120"/>
+            <a:ext cx="6675120" cy="3758184"/>
+          </a:xfrm>
+          <a:prstGeom prst="rect">
+            <a:avLst/>
+          </a:prstGeom>
+        </p:spPr>
+      </p:pic>
+      <p:sp>
+        <p:nvSpPr>
+          <p:cNvPr id="5" name="TextBox 4"/>
+          <p:cNvSpPr txBox="1"/>
+          <p:nvPr/>
+        </p:nvSpPr>
+        <p:spPr>
+          <a:xfrm>
+            <a:off x="11430000" y="6309360"/>
+            <a:ext cx="548640" cy="301752"/>
+          </a:xfrm>
+          <a:prstGeom prst="rect">
+            <a:avLst/>
+          </a:prstGeom>
+          <a:noFill/>
+        </p:spPr>
+        <p:txBody>
+          <a:bodyPr wrap="square">
+            <a:spAutoFit/>
+          </a:bodyPr>
+          <a:lstStyle/>
+          <a:p>
+            <a:r>
+              <a:rPr sz="1200" b="0">
+                <a:solidFill>
+                  <a:srgbClr val="C9A23F"/>
+                </a:solidFill>
+                <a:latin typeface="Calibri"/>
+              </a:rPr>
+              <a:t>20</a:t>
+            </a:r>
+          </a:p>
+        </p:txBody>
+      </p:sp>
+    </p:spTree>
+  </p:cSld>
+  <p:clrMapOvr>
+    <a:masterClrMapping/>
+  </p:clrMapOvr>
+</p:sld>
+</file>
+
+<file path=ppt/slides/slide21.xml><?xml version="1.0" encoding="utf-8"?>
+<p:sld xmlns:a="http://schemas.openxmlformats.org/drawingml/2006/main" xmlns:p="http://schemas.openxmlformats.org/presentationml/2006/main" xmlns:r="http://schemas.openxmlformats.org/officeDocument/2006/relationships">
+  <p:cSld>
+    <p:bg>
+      <p:bgPr>
+        <a:solidFill>
+          <a:srgbClr val="00002A"/>
+        </a:solidFill>
+        <a:effectLst/>
+      </p:bgPr>
+    </p:bg>
+    <p:spTree>
+      <p:nvGrpSpPr>
+        <p:cNvPr id="1" name=""/>
+        <p:cNvGrpSpPr/>
+        <p:nvPr/>
+      </p:nvGrpSpPr>
+      <p:grpSpPr/>
+      <p:sp>
+        <p:nvSpPr>
+          <p:cNvPr id="2" name="TextBox 1"/>
+          <p:cNvSpPr txBox="1"/>
+          <p:nvPr/>
+        </p:nvSpPr>
+        <p:spPr>
+          <a:xfrm>
+            <a:off x="640080" y="320040"/>
+            <a:ext cx="10881360" cy="914400"/>
+          </a:xfrm>
+          <a:prstGeom prst="rect">
+            <a:avLst/>
+          </a:prstGeom>
+          <a:noFill/>
+        </p:spPr>
+        <p:txBody>
+          <a:bodyPr wrap="square">
+            <a:spAutoFit/>
+          </a:bodyPr>
+          <a:lstStyle/>
+          <a:p>
+            <a:r>
+              <a:rPr sz="3600" b="1">
+                <a:solidFill>
+                  <a:srgbClr val="D7C7EE"/>
+                </a:solidFill>
+                <a:latin typeface="Cinzel"/>
+              </a:rPr>
+              <a:t>404 is expected.</a:t>
+            </a:r>
+          </a:p>
+        </p:txBody>
+      </p:sp>
+      <p:sp>
+        <p:nvSpPr>
+          <p:cNvPr id="11" name="TextBox 5"/>
+          <p:cNvSpPr txBox="1"/>
+          <p:nvPr/>
+        </p:nvSpPr>
+        <p:spPr>
+          <a:xfrm>
+            <a:off x="640080" y="1920240"/>
+            <a:ext cx="3840480" cy="4206240"/>
+          </a:xfrm>
+          <a:prstGeom prst="rect">
+            <a:avLst/>
+          </a:prstGeom>
+          <a:noFill/>
+        </p:spPr>
+        <p:txBody>
+          <a:bodyPr wrap="square">
+            <a:noAutofit/>
+          </a:bodyPr>
+          <a:lstStyle/>
+          <a:p>
+            <a:pPr>
+              <a:spcAft>
+                <a:spcPts val="3400"/>
+              </a:spcAft>
+            </a:pPr>
+            <a:r>
+              <a:rPr sz="2400">
+                <a:solidFill>
+                  <a:srgbClr val="F0F0F0"/>
+                </a:solidFill>
+                <a:latin typeface="Arial"/>
+              </a:rPr>
+              <a:t>Prefix empty until deploy.</a:t>
+            </a:r>
+          </a:p>
+          <a:p>
+            <a:pPr>
+              <a:spcAft>
+                <a:spcPts val="3400"/>
+              </a:spcAft>
+            </a:pPr>
+            <a:r>
+              <a:rPr sz="2400">
+                <a:solidFill>
+                  <a:srgbClr val="F0F0F0"/>
+                </a:solidFill>
+                <a:latin typeface="Arial"/>
+              </a:rPr>
+              <a:t>Dist verified pre-show.</a:t>
+            </a:r>
+          </a:p>
+          <a:p>
+            <a:pPr>
+              <a:spcAft>
+                <a:spcPts val="3400"/>
+              </a:spcAft>
+            </a:pPr>
+            <a:r>
+              <a:rPr sz="2400">
+                <a:solidFill>
+                  <a:srgbClr val="F0F0F0"/>
+                </a:solidFill>
+                <a:latin typeface="Arial"/>
+              </a:rPr>
+              <a:t>Curl proves it after.</a:t>
+            </a:r>
+          </a:p>
+        </p:txBody>
+      </p:sp>
+      <p:pic>
+        <p:nvPicPr>
+          <p:cNvPr id="4" name="Picture 3" descr="image.png"/>
+          <p:cNvPicPr>
+            <a:picLocks noChangeAspect="1"/>
+          </p:cNvPicPr>
+          <p:nvPr/>
+        </p:nvPicPr>
+        <p:blipFill>
+          <a:blip r:embed="rId2"/>
+          <a:stretch>
+            <a:fillRect/>
+          </a:stretch>
+        </p:blipFill>
+        <p:spPr>
+          <a:xfrm>
+            <a:off x="4965192" y="2103120"/>
+            <a:ext cx="6675120" cy="3758184"/>
+          </a:xfrm>
+          <a:prstGeom prst="rect">
+            <a:avLst/>
+          </a:prstGeom>
+        </p:spPr>
+      </p:pic>
+      <p:sp>
+        <p:nvSpPr>
+          <p:cNvPr id="5" name="TextBox 4"/>
+          <p:cNvSpPr txBox="1"/>
+          <p:nvPr/>
+        </p:nvSpPr>
+        <p:spPr>
+          <a:xfrm>
+            <a:off x="11430000" y="6309360"/>
+            <a:ext cx="548640" cy="301752"/>
+          </a:xfrm>
+          <a:prstGeom prst="rect">
+            <a:avLst/>
+          </a:prstGeom>
+          <a:noFill/>
+        </p:spPr>
+        <p:txBody>
+          <a:bodyPr wrap="square">
+            <a:spAutoFit/>
+          </a:bodyPr>
+          <a:lstStyle/>
+          <a:p>
+            <a:r>
+              <a:rPr sz="1200" b="0">
+                <a:solidFill>
+                  <a:srgbClr val="C9A23F"/>
+                </a:solidFill>
+                <a:latin typeface="Calibri"/>
+              </a:rPr>
+              <a:t>21</a:t>
+            </a:r>
+          </a:p>
+        </p:txBody>
+      </p:sp>
+    </p:spTree>
+  </p:cSld>
+  <p:clrMapOvr>
+    <a:masterClrMapping/>
+  </p:clrMapOvr>
+</p:sld>
+</file>
+
+<file path=ppt/slides/slide22.xml><?xml version="1.0" encoding="utf-8"?>
+<p:sld xmlns:a="http://schemas.openxmlformats.org/drawingml/2006/main" xmlns:p="http://schemas.openxmlformats.org/presentationml/2006/main" xmlns:r="http://schemas.openxmlformats.org/officeDocument/2006/relationships">
+  <p:cSld>
+    <p:bg>
+      <p:bgPr>
+        <a:solidFill>
+          <a:srgbClr val="00002A"/>
+        </a:solidFill>
+        <a:effectLst/>
+      </p:bgPr>
+    </p:bg>
+    <p:spTree>
+      <p:nvGrpSpPr>
+        <p:cNvPr id="1" name=""/>
+        <p:cNvGrpSpPr/>
+        <p:nvPr/>
+      </p:nvGrpSpPr>
+      <p:grpSpPr/>
+      <p:sp>
+        <p:nvSpPr>
+          <p:cNvPr id="2" name="TextBox 1"/>
+          <p:cNvSpPr txBox="1"/>
+          <p:nvPr/>
+        </p:nvSpPr>
+        <p:spPr>
+          <a:xfrm>
+            <a:off x="640080" y="320040"/>
+            <a:ext cx="10881360" cy="914400"/>
+          </a:xfrm>
+          <a:prstGeom prst="rect">
+            <a:avLst/>
+          </a:prstGeom>
+          <a:noFill/>
+        </p:spPr>
+        <p:txBody>
+          <a:bodyPr wrap="square">
+            <a:spAutoFit/>
+          </a:bodyPr>
+          <a:lstStyle/>
+          <a:p>
+            <a:r>
+              <a:rPr sz="3600" b="1">
+                <a:solidFill>
+                  <a:srgbClr val="D7C7EE"/>
+                </a:solidFill>
+                <a:latin typeface="Cinzel"/>
+              </a:rPr>
+              <a:t>VRAM held, show goes on.</a:t>
+            </a:r>
+          </a:p>
+        </p:txBody>
+      </p:sp>
+      <p:sp>
+        <p:nvSpPr>
+          <p:cNvPr id="12" name="TextBox 5"/>
+          <p:cNvSpPr txBox="1"/>
+          <p:nvPr/>
+        </p:nvSpPr>
+        <p:spPr>
+          <a:xfrm>
+            <a:off x="640080" y="1920240"/>
+            <a:ext cx="3840480" cy="4206240"/>
+          </a:xfrm>
+          <a:prstGeom prst="rect">
+            <a:avLst/>
+          </a:prstGeom>
+          <a:noFill/>
+        </p:spPr>
+        <p:txBody>
+          <a:bodyPr wrap="square">
+            <a:noAutofit/>
+          </a:bodyPr>
+          <a:lstStyle/>
+          <a:p>
+            <a:pPr>
+              <a:spcAft>
+                <a:spcPts val="3400"/>
+              </a:spcAft>
+            </a:pPr>
+            <a:r>
+              <a:rPr sz="2400">
+                <a:solidFill>
+                  <a:srgbClr val="F0F0F0"/>
+                </a:solidFill>
+                <a:latin typeface="Arial"/>
+              </a:rPr>
+              <a:t>ComfyUI holds VRAM.</a:t>
+            </a:r>
+          </a:p>
+          <a:p>
+            <a:pPr>
+              <a:spcAft>
+                <a:spcPts val="3400"/>
+              </a:spcAft>
+            </a:pPr>
+            <a:r>
+              <a:rPr sz="2400">
+                <a:solidFill>
+                  <a:srgbClr val="F0F0F0"/>
+                </a:solidFill>
+                <a:latin typeface="Arial"/>
+              </a:rPr>
+              <a:t>Coordinate pre-show.</a:t>
+            </a:r>
+          </a:p>
+          <a:p>
+            <a:pPr>
+              <a:spcAft>
+                <a:spcPts val="3400"/>
+              </a:spcAft>
+            </a:pPr>
+            <a:r>
+              <a:rPr sz="2400">
+                <a:solidFill>
+                  <a:srgbClr val="F0F0F0"/>
+                </a:solidFill>
+                <a:latin typeface="Arial"/>
+              </a:rPr>
+              <a:t>Spark covers gaps.</a:t>
+            </a:r>
+          </a:p>
+        </p:txBody>
+      </p:sp>
+      <p:pic>
+        <p:nvPicPr>
+          <p:cNvPr id="4" name="Picture 3" descr="image.png"/>
+          <p:cNvPicPr>
+            <a:picLocks noChangeAspect="1"/>
+          </p:cNvPicPr>
+          <p:nvPr/>
+        </p:nvPicPr>
+        <p:blipFill>
+          <a:blip r:embed="rId2"/>
+          <a:stretch>
+            <a:fillRect/>
+          </a:stretch>
+        </p:blipFill>
+        <p:spPr>
+          <a:xfrm>
+            <a:off x="4965192" y="2103120"/>
+            <a:ext cx="6675120" cy="3758184"/>
+          </a:xfrm>
+          <a:prstGeom prst="rect">
+            <a:avLst/>
+          </a:prstGeom>
+        </p:spPr>
+      </p:pic>
+      <p:sp>
+        <p:nvSpPr>
+          <p:cNvPr id="5" name="TextBox 4"/>
+          <p:cNvSpPr txBox="1"/>
+          <p:nvPr/>
+        </p:nvSpPr>
+        <p:spPr>
+          <a:xfrm>
+            <a:off x="11430000" y="6309360"/>
+            <a:ext cx="548640" cy="301752"/>
+          </a:xfrm>
+          <a:prstGeom prst="rect">
+            <a:avLst/>
+          </a:prstGeom>
+          <a:noFill/>
+        </p:spPr>
+        <p:txBody>
+          <a:bodyPr wrap="square">
+            <a:spAutoFit/>
+          </a:bodyPr>
+          <a:lstStyle/>
+          <a:p>
+            <a:r>
+              <a:rPr sz="1200" b="0">
+                <a:solidFill>
+                  <a:srgbClr val="C9A23F"/>
+                </a:solidFill>
+                <a:latin typeface="Calibri"/>
+              </a:rPr>
+              <a:t>22</a:t>
+            </a:r>
+          </a:p>
+        </p:txBody>
+      </p:sp>
     </p:spTree>
   </p:cSld>
   <p:clrMapOvr>

</xml_diff>

<commit_message>
deck: slides 1-2 plain words, drop unverified AWS line
</commit_message>
<xml_diff>
--- a/deck/unified.pptx
+++ b/deck/unified.pptx
@@ -506,6 +506,10 @@
           </p:nvPr>
         </p:nvSpPr>
         <p:spPr/>
+        <p:txBody>
+          <a:bodyPr/>
+          <a:p/>
+        </p:txBody>
       </p:sp>
       <p:sp>
         <p:nvSpPr>
@@ -539,6 +543,10 @@
           </p:nvPr>
         </p:nvSpPr>
         <p:spPr/>
+        <p:txBody>
+          <a:bodyPr/>
+          <a:p/>
+        </p:txBody>
       </p:sp>
     </p:spTree>
   </p:cSld>
@@ -1284,6 +1292,10 @@
           </p:nvPr>
         </p:nvSpPr>
         <p:spPr/>
+        <p:txBody>
+          <a:bodyPr/>
+          <a:p/>
+        </p:txBody>
       </p:sp>
       <p:sp>
         <p:nvSpPr>
@@ -1317,6 +1329,10 @@
           </p:nvPr>
         </p:nvSpPr>
         <p:spPr/>
+        <p:txBody>
+          <a:bodyPr/>
+          <a:p/>
+        </p:txBody>
       </p:sp>
     </p:spTree>
   </p:cSld>
@@ -5250,13 +5266,13 @@
               </a:spcAft>
             </a:pPr>
             <a:r>
-              <a:rPr sz="2400">
+              <a:rPr sz="2400" b="0">
                 <a:solidFill>
                   <a:srgbClr val="F0F0F0"/>
                 </a:solidFill>
                 <a:latin typeface="Arial"/>
               </a:rPr>
-              <a:t>Every player and the ball, located 10 times a second.</a:t>
+              <a:t>Every player and the ball, on every frame.</a:t>
             </a:r>
           </a:p>
           <a:p>
@@ -8279,7 +8295,7 @@
                 </a:solidFill>
                 <a:latin typeface="Cinzel"/>
               </a:rPr>
-              <a:t>Invent a stat fit for live TV</a:t>
+              <a:t>The contest.</a:t>
             </a:r>
           </a:p>
         </p:txBody>
@@ -8312,13 +8328,13 @@
               </a:spcAft>
             </a:pPr>
             <a:r>
-              <a:rPr sz="2400">
+              <a:rPr sz="2400" b="0">
                 <a:solidFill>
                   <a:srgbClr val="F0F0F0"/>
                 </a:solidFill>
                 <a:latin typeface="Arial"/>
               </a:rPr>
-              <a:t>Run by the league. Powered by AWS.</a:t>
+              <a:t>Run by the league.</a:t>
             </a:r>
           </a:p>
           <a:p>
@@ -8328,7 +8344,7 @@
               </a:spcAft>
             </a:pPr>
             <a:r>
-              <a:rPr sz="2400">
+              <a:rPr sz="2400" b="0">
                 <a:solidFill>
                   <a:srgbClr val="F0F0F0"/>
                 </a:solidFill>
@@ -8344,7 +8360,7 @@
               </a:spcAft>
             </a:pPr>
             <a:r>
-              <a:rPr sz="2400">
+              <a:rPr sz="2400" b="0">
                 <a:solidFill>
                   <a:srgbClr val="F0F0F0"/>
                 </a:solidFill>

</xml_diff>